<commit_message>
Add wave-scope data checklist, pilot architecture diagram, dated Gantt
- Чек-лист (§3): 4 параметра для оценки скоупа любой волны (состав
  данных, количество витрин/коллекций, пользователей, ролей) отдельно
  для КХД/ESB и для RAG; вопросы 1, 3, 6 дополнены явным запросом чисел.
- Архитектура пилота: диаграмма (SVG + PNG) — платформа в центре,
  источники слева, получатели данных справа, по фактам пилота.
- Диаграмма Ганта в презентации переведена с недель на ориентировочные
  календарные даты (окт 2026 – апр 2027), явно показывает переход
  волны 3+/П4/П5 в 2027 год без фиксированного завершения.

Co-Authored-By: Claude Sonnet 5 <noreply@anthropic.com>
Claude-Session: https://claude.ai/code/session_01DpSN8JwCJ3tg3JVUadr2zE
</commit_message>
<xml_diff>
--- a/docs/presentations/case-27-proekt-d8-skoup-i-voprosy.pptx
+++ b/docs/presentations/case-27-proekt-d8-skoup-i-voprosy.pptx
@@ -133,7 +133,7 @@
               <c:strCache>
                 <c:ptCount val="1"/>
                 <c:pt idx="0">
-                  <c:v>Старт (нед.)</c:v>
+                  <c:v>Старт</c:v>
                 </c:pt>
               </c:strCache>
             </c:strRef>
@@ -204,22 +204,22 @@
                 <c:formatCode>General</c:formatCode>
                 <c:ptCount val="6"/>
                 <c:pt idx="0">
-                  <c:v>13</c:v>
+                  <c:v>46387</c:v>
                 </c:pt>
                 <c:pt idx="1">
-                  <c:v>13</c:v>
+                  <c:v>46387</c:v>
                 </c:pt>
                 <c:pt idx="2">
-                  <c:v>13</c:v>
+                  <c:v>46387</c:v>
                 </c:pt>
                 <c:pt idx="3">
-                  <c:v>7</c:v>
+                  <c:v>46345</c:v>
                 </c:pt>
                 <c:pt idx="4">
-                  <c:v>3</c:v>
+                  <c:v>46317</c:v>
                 </c:pt>
                 <c:pt idx="5">
-                  <c:v>0</c:v>
+                  <c:v>46296</c:v>
                 </c:pt>
               </c:numCache>
             </c:numRef>
@@ -268,7 +268,7 @@
               <c:strCache>
                 <c:ptCount val="1"/>
                 <c:pt idx="0">
-                  <c:v>Длительность (нед.)</c:v>
+                  <c:v>Длительность</c:v>
                 </c:pt>
               </c:strCache>
             </c:strRef>
@@ -405,22 +405,22 @@
                 <c:formatCode>General</c:formatCode>
                 <c:ptCount val="6"/>
                 <c:pt idx="0">
-                  <c:v>9</c:v>
+                  <c:v>63</c:v>
                 </c:pt>
                 <c:pt idx="1">
-                  <c:v>9</c:v>
+                  <c:v>63</c:v>
                 </c:pt>
                 <c:pt idx="2">
-                  <c:v>5</c:v>
+                  <c:v>35</c:v>
                 </c:pt>
                 <c:pt idx="3">
-                  <c:v>6</c:v>
+                  <c:v>42</c:v>
                 </c:pt>
                 <c:pt idx="4">
-                  <c:v>4</c:v>
+                  <c:v>28</c:v>
                 </c:pt>
                 <c:pt idx="5">
-                  <c:v>3</c:v>
+                  <c:v>21</c:v>
                 </c:pt>
               </c:numCache>
             </c:numRef>
@@ -501,8 +501,8 @@
         <c:axId val="2094734552"/>
         <c:scaling>
           <c:orientation val="minMax"/>
-          <c:max val="24"/>
-          <c:min val="0"/>
+          <c:max val="46486"/>
+          <c:min val="46296"/>
         </c:scaling>
         <c:delete val="0"/>
         <c:axPos val="b"/>
@@ -538,7 +538,7 @@
                     </a:solidFill>
                     <a:latin typeface="Calibri"/>
                   </a:rPr>
-                  <a:t>Неделя от старта проекта</a:t>
+                  <a:t>Ориентировочная дата (2026–2027)</a:t>
                 </a:r>
               </a:p>
             </c:rich>
@@ -546,7 +546,7 @@
           <c:layout/>
           <c:overlay val="0"/>
         </c:title>
-        <c:numFmt formatCode="General" sourceLinked="0"/>
+        <c:numFmt formatCode="[$-419]mmm yy" sourceLinked="0"/>
         <c:majorTickMark val="out"/>
         <c:minorTickMark val="none"/>
         <c:tickLblPos val="low"/>
@@ -564,7 +564,7 @@
           <a:lstStyle/>
           <a:p>
             <a:pPr>
-              <a:defRPr sz="1050" b="0" i="0" u="none" strike="noStrike">
+              <a:defRPr sz="1000" b="0" i="0" u="none" strike="noStrike">
                 <a:solidFill>
                   <a:srgbClr val="5B6B7A"/>
                 </a:solidFill>
@@ -577,7 +577,7 @@
         <c:crossAx val="2094734554"/>
         <c:crosses val="autoZero"/>
         <c:crossBetween val="between"/>
-        <c:majorUnit val="4"/>
+        <c:majorUnit val="31"/>
       </c:valAx>
       <c:spPr>
         <a:noFill/>
@@ -4701,7 +4701,7 @@
                 <a:ea typeface="Calibri" pitchFamily="34" charset="-122"/>
                 <a:cs typeface="Calibri" pitchFamily="34" charset="-120"/>
               </a:rPr>
-              <a:t>Недели от старта проекта. Волна 3+, П4, П5 — ориентировочно, точка старта уточняется по факту приёмки</a:t>
+              <a:t>Ориентировочные даты при условном старте в октябре 2026. Волна 3+, П4, П5 продолжаются в 2027 году — без фиксированного окончания (Кейс 2 методики)</a:t>
             </a:r>
             <a:endParaRPr lang="en-US" sz="1300" dirty="0"/>
           </a:p>
@@ -4715,7 +4715,7 @@
         </p:nvGraphicFramePr>
         <p:xfrm>
           <a:off x="502920" y="1691640"/>
-          <a:ext cx="11155680" cy="4343400"/>
+          <a:ext cx="11155680" cy="4206240"/>
         </p:xfrm>
         <a:graphic xmlns:a="http://schemas.openxmlformats.org/drawingml/2006/main">
           <a:graphicData uri="http://schemas.openxmlformats.org/drawingml/2006/chart">
@@ -4731,7 +4731,7 @@
         </p:nvSpPr>
         <p:spPr>
           <a:xfrm>
-            <a:off x="502920" y="6172200"/>
+            <a:off x="502920" y="6035040"/>
             <a:ext cx="256032" cy="182880"/>
           </a:xfrm>
           <a:prstGeom prst="rect">
@@ -4751,7 +4751,7 @@
         </p:nvSpPr>
         <p:spPr>
           <a:xfrm>
-            <a:off x="822960" y="6126480"/>
+            <a:off x="822960" y="5989320"/>
             <a:ext cx="2926080" cy="274320"/>
           </a:xfrm>
           <a:prstGeom prst="rect">
@@ -4790,7 +4790,7 @@
         </p:nvSpPr>
         <p:spPr>
           <a:xfrm>
-            <a:off x="3931920" y="6172200"/>
+            <a:off x="3931920" y="6035040"/>
             <a:ext cx="256032" cy="182880"/>
           </a:xfrm>
           <a:prstGeom prst="rect">
@@ -4810,7 +4810,7 @@
         </p:nvSpPr>
         <p:spPr>
           <a:xfrm>
-            <a:off x="4251960" y="6126480"/>
+            <a:off x="4251960" y="5989320"/>
             <a:ext cx="3200400" cy="274320"/>
           </a:xfrm>
           <a:prstGeom prst="rect">
@@ -4844,6 +4844,45 @@
       <p:sp>
         <p:nvSpPr>
           <p:cNvPr id="10" name="Text 7"/>
+          <p:cNvSpPr txBox="1"/>
+          <p:nvPr/>
+        </p:nvSpPr>
+        <p:spPr>
+          <a:xfrm>
+            <a:off x="502920" y="6355080"/>
+            <a:ext cx="11155680" cy="320040"/>
+          </a:xfrm>
+          <a:prstGeom prst="rect">
+            <a:avLst/>
+          </a:prstGeom>
+          <a:noFill/>
+          <a:ln/>
+        </p:spPr>
+        <p:txBody>
+          <a:bodyPr wrap="square" lIns="0" tIns="0" rIns="0" bIns="0" rtlCol="0" anchor="ctr"/>
+          <a:lstStyle/>
+          <a:p>
+            <a:pPr indent="0" marL="0">
+              <a:buNone/>
+            </a:pPr>
+            <a:r>
+              <a:rPr lang="en-US" sz="1050" i="1" dirty="0">
+                <a:solidFill>
+                  <a:srgbClr val="5B6B7A"/>
+                </a:solidFill>
+                <a:latin typeface="Calibri" pitchFamily="34" charset="0"/>
+                <a:ea typeface="Calibri" pitchFamily="34" charset="-122"/>
+                <a:cs typeface="Calibri" pitchFamily="34" charset="-120"/>
+              </a:rPr>
+              <a:t>→ Волна 3+, П4 и П5 продолжаются за пределами отображённого периода — переход в промышленную эксплуатацию и режим постоянных улучшений не имеет фиксированной даты завершения.</a:t>
+            </a:r>
+            <a:endParaRPr lang="en-US" sz="1050" dirty="0"/>
+          </a:p>
+        </p:txBody>
+      </p:sp>
+      <p:sp>
+        <p:nvSpPr>
+          <p:cNvPr id="11" name="Text 8"/>
           <p:cNvSpPr txBox="1"/>
           <p:nvPr/>
         </p:nvSpPr>

</xml_diff>

<commit_message>
Remove Gantt chart slide from D8 scope deck (broken in PowerPoint)
Native chart rendered fine in LibreOffice QA but came up blank in
PowerPoint. Dropping the slide rather than debugging the renderer
mismatch; deck is now 5 slides (cover, программа, реестр, 2×вопросы).
</commit_message>
<xml_diff>
--- a/docs/presentations/case-27-proekt-d8-skoup-i-voprosy.pptx
+++ b/docs/presentations/case-27-proekt-d8-skoup-i-voprosy.pptx
@@ -10,10 +10,9 @@
     <p:sldId id="258" r:id="rId4"/>
     <p:sldId id="259" r:id="rId5"/>
     <p:sldId id="260" r:id="rId6"/>
-    <p:sldId id="261" r:id="rId7"/>
   </p:sldIdLst>
   <p:notesMasterIdLst>
-    <p:notesMasterId r:id="rId8"/>
+    <p:notesMasterId r:id="rId7"/>
   </p:notesMasterIdLst>
   <p:sldSz cx="12192000" cy="6858000"/>
   <p:notesSz cx="6858000" cy="12192000"/>
@@ -110,497 +109,6 @@
     </a:lvl9pPr>
   </p:defaultTextStyle>
 </p:presentation>
-</file>
-
-<file path=ppt/charts/chart1.xml><?xml version="1.0" encoding="utf-8"?>
-<c:chartSpace xmlns:c="http://schemas.openxmlformats.org/drawingml/2006/chart" xmlns:a="http://schemas.openxmlformats.org/drawingml/2006/main" xmlns:r="http://schemas.openxmlformats.org/officeDocument/2006/relationships">
-  <c:date1904 val="0"/>
-  <c:roundedCorners val="1"/>
-  <c:chart>
-    <c:autoTitleDeleted val="1"/>
-    <c:plotArea>
-      <c:layout/>
-      <c:barChart>
-        <c:barDir val="bar"/>
-        <c:grouping val="stacked"/>
-        <c:varyColors val="0"/>
-        <c:ser>
-          <c:idx val="0"/>
-          <c:order val="0"/>
-          <c:tx>
-            <c:strRef>
-              <c:f>Sheet1!$B$1</c:f>
-              <c:strCache>
-                <c:ptCount val="1"/>
-                <c:pt idx="0">
-                  <c:v>Старт</c:v>
-                </c:pt>
-              </c:strCache>
-            </c:strRef>
-          </c:tx>
-          <c:spPr>
-            <a:solidFill>
-              <a:srgbClr val="FFFFFF"/>
-            </a:solidFill>
-            <a:effectLst/>
-          </c:spPr>
-          <c:invertIfNegative val="0"/>
-          <c:dLbls>
-            <c:numFmt formatCode="0;-0;&quot;&quot;" sourceLinked="0"/>
-            <c:txPr>
-              <a:bodyPr/>
-              <a:lstStyle/>
-              <a:p>
-                <a:pPr>
-                  <a:defRPr b="0" i="0" strike="noStrike" sz="1200" u="none">
-                    <a:solidFill>
-                      <a:srgbClr val="FFFFFF"/>
-                    </a:solidFill>
-                    <a:latin typeface="Arial"/>
-                  </a:defRPr>
-                </a:pPr>
-              </a:p>
-            </c:txPr>
-            <c:showLegendKey val="0"/>
-            <c:showVal val="0"/>
-            <c:showCatName val="0"/>
-            <c:showSerName val="0"/>
-            <c:showPercent val="0"/>
-            <c:showBubbleSize val="0"/>
-            <c:showLeaderLines val="0"/>
-          </c:dLbls>
-          <c:cat>
-            <c:multiLvlStrRef>
-              <c:f>Sheet1!$A$2:$A$7</c:f>
-              <c:multiLvlStrCache>
-                <c:ptCount val="6"/>
-                <c:lvl>
-                  <c:pt idx="0">
-                    <c:v>П5</c:v>
-                  </c:pt>
-                  <c:pt idx="1">
-                    <c:v>П4</c:v>
-                  </c:pt>
-                  <c:pt idx="2">
-                    <c:v>Волна 3+</c:v>
-                  </c:pt>
-                  <c:pt idx="3">
-                    <c:v>Волна 2</c:v>
-                  </c:pt>
-                  <c:pt idx="4">
-                    <c:v>Волна 1</c:v>
-                  </c:pt>
-                  <c:pt idx="5">
-                    <c:v>П2</c:v>
-                  </c:pt>
-                </c:lvl>
-              </c:multiLvlStrCache>
-            </c:multiLvlStrRef>
-          </c:cat>
-          <c:val>
-            <c:numRef>
-              <c:f>Sheet1!$B$2:$B$7</c:f>
-              <c:numCache>
-                <c:formatCode>General</c:formatCode>
-                <c:ptCount val="6"/>
-                <c:pt idx="0">
-                  <c:v>46387</c:v>
-                </c:pt>
-                <c:pt idx="1">
-                  <c:v>46387</c:v>
-                </c:pt>
-                <c:pt idx="2">
-                  <c:v>46387</c:v>
-                </c:pt>
-                <c:pt idx="3">
-                  <c:v>46345</c:v>
-                </c:pt>
-                <c:pt idx="4">
-                  <c:v>46317</c:v>
-                </c:pt>
-                <c:pt idx="5">
-                  <c:v>46296</c:v>
-                </c:pt>
-              </c:numCache>
-            </c:numRef>
-          </c:val>
-        </c:ser>
-        <c:dLbls>
-          <c:numFmt formatCode="0;-0;&quot;&quot;" sourceLinked="0"/>
-          <c:txPr>
-            <a:bodyPr/>
-            <a:lstStyle/>
-            <a:p>
-              <a:pPr>
-                <a:defRPr b="0" i="0" strike="noStrike" sz="1200" u="none">
-                  <a:solidFill>
-                    <a:srgbClr val="FFFFFF"/>
-                  </a:solidFill>
-                  <a:latin typeface="Arial"/>
-                </a:defRPr>
-              </a:pPr>
-            </a:p>
-          </c:txPr>
-          <c:showLegendKey val="0"/>
-          <c:showVal val="0"/>
-          <c:showCatName val="0"/>
-          <c:showSerName val="0"/>
-          <c:showPercent val="0"/>
-          <c:showBubbleSize val="0"/>
-          <c:showLeaderLines val="0"/>
-        </c:dLbls>
-        <c:gapWidth val="50"/>
-        <c:overlap val="100"/>
-        <c:axId val="2094734554"/>
-        <c:axId val="2094734552"/>
-        <c:axId val="2094734556"/>
-      </c:barChart>
-      <c:barChart>
-        <c:barDir val="bar"/>
-        <c:grouping val="stacked"/>
-        <c:varyColors val="0"/>
-        <c:ser>
-          <c:idx val="1"/>
-          <c:order val="1"/>
-          <c:tx>
-            <c:strRef>
-              <c:f>Sheet1!$C$1</c:f>
-              <c:strCache>
-                <c:ptCount val="1"/>
-                <c:pt idx="0">
-                  <c:v>Длительность</c:v>
-                </c:pt>
-              </c:strCache>
-            </c:strRef>
-          </c:tx>
-          <c:spPr>
-            <a:solidFill>
-              <a:srgbClr val="8FC5C9"/>
-            </a:solidFill>
-            <a:effectLst/>
-          </c:spPr>
-          <c:invertIfNegative val="0"/>
-          <c:dLbls>
-            <c:numFmt formatCode="0;-0;&quot;&quot;" sourceLinked="0"/>
-            <c:txPr>
-              <a:bodyPr/>
-              <a:lstStyle/>
-              <a:p>
-                <a:pPr>
-                  <a:defRPr b="0" i="0" strike="noStrike" sz="1200" u="none">
-                    <a:solidFill>
-                      <a:srgbClr val="FFFFFF"/>
-                    </a:solidFill>
-                    <a:latin typeface="Arial"/>
-                  </a:defRPr>
-                </a:pPr>
-              </a:p>
-            </c:txPr>
-            <c:showLegendKey val="0"/>
-            <c:showVal val="0"/>
-            <c:showCatName val="0"/>
-            <c:showSerName val="0"/>
-            <c:showPercent val="0"/>
-            <c:showBubbleSize val="0"/>
-            <c:showLeaderLines val="0"/>
-          </c:dLbls>
-          <c:dPt>
-            <c:idx val="0"/>
-            <c:invertIfNegative val="0"/>
-            <c:bubble3D val="0"/>
-            <c:spPr>
-              <a:solidFill>
-                <a:srgbClr val="8FC5C9"/>
-              </a:solidFill>
-              <a:effectLst/>
-            </c:spPr>
-          </c:dPt>
-          <c:dPt>
-            <c:idx val="1"/>
-            <c:invertIfNegative val="0"/>
-            <c:bubble3D val="0"/>
-            <c:spPr>
-              <a:solidFill>
-                <a:srgbClr val="8FC5C9"/>
-              </a:solidFill>
-              <a:effectLst/>
-            </c:spPr>
-          </c:dPt>
-          <c:dPt>
-            <c:idx val="2"/>
-            <c:invertIfNegative val="0"/>
-            <c:bubble3D val="0"/>
-            <c:spPr>
-              <a:solidFill>
-                <a:srgbClr val="8FC5C9"/>
-              </a:solidFill>
-              <a:effectLst/>
-            </c:spPr>
-          </c:dPt>
-          <c:dPt>
-            <c:idx val="3"/>
-            <c:invertIfNegative val="0"/>
-            <c:bubble3D val="0"/>
-            <c:spPr>
-              <a:solidFill>
-                <a:srgbClr val="0E7C86"/>
-              </a:solidFill>
-              <a:effectLst/>
-            </c:spPr>
-          </c:dPt>
-          <c:dPt>
-            <c:idx val="4"/>
-            <c:invertIfNegative val="0"/>
-            <c:bubble3D val="0"/>
-            <c:spPr>
-              <a:solidFill>
-                <a:srgbClr val="0E7C86"/>
-              </a:solidFill>
-              <a:effectLst/>
-            </c:spPr>
-          </c:dPt>
-          <c:dPt>
-            <c:idx val="5"/>
-            <c:invertIfNegative val="0"/>
-            <c:bubble3D val="0"/>
-            <c:spPr>
-              <a:solidFill>
-                <a:srgbClr val="0E7C86"/>
-              </a:solidFill>
-              <a:effectLst/>
-            </c:spPr>
-          </c:dPt>
-          <c:cat>
-            <c:multiLvlStrRef>
-              <c:f>Sheet1!$A$2:$A$7</c:f>
-              <c:multiLvlStrCache>
-                <c:ptCount val="6"/>
-                <c:lvl>
-                  <c:pt idx="0">
-                    <c:v>П5</c:v>
-                  </c:pt>
-                  <c:pt idx="1">
-                    <c:v>П4</c:v>
-                  </c:pt>
-                  <c:pt idx="2">
-                    <c:v>Волна 3+</c:v>
-                  </c:pt>
-                  <c:pt idx="3">
-                    <c:v>Волна 2</c:v>
-                  </c:pt>
-                  <c:pt idx="4">
-                    <c:v>Волна 1</c:v>
-                  </c:pt>
-                  <c:pt idx="5">
-                    <c:v>П2</c:v>
-                  </c:pt>
-                </c:lvl>
-              </c:multiLvlStrCache>
-            </c:multiLvlStrRef>
-          </c:cat>
-          <c:val>
-            <c:numRef>
-              <c:f>Sheet1!$C$2:$C$7</c:f>
-              <c:numCache>
-                <c:formatCode>General</c:formatCode>
-                <c:ptCount val="6"/>
-                <c:pt idx="0">
-                  <c:v>63</c:v>
-                </c:pt>
-                <c:pt idx="1">
-                  <c:v>63</c:v>
-                </c:pt>
-                <c:pt idx="2">
-                  <c:v>35</c:v>
-                </c:pt>
-                <c:pt idx="3">
-                  <c:v>42</c:v>
-                </c:pt>
-                <c:pt idx="4">
-                  <c:v>28</c:v>
-                </c:pt>
-                <c:pt idx="5">
-                  <c:v>21</c:v>
-                </c:pt>
-              </c:numCache>
-            </c:numRef>
-          </c:val>
-        </c:ser>
-        <c:dLbls>
-          <c:numFmt formatCode="0;-0;&quot;&quot;" sourceLinked="0"/>
-          <c:txPr>
-            <a:bodyPr/>
-            <a:lstStyle/>
-            <a:p>
-              <a:pPr>
-                <a:defRPr b="0" i="0" strike="noStrike" sz="1200" u="none">
-                  <a:solidFill>
-                    <a:srgbClr val="FFFFFF"/>
-                  </a:solidFill>
-                  <a:latin typeface="Arial"/>
-                </a:defRPr>
-              </a:pPr>
-            </a:p>
-          </c:txPr>
-          <c:showLegendKey val="0"/>
-          <c:showVal val="0"/>
-          <c:showCatName val="0"/>
-          <c:showSerName val="0"/>
-          <c:showPercent val="0"/>
-          <c:showBubbleSize val="0"/>
-          <c:showLeaderLines val="0"/>
-        </c:dLbls>
-        <c:gapWidth val="50"/>
-        <c:overlap val="100"/>
-        <c:axId val="2094734554"/>
-        <c:axId val="2094734552"/>
-        <c:axId val="2094734556"/>
-      </c:barChart>
-      <c:catAx>
-        <c:axId val="2094734554"/>
-        <c:scaling>
-          <c:orientation val="minMax"/>
-        </c:scaling>
-        <c:delete val="0"/>
-        <c:axPos val="l"/>
-        <c:numFmt formatCode="General" sourceLinked="1"/>
-        <c:majorTickMark val="out"/>
-        <c:minorTickMark val="none"/>
-        <c:tickLblPos val="nextTo"/>
-        <c:spPr>
-          <a:ln w="12700" cap="flat">
-            <a:solidFill>
-              <a:srgbClr val="D8DEE2"/>
-            </a:solidFill>
-            <a:prstDash val="solid"/>
-            <a:round/>
-          </a:ln>
-        </c:spPr>
-        <c:txPr>
-          <a:bodyPr/>
-          <a:lstStyle/>
-          <a:p>
-            <a:pPr>
-              <a:defRPr sz="1250" b="1" i="0" u="none" strike="noStrike">
-                <a:solidFill>
-                  <a:srgbClr val="1A2733"/>
-                </a:solidFill>
-                <a:latin typeface="Calibri"/>
-              </a:defRPr>
-            </a:pPr>
-            <a:endParaRPr lang="en-US"/>
-          </a:p>
-        </c:txPr>
-        <c:crossAx val="2094734552"/>
-        <c:crosses val="autoZero"/>
-        <c:auto val="1"/>
-        <c:lblAlgn val="ctr"/>
-        <c:noMultiLvlLbl val="1"/>
-      </c:catAx>
-      <c:valAx>
-        <c:axId val="2094734552"/>
-        <c:scaling>
-          <c:orientation val="minMax"/>
-          <c:max val="46486"/>
-          <c:min val="46296"/>
-        </c:scaling>
-        <c:delete val="0"/>
-        <c:axPos val="b"/>
-        <c:majorGridlines>
-          <c:spPr>
-            <a:ln w="9525" cap="flat">
-              <a:solidFill>
-                <a:srgbClr val="D8DEE2"/>
-              </a:solidFill>
-              <a:prstDash val="solid"/>
-              <a:round/>
-            </a:ln>
-          </c:spPr>
-        </c:majorGridlines>
-        <c:title>
-          <c:tx>
-            <c:rich>
-              <a:bodyPr/>
-              <a:lstStyle/>
-              <a:p>
-                <a:pPr>
-                  <a:defRPr sz="1100" b="0" i="0" u="none" strike="noStrike">
-                    <a:solidFill>
-                      <a:srgbClr val="5B6B7A"/>
-                    </a:solidFill>
-                    <a:latin typeface="Calibri"/>
-                  </a:defRPr>
-                </a:pPr>
-                <a:r>
-                  <a:rPr sz="1100" b="0" i="0" u="none" strike="noStrike">
-                    <a:solidFill>
-                      <a:srgbClr val="5B6B7A"/>
-                    </a:solidFill>
-                    <a:latin typeface="Calibri"/>
-                  </a:rPr>
-                  <a:t>Ориентировочная дата (2026–2027)</a:t>
-                </a:r>
-              </a:p>
-            </c:rich>
-          </c:tx>
-          <c:layout/>
-          <c:overlay val="0"/>
-        </c:title>
-        <c:numFmt formatCode="[$-419]mmm yy" sourceLinked="0"/>
-        <c:majorTickMark val="out"/>
-        <c:minorTickMark val="none"/>
-        <c:tickLblPos val="low"/>
-        <c:spPr>
-          <a:ln w="12700" cap="flat">
-            <a:solidFill>
-              <a:srgbClr val="888888"/>
-            </a:solidFill>
-            <a:prstDash val="solid"/>
-            <a:round/>
-          </a:ln>
-        </c:spPr>
-        <c:txPr>
-          <a:bodyPr/>
-          <a:lstStyle/>
-          <a:p>
-            <a:pPr>
-              <a:defRPr sz="1000" b="0" i="0" u="none" strike="noStrike">
-                <a:solidFill>
-                  <a:srgbClr val="5B6B7A"/>
-                </a:solidFill>
-                <a:latin typeface="Calibri"/>
-              </a:defRPr>
-            </a:pPr>
-            <a:endParaRPr lang="en-US"/>
-          </a:p>
-        </c:txPr>
-        <c:crossAx val="2094734554"/>
-        <c:crosses val="autoZero"/>
-        <c:crossBetween val="between"/>
-        <c:majorUnit val="31"/>
-      </c:valAx>
-      <c:spPr>
-        <a:noFill/>
-        <a:ln>
-          <a:noFill/>
-        </a:ln>
-        <a:effectLst/>
-      </c:spPr>
-    </c:plotArea>
-    <c:plotVisOnly val="1"/>
-    <c:dispBlanksAs val="span"/>
-  </c:chart>
-  <c:spPr>
-    <a:noFill/>
-    <a:ln>
-      <a:noFill/>
-    </a:ln>
-    <a:effectLst/>
-  </c:spPr>
-  <c:externalData r:id="rId1">
-    <c:autoUpdate val="0"/>
-  </c:externalData>
-</c:chartSpace>
 </file>
 
 <file path=ppt/notesMasters/notesMaster1.xml><?xml version="1.0" encoding="utf-8"?>
@@ -1374,94 +882,6 @@
             <a:fld id="{F7021451-1387-4CA6-816F-3879F97B5CBC}" type="slidenum">
               <a:rPr lang="en-US"/>
               <a:t>5</a:t>
-            </a:fld>
-            <a:endParaRPr lang="en-US"/>
-          </a:p>
-        </p:txBody>
-      </p:sp>
-    </p:spTree>
-    <p:extLst>
-      <p:ext uri="{BB962C8B-B14F-4D97-AF65-F5344CB8AC3E}">
-        <p14:creationId xmlns:p14="http://schemas.microsoft.com/office/powerpoint/2010/main" val="1024086991"/>
-      </p:ext>
-    </p:extLst>
-  </p:cSld>
-  <p:clrMapOvr>
-    <a:masterClrMapping/>
-  </p:clrMapOvr>
-</p:notes>
-</file>
-
-<file path=ppt/notesSlides/notesSlide6.xml><?xml version="1.0" encoding="utf-8"?>
-<p:notes xmlns:a="http://schemas.openxmlformats.org/drawingml/2006/main" xmlns:r="http://schemas.openxmlformats.org/officeDocument/2006/relationships" xmlns:p="http://schemas.openxmlformats.org/presentationml/2006/main">
-  <p:cSld>
-    <p:spTree>
-      <p:nvGrpSpPr>
-        <p:cNvPr id="1" name=""/>
-        <p:cNvGrpSpPr/>
-        <p:nvPr/>
-      </p:nvGrpSpPr>
-      <p:grpSpPr>
-        <a:xfrm>
-          <a:off x="0" y="0"/>
-          <a:ext cx="0" cy="0"/>
-          <a:chOff x="0" y="0"/>
-          <a:chExt cx="0" cy="0"/>
-        </a:xfrm>
-      </p:grpSpPr>
-      <p:sp>
-        <p:nvSpPr>
-          <p:cNvPr id="2" name="Slide Image Placeholder 1"/>
-          <p:cNvSpPr>
-            <a:spLocks noGrp="1" noRot="1" noChangeAspect="1"/>
-          </p:cNvSpPr>
-          <p:nvPr>
-            <p:ph type="sldImg"/>
-          </p:nvPr>
-        </p:nvSpPr>
-        <p:spPr/>
-      </p:sp>
-      <p:sp>
-        <p:nvSpPr>
-          <p:cNvPr id="3" name="Notes Placeholder 2"/>
-          <p:cNvSpPr>
-            <a:spLocks noGrp="1"/>
-          </p:cNvSpPr>
-          <p:nvPr>
-            <p:ph type="body" idx="1"/>
-          </p:nvPr>
-        </p:nvSpPr>
-        <p:spPr/>
-        <p:txBody>
-          <a:bodyPr/>
-          <a:lstStyle/>
-          <a:p>
-            <a:r>
-              <a:rPr lang="en-US" dirty="0"/>
-              <a:t/>
-            </a:r>
-            <a:endParaRPr lang="en-US" dirty="0"/>
-          </a:p>
-        </p:txBody>
-      </p:sp>
-      <p:sp>
-        <p:nvSpPr>
-          <p:cNvPr id="4" name="Slide Number Placeholder 3"/>
-          <p:cNvSpPr>
-            <a:spLocks noGrp="1"/>
-          </p:cNvSpPr>
-          <p:nvPr>
-            <p:ph type="sldNum" sz="quarter" idx="10"/>
-          </p:nvPr>
-        </p:nvSpPr>
-        <p:spPr/>
-        <p:txBody>
-          <a:bodyPr/>
-          <a:lstStyle/>
-          <a:p>
-            <a:fld id="{F7021451-1387-4CA6-816F-3879F97B5CBC}" type="slidenum">
-              <a:rPr lang="en-US"/>
-              <a:t>6</a:t>
             </a:fld>
             <a:endParaRPr lang="en-US"/>
           </a:p>
@@ -2461,7 +1881,7 @@
                 <a:ea typeface="Calibri" pitchFamily="34" charset="-122"/>
                 <a:cs typeface="Calibri" pitchFamily="34" charset="-120"/>
               </a:rPr>
-              <a:t>1 / 6</a:t>
+              <a:t>1 / 5</a:t>
             </a:r>
             <a:endParaRPr lang="en-US" sz="1050" dirty="0"/>
           </a:p>
@@ -4559,7 +3979,7 @@
                 <a:ea typeface="Calibri" pitchFamily="34" charset="-122"/>
                 <a:cs typeface="Calibri" pitchFamily="34" charset="-120"/>
               </a:rPr>
-              <a:t>2 / 6</a:t>
+              <a:t>2 / 5</a:t>
             </a:r>
             <a:endParaRPr lang="en-US" sz="1050" dirty="0"/>
           </a:p>
@@ -4623,361 +4043,7 @@
                 <a:ea typeface="Calibri" pitchFamily="34" charset="-122"/>
                 <a:cs typeface="Calibri" pitchFamily="34" charset="-120"/>
               </a:rPr>
-              <a:t>2 · ДИАГРАММА ГАНТА</a:t>
-            </a:r>
-            <a:endParaRPr lang="en-US" sz="1100" dirty="0"/>
-          </a:p>
-        </p:txBody>
-      </p:sp>
-      <p:sp>
-        <p:nvSpPr>
-          <p:cNvPr id="3" name="Text 1"/>
-          <p:cNvSpPr txBox="1"/>
-          <p:nvPr/>
-        </p:nvSpPr>
-        <p:spPr>
-          <a:xfrm>
-            <a:off x="502920" y="621792"/>
-            <a:ext cx="11155680" cy="548640"/>
-          </a:xfrm>
-          <a:prstGeom prst="rect">
-            <a:avLst/>
-          </a:prstGeom>
-          <a:noFill/>
-          <a:ln/>
-        </p:spPr>
-        <p:txBody>
-          <a:bodyPr wrap="square" lIns="0" tIns="0" rIns="0" bIns="0" rtlCol="0" anchor="ctr"/>
-          <a:lstStyle/>
-          <a:p>
-            <a:pPr indent="0" marL="0">
-              <a:buNone/>
-            </a:pPr>
-            <a:r>
-              <a:rPr lang="en-US" sz="2700" b="1" dirty="0">
-                <a:solidFill>
-                  <a:srgbClr val="1A2733"/>
-                </a:solidFill>
-                <a:latin typeface="Cambria" pitchFamily="34" charset="0"/>
-                <a:ea typeface="Cambria" pitchFamily="34" charset="-122"/>
-                <a:cs typeface="Cambria" pitchFamily="34" charset="-120"/>
-              </a:rPr>
-              <a:t>Длительность этапов программы</a:t>
-            </a:r>
-            <a:endParaRPr lang="en-US" sz="2700" dirty="0"/>
-          </a:p>
-        </p:txBody>
-      </p:sp>
-      <p:sp>
-        <p:nvSpPr>
-          <p:cNvPr id="4" name="Text 2"/>
-          <p:cNvSpPr txBox="1"/>
-          <p:nvPr/>
-        </p:nvSpPr>
-        <p:spPr>
-          <a:xfrm>
-            <a:off x="502920" y="1170432"/>
-            <a:ext cx="11155680" cy="365760"/>
-          </a:xfrm>
-          <a:prstGeom prst="rect">
-            <a:avLst/>
-          </a:prstGeom>
-          <a:noFill/>
-          <a:ln/>
-        </p:spPr>
-        <p:txBody>
-          <a:bodyPr wrap="square" lIns="0" tIns="0" rIns="0" bIns="0" rtlCol="0" anchor="ctr"/>
-          <a:lstStyle/>
-          <a:p>
-            <a:pPr indent="0" marL="0">
-              <a:buNone/>
-            </a:pPr>
-            <a:r>
-              <a:rPr lang="en-US" sz="1300" dirty="0">
-                <a:solidFill>
-                  <a:srgbClr val="5B6B7A"/>
-                </a:solidFill>
-                <a:latin typeface="Calibri" pitchFamily="34" charset="0"/>
-                <a:ea typeface="Calibri" pitchFamily="34" charset="-122"/>
-                <a:cs typeface="Calibri" pitchFamily="34" charset="-120"/>
-              </a:rPr>
-              <a:t>Ориентировочные даты при условном старте в октябре 2026. Волна 3+, П4, П5 продолжаются в 2027 году — без фиксированного окончания (Кейс 2 методики)</a:t>
-            </a:r>
-            <a:endParaRPr lang="en-US" sz="1300" dirty="0"/>
-          </a:p>
-        </p:txBody>
-      </p:sp>
-      <p:graphicFrame>
-        <p:nvGraphicFramePr>
-          <p:cNvPr id="5" name="Chart 0" descr=""/>
-          <p:cNvGraphicFramePr/>
-          <p:nvPr/>
-        </p:nvGraphicFramePr>
-        <p:xfrm>
-          <a:off x="502920" y="1691640"/>
-          <a:ext cx="11155680" cy="4206240"/>
-        </p:xfrm>
-        <a:graphic xmlns:a="http://schemas.openxmlformats.org/drawingml/2006/main">
-          <a:graphicData uri="http://schemas.openxmlformats.org/drawingml/2006/chart">
-            <c:chart xmlns:c="http://schemas.openxmlformats.org/drawingml/2006/chart" r:id="rId1"/>
-          </a:graphicData>
-        </a:graphic>
-      </p:graphicFrame>
-      <p:sp>
-        <p:nvSpPr>
-          <p:cNvPr id="6" name="Shape 3"/>
-          <p:cNvSpPr/>
-          <p:nvPr/>
-        </p:nvSpPr>
-        <p:spPr>
-          <a:xfrm>
-            <a:off x="502920" y="6035040"/>
-            <a:ext cx="256032" cy="182880"/>
-          </a:xfrm>
-          <a:prstGeom prst="rect">
-            <a:avLst/>
-          </a:prstGeom>
-          <a:solidFill>
-            <a:srgbClr val="0E7C86"/>
-          </a:solidFill>
-          <a:ln/>
-        </p:spPr>
-      </p:sp>
-      <p:sp>
-        <p:nvSpPr>
-          <p:cNvPr id="7" name="Text 4"/>
-          <p:cNvSpPr txBox="1"/>
-          <p:nvPr/>
-        </p:nvSpPr>
-        <p:spPr>
-          <a:xfrm>
-            <a:off x="822960" y="5989320"/>
-            <a:ext cx="2926080" cy="274320"/>
-          </a:xfrm>
-          <a:prstGeom prst="rect">
-            <a:avLst/>
-          </a:prstGeom>
-          <a:noFill/>
-          <a:ln/>
-        </p:spPr>
-        <p:txBody>
-          <a:bodyPr wrap="square" lIns="0" tIns="0" rIns="0" bIns="0" rtlCol="0" anchor="ctr"/>
-          <a:lstStyle/>
-          <a:p>
-            <a:pPr indent="0" marL="0">
-              <a:buNone/>
-            </a:pPr>
-            <a:r>
-              <a:rPr lang="en-US" sz="1100" dirty="0">
-                <a:solidFill>
-                  <a:srgbClr val="5B6B7A"/>
-                </a:solidFill>
-                <a:latin typeface="Calibri" pitchFamily="34" charset="0"/>
-                <a:ea typeface="Calibri" pitchFamily="34" charset="-122"/>
-                <a:cs typeface="Calibri" pitchFamily="34" charset="-120"/>
-              </a:rPr>
-              <a:t>Подтверждено программой</a:t>
-            </a:r>
-            <a:endParaRPr lang="en-US" sz="1100" dirty="0"/>
-          </a:p>
-        </p:txBody>
-      </p:sp>
-      <p:sp>
-        <p:nvSpPr>
-          <p:cNvPr id="8" name="Shape 5"/>
-          <p:cNvSpPr/>
-          <p:nvPr/>
-        </p:nvSpPr>
-        <p:spPr>
-          <a:xfrm>
-            <a:off x="3931920" y="6035040"/>
-            <a:ext cx="256032" cy="182880"/>
-          </a:xfrm>
-          <a:prstGeom prst="rect">
-            <a:avLst/>
-          </a:prstGeom>
-          <a:solidFill>
-            <a:srgbClr val="8FC5C9"/>
-          </a:solidFill>
-          <a:ln/>
-        </p:spPr>
-      </p:sp>
-      <p:sp>
-        <p:nvSpPr>
-          <p:cNvPr id="9" name="Text 6"/>
-          <p:cNvSpPr txBox="1"/>
-          <p:nvPr/>
-        </p:nvSpPr>
-        <p:spPr>
-          <a:xfrm>
-            <a:off x="4251960" y="5989320"/>
-            <a:ext cx="3200400" cy="274320"/>
-          </a:xfrm>
-          <a:prstGeom prst="rect">
-            <a:avLst/>
-          </a:prstGeom>
-          <a:noFill/>
-          <a:ln/>
-        </p:spPr>
-        <p:txBody>
-          <a:bodyPr wrap="square" lIns="0" tIns="0" rIns="0" bIns="0" rtlCol="0" anchor="ctr"/>
-          <a:lstStyle/>
-          <a:p>
-            <a:pPr indent="0" marL="0">
-              <a:buNone/>
-            </a:pPr>
-            <a:r>
-              <a:rPr lang="en-US" sz="1100" dirty="0">
-                <a:solidFill>
-                  <a:srgbClr val="5B6B7A"/>
-                </a:solidFill>
-                <a:latin typeface="Calibri" pitchFamily="34" charset="0"/>
-                <a:ea typeface="Calibri" pitchFamily="34" charset="-122"/>
-                <a:cs typeface="Calibri" pitchFamily="34" charset="-120"/>
-              </a:rPr>
-              <a:t>Ориентировочно / открыто</a:t>
-            </a:r>
-            <a:endParaRPr lang="en-US" sz="1100" dirty="0"/>
-          </a:p>
-        </p:txBody>
-      </p:sp>
-      <p:sp>
-        <p:nvSpPr>
-          <p:cNvPr id="10" name="Text 7"/>
-          <p:cNvSpPr txBox="1"/>
-          <p:nvPr/>
-        </p:nvSpPr>
-        <p:spPr>
-          <a:xfrm>
-            <a:off x="502920" y="6355080"/>
-            <a:ext cx="11155680" cy="320040"/>
-          </a:xfrm>
-          <a:prstGeom prst="rect">
-            <a:avLst/>
-          </a:prstGeom>
-          <a:noFill/>
-          <a:ln/>
-        </p:spPr>
-        <p:txBody>
-          <a:bodyPr wrap="square" lIns="0" tIns="0" rIns="0" bIns="0" rtlCol="0" anchor="ctr"/>
-          <a:lstStyle/>
-          <a:p>
-            <a:pPr indent="0" marL="0">
-              <a:buNone/>
-            </a:pPr>
-            <a:r>
-              <a:rPr lang="en-US" sz="1050" i="1" dirty="0">
-                <a:solidFill>
-                  <a:srgbClr val="5B6B7A"/>
-                </a:solidFill>
-                <a:latin typeface="Calibri" pitchFamily="34" charset="0"/>
-                <a:ea typeface="Calibri" pitchFamily="34" charset="-122"/>
-                <a:cs typeface="Calibri" pitchFamily="34" charset="-120"/>
-              </a:rPr>
-              <a:t>→ Волна 3+, П4 и П5 продолжаются за пределами отображённого периода — переход в промышленную эксплуатацию и режим постоянных улучшений не имеет фиксированной даты завершения.</a:t>
-            </a:r>
-            <a:endParaRPr lang="en-US" sz="1050" dirty="0"/>
-          </a:p>
-        </p:txBody>
-      </p:sp>
-      <p:sp>
-        <p:nvSpPr>
-          <p:cNvPr id="11" name="Text 8"/>
-          <p:cNvSpPr txBox="1"/>
-          <p:nvPr/>
-        </p:nvSpPr>
-        <p:spPr>
-          <a:xfrm>
-            <a:off x="10881360" y="6473952"/>
-            <a:ext cx="822960" cy="274320"/>
-          </a:xfrm>
-          <a:prstGeom prst="rect">
-            <a:avLst/>
-          </a:prstGeom>
-          <a:noFill/>
-          <a:ln/>
-        </p:spPr>
-        <p:txBody>
-          <a:bodyPr wrap="square" lIns="0" tIns="0" rIns="0" bIns="0" rtlCol="0" anchor="ctr"/>
-          <a:lstStyle/>
-          <a:p>
-            <a:pPr algn="r" indent="0" marL="0">
-              <a:buNone/>
-            </a:pPr>
-            <a:r>
-              <a:rPr lang="en-US" sz="1050" dirty="0">
-                <a:solidFill>
-                  <a:srgbClr val="8C99A6"/>
-                </a:solidFill>
-                <a:latin typeface="Calibri" pitchFamily="34" charset="0"/>
-                <a:ea typeface="Calibri" pitchFamily="34" charset="-122"/>
-                <a:cs typeface="Calibri" pitchFamily="34" charset="-120"/>
-              </a:rPr>
-              <a:t>3 / 6</a:t>
-            </a:r>
-            <a:endParaRPr lang="en-US" sz="1050" dirty="0"/>
-          </a:p>
-        </p:txBody>
-      </p:sp>
-    </p:spTree>
-  </p:cSld>
-  <p:clrMapOvr>
-    <a:masterClrMapping/>
-  </p:clrMapOvr>
-</p:sld>
-</file>
-
-<file path=ppt/slides/slide4.xml><?xml version="1.0" encoding="utf-8"?>
-<p:sld xmlns:a="http://schemas.openxmlformats.org/drawingml/2006/main" xmlns:r="http://schemas.openxmlformats.org/officeDocument/2006/relationships" xmlns:p="http://schemas.openxmlformats.org/presentationml/2006/main">
-  <p:cSld name="Slide 4">
-    <p:spTree>
-      <p:nvGrpSpPr>
-        <p:cNvPr id="1" name=""/>
-        <p:cNvGrpSpPr/>
-        <p:nvPr/>
-      </p:nvGrpSpPr>
-      <p:grpSpPr>
-        <a:xfrm>
-          <a:off x="0" y="0"/>
-          <a:ext cx="0" cy="0"/>
-          <a:chOff x="0" y="0"/>
-          <a:chExt cx="0" cy="0"/>
-        </a:xfrm>
-      </p:grpSpPr>
-      <p:sp>
-        <p:nvSpPr>
-          <p:cNvPr id="2" name="Text 0"/>
-          <p:cNvSpPr txBox="1"/>
-          <p:nvPr/>
-        </p:nvSpPr>
-        <p:spPr>
-          <a:xfrm>
-            <a:off x="502920" y="320040"/>
-            <a:ext cx="11155680" cy="274320"/>
-          </a:xfrm>
-          <a:prstGeom prst="rect">
-            <a:avLst/>
-          </a:prstGeom>
-          <a:noFill/>
-          <a:ln/>
-        </p:spPr>
-        <p:txBody>
-          <a:bodyPr wrap="square" lIns="0" tIns="0" rIns="0" bIns="0" rtlCol="0" anchor="ctr"/>
-          <a:lstStyle/>
-          <a:p>
-            <a:pPr indent="0" marL="0">
-              <a:buNone/>
-            </a:pPr>
-            <a:r>
-              <a:rPr lang="en-US" sz="1100" b="1" spc="120" kern="0" dirty="0">
-                <a:solidFill>
-                  <a:srgbClr val="0E7C86"/>
-                </a:solidFill>
-                <a:latin typeface="Calibri" pitchFamily="34" charset="0"/>
-                <a:ea typeface="Calibri" pitchFamily="34" charset="-122"/>
-                <a:cs typeface="Calibri" pitchFamily="34" charset="-120"/>
-              </a:rPr>
-              <a:t>3 · ЗАФИКСИРОВАННЫЕ ПОЖЕЛАНИЯ ЗАКАЗЧИКА</a:t>
+              <a:t>2 · ЗАФИКСИРОВАННЫЕ ПОЖЕЛАНИЯ ЗАКАЗЧИКА</a:t>
             </a:r>
             <a:endParaRPr lang="en-US" sz="1100" dirty="0"/>
           </a:p>
@@ -5063,7 +4129,7 @@
       </p:sp>
       <p:graphicFrame>
         <p:nvGraphicFramePr>
-          <p:cNvPr id="5" name="Table 0"/>
+          <p:cNvPr id="4" name="Table 0"/>
           <p:cNvGraphicFramePr>
             <a:graphicFrameLocks noGrp="1"/>
           </p:cNvGraphicFramePr>
@@ -8216,7 +7282,7 @@
                 <a:ea typeface="Calibri" pitchFamily="34" charset="-122"/>
                 <a:cs typeface="Calibri" pitchFamily="34" charset="-120"/>
               </a:rPr>
-              <a:t>4 / 6</a:t>
+              <a:t>3 / 5</a:t>
             </a:r>
             <a:endParaRPr lang="en-US" sz="1050" dirty="0"/>
           </a:p>
@@ -8230,9 +7296,9 @@
 </p:sld>
 </file>
 
-<file path=ppt/slides/slide5.xml><?xml version="1.0" encoding="utf-8"?>
+<file path=ppt/slides/slide4.xml><?xml version="1.0" encoding="utf-8"?>
 <p:sld xmlns:a="http://schemas.openxmlformats.org/drawingml/2006/main" xmlns:r="http://schemas.openxmlformats.org/officeDocument/2006/relationships" xmlns:p="http://schemas.openxmlformats.org/presentationml/2006/main">
-  <p:cSld name="Slide 5">
+  <p:cSld name="Slide 4">
     <p:spTree>
       <p:nvGrpSpPr>
         <p:cNvPr id="1" name=""/>
@@ -8280,7 +7346,7 @@
                 <a:ea typeface="Calibri" pitchFamily="34" charset="-122"/>
                 <a:cs typeface="Calibri" pitchFamily="34" charset="-120"/>
               </a:rPr>
-              <a:t>4 · НАШИ ВОПРОСЫ · ПО НАПОЛНЕНИЮ ЭТАПОВ</a:t>
+              <a:t>3 · НАШИ ВОПРОСЫ · ПО НАПОЛНЕНИЮ ЭТАПОВ</a:t>
             </a:r>
             <a:endParaRPr lang="en-US" sz="1100" dirty="0"/>
           </a:p>
@@ -8366,7 +7432,7 @@
       </p:sp>
       <p:graphicFrame>
         <p:nvGraphicFramePr>
-          <p:cNvPr id="6" name="Table 0"/>
+          <p:cNvPr id="5" name="Table 0"/>
           <p:cNvGraphicFramePr>
             <a:graphicFrameLocks noGrp="1"/>
           </p:cNvGraphicFramePr>
@@ -10799,7 +9865,7 @@
                 <a:ea typeface="Calibri" pitchFamily="34" charset="-122"/>
                 <a:cs typeface="Calibri" pitchFamily="34" charset="-120"/>
               </a:rPr>
-              <a:t>5 / 6</a:t>
+              <a:t>4 / 5</a:t>
             </a:r>
             <a:endParaRPr lang="en-US" sz="1050" dirty="0"/>
           </a:p>
@@ -10813,9 +9879,9 @@
 </p:sld>
 </file>
 
-<file path=ppt/slides/slide6.xml><?xml version="1.0" encoding="utf-8"?>
+<file path=ppt/slides/slide5.xml><?xml version="1.0" encoding="utf-8"?>
 <p:sld xmlns:a="http://schemas.openxmlformats.org/drawingml/2006/main" xmlns:r="http://schemas.openxmlformats.org/officeDocument/2006/relationships" xmlns:p="http://schemas.openxmlformats.org/presentationml/2006/main">
-  <p:cSld name="Slide 6">
+  <p:cSld name="Slide 5">
     <p:spTree>
       <p:nvGrpSpPr>
         <p:cNvPr id="1" name=""/>
@@ -10863,7 +9929,7 @@
                 <a:ea typeface="Calibri" pitchFamily="34" charset="-122"/>
                 <a:cs typeface="Calibri" pitchFamily="34" charset="-120"/>
               </a:rPr>
-              <a:t>4 · НАШИ ВОПРОСЫ · ПО ПОЖЕЛАНИЯМ ЗАКАЗЧИКА</a:t>
+              <a:t>3 · НАШИ ВОПРОСЫ · ПО ПОЖЕЛАНИЯМ ЗАКАЗЧИКА</a:t>
             </a:r>
             <a:endParaRPr lang="en-US" sz="1100" dirty="0"/>
           </a:p>
@@ -10949,7 +10015,7 @@
       </p:sp>
       <p:graphicFrame>
         <p:nvGraphicFramePr>
-          <p:cNvPr id="7" name="Table 0"/>
+          <p:cNvPr id="6" name="Table 0"/>
           <p:cNvGraphicFramePr>
             <a:graphicFrameLocks noGrp="1"/>
           </p:cNvGraphicFramePr>
@@ -12663,7 +11729,7 @@
                 <a:ea typeface="Calibri" pitchFamily="34" charset="-122"/>
                 <a:cs typeface="Calibri" pitchFamily="34" charset="-120"/>
               </a:rPr>
-              <a:t>6 / 6</a:t>
+              <a:t>5 / 5</a:t>
             </a:r>
             <a:endParaRPr lang="en-US" sz="1050" dirty="0"/>
           </a:p>

</xml_diff>

<commit_message>
Rework D8 deck: architecture slide, per-wave checklist, refined questions
- Презентация: добавлен слайд архитектуры пилота (2/6), вопросы по
  волнам переведены из плоской таблицы в 3 карточки (Волна 1/2/3+),
  каждая по единому набору параметров — состав данных, витрины/
  коллекции, пользователи, роли; вопросы 6/7/12 из старой таблицы
  поглощены этим форматом. Обложка: убраны путь к xlsx и дата среза.
- Вопросы 8-11 (права доступа, кастомизация источников, персональные
  RAG-коллекции, упрощение регистрации) переформулированы по прямым
  уточнениям заказчика — синхронизировано в md/docx/xlsx/pptx.

Co-Authored-By: Claude Sonnet 5 <noreply@anthropic.com>
Claude-Session: https://claude.ai/code/session_01DpSN8JwCJ3tg3JVUadr2zE
</commit_message>
<xml_diff>
--- a/docs/presentations/case-27-proekt-d8-skoup-i-voprosy.pptx
+++ b/docs/presentations/case-27-proekt-d8-skoup-i-voprosy.pptx
@@ -10,9 +10,10 @@
     <p:sldId id="258" r:id="rId4"/>
     <p:sldId id="259" r:id="rId5"/>
     <p:sldId id="260" r:id="rId6"/>
+    <p:sldId id="261" r:id="rId7"/>
   </p:sldIdLst>
   <p:notesMasterIdLst>
-    <p:notesMasterId r:id="rId7"/>
+    <p:notesMasterId r:id="rId8"/>
   </p:notesMasterIdLst>
   <p:sldSz cx="12192000" cy="6858000"/>
   <p:notesSz cx="6858000" cy="12192000"/>
@@ -900,6 +901,94 @@
 </p:notes>
 </file>
 
+<file path=ppt/notesSlides/notesSlide6.xml><?xml version="1.0" encoding="utf-8"?>
+<p:notes xmlns:a="http://schemas.openxmlformats.org/drawingml/2006/main" xmlns:r="http://schemas.openxmlformats.org/officeDocument/2006/relationships" xmlns:p="http://schemas.openxmlformats.org/presentationml/2006/main">
+  <p:cSld>
+    <p:spTree>
+      <p:nvGrpSpPr>
+        <p:cNvPr id="1" name=""/>
+        <p:cNvGrpSpPr/>
+        <p:nvPr/>
+      </p:nvGrpSpPr>
+      <p:grpSpPr>
+        <a:xfrm>
+          <a:off x="0" y="0"/>
+          <a:ext cx="0" cy="0"/>
+          <a:chOff x="0" y="0"/>
+          <a:chExt cx="0" cy="0"/>
+        </a:xfrm>
+      </p:grpSpPr>
+      <p:sp>
+        <p:nvSpPr>
+          <p:cNvPr id="2" name="Slide Image Placeholder 1"/>
+          <p:cNvSpPr>
+            <a:spLocks noGrp="1" noRot="1" noChangeAspect="1"/>
+          </p:cNvSpPr>
+          <p:nvPr>
+            <p:ph type="sldImg"/>
+          </p:nvPr>
+        </p:nvSpPr>
+        <p:spPr/>
+      </p:sp>
+      <p:sp>
+        <p:nvSpPr>
+          <p:cNvPr id="3" name="Notes Placeholder 2"/>
+          <p:cNvSpPr>
+            <a:spLocks noGrp="1"/>
+          </p:cNvSpPr>
+          <p:nvPr>
+            <p:ph type="body" idx="1"/>
+          </p:nvPr>
+        </p:nvSpPr>
+        <p:spPr/>
+        <p:txBody>
+          <a:bodyPr/>
+          <a:lstStyle/>
+          <a:p>
+            <a:r>
+              <a:rPr lang="en-US" dirty="0"/>
+              <a:t/>
+            </a:r>
+            <a:endParaRPr lang="en-US" dirty="0"/>
+          </a:p>
+        </p:txBody>
+      </p:sp>
+      <p:sp>
+        <p:nvSpPr>
+          <p:cNvPr id="4" name="Slide Number Placeholder 3"/>
+          <p:cNvSpPr>
+            <a:spLocks noGrp="1"/>
+          </p:cNvSpPr>
+          <p:nvPr>
+            <p:ph type="sldNum" sz="quarter" idx="10"/>
+          </p:nvPr>
+        </p:nvSpPr>
+        <p:spPr/>
+        <p:txBody>
+          <a:bodyPr/>
+          <a:lstStyle/>
+          <a:p>
+            <a:fld id="{F7021451-1387-4CA6-816F-3879F97B5CBC}" type="slidenum">
+              <a:rPr lang="en-US"/>
+              <a:t>6</a:t>
+            </a:fld>
+            <a:endParaRPr lang="en-US"/>
+          </a:p>
+        </p:txBody>
+      </p:sp>
+    </p:spTree>
+    <p:extLst>
+      <p:ext uri="{BB962C8B-B14F-4D97-AF65-F5344CB8AC3E}">
+        <p14:creationId xmlns:p14="http://schemas.microsoft.com/office/powerpoint/2010/main" val="1024086991"/>
+      </p:ext>
+    </p:extLst>
+  </p:cSld>
+  <p:clrMapOvr>
+    <a:masterClrMapping/>
+  </p:clrMapOvr>
+</p:notes>
+</file>
+
 <file path=ppt/slideLayouts/slideLayout1.xml><?xml version="1.0" encoding="utf-8"?>
 <p:sldLayout xmlns:a="http://schemas.openxmlformats.org/drawingml/2006/main" xmlns:r="http://schemas.openxmlformats.org/officeDocument/2006/relationships" xmlns:p="http://schemas.openxmlformats.org/presentationml/2006/main" preserve="1">
   <p:cSld name="DEFAULT">
@@ -1371,7 +1460,7 @@
                 <a:ea typeface="Calibri" pitchFamily="34" charset="-122"/>
                 <a:cs typeface="Calibri" pitchFamily="34" charset="-120"/>
               </a:rPr>
-              <a:t>Программа проекта, реестр зафиксированных пожеланий заказчика и наши вопросы — рабочий срез на 13–14.09.2026.</a:t>
+              <a:t>Программа проекта, реестр зафиксированных пожеланий заказчика и наши вопросы.</a:t>
             </a:r>
             <a:endParaRPr lang="en-US" sz="1450" dirty="0"/>
           </a:p>
@@ -1653,7 +1742,7 @@
                 <a:ea typeface="Cambria" pitchFamily="34" charset="-122"/>
                 <a:cs typeface="Cambria" pitchFamily="34" charset="-120"/>
               </a:rPr>
-              <a:t>8</a:t>
+              <a:t>3</a:t>
             </a:r>
             <a:endParaRPr lang="en-US" sz="3400" dirty="0"/>
           </a:p>
@@ -1695,7 +1784,7 @@
                 <a:ea typeface="Calibri" pitchFamily="34" charset="-122"/>
                 <a:cs typeface="Calibri" pitchFamily="34" charset="-120"/>
               </a:rPr>
-              <a:t>вопросов по наполнению этапов</a:t>
+              <a:t>волны требуют детализации</a:t>
             </a:r>
             <a:endParaRPr lang="en-US" sz="1200" dirty="0"/>
           </a:p>
@@ -1817,45 +1906,6 @@
         </p:nvSpPr>
         <p:spPr>
           <a:xfrm>
-            <a:off x="502920" y="6263640"/>
-            <a:ext cx="7315200" cy="274320"/>
-          </a:xfrm>
-          <a:prstGeom prst="rect">
-            <a:avLst/>
-          </a:prstGeom>
-          <a:noFill/>
-          <a:ln/>
-        </p:spPr>
-        <p:txBody>
-          <a:bodyPr wrap="square" lIns="0" tIns="0" rIns="0" bIns="0" rtlCol="0" anchor="ctr"/>
-          <a:lstStyle/>
-          <a:p>
-            <a:pPr indent="0" marL="0">
-              <a:buNone/>
-            </a:pPr>
-            <a:r>
-              <a:rPr lang="en-US" sz="1100" dirty="0">
-                <a:solidFill>
-                  <a:srgbClr val="8C99A6"/>
-                </a:solidFill>
-                <a:latin typeface="Calibri" pitchFamily="34" charset="0"/>
-                <a:ea typeface="Calibri" pitchFamily="34" charset="-122"/>
-                <a:cs typeface="Calibri" pitchFamily="34" charset="-120"/>
-              </a:rPr>
-              <a:t>docs/analysis/case-27-proekt-d8-skoup-i-voprosy.xlsx</a:t>
-            </a:r>
-            <a:endParaRPr lang="en-US" sz="1100" dirty="0"/>
-          </a:p>
-        </p:txBody>
-      </p:sp>
-      <p:sp>
-        <p:nvSpPr>
-          <p:cNvPr id="18" name="Text 16"/>
-          <p:cNvSpPr txBox="1"/>
-          <p:nvPr/>
-        </p:nvSpPr>
-        <p:spPr>
-          <a:xfrm>
             <a:off x="10881360" y="6473952"/>
             <a:ext cx="822960" cy="274320"/>
           </a:xfrm>
@@ -1881,7 +1931,7 @@
                 <a:ea typeface="Calibri" pitchFamily="34" charset="-122"/>
                 <a:cs typeface="Calibri" pitchFamily="34" charset="-120"/>
               </a:rPr>
-              <a:t>1 / 5</a:t>
+              <a:t>1 / 6</a:t>
             </a:r>
             <a:endParaRPr lang="en-US" sz="1050" dirty="0"/>
           </a:p>
@@ -1945,7 +1995,212 @@
                 <a:ea typeface="Calibri" pitchFamily="34" charset="-122"/>
                 <a:cs typeface="Calibri" pitchFamily="34" charset="-120"/>
               </a:rPr>
-              <a:t>1 · ПРОГРАММА ПРОЕКТА</a:t>
+              <a:t>1 · АРХИТЕКТУРА ПИЛОТА</a:t>
+            </a:r>
+            <a:endParaRPr lang="en-US" sz="1100" dirty="0"/>
+          </a:p>
+        </p:txBody>
+      </p:sp>
+      <p:sp>
+        <p:nvSpPr>
+          <p:cNvPr id="3" name="Text 1"/>
+          <p:cNvSpPr txBox="1"/>
+          <p:nvPr/>
+        </p:nvSpPr>
+        <p:spPr>
+          <a:xfrm>
+            <a:off x="502920" y="621792"/>
+            <a:ext cx="11155680" cy="548640"/>
+          </a:xfrm>
+          <a:prstGeom prst="rect">
+            <a:avLst/>
+          </a:prstGeom>
+          <a:noFill/>
+          <a:ln/>
+        </p:spPr>
+        <p:txBody>
+          <a:bodyPr wrap="square" lIns="0" tIns="0" rIns="0" bIns="0" rtlCol="0" anchor="ctr"/>
+          <a:lstStyle/>
+          <a:p>
+            <a:pPr indent="0" marL="0">
+              <a:buNone/>
+            </a:pPr>
+            <a:r>
+              <a:rPr lang="en-US" sz="2700" b="1" dirty="0">
+                <a:solidFill>
+                  <a:srgbClr val="1A2733"/>
+                </a:solidFill>
+                <a:latin typeface="Cambria" pitchFamily="34" charset="0"/>
+                <a:ea typeface="Cambria" pitchFamily="34" charset="-122"/>
+                <a:cs typeface="Cambria" pitchFamily="34" charset="-120"/>
+              </a:rPr>
+              <a:t>Источники и получатели данных</a:t>
+            </a:r>
+            <a:endParaRPr lang="en-US" sz="2700" dirty="0"/>
+          </a:p>
+        </p:txBody>
+      </p:sp>
+      <p:sp>
+        <p:nvSpPr>
+          <p:cNvPr id="4" name="Text 2"/>
+          <p:cNvSpPr txBox="1"/>
+          <p:nvPr/>
+        </p:nvSpPr>
+        <p:spPr>
+          <a:xfrm>
+            <a:off x="502920" y="1170432"/>
+            <a:ext cx="11155680" cy="365760"/>
+          </a:xfrm>
+          <a:prstGeom prst="rect">
+            <a:avLst/>
+          </a:prstGeom>
+          <a:noFill/>
+          <a:ln/>
+        </p:spPr>
+        <p:txBody>
+          <a:bodyPr wrap="square" lIns="0" tIns="0" rIns="0" bIns="0" rtlCol="0" anchor="ctr"/>
+          <a:lstStyle/>
+          <a:p>
+            <a:pPr indent="0" marL="0">
+              <a:buNone/>
+            </a:pPr>
+            <a:r>
+              <a:rPr lang="en-US" sz="1300" dirty="0">
+                <a:solidFill>
+                  <a:srgbClr val="5B6B7A"/>
+                </a:solidFill>
+                <a:latin typeface="Calibri" pitchFamily="34" charset="0"/>
+                <a:ea typeface="Calibri" pitchFamily="34" charset="-122"/>
+                <a:cs typeface="Calibri" pitchFamily="34" charset="-120"/>
+              </a:rPr>
+              <a:t>Платформа «Камерата» по фактам пилота (не проектный скоуп) — расширение на следующих слайдах</a:t>
+            </a:r>
+            <a:endParaRPr lang="en-US" sz="1300" dirty="0"/>
+          </a:p>
+        </p:txBody>
+      </p:sp>
+      <p:pic>
+        <p:nvPicPr>
+          <p:cNvPr id="5" name="Image 0" descr="arhitektura-pilota.png">    </p:cNvPr>
+          <p:cNvPicPr>
+            <a:picLocks noChangeAspect="1"/>
+          </p:cNvPicPr>
+          <p:nvPr/>
+        </p:nvPicPr>
+        <p:blipFill>
+          <a:blip r:embed="rId1"/>
+          <a:stretch>
+            <a:fillRect/>
+          </a:stretch>
+        </p:blipFill>
+        <p:spPr>
+          <a:xfrm>
+            <a:off x="2148840" y="1783080"/>
+            <a:ext cx="7863840" cy="4456176"/>
+          </a:xfrm>
+          <a:prstGeom prst="rect">
+            <a:avLst/>
+          </a:prstGeom>
+        </p:spPr>
+      </p:pic>
+      <p:sp>
+        <p:nvSpPr>
+          <p:cNvPr id="6" name="Text 3"/>
+          <p:cNvSpPr txBox="1"/>
+          <p:nvPr/>
+        </p:nvSpPr>
+        <p:spPr>
+          <a:xfrm>
+            <a:off x="10881360" y="6473952"/>
+            <a:ext cx="822960" cy="274320"/>
+          </a:xfrm>
+          <a:prstGeom prst="rect">
+            <a:avLst/>
+          </a:prstGeom>
+          <a:noFill/>
+          <a:ln/>
+        </p:spPr>
+        <p:txBody>
+          <a:bodyPr wrap="square" lIns="0" tIns="0" rIns="0" bIns="0" rtlCol="0" anchor="ctr"/>
+          <a:lstStyle/>
+          <a:p>
+            <a:pPr algn="r" indent="0" marL="0">
+              <a:buNone/>
+            </a:pPr>
+            <a:r>
+              <a:rPr lang="en-US" sz="1050" dirty="0">
+                <a:solidFill>
+                  <a:srgbClr val="8C99A6"/>
+                </a:solidFill>
+                <a:latin typeface="Calibri" pitchFamily="34" charset="0"/>
+                <a:ea typeface="Calibri" pitchFamily="34" charset="-122"/>
+                <a:cs typeface="Calibri" pitchFamily="34" charset="-120"/>
+              </a:rPr>
+              <a:t>2 / 6</a:t>
+            </a:r>
+            <a:endParaRPr lang="en-US" sz="1050" dirty="0"/>
+          </a:p>
+        </p:txBody>
+      </p:sp>
+    </p:spTree>
+  </p:cSld>
+  <p:clrMapOvr>
+    <a:masterClrMapping/>
+  </p:clrMapOvr>
+</p:sld>
+</file>
+
+<file path=ppt/slides/slide3.xml><?xml version="1.0" encoding="utf-8"?>
+<p:sld xmlns:a="http://schemas.openxmlformats.org/drawingml/2006/main" xmlns:r="http://schemas.openxmlformats.org/officeDocument/2006/relationships" xmlns:p="http://schemas.openxmlformats.org/presentationml/2006/main">
+  <p:cSld name="Slide 3">
+    <p:spTree>
+      <p:nvGrpSpPr>
+        <p:cNvPr id="1" name=""/>
+        <p:cNvGrpSpPr/>
+        <p:nvPr/>
+      </p:nvGrpSpPr>
+      <p:grpSpPr>
+        <a:xfrm>
+          <a:off x="0" y="0"/>
+          <a:ext cx="0" cy="0"/>
+          <a:chOff x="0" y="0"/>
+          <a:chExt cx="0" cy="0"/>
+        </a:xfrm>
+      </p:grpSpPr>
+      <p:sp>
+        <p:nvSpPr>
+          <p:cNvPr id="2" name="Text 0"/>
+          <p:cNvSpPr txBox="1"/>
+          <p:nvPr/>
+        </p:nvSpPr>
+        <p:spPr>
+          <a:xfrm>
+            <a:off x="502920" y="320040"/>
+            <a:ext cx="11155680" cy="274320"/>
+          </a:xfrm>
+          <a:prstGeom prst="rect">
+            <a:avLst/>
+          </a:prstGeom>
+          <a:noFill/>
+          <a:ln/>
+        </p:spPr>
+        <p:txBody>
+          <a:bodyPr wrap="square" lIns="0" tIns="0" rIns="0" bIns="0" rtlCol="0" anchor="ctr"/>
+          <a:lstStyle/>
+          <a:p>
+            <a:pPr indent="0" marL="0">
+              <a:buNone/>
+            </a:pPr>
+            <a:r>
+              <a:rPr lang="en-US" sz="1100" b="1" spc="120" kern="0" dirty="0">
+                <a:solidFill>
+                  <a:srgbClr val="0E7C86"/>
+                </a:solidFill>
+                <a:latin typeface="Calibri" pitchFamily="34" charset="0"/>
+                <a:ea typeface="Calibri" pitchFamily="34" charset="-122"/>
+                <a:cs typeface="Calibri" pitchFamily="34" charset="-120"/>
+              </a:rPr>
+              <a:t>2 · ПРОГРАММА ПРОЕКТА</a:t>
             </a:r>
             <a:endParaRPr lang="en-US" sz="1100" dirty="0"/>
           </a:p>
@@ -2031,7 +2286,7 @@
       </p:sp>
       <p:graphicFrame>
         <p:nvGraphicFramePr>
-          <p:cNvPr id="3" name="Table 0"/>
+          <p:cNvPr id="4" name="Table 0"/>
           <p:cNvGraphicFramePr>
             <a:graphicFrameLocks noGrp="1"/>
           </p:cNvGraphicFramePr>
@@ -3940,7 +4195,7 @@
                 <a:ea typeface="Calibri" pitchFamily="34" charset="-122"/>
                 <a:cs typeface="Calibri" pitchFamily="34" charset="-120"/>
               </a:rPr>
-              <a:t>Волна 2 требует отдельного детального состава работ (см. вопрос №2 к заказчику) — срок 4–6 недель ориентировочен на весь объём расширения ESB/КХД.</a:t>
+              <a:t>Волна 2 требует отдельного детального состава работ (см. «Наши вопросы» → Волна 2) — срок 4–6 недель ориентировочен на весь объём расширения ESB/КХД.</a:t>
             </a:r>
             <a:endParaRPr lang="en-US" sz="1150" dirty="0"/>
           </a:p>
@@ -3979,7 +4234,7 @@
                 <a:ea typeface="Calibri" pitchFamily="34" charset="-122"/>
                 <a:cs typeface="Calibri" pitchFamily="34" charset="-120"/>
               </a:rPr>
-              <a:t>2 / 5</a:t>
+              <a:t>3 / 6</a:t>
             </a:r>
             <a:endParaRPr lang="en-US" sz="1050" dirty="0"/>
           </a:p>
@@ -3993,9 +4248,9 @@
 </p:sld>
 </file>
 
-<file path=ppt/slides/slide3.xml><?xml version="1.0" encoding="utf-8"?>
+<file path=ppt/slides/slide4.xml><?xml version="1.0" encoding="utf-8"?>
 <p:sld xmlns:a="http://schemas.openxmlformats.org/drawingml/2006/main" xmlns:r="http://schemas.openxmlformats.org/officeDocument/2006/relationships" xmlns:p="http://schemas.openxmlformats.org/presentationml/2006/main">
-  <p:cSld name="Slide 3">
+  <p:cSld name="Slide 4">
     <p:spTree>
       <p:nvGrpSpPr>
         <p:cNvPr id="1" name=""/>
@@ -4043,7 +4298,7 @@
                 <a:ea typeface="Calibri" pitchFamily="34" charset="-122"/>
                 <a:cs typeface="Calibri" pitchFamily="34" charset="-120"/>
               </a:rPr>
-              <a:t>2 · ЗАФИКСИРОВАННЫЕ ПОЖЕЛАНИЯ ЗАКАЗЧИКА</a:t>
+              <a:t>3 · ЗАФИКСИРОВАННЫЕ ПОЖЕЛАНИЯ ЗАКАЗЧИКА</a:t>
             </a:r>
             <a:endParaRPr lang="en-US" sz="1100" dirty="0"/>
           </a:p>
@@ -4129,7 +4384,7 @@
       </p:sp>
       <p:graphicFrame>
         <p:nvGraphicFramePr>
-          <p:cNvPr id="4" name="Table 0"/>
+          <p:cNvPr id="5" name="Table 0"/>
           <p:cNvGraphicFramePr>
             <a:graphicFrameLocks noGrp="1"/>
           </p:cNvGraphicFramePr>
@@ -7282,2590 +7537,7 @@
                 <a:ea typeface="Calibri" pitchFamily="34" charset="-122"/>
                 <a:cs typeface="Calibri" pitchFamily="34" charset="-120"/>
               </a:rPr>
-              <a:t>3 / 5</a:t>
-            </a:r>
-            <a:endParaRPr lang="en-US" sz="1050" dirty="0"/>
-          </a:p>
-        </p:txBody>
-      </p:sp>
-    </p:spTree>
-  </p:cSld>
-  <p:clrMapOvr>
-    <a:masterClrMapping/>
-  </p:clrMapOvr>
-</p:sld>
-</file>
-
-<file path=ppt/slides/slide4.xml><?xml version="1.0" encoding="utf-8"?>
-<p:sld xmlns:a="http://schemas.openxmlformats.org/drawingml/2006/main" xmlns:r="http://schemas.openxmlformats.org/officeDocument/2006/relationships" xmlns:p="http://schemas.openxmlformats.org/presentationml/2006/main">
-  <p:cSld name="Slide 4">
-    <p:spTree>
-      <p:nvGrpSpPr>
-        <p:cNvPr id="1" name=""/>
-        <p:cNvGrpSpPr/>
-        <p:nvPr/>
-      </p:nvGrpSpPr>
-      <p:grpSpPr>
-        <a:xfrm>
-          <a:off x="0" y="0"/>
-          <a:ext cx="0" cy="0"/>
-          <a:chOff x="0" y="0"/>
-          <a:chExt cx="0" cy="0"/>
-        </a:xfrm>
-      </p:grpSpPr>
-      <p:sp>
-        <p:nvSpPr>
-          <p:cNvPr id="2" name="Text 0"/>
-          <p:cNvSpPr txBox="1"/>
-          <p:nvPr/>
-        </p:nvSpPr>
-        <p:spPr>
-          <a:xfrm>
-            <a:off x="502920" y="320040"/>
-            <a:ext cx="11155680" cy="274320"/>
-          </a:xfrm>
-          <a:prstGeom prst="rect">
-            <a:avLst/>
-          </a:prstGeom>
-          <a:noFill/>
-          <a:ln/>
-        </p:spPr>
-        <p:txBody>
-          <a:bodyPr wrap="square" lIns="0" tIns="0" rIns="0" bIns="0" rtlCol="0" anchor="ctr"/>
-          <a:lstStyle/>
-          <a:p>
-            <a:pPr indent="0" marL="0">
-              <a:buNone/>
-            </a:pPr>
-            <a:r>
-              <a:rPr lang="en-US" sz="1100" b="1" spc="120" kern="0" dirty="0">
-                <a:solidFill>
-                  <a:srgbClr val="0E7C86"/>
-                </a:solidFill>
-                <a:latin typeface="Calibri" pitchFamily="34" charset="0"/>
-                <a:ea typeface="Calibri" pitchFamily="34" charset="-122"/>
-                <a:cs typeface="Calibri" pitchFamily="34" charset="-120"/>
-              </a:rPr>
-              <a:t>3 · НАШИ ВОПРОСЫ · ПО НАПОЛНЕНИЮ ЭТАПОВ</a:t>
-            </a:r>
-            <a:endParaRPr lang="en-US" sz="1100" dirty="0"/>
-          </a:p>
-        </p:txBody>
-      </p:sp>
-      <p:sp>
-        <p:nvSpPr>
-          <p:cNvPr id="3" name="Text 1"/>
-          <p:cNvSpPr txBox="1"/>
-          <p:nvPr/>
-        </p:nvSpPr>
-        <p:spPr>
-          <a:xfrm>
-            <a:off x="502920" y="621792"/>
-            <a:ext cx="11155680" cy="548640"/>
-          </a:xfrm>
-          <a:prstGeom prst="rect">
-            <a:avLst/>
-          </a:prstGeom>
-          <a:noFill/>
-          <a:ln/>
-        </p:spPr>
-        <p:txBody>
-          <a:bodyPr wrap="square" lIns="0" tIns="0" rIns="0" bIns="0" rtlCol="0" anchor="ctr"/>
-          <a:lstStyle/>
-          <a:p>
-            <a:pPr indent="0" marL="0">
-              <a:buNone/>
-            </a:pPr>
-            <a:r>
-              <a:rPr lang="en-US" sz="2700" b="1" dirty="0">
-                <a:solidFill>
-                  <a:srgbClr val="1A2733"/>
-                </a:solidFill>
-                <a:latin typeface="Cambria" pitchFamily="34" charset="0"/>
-                <a:ea typeface="Cambria" pitchFamily="34" charset="-122"/>
-                <a:cs typeface="Cambria" pitchFamily="34" charset="-120"/>
-              </a:rPr>
-              <a:t>Вопросы к содержанию волн и этапов</a:t>
-            </a:r>
-            <a:endParaRPr lang="en-US" sz="2700" dirty="0"/>
-          </a:p>
-        </p:txBody>
-      </p:sp>
-      <p:sp>
-        <p:nvSpPr>
-          <p:cNvPr id="4" name="Text 2"/>
-          <p:cNvSpPr txBox="1"/>
-          <p:nvPr/>
-        </p:nvSpPr>
-        <p:spPr>
-          <a:xfrm>
-            <a:off x="502920" y="1170432"/>
-            <a:ext cx="11155680" cy="365760"/>
-          </a:xfrm>
-          <a:prstGeom prst="rect">
-            <a:avLst/>
-          </a:prstGeom>
-          <a:noFill/>
-          <a:ln/>
-        </p:spPr>
-        <p:txBody>
-          <a:bodyPr wrap="square" lIns="0" tIns="0" rIns="0" bIns="0" rtlCol="0" anchor="ctr"/>
-          <a:lstStyle/>
-          <a:p>
-            <a:pPr indent="0" marL="0">
-              <a:buNone/>
-            </a:pPr>
-            <a:r>
-              <a:rPr lang="en-US" sz="1300" dirty="0">
-                <a:solidFill>
-                  <a:srgbClr val="5B6B7A"/>
-                </a:solidFill>
-                <a:latin typeface="Calibri" pitchFamily="34" charset="0"/>
-                <a:ea typeface="Calibri" pitchFamily="34" charset="-122"/>
-                <a:cs typeface="Calibri" pitchFamily="34" charset="-120"/>
-              </a:rPr>
-              <a:t>Без ответов заказчика состав работ волны 2 и старт волны 3+ не оценить</a:t>
-            </a:r>
-            <a:endParaRPr lang="en-US" sz="1300" dirty="0"/>
-          </a:p>
-        </p:txBody>
-      </p:sp>
-      <p:graphicFrame>
-        <p:nvGraphicFramePr>
-          <p:cNvPr id="5" name="Table 0"/>
-          <p:cNvGraphicFramePr>
-            <a:graphicFrameLocks noGrp="1"/>
-          </p:cNvGraphicFramePr>
-          <p:nvPr>
-            <p:extLst>
-              <p:ext uri="{D42A27DB-BD31-4B8C-83A1-F6EECF244321}">
-                <p14:modId xmlns:p14="http://schemas.microsoft.com/office/powerpoint/2010/main" val="1579011935"/>
-              </p:ext>
-            </p:extLst>
-          </p:nvPr>
-        </p:nvGraphicFramePr>
-        <p:xfrm>
-          <a:off x="502920" y="1691640"/>
-          <a:ext cx="11155680" cy="4480560"/>
-        </p:xfrm>
-        <a:graphic>
-          <a:graphicData uri="http://schemas.openxmlformats.org/drawingml/2006/table">
-            <a:tbl>
-              <a:tblPr/>
-              <a:tblGrid>
-                <a:gridCol w="548640"/>
-                <a:gridCol w="1828800"/>
-                <a:gridCol w="1280160"/>
-                <a:gridCol w="7498080"/>
-              </a:tblGrid>
-              <a:tr h="497840">
-                <a:tc>
-                  <a:txBody>
-                    <a:bodyPr/>
-                    <a:lstStyle/>
-                    <a:p>
-                      <a:pPr algn="ctr" indent="0" marL="0">
-                        <a:buNone/>
-                      </a:pPr>
-                      <a:r>
-                        <a:rPr lang="en-US" sz="1100" b="1" dirty="0">
-                          <a:solidFill>
-                            <a:srgbClr val="FFFFFF"/>
-                          </a:solidFill>
-                          <a:latin typeface="Calibri" pitchFamily="34" charset="0"/>
-                          <a:ea typeface="Calibri" pitchFamily="34" charset="-122"/>
-                          <a:cs typeface="Calibri" pitchFamily="34" charset="-120"/>
-                        </a:rPr>
-                        <a:t>№</a:t>
-                      </a:r>
-                      <a:endParaRPr lang="en-US" sz="1100" dirty="0">
-                        <a:latin typeface="Calibri" charset="0"/>
-                        <a:ea typeface="Calibri" charset="0"/>
-                        <a:cs typeface="Calibri" charset="0"/>
-                      </a:endParaRPr>
-                    </a:p>
-                  </a:txBody>
-                  <a:tcPr marL="101600" marR="101600" marT="63500" marB="63500" anchor="ctr">
-                    <a:lnL w="9525" cap="flat" cmpd="sng" algn="ctr">
-                      <a:solidFill>
-                        <a:srgbClr val="D8DEE2"/>
-                      </a:solidFill>
-                      <a:prstDash val="solid"/>
-                      <a:round/>
-                      <a:headEnd type="none" w="med" len="med"/>
-                      <a:tailEnd type="none" w="med" len="med"/>
-                    </a:lnL>
-                    <a:lnR w="9525" cap="flat" cmpd="sng" algn="ctr">
-                      <a:solidFill>
-                        <a:srgbClr val="D8DEE2"/>
-                      </a:solidFill>
-                      <a:prstDash val="solid"/>
-                      <a:round/>
-                      <a:headEnd type="none" w="med" len="med"/>
-                      <a:tailEnd type="none" w="med" len="med"/>
-                    </a:lnR>
-                    <a:lnT w="9525" cap="flat" cmpd="sng" algn="ctr">
-                      <a:solidFill>
-                        <a:srgbClr val="D8DEE2"/>
-                      </a:solidFill>
-                      <a:prstDash val="solid"/>
-                      <a:round/>
-                      <a:headEnd type="none" w="med" len="med"/>
-                      <a:tailEnd type="none" w="med" len="med"/>
-                    </a:lnT>
-                    <a:lnB w="9525" cap="flat" cmpd="sng" algn="ctr">
-                      <a:solidFill>
-                        <a:srgbClr val="D8DEE2"/>
-                      </a:solidFill>
-                      <a:prstDash val="solid"/>
-                      <a:round/>
-                      <a:headEnd type="none" w="med" len="med"/>
-                      <a:tailEnd type="none" w="med" len="med"/>
-                    </a:lnB>
-                    <a:solidFill>
-                      <a:srgbClr val="1A2733"/>
-                    </a:solidFill>
-                  </a:tcPr>
-                </a:tc>
-                <a:tc>
-                  <a:txBody>
-                    <a:bodyPr/>
-                    <a:lstStyle/>
-                    <a:p>
-                      <a:pPr indent="0" marL="0">
-                        <a:buNone/>
-                      </a:pPr>
-                      <a:r>
-                        <a:rPr lang="en-US" sz="1100" b="1" dirty="0">
-                          <a:solidFill>
-                            <a:srgbClr val="FFFFFF"/>
-                          </a:solidFill>
-                          <a:latin typeface="Calibri" pitchFamily="34" charset="0"/>
-                          <a:ea typeface="Calibri" pitchFamily="34" charset="-122"/>
-                          <a:cs typeface="Calibri" pitchFamily="34" charset="-120"/>
-                        </a:rPr>
-                        <a:t>Категория</a:t>
-                      </a:r>
-                      <a:endParaRPr lang="en-US" sz="1100" dirty="0">
-                        <a:latin typeface="Calibri" charset="0"/>
-                        <a:ea typeface="Calibri" charset="0"/>
-                        <a:cs typeface="Calibri" charset="0"/>
-                      </a:endParaRPr>
-                    </a:p>
-                  </a:txBody>
-                  <a:tcPr marL="101600" marR="101600" marT="63500" marB="63500" anchor="ctr">
-                    <a:lnL w="9525" cap="flat" cmpd="sng" algn="ctr">
-                      <a:solidFill>
-                        <a:srgbClr val="D8DEE2"/>
-                      </a:solidFill>
-                      <a:prstDash val="solid"/>
-                      <a:round/>
-                      <a:headEnd type="none" w="med" len="med"/>
-                      <a:tailEnd type="none" w="med" len="med"/>
-                    </a:lnL>
-                    <a:lnR w="9525" cap="flat" cmpd="sng" algn="ctr">
-                      <a:solidFill>
-                        <a:srgbClr val="D8DEE2"/>
-                      </a:solidFill>
-                      <a:prstDash val="solid"/>
-                      <a:round/>
-                      <a:headEnd type="none" w="med" len="med"/>
-                      <a:tailEnd type="none" w="med" len="med"/>
-                    </a:lnR>
-                    <a:lnT w="9525" cap="flat" cmpd="sng" algn="ctr">
-                      <a:solidFill>
-                        <a:srgbClr val="D8DEE2"/>
-                      </a:solidFill>
-                      <a:prstDash val="solid"/>
-                      <a:round/>
-                      <a:headEnd type="none" w="med" len="med"/>
-                      <a:tailEnd type="none" w="med" len="med"/>
-                    </a:lnT>
-                    <a:lnB w="9525" cap="flat" cmpd="sng" algn="ctr">
-                      <a:solidFill>
-                        <a:srgbClr val="D8DEE2"/>
-                      </a:solidFill>
-                      <a:prstDash val="solid"/>
-                      <a:round/>
-                      <a:headEnd type="none" w="med" len="med"/>
-                      <a:tailEnd type="none" w="med" len="med"/>
-                    </a:lnB>
-                    <a:solidFill>
-                      <a:srgbClr val="1A2733"/>
-                    </a:solidFill>
-                  </a:tcPr>
-                </a:tc>
-                <a:tc>
-                  <a:txBody>
-                    <a:bodyPr/>
-                    <a:lstStyle/>
-                    <a:p>
-                      <a:pPr algn="ctr" indent="0" marL="0">
-                        <a:buNone/>
-                      </a:pPr>
-                      <a:r>
-                        <a:rPr lang="en-US" sz="1100" b="1" dirty="0">
-                          <a:solidFill>
-                            <a:srgbClr val="FFFFFF"/>
-                          </a:solidFill>
-                          <a:latin typeface="Calibri" pitchFamily="34" charset="0"/>
-                          <a:ea typeface="Calibri" pitchFamily="34" charset="-122"/>
-                          <a:cs typeface="Calibri" pitchFamily="34" charset="-120"/>
-                        </a:rPr>
-                        <a:t>Приоритет</a:t>
-                      </a:r>
-                      <a:endParaRPr lang="en-US" sz="1100" dirty="0">
-                        <a:latin typeface="Calibri" charset="0"/>
-                        <a:ea typeface="Calibri" charset="0"/>
-                        <a:cs typeface="Calibri" charset="0"/>
-                      </a:endParaRPr>
-                    </a:p>
-                  </a:txBody>
-                  <a:tcPr marL="101600" marR="101600" marT="63500" marB="63500" anchor="ctr">
-                    <a:lnL w="9525" cap="flat" cmpd="sng" algn="ctr">
-                      <a:solidFill>
-                        <a:srgbClr val="D8DEE2"/>
-                      </a:solidFill>
-                      <a:prstDash val="solid"/>
-                      <a:round/>
-                      <a:headEnd type="none" w="med" len="med"/>
-                      <a:tailEnd type="none" w="med" len="med"/>
-                    </a:lnL>
-                    <a:lnR w="9525" cap="flat" cmpd="sng" algn="ctr">
-                      <a:solidFill>
-                        <a:srgbClr val="D8DEE2"/>
-                      </a:solidFill>
-                      <a:prstDash val="solid"/>
-                      <a:round/>
-                      <a:headEnd type="none" w="med" len="med"/>
-                      <a:tailEnd type="none" w="med" len="med"/>
-                    </a:lnR>
-                    <a:lnT w="9525" cap="flat" cmpd="sng" algn="ctr">
-                      <a:solidFill>
-                        <a:srgbClr val="D8DEE2"/>
-                      </a:solidFill>
-                      <a:prstDash val="solid"/>
-                      <a:round/>
-                      <a:headEnd type="none" w="med" len="med"/>
-                      <a:tailEnd type="none" w="med" len="med"/>
-                    </a:lnT>
-                    <a:lnB w="9525" cap="flat" cmpd="sng" algn="ctr">
-                      <a:solidFill>
-                        <a:srgbClr val="D8DEE2"/>
-                      </a:solidFill>
-                      <a:prstDash val="solid"/>
-                      <a:round/>
-                      <a:headEnd type="none" w="med" len="med"/>
-                      <a:tailEnd type="none" w="med" len="med"/>
-                    </a:lnB>
-                    <a:solidFill>
-                      <a:srgbClr val="1A2733"/>
-                    </a:solidFill>
-                  </a:tcPr>
-                </a:tc>
-                <a:tc>
-                  <a:txBody>
-                    <a:bodyPr/>
-                    <a:lstStyle/>
-                    <a:p>
-                      <a:pPr indent="0" marL="0">
-                        <a:buNone/>
-                      </a:pPr>
-                      <a:r>
-                        <a:rPr lang="en-US" sz="1100" b="1" dirty="0">
-                          <a:solidFill>
-                            <a:srgbClr val="FFFFFF"/>
-                          </a:solidFill>
-                          <a:latin typeface="Calibri" pitchFamily="34" charset="0"/>
-                          <a:ea typeface="Calibri" pitchFamily="34" charset="-122"/>
-                          <a:cs typeface="Calibri" pitchFamily="34" charset="-120"/>
-                        </a:rPr>
-                        <a:t>Вопрос</a:t>
-                      </a:r>
-                      <a:endParaRPr lang="en-US" sz="1100" dirty="0">
-                        <a:latin typeface="Calibri" charset="0"/>
-                        <a:ea typeface="Calibri" charset="0"/>
-                        <a:cs typeface="Calibri" charset="0"/>
-                      </a:endParaRPr>
-                    </a:p>
-                  </a:txBody>
-                  <a:tcPr marL="101600" marR="101600" marT="63500" marB="63500" anchor="ctr">
-                    <a:lnL w="9525" cap="flat" cmpd="sng" algn="ctr">
-                      <a:solidFill>
-                        <a:srgbClr val="D8DEE2"/>
-                      </a:solidFill>
-                      <a:prstDash val="solid"/>
-                      <a:round/>
-                      <a:headEnd type="none" w="med" len="med"/>
-                      <a:tailEnd type="none" w="med" len="med"/>
-                    </a:lnL>
-                    <a:lnR w="9525" cap="flat" cmpd="sng" algn="ctr">
-                      <a:solidFill>
-                        <a:srgbClr val="D8DEE2"/>
-                      </a:solidFill>
-                      <a:prstDash val="solid"/>
-                      <a:round/>
-                      <a:headEnd type="none" w="med" len="med"/>
-                      <a:tailEnd type="none" w="med" len="med"/>
-                    </a:lnR>
-                    <a:lnT w="9525" cap="flat" cmpd="sng" algn="ctr">
-                      <a:solidFill>
-                        <a:srgbClr val="D8DEE2"/>
-                      </a:solidFill>
-                      <a:prstDash val="solid"/>
-                      <a:round/>
-                      <a:headEnd type="none" w="med" len="med"/>
-                      <a:tailEnd type="none" w="med" len="med"/>
-                    </a:lnT>
-                    <a:lnB w="9525" cap="flat" cmpd="sng" algn="ctr">
-                      <a:solidFill>
-                        <a:srgbClr val="D8DEE2"/>
-                      </a:solidFill>
-                      <a:prstDash val="solid"/>
-                      <a:round/>
-                      <a:headEnd type="none" w="med" len="med"/>
-                      <a:tailEnd type="none" w="med" len="med"/>
-                    </a:lnB>
-                    <a:solidFill>
-                      <a:srgbClr val="1A2733"/>
-                    </a:solidFill>
-                  </a:tcPr>
-                </a:tc>
-              </a:tr>
-              <a:tr h="497840">
-                <a:tc>
-                  <a:txBody>
-                    <a:bodyPr/>
-                    <a:lstStyle/>
-                    <a:p>
-                      <a:pPr algn="ctr" indent="0" marL="0">
-                        <a:buNone/>
-                      </a:pPr>
-                      <a:r>
-                        <a:rPr lang="en-US" sz="1100" dirty="0">
-                          <a:solidFill>
-                            <a:srgbClr val="5B6B7A"/>
-                          </a:solidFill>
-                          <a:latin typeface="Calibri" pitchFamily="34" charset="0"/>
-                          <a:ea typeface="Calibri" pitchFamily="34" charset="-122"/>
-                          <a:cs typeface="Calibri" pitchFamily="34" charset="-120"/>
-                        </a:rPr>
-                        <a:t>1</a:t>
-                      </a:r>
-                      <a:endParaRPr lang="en-US" sz="1100" dirty="0">
-                        <a:latin typeface="Calibri" charset="0"/>
-                        <a:ea typeface="Calibri" charset="0"/>
-                        <a:cs typeface="Calibri" charset="0"/>
-                      </a:endParaRPr>
-                    </a:p>
-                  </a:txBody>
-                  <a:tcPr marL="101600" marR="101600" marT="63500" marB="63500" anchor="ctr">
-                    <a:lnL w="9525" cap="flat" cmpd="sng" algn="ctr">
-                      <a:solidFill>
-                        <a:srgbClr val="D8DEE2"/>
-                      </a:solidFill>
-                      <a:prstDash val="solid"/>
-                      <a:round/>
-                      <a:headEnd type="none" w="med" len="med"/>
-                      <a:tailEnd type="none" w="med" len="med"/>
-                    </a:lnL>
-                    <a:lnR w="9525" cap="flat" cmpd="sng" algn="ctr">
-                      <a:solidFill>
-                        <a:srgbClr val="D8DEE2"/>
-                      </a:solidFill>
-                      <a:prstDash val="solid"/>
-                      <a:round/>
-                      <a:headEnd type="none" w="med" len="med"/>
-                      <a:tailEnd type="none" w="med" len="med"/>
-                    </a:lnR>
-                    <a:lnT w="9525" cap="flat" cmpd="sng" algn="ctr">
-                      <a:solidFill>
-                        <a:srgbClr val="D8DEE2"/>
-                      </a:solidFill>
-                      <a:prstDash val="solid"/>
-                      <a:round/>
-                      <a:headEnd type="none" w="med" len="med"/>
-                      <a:tailEnd type="none" w="med" len="med"/>
-                    </a:lnT>
-                    <a:lnB w="9525" cap="flat" cmpd="sng" algn="ctr">
-                      <a:solidFill>
-                        <a:srgbClr val="D8DEE2"/>
-                      </a:solidFill>
-                      <a:prstDash val="solid"/>
-                      <a:round/>
-                      <a:headEnd type="none" w="med" len="med"/>
-                      <a:tailEnd type="none" w="med" len="med"/>
-                    </a:lnB>
-                  </a:tcPr>
-                </a:tc>
-                <a:tc>
-                  <a:txBody>
-                    <a:bodyPr/>
-                    <a:lstStyle/>
-                    <a:p>
-                      <a:pPr indent="0" marL="0">
-                        <a:buNone/>
-                      </a:pPr>
-                      <a:r>
-                        <a:rPr lang="en-US" sz="1100" b="1" dirty="0">
-                          <a:solidFill>
-                            <a:srgbClr val="1A2733"/>
-                          </a:solidFill>
-                          <a:latin typeface="Calibri" pitchFamily="34" charset="0"/>
-                          <a:ea typeface="Calibri" pitchFamily="34" charset="-122"/>
-                          <a:cs typeface="Calibri" pitchFamily="34" charset="-120"/>
-                        </a:rPr>
-                        <a:t>Волны</a:t>
-                      </a:r>
-                      <a:endParaRPr lang="en-US" sz="1100" dirty="0">
-                        <a:latin typeface="Calibri" charset="0"/>
-                        <a:ea typeface="Calibri" charset="0"/>
-                        <a:cs typeface="Calibri" charset="0"/>
-                      </a:endParaRPr>
-                    </a:p>
-                  </a:txBody>
-                  <a:tcPr marL="101600" marR="101600" marT="63500" marB="63500" anchor="ctr">
-                    <a:lnL w="9525" cap="flat" cmpd="sng" algn="ctr">
-                      <a:solidFill>
-                        <a:srgbClr val="D8DEE2"/>
-                      </a:solidFill>
-                      <a:prstDash val="solid"/>
-                      <a:round/>
-                      <a:headEnd type="none" w="med" len="med"/>
-                      <a:tailEnd type="none" w="med" len="med"/>
-                    </a:lnL>
-                    <a:lnR w="9525" cap="flat" cmpd="sng" algn="ctr">
-                      <a:solidFill>
-                        <a:srgbClr val="D8DEE2"/>
-                      </a:solidFill>
-                      <a:prstDash val="solid"/>
-                      <a:round/>
-                      <a:headEnd type="none" w="med" len="med"/>
-                      <a:tailEnd type="none" w="med" len="med"/>
-                    </a:lnR>
-                    <a:lnT w="9525" cap="flat" cmpd="sng" algn="ctr">
-                      <a:solidFill>
-                        <a:srgbClr val="D8DEE2"/>
-                      </a:solidFill>
-                      <a:prstDash val="solid"/>
-                      <a:round/>
-                      <a:headEnd type="none" w="med" len="med"/>
-                      <a:tailEnd type="none" w="med" len="med"/>
-                    </a:lnT>
-                    <a:lnB w="9525" cap="flat" cmpd="sng" algn="ctr">
-                      <a:solidFill>
-                        <a:srgbClr val="D8DEE2"/>
-                      </a:solidFill>
-                      <a:prstDash val="solid"/>
-                      <a:round/>
-                      <a:headEnd type="none" w="med" len="med"/>
-                      <a:tailEnd type="none" w="med" len="med"/>
-                    </a:lnB>
-                  </a:tcPr>
-                </a:tc>
-                <a:tc>
-                  <a:txBody>
-                    <a:bodyPr/>
-                    <a:lstStyle/>
-                    <a:p>
-                      <a:pPr algn="ctr" indent="0" marL="0">
-                        <a:buNone/>
-                      </a:pPr>
-                      <a:r>
-                        <a:rPr lang="en-US" sz="1050" b="1" dirty="0">
-                          <a:solidFill>
-                            <a:srgbClr val="C0392B"/>
-                          </a:solidFill>
-                          <a:latin typeface="Calibri" pitchFamily="34" charset="0"/>
-                          <a:ea typeface="Calibri" pitchFamily="34" charset="-122"/>
-                          <a:cs typeface="Calibri" pitchFamily="34" charset="-120"/>
-                        </a:rPr>
-                        <a:t>Критичный</a:t>
-                      </a:r>
-                      <a:endParaRPr lang="en-US" sz="1050" dirty="0">
-                        <a:latin typeface="Calibri" charset="0"/>
-                        <a:ea typeface="Calibri" charset="0"/>
-                        <a:cs typeface="Calibri" charset="0"/>
-                      </a:endParaRPr>
-                    </a:p>
-                  </a:txBody>
-                  <a:tcPr marL="101600" marR="101600" marT="63500" marB="63500" anchor="ctr">
-                    <a:lnL w="9525" cap="flat" cmpd="sng" algn="ctr">
-                      <a:solidFill>
-                        <a:srgbClr val="D8DEE2"/>
-                      </a:solidFill>
-                      <a:prstDash val="solid"/>
-                      <a:round/>
-                      <a:headEnd type="none" w="med" len="med"/>
-                      <a:tailEnd type="none" w="med" len="med"/>
-                    </a:lnL>
-                    <a:lnR w="9525" cap="flat" cmpd="sng" algn="ctr">
-                      <a:solidFill>
-                        <a:srgbClr val="D8DEE2"/>
-                      </a:solidFill>
-                      <a:prstDash val="solid"/>
-                      <a:round/>
-                      <a:headEnd type="none" w="med" len="med"/>
-                      <a:tailEnd type="none" w="med" len="med"/>
-                    </a:lnR>
-                    <a:lnT w="9525" cap="flat" cmpd="sng" algn="ctr">
-                      <a:solidFill>
-                        <a:srgbClr val="D8DEE2"/>
-                      </a:solidFill>
-                      <a:prstDash val="solid"/>
-                      <a:round/>
-                      <a:headEnd type="none" w="med" len="med"/>
-                      <a:tailEnd type="none" w="med" len="med"/>
-                    </a:lnT>
-                    <a:lnB w="9525" cap="flat" cmpd="sng" algn="ctr">
-                      <a:solidFill>
-                        <a:srgbClr val="D8DEE2"/>
-                      </a:solidFill>
-                      <a:prstDash val="solid"/>
-                      <a:round/>
-                      <a:headEnd type="none" w="med" len="med"/>
-                      <a:tailEnd type="none" w="med" len="med"/>
-                    </a:lnB>
-                  </a:tcPr>
-                </a:tc>
-                <a:tc>
-                  <a:txBody>
-                    <a:bodyPr/>
-                    <a:lstStyle/>
-                    <a:p>
-                      <a:pPr indent="0" marL="0">
-                        <a:buNone/>
-                      </a:pPr>
-                      <a:r>
-                        <a:rPr lang="en-US" sz="1100" dirty="0">
-                          <a:solidFill>
-                            <a:srgbClr val="5B6B7A"/>
-                          </a:solidFill>
-                          <a:latin typeface="Calibri" pitchFamily="34" charset="0"/>
-                          <a:ea typeface="Calibri" pitchFamily="34" charset="-122"/>
-                          <a:cs typeface="Calibri" pitchFamily="34" charset="-120"/>
-                        </a:rPr>
-                        <a:t>Волна 1 «RAG-документы» — новые типы документов / улучшение качества существующих / отдельная новая коллекция?</a:t>
-                      </a:r>
-                      <a:endParaRPr lang="en-US" sz="1100" dirty="0">
-                        <a:latin typeface="Calibri" charset="0"/>
-                        <a:ea typeface="Calibri" charset="0"/>
-                        <a:cs typeface="Calibri" charset="0"/>
-                      </a:endParaRPr>
-                    </a:p>
-                  </a:txBody>
-                  <a:tcPr marL="101600" marR="101600" marT="63500" marB="63500" anchor="ctr">
-                    <a:lnL w="9525" cap="flat" cmpd="sng" algn="ctr">
-                      <a:solidFill>
-                        <a:srgbClr val="D8DEE2"/>
-                      </a:solidFill>
-                      <a:prstDash val="solid"/>
-                      <a:round/>
-                      <a:headEnd type="none" w="med" len="med"/>
-                      <a:tailEnd type="none" w="med" len="med"/>
-                    </a:lnL>
-                    <a:lnR w="9525" cap="flat" cmpd="sng" algn="ctr">
-                      <a:solidFill>
-                        <a:srgbClr val="D8DEE2"/>
-                      </a:solidFill>
-                      <a:prstDash val="solid"/>
-                      <a:round/>
-                      <a:headEnd type="none" w="med" len="med"/>
-                      <a:tailEnd type="none" w="med" len="med"/>
-                    </a:lnR>
-                    <a:lnT w="9525" cap="flat" cmpd="sng" algn="ctr">
-                      <a:solidFill>
-                        <a:srgbClr val="D8DEE2"/>
-                      </a:solidFill>
-                      <a:prstDash val="solid"/>
-                      <a:round/>
-                      <a:headEnd type="none" w="med" len="med"/>
-                      <a:tailEnd type="none" w="med" len="med"/>
-                    </a:lnT>
-                    <a:lnB w="9525" cap="flat" cmpd="sng" algn="ctr">
-                      <a:solidFill>
-                        <a:srgbClr val="D8DEE2"/>
-                      </a:solidFill>
-                      <a:prstDash val="solid"/>
-                      <a:round/>
-                      <a:headEnd type="none" w="med" len="med"/>
-                      <a:tailEnd type="none" w="med" len="med"/>
-                    </a:lnB>
-                  </a:tcPr>
-                </a:tc>
-              </a:tr>
-              <a:tr h="497840">
-                <a:tc>
-                  <a:txBody>
-                    <a:bodyPr/>
-                    <a:lstStyle/>
-                    <a:p>
-                      <a:pPr algn="ctr" indent="0" marL="0">
-                        <a:buNone/>
-                      </a:pPr>
-                      <a:r>
-                        <a:rPr lang="en-US" sz="1100" dirty="0">
-                          <a:solidFill>
-                            <a:srgbClr val="5B6B7A"/>
-                          </a:solidFill>
-                          <a:latin typeface="Calibri" pitchFamily="34" charset="0"/>
-                          <a:ea typeface="Calibri" pitchFamily="34" charset="-122"/>
-                          <a:cs typeface="Calibri" pitchFamily="34" charset="-120"/>
-                        </a:rPr>
-                        <a:t>2</a:t>
-                      </a:r>
-                      <a:endParaRPr lang="en-US" sz="1100" dirty="0">
-                        <a:latin typeface="Calibri" charset="0"/>
-                        <a:ea typeface="Calibri" charset="0"/>
-                        <a:cs typeface="Calibri" charset="0"/>
-                      </a:endParaRPr>
-                    </a:p>
-                  </a:txBody>
-                  <a:tcPr marL="101600" marR="101600" marT="63500" marB="63500" anchor="ctr">
-                    <a:lnL w="9525" cap="flat" cmpd="sng" algn="ctr">
-                      <a:solidFill>
-                        <a:srgbClr val="D8DEE2"/>
-                      </a:solidFill>
-                      <a:prstDash val="solid"/>
-                      <a:round/>
-                      <a:headEnd type="none" w="med" len="med"/>
-                      <a:tailEnd type="none" w="med" len="med"/>
-                    </a:lnL>
-                    <a:lnR w="9525" cap="flat" cmpd="sng" algn="ctr">
-                      <a:solidFill>
-                        <a:srgbClr val="D8DEE2"/>
-                      </a:solidFill>
-                      <a:prstDash val="solid"/>
-                      <a:round/>
-                      <a:headEnd type="none" w="med" len="med"/>
-                      <a:tailEnd type="none" w="med" len="med"/>
-                    </a:lnR>
-                    <a:lnT w="9525" cap="flat" cmpd="sng" algn="ctr">
-                      <a:solidFill>
-                        <a:srgbClr val="D8DEE2"/>
-                      </a:solidFill>
-                      <a:prstDash val="solid"/>
-                      <a:round/>
-                      <a:headEnd type="none" w="med" len="med"/>
-                      <a:tailEnd type="none" w="med" len="med"/>
-                    </a:lnT>
-                    <a:lnB w="9525" cap="flat" cmpd="sng" algn="ctr">
-                      <a:solidFill>
-                        <a:srgbClr val="D8DEE2"/>
-                      </a:solidFill>
-                      <a:prstDash val="solid"/>
-                      <a:round/>
-                      <a:headEnd type="none" w="med" len="med"/>
-                      <a:tailEnd type="none" w="med" len="med"/>
-                    </a:lnB>
-                  </a:tcPr>
-                </a:tc>
-                <a:tc>
-                  <a:txBody>
-                    <a:bodyPr/>
-                    <a:lstStyle/>
-                    <a:p>
-                      <a:pPr indent="0" marL="0">
-                        <a:buNone/>
-                      </a:pPr>
-                      <a:r>
-                        <a:rPr lang="en-US" sz="1100" b="1" dirty="0">
-                          <a:solidFill>
-                            <a:srgbClr val="1A2733"/>
-                          </a:solidFill>
-                          <a:latin typeface="Calibri" pitchFamily="34" charset="0"/>
-                          <a:ea typeface="Calibri" pitchFamily="34" charset="-122"/>
-                          <a:cs typeface="Calibri" pitchFamily="34" charset="-120"/>
-                        </a:rPr>
-                        <a:t>Волны</a:t>
-                      </a:r>
-                      <a:endParaRPr lang="en-US" sz="1100" dirty="0">
-                        <a:latin typeface="Calibri" charset="0"/>
-                        <a:ea typeface="Calibri" charset="0"/>
-                        <a:cs typeface="Calibri" charset="0"/>
-                      </a:endParaRPr>
-                    </a:p>
-                  </a:txBody>
-                  <a:tcPr marL="101600" marR="101600" marT="63500" marB="63500" anchor="ctr">
-                    <a:lnL w="9525" cap="flat" cmpd="sng" algn="ctr">
-                      <a:solidFill>
-                        <a:srgbClr val="D8DEE2"/>
-                      </a:solidFill>
-                      <a:prstDash val="solid"/>
-                      <a:round/>
-                      <a:headEnd type="none" w="med" len="med"/>
-                      <a:tailEnd type="none" w="med" len="med"/>
-                    </a:lnL>
-                    <a:lnR w="9525" cap="flat" cmpd="sng" algn="ctr">
-                      <a:solidFill>
-                        <a:srgbClr val="D8DEE2"/>
-                      </a:solidFill>
-                      <a:prstDash val="solid"/>
-                      <a:round/>
-                      <a:headEnd type="none" w="med" len="med"/>
-                      <a:tailEnd type="none" w="med" len="med"/>
-                    </a:lnR>
-                    <a:lnT w="9525" cap="flat" cmpd="sng" algn="ctr">
-                      <a:solidFill>
-                        <a:srgbClr val="D8DEE2"/>
-                      </a:solidFill>
-                      <a:prstDash val="solid"/>
-                      <a:round/>
-                      <a:headEnd type="none" w="med" len="med"/>
-                      <a:tailEnd type="none" w="med" len="med"/>
-                    </a:lnT>
-                    <a:lnB w="9525" cap="flat" cmpd="sng" algn="ctr">
-                      <a:solidFill>
-                        <a:srgbClr val="D8DEE2"/>
-                      </a:solidFill>
-                      <a:prstDash val="solid"/>
-                      <a:round/>
-                      <a:headEnd type="none" w="med" len="med"/>
-                      <a:tailEnd type="none" w="med" len="med"/>
-                    </a:lnB>
-                  </a:tcPr>
-                </a:tc>
-                <a:tc>
-                  <a:txBody>
-                    <a:bodyPr/>
-                    <a:lstStyle/>
-                    <a:p>
-                      <a:pPr algn="ctr" indent="0" marL="0">
-                        <a:buNone/>
-                      </a:pPr>
-                      <a:r>
-                        <a:rPr lang="en-US" sz="1050" b="1" dirty="0">
-                          <a:solidFill>
-                            <a:srgbClr val="C0392B"/>
-                          </a:solidFill>
-                          <a:latin typeface="Calibri" pitchFamily="34" charset="0"/>
-                          <a:ea typeface="Calibri" pitchFamily="34" charset="-122"/>
-                          <a:cs typeface="Calibri" pitchFamily="34" charset="-120"/>
-                        </a:rPr>
-                        <a:t>Критичный</a:t>
-                      </a:r>
-                      <a:endParaRPr lang="en-US" sz="1050" dirty="0">
-                        <a:latin typeface="Calibri" charset="0"/>
-                        <a:ea typeface="Calibri" charset="0"/>
-                        <a:cs typeface="Calibri" charset="0"/>
-                      </a:endParaRPr>
-                    </a:p>
-                  </a:txBody>
-                  <a:tcPr marL="101600" marR="101600" marT="63500" marB="63500" anchor="ctr">
-                    <a:lnL w="9525" cap="flat" cmpd="sng" algn="ctr">
-                      <a:solidFill>
-                        <a:srgbClr val="D8DEE2"/>
-                      </a:solidFill>
-                      <a:prstDash val="solid"/>
-                      <a:round/>
-                      <a:headEnd type="none" w="med" len="med"/>
-                      <a:tailEnd type="none" w="med" len="med"/>
-                    </a:lnL>
-                    <a:lnR w="9525" cap="flat" cmpd="sng" algn="ctr">
-                      <a:solidFill>
-                        <a:srgbClr val="D8DEE2"/>
-                      </a:solidFill>
-                      <a:prstDash val="solid"/>
-                      <a:round/>
-                      <a:headEnd type="none" w="med" len="med"/>
-                      <a:tailEnd type="none" w="med" len="med"/>
-                    </a:lnR>
-                    <a:lnT w="9525" cap="flat" cmpd="sng" algn="ctr">
-                      <a:solidFill>
-                        <a:srgbClr val="D8DEE2"/>
-                      </a:solidFill>
-                      <a:prstDash val="solid"/>
-                      <a:round/>
-                      <a:headEnd type="none" w="med" len="med"/>
-                      <a:tailEnd type="none" w="med" len="med"/>
-                    </a:lnT>
-                    <a:lnB w="9525" cap="flat" cmpd="sng" algn="ctr">
-                      <a:solidFill>
-                        <a:srgbClr val="D8DEE2"/>
-                      </a:solidFill>
-                      <a:prstDash val="solid"/>
-                      <a:round/>
-                      <a:headEnd type="none" w="med" len="med"/>
-                      <a:tailEnd type="none" w="med" len="med"/>
-                    </a:lnB>
-                  </a:tcPr>
-                </a:tc>
-                <a:tc>
-                  <a:txBody>
-                    <a:bodyPr/>
-                    <a:lstStyle/>
-                    <a:p>
-                      <a:pPr indent="0" marL="0">
-                        <a:buNone/>
-                      </a:pPr>
-                      <a:r>
-                        <a:rPr lang="en-US" sz="1100" dirty="0">
-                          <a:solidFill>
-                            <a:srgbClr val="5B6B7A"/>
-                          </a:solidFill>
-                          <a:latin typeface="Calibri" pitchFamily="34" charset="0"/>
-                          <a:ea typeface="Calibri" pitchFamily="34" charset="-122"/>
-                          <a:cs typeface="Calibri" pitchFamily="34" charset="-120"/>
-                        </a:rPr>
-                        <a:t>Волна 2 — нужен детальный состав работ: список конкретных витрин/API для ESB и КХД.</a:t>
-                      </a:r>
-                      <a:endParaRPr lang="en-US" sz="1100" dirty="0">
-                        <a:latin typeface="Calibri" charset="0"/>
-                        <a:ea typeface="Calibri" charset="0"/>
-                        <a:cs typeface="Calibri" charset="0"/>
-                      </a:endParaRPr>
-                    </a:p>
-                  </a:txBody>
-                  <a:tcPr marL="101600" marR="101600" marT="63500" marB="63500" anchor="ctr">
-                    <a:lnL w="9525" cap="flat" cmpd="sng" algn="ctr">
-                      <a:solidFill>
-                        <a:srgbClr val="D8DEE2"/>
-                      </a:solidFill>
-                      <a:prstDash val="solid"/>
-                      <a:round/>
-                      <a:headEnd type="none" w="med" len="med"/>
-                      <a:tailEnd type="none" w="med" len="med"/>
-                    </a:lnL>
-                    <a:lnR w="9525" cap="flat" cmpd="sng" algn="ctr">
-                      <a:solidFill>
-                        <a:srgbClr val="D8DEE2"/>
-                      </a:solidFill>
-                      <a:prstDash val="solid"/>
-                      <a:round/>
-                      <a:headEnd type="none" w="med" len="med"/>
-                      <a:tailEnd type="none" w="med" len="med"/>
-                    </a:lnR>
-                    <a:lnT w="9525" cap="flat" cmpd="sng" algn="ctr">
-                      <a:solidFill>
-                        <a:srgbClr val="D8DEE2"/>
-                      </a:solidFill>
-                      <a:prstDash val="solid"/>
-                      <a:round/>
-                      <a:headEnd type="none" w="med" len="med"/>
-                      <a:tailEnd type="none" w="med" len="med"/>
-                    </a:lnT>
-                    <a:lnB w="9525" cap="flat" cmpd="sng" algn="ctr">
-                      <a:solidFill>
-                        <a:srgbClr val="D8DEE2"/>
-                      </a:solidFill>
-                      <a:prstDash val="solid"/>
-                      <a:round/>
-                      <a:headEnd type="none" w="med" len="med"/>
-                      <a:tailEnd type="none" w="med" len="med"/>
-                    </a:lnB>
-                  </a:tcPr>
-                </a:tc>
-              </a:tr>
-              <a:tr h="497840">
-                <a:tc>
-                  <a:txBody>
-                    <a:bodyPr/>
-                    <a:lstStyle/>
-                    <a:p>
-                      <a:pPr algn="ctr" indent="0" marL="0">
-                        <a:buNone/>
-                      </a:pPr>
-                      <a:r>
-                        <a:rPr lang="en-US" sz="1100" dirty="0">
-                          <a:solidFill>
-                            <a:srgbClr val="5B6B7A"/>
-                          </a:solidFill>
-                          <a:latin typeface="Calibri" pitchFamily="34" charset="0"/>
-                          <a:ea typeface="Calibri" pitchFamily="34" charset="-122"/>
-                          <a:cs typeface="Calibri" pitchFamily="34" charset="-120"/>
-                        </a:rPr>
-                        <a:t>3</a:t>
-                      </a:r>
-                      <a:endParaRPr lang="en-US" sz="1100" dirty="0">
-                        <a:latin typeface="Calibri" charset="0"/>
-                        <a:ea typeface="Calibri" charset="0"/>
-                        <a:cs typeface="Calibri" charset="0"/>
-                      </a:endParaRPr>
-                    </a:p>
-                  </a:txBody>
-                  <a:tcPr marL="101600" marR="101600" marT="63500" marB="63500" anchor="ctr">
-                    <a:lnL w="9525" cap="flat" cmpd="sng" algn="ctr">
-                      <a:solidFill>
-                        <a:srgbClr val="D8DEE2"/>
-                      </a:solidFill>
-                      <a:prstDash val="solid"/>
-                      <a:round/>
-                      <a:headEnd type="none" w="med" len="med"/>
-                      <a:tailEnd type="none" w="med" len="med"/>
-                    </a:lnL>
-                    <a:lnR w="9525" cap="flat" cmpd="sng" algn="ctr">
-                      <a:solidFill>
-                        <a:srgbClr val="D8DEE2"/>
-                      </a:solidFill>
-                      <a:prstDash val="solid"/>
-                      <a:round/>
-                      <a:headEnd type="none" w="med" len="med"/>
-                      <a:tailEnd type="none" w="med" len="med"/>
-                    </a:lnR>
-                    <a:lnT w="9525" cap="flat" cmpd="sng" algn="ctr">
-                      <a:solidFill>
-                        <a:srgbClr val="D8DEE2"/>
-                      </a:solidFill>
-                      <a:prstDash val="solid"/>
-                      <a:round/>
-                      <a:headEnd type="none" w="med" len="med"/>
-                      <a:tailEnd type="none" w="med" len="med"/>
-                    </a:lnT>
-                    <a:lnB w="9525" cap="flat" cmpd="sng" algn="ctr">
-                      <a:solidFill>
-                        <a:srgbClr val="D8DEE2"/>
-                      </a:solidFill>
-                      <a:prstDash val="solid"/>
-                      <a:round/>
-                      <a:headEnd type="none" w="med" len="med"/>
-                      <a:tailEnd type="none" w="med" len="med"/>
-                    </a:lnB>
-                  </a:tcPr>
-                </a:tc>
-                <a:tc>
-                  <a:txBody>
-                    <a:bodyPr/>
-                    <a:lstStyle/>
-                    <a:p>
-                      <a:pPr indent="0" marL="0">
-                        <a:buNone/>
-                      </a:pPr>
-                      <a:r>
-                        <a:rPr lang="en-US" sz="1100" b="1" dirty="0">
-                          <a:solidFill>
-                            <a:srgbClr val="1A2733"/>
-                          </a:solidFill>
-                          <a:latin typeface="Calibri" pitchFamily="34" charset="0"/>
-                          <a:ea typeface="Calibri" pitchFamily="34" charset="-122"/>
-                          <a:cs typeface="Calibri" pitchFamily="34" charset="-120"/>
-                        </a:rPr>
-                        <a:t>Волны</a:t>
-                      </a:r>
-                      <a:endParaRPr lang="en-US" sz="1100" dirty="0">
-                        <a:latin typeface="Calibri" charset="0"/>
-                        <a:ea typeface="Calibri" charset="0"/>
-                        <a:cs typeface="Calibri" charset="0"/>
-                      </a:endParaRPr>
-                    </a:p>
-                  </a:txBody>
-                  <a:tcPr marL="101600" marR="101600" marT="63500" marB="63500" anchor="ctr">
-                    <a:lnL w="9525" cap="flat" cmpd="sng" algn="ctr">
-                      <a:solidFill>
-                        <a:srgbClr val="D8DEE2"/>
-                      </a:solidFill>
-                      <a:prstDash val="solid"/>
-                      <a:round/>
-                      <a:headEnd type="none" w="med" len="med"/>
-                      <a:tailEnd type="none" w="med" len="med"/>
-                    </a:lnL>
-                    <a:lnR w="9525" cap="flat" cmpd="sng" algn="ctr">
-                      <a:solidFill>
-                        <a:srgbClr val="D8DEE2"/>
-                      </a:solidFill>
-                      <a:prstDash val="solid"/>
-                      <a:round/>
-                      <a:headEnd type="none" w="med" len="med"/>
-                      <a:tailEnd type="none" w="med" len="med"/>
-                    </a:lnR>
-                    <a:lnT w="9525" cap="flat" cmpd="sng" algn="ctr">
-                      <a:solidFill>
-                        <a:srgbClr val="D8DEE2"/>
-                      </a:solidFill>
-                      <a:prstDash val="solid"/>
-                      <a:round/>
-                      <a:headEnd type="none" w="med" len="med"/>
-                      <a:tailEnd type="none" w="med" len="med"/>
-                    </a:lnT>
-                    <a:lnB w="9525" cap="flat" cmpd="sng" algn="ctr">
-                      <a:solidFill>
-                        <a:srgbClr val="D8DEE2"/>
-                      </a:solidFill>
-                      <a:prstDash val="solid"/>
-                      <a:round/>
-                      <a:headEnd type="none" w="med" len="med"/>
-                      <a:tailEnd type="none" w="med" len="med"/>
-                    </a:lnB>
-                  </a:tcPr>
-                </a:tc>
-                <a:tc>
-                  <a:txBody>
-                    <a:bodyPr/>
-                    <a:lstStyle/>
-                    <a:p>
-                      <a:pPr algn="ctr" indent="0" marL="0">
-                        <a:buNone/>
-                      </a:pPr>
-                      <a:r>
-                        <a:rPr lang="en-US" sz="1050" b="1" dirty="0">
-                          <a:solidFill>
-                            <a:srgbClr val="C97A1A"/>
-                          </a:solidFill>
-                          <a:latin typeface="Calibri" pitchFamily="34" charset="0"/>
-                          <a:ea typeface="Calibri" pitchFamily="34" charset="-122"/>
-                          <a:cs typeface="Calibri" pitchFamily="34" charset="-120"/>
-                        </a:rPr>
-                        <a:t>Высокий</a:t>
-                      </a:r>
-                      <a:endParaRPr lang="en-US" sz="1050" dirty="0">
-                        <a:latin typeface="Calibri" charset="0"/>
-                        <a:ea typeface="Calibri" charset="0"/>
-                        <a:cs typeface="Calibri" charset="0"/>
-                      </a:endParaRPr>
-                    </a:p>
-                  </a:txBody>
-                  <a:tcPr marL="101600" marR="101600" marT="63500" marB="63500" anchor="ctr">
-                    <a:lnL w="9525" cap="flat" cmpd="sng" algn="ctr">
-                      <a:solidFill>
-                        <a:srgbClr val="D8DEE2"/>
-                      </a:solidFill>
-                      <a:prstDash val="solid"/>
-                      <a:round/>
-                      <a:headEnd type="none" w="med" len="med"/>
-                      <a:tailEnd type="none" w="med" len="med"/>
-                    </a:lnL>
-                    <a:lnR w="9525" cap="flat" cmpd="sng" algn="ctr">
-                      <a:solidFill>
-                        <a:srgbClr val="D8DEE2"/>
-                      </a:solidFill>
-                      <a:prstDash val="solid"/>
-                      <a:round/>
-                      <a:headEnd type="none" w="med" len="med"/>
-                      <a:tailEnd type="none" w="med" len="med"/>
-                    </a:lnR>
-                    <a:lnT w="9525" cap="flat" cmpd="sng" algn="ctr">
-                      <a:solidFill>
-                        <a:srgbClr val="D8DEE2"/>
-                      </a:solidFill>
-                      <a:prstDash val="solid"/>
-                      <a:round/>
-                      <a:headEnd type="none" w="med" len="med"/>
-                      <a:tailEnd type="none" w="med" len="med"/>
-                    </a:lnT>
-                    <a:lnB w="9525" cap="flat" cmpd="sng" algn="ctr">
-                      <a:solidFill>
-                        <a:srgbClr val="D8DEE2"/>
-                      </a:solidFill>
-                      <a:prstDash val="solid"/>
-                      <a:round/>
-                      <a:headEnd type="none" w="med" len="med"/>
-                      <a:tailEnd type="none" w="med" len="med"/>
-                    </a:lnB>
-                  </a:tcPr>
-                </a:tc>
-                <a:tc>
-                  <a:txBody>
-                    <a:bodyPr/>
-                    <a:lstStyle/>
-                    <a:p>
-                      <a:pPr indent="0" marL="0">
-                        <a:buNone/>
-                      </a:pPr>
-                      <a:r>
-                        <a:rPr lang="en-US" sz="1100" dirty="0">
-                          <a:solidFill>
-                            <a:srgbClr val="5B6B7A"/>
-                          </a:solidFill>
-                          <a:latin typeface="Calibri" pitchFamily="34" charset="0"/>
-                          <a:ea typeface="Calibri" pitchFamily="34" charset="-122"/>
-                          <a:cs typeface="Calibri" pitchFamily="34" charset="-120"/>
-                        </a:rPr>
-                        <a:t>Волна 3 и далее — есть примерное направление, или открытый вопрос до завершения волны 2?</a:t>
-                      </a:r>
-                      <a:endParaRPr lang="en-US" sz="1100" dirty="0">
-                        <a:latin typeface="Calibri" charset="0"/>
-                        <a:ea typeface="Calibri" charset="0"/>
-                        <a:cs typeface="Calibri" charset="0"/>
-                      </a:endParaRPr>
-                    </a:p>
-                  </a:txBody>
-                  <a:tcPr marL="101600" marR="101600" marT="63500" marB="63500" anchor="ctr">
-                    <a:lnL w="9525" cap="flat" cmpd="sng" algn="ctr">
-                      <a:solidFill>
-                        <a:srgbClr val="D8DEE2"/>
-                      </a:solidFill>
-                      <a:prstDash val="solid"/>
-                      <a:round/>
-                      <a:headEnd type="none" w="med" len="med"/>
-                      <a:tailEnd type="none" w="med" len="med"/>
-                    </a:lnL>
-                    <a:lnR w="9525" cap="flat" cmpd="sng" algn="ctr">
-                      <a:solidFill>
-                        <a:srgbClr val="D8DEE2"/>
-                      </a:solidFill>
-                      <a:prstDash val="solid"/>
-                      <a:round/>
-                      <a:headEnd type="none" w="med" len="med"/>
-                      <a:tailEnd type="none" w="med" len="med"/>
-                    </a:lnR>
-                    <a:lnT w="9525" cap="flat" cmpd="sng" algn="ctr">
-                      <a:solidFill>
-                        <a:srgbClr val="D8DEE2"/>
-                      </a:solidFill>
-                      <a:prstDash val="solid"/>
-                      <a:round/>
-                      <a:headEnd type="none" w="med" len="med"/>
-                      <a:tailEnd type="none" w="med" len="med"/>
-                    </a:lnT>
-                    <a:lnB w="9525" cap="flat" cmpd="sng" algn="ctr">
-                      <a:solidFill>
-                        <a:srgbClr val="D8DEE2"/>
-                      </a:solidFill>
-                      <a:prstDash val="solid"/>
-                      <a:round/>
-                      <a:headEnd type="none" w="med" len="med"/>
-                      <a:tailEnd type="none" w="med" len="med"/>
-                    </a:lnB>
-                  </a:tcPr>
-                </a:tc>
-              </a:tr>
-              <a:tr h="497840">
-                <a:tc>
-                  <a:txBody>
-                    <a:bodyPr/>
-                    <a:lstStyle/>
-                    <a:p>
-                      <a:pPr algn="ctr" indent="0" marL="0">
-                        <a:buNone/>
-                      </a:pPr>
-                      <a:r>
-                        <a:rPr lang="en-US" sz="1100" dirty="0">
-                          <a:solidFill>
-                            <a:srgbClr val="5B6B7A"/>
-                          </a:solidFill>
-                          <a:latin typeface="Calibri" pitchFamily="34" charset="0"/>
-                          <a:ea typeface="Calibri" pitchFamily="34" charset="-122"/>
-                          <a:cs typeface="Calibri" pitchFamily="34" charset="-120"/>
-                        </a:rPr>
-                        <a:t>4</a:t>
-                      </a:r>
-                      <a:endParaRPr lang="en-US" sz="1100" dirty="0">
-                        <a:latin typeface="Calibri" charset="0"/>
-                        <a:ea typeface="Calibri" charset="0"/>
-                        <a:cs typeface="Calibri" charset="0"/>
-                      </a:endParaRPr>
-                    </a:p>
-                  </a:txBody>
-                  <a:tcPr marL="101600" marR="101600" marT="63500" marB="63500" anchor="ctr">
-                    <a:lnL w="9525" cap="flat" cmpd="sng" algn="ctr">
-                      <a:solidFill>
-                        <a:srgbClr val="D8DEE2"/>
-                      </a:solidFill>
-                      <a:prstDash val="solid"/>
-                      <a:round/>
-                      <a:headEnd type="none" w="med" len="med"/>
-                      <a:tailEnd type="none" w="med" len="med"/>
-                    </a:lnL>
-                    <a:lnR w="9525" cap="flat" cmpd="sng" algn="ctr">
-                      <a:solidFill>
-                        <a:srgbClr val="D8DEE2"/>
-                      </a:solidFill>
-                      <a:prstDash val="solid"/>
-                      <a:round/>
-                      <a:headEnd type="none" w="med" len="med"/>
-                      <a:tailEnd type="none" w="med" len="med"/>
-                    </a:lnR>
-                    <a:lnT w="9525" cap="flat" cmpd="sng" algn="ctr">
-                      <a:solidFill>
-                        <a:srgbClr val="D8DEE2"/>
-                      </a:solidFill>
-                      <a:prstDash val="solid"/>
-                      <a:round/>
-                      <a:headEnd type="none" w="med" len="med"/>
-                      <a:tailEnd type="none" w="med" len="med"/>
-                    </a:lnT>
-                    <a:lnB w="9525" cap="flat" cmpd="sng" algn="ctr">
-                      <a:solidFill>
-                        <a:srgbClr val="D8DEE2"/>
-                      </a:solidFill>
-                      <a:prstDash val="solid"/>
-                      <a:round/>
-                      <a:headEnd type="none" w="med" len="med"/>
-                      <a:tailEnd type="none" w="med" len="med"/>
-                    </a:lnB>
-                  </a:tcPr>
-                </a:tc>
-                <a:tc>
-                  <a:txBody>
-                    <a:bodyPr/>
-                    <a:lstStyle/>
-                    <a:p>
-                      <a:pPr indent="0" marL="0">
-                        <a:buNone/>
-                      </a:pPr>
-                      <a:r>
-                        <a:rPr lang="en-US" sz="1100" b="1" dirty="0">
-                          <a:solidFill>
-                            <a:srgbClr val="1A2733"/>
-                          </a:solidFill>
-                          <a:latin typeface="Calibri" pitchFamily="34" charset="0"/>
-                          <a:ea typeface="Calibri" pitchFamily="34" charset="-122"/>
-                          <a:cs typeface="Calibri" pitchFamily="34" charset="-120"/>
-                        </a:rPr>
-                        <a:t>Интеграция</a:t>
-                      </a:r>
-                      <a:endParaRPr lang="en-US" sz="1100" dirty="0">
-                        <a:latin typeface="Calibri" charset="0"/>
-                        <a:ea typeface="Calibri" charset="0"/>
-                        <a:cs typeface="Calibri" charset="0"/>
-                      </a:endParaRPr>
-                    </a:p>
-                  </a:txBody>
-                  <a:tcPr marL="101600" marR="101600" marT="63500" marB="63500" anchor="ctr">
-                    <a:lnL w="9525" cap="flat" cmpd="sng" algn="ctr">
-                      <a:solidFill>
-                        <a:srgbClr val="D8DEE2"/>
-                      </a:solidFill>
-                      <a:prstDash val="solid"/>
-                      <a:round/>
-                      <a:headEnd type="none" w="med" len="med"/>
-                      <a:tailEnd type="none" w="med" len="med"/>
-                    </a:lnL>
-                    <a:lnR w="9525" cap="flat" cmpd="sng" algn="ctr">
-                      <a:solidFill>
-                        <a:srgbClr val="D8DEE2"/>
-                      </a:solidFill>
-                      <a:prstDash val="solid"/>
-                      <a:round/>
-                      <a:headEnd type="none" w="med" len="med"/>
-                      <a:tailEnd type="none" w="med" len="med"/>
-                    </a:lnR>
-                    <a:lnT w="9525" cap="flat" cmpd="sng" algn="ctr">
-                      <a:solidFill>
-                        <a:srgbClr val="D8DEE2"/>
-                      </a:solidFill>
-                      <a:prstDash val="solid"/>
-                      <a:round/>
-                      <a:headEnd type="none" w="med" len="med"/>
-                      <a:tailEnd type="none" w="med" len="med"/>
-                    </a:lnT>
-                    <a:lnB w="9525" cap="flat" cmpd="sng" algn="ctr">
-                      <a:solidFill>
-                        <a:srgbClr val="D8DEE2"/>
-                      </a:solidFill>
-                      <a:prstDash val="solid"/>
-                      <a:round/>
-                      <a:headEnd type="none" w="med" len="med"/>
-                      <a:tailEnd type="none" w="med" len="med"/>
-                    </a:lnB>
-                  </a:tcPr>
-                </a:tc>
-                <a:tc>
-                  <a:txBody>
-                    <a:bodyPr/>
-                    <a:lstStyle/>
-                    <a:p>
-                      <a:pPr algn="ctr" indent="0" marL="0">
-                        <a:buNone/>
-                      </a:pPr>
-                      <a:r>
-                        <a:rPr lang="en-US" sz="1050" b="1" dirty="0">
-                          <a:solidFill>
-                            <a:srgbClr val="C97A1A"/>
-                          </a:solidFill>
-                          <a:latin typeface="Calibri" pitchFamily="34" charset="0"/>
-                          <a:ea typeface="Calibri" pitchFamily="34" charset="-122"/>
-                          <a:cs typeface="Calibri" pitchFamily="34" charset="-120"/>
-                        </a:rPr>
-                        <a:t>Высокий</a:t>
-                      </a:r>
-                      <a:endParaRPr lang="en-US" sz="1050" dirty="0">
-                        <a:latin typeface="Calibri" charset="0"/>
-                        <a:ea typeface="Calibri" charset="0"/>
-                        <a:cs typeface="Calibri" charset="0"/>
-                      </a:endParaRPr>
-                    </a:p>
-                  </a:txBody>
-                  <a:tcPr marL="101600" marR="101600" marT="63500" marB="63500" anchor="ctr">
-                    <a:lnL w="9525" cap="flat" cmpd="sng" algn="ctr">
-                      <a:solidFill>
-                        <a:srgbClr val="D8DEE2"/>
-                      </a:solidFill>
-                      <a:prstDash val="solid"/>
-                      <a:round/>
-                      <a:headEnd type="none" w="med" len="med"/>
-                      <a:tailEnd type="none" w="med" len="med"/>
-                    </a:lnL>
-                    <a:lnR w="9525" cap="flat" cmpd="sng" algn="ctr">
-                      <a:solidFill>
-                        <a:srgbClr val="D8DEE2"/>
-                      </a:solidFill>
-                      <a:prstDash val="solid"/>
-                      <a:round/>
-                      <a:headEnd type="none" w="med" len="med"/>
-                      <a:tailEnd type="none" w="med" len="med"/>
-                    </a:lnR>
-                    <a:lnT w="9525" cap="flat" cmpd="sng" algn="ctr">
-                      <a:solidFill>
-                        <a:srgbClr val="D8DEE2"/>
-                      </a:solidFill>
-                      <a:prstDash val="solid"/>
-                      <a:round/>
-                      <a:headEnd type="none" w="med" len="med"/>
-                      <a:tailEnd type="none" w="med" len="med"/>
-                    </a:lnT>
-                    <a:lnB w="9525" cap="flat" cmpd="sng" algn="ctr">
-                      <a:solidFill>
-                        <a:srgbClr val="D8DEE2"/>
-                      </a:solidFill>
-                      <a:prstDash val="solid"/>
-                      <a:round/>
-                      <a:headEnd type="none" w="med" len="med"/>
-                      <a:tailEnd type="none" w="med" len="med"/>
-                    </a:lnB>
-                  </a:tcPr>
-                </a:tc>
-                <a:tc>
-                  <a:txBody>
-                    <a:bodyPr/>
-                    <a:lstStyle/>
-                    <a:p>
-                      <a:pPr indent="0" marL="0">
-                        <a:buNone/>
-                      </a:pPr>
-                      <a:r>
-                        <a:rPr lang="en-US" sz="1100" dirty="0">
-                          <a:solidFill>
-                            <a:srgbClr val="5B6B7A"/>
-                          </a:solidFill>
-                          <a:latin typeface="Calibri" pitchFamily="34" charset="0"/>
-                          <a:ea typeface="Calibri" pitchFamily="34" charset="-122"/>
-                          <a:cs typeface="Calibri" pitchFamily="34" charset="-120"/>
-                        </a:rPr>
-                        <a:t>Какие конкретно витрины данных добавить в ESB сверх текущего среза CRM (Bitrix24)?</a:t>
-                      </a:r>
-                      <a:endParaRPr lang="en-US" sz="1100" dirty="0">
-                        <a:latin typeface="Calibri" charset="0"/>
-                        <a:ea typeface="Calibri" charset="0"/>
-                        <a:cs typeface="Calibri" charset="0"/>
-                      </a:endParaRPr>
-                    </a:p>
-                  </a:txBody>
-                  <a:tcPr marL="101600" marR="101600" marT="63500" marB="63500" anchor="ctr">
-                    <a:lnL w="9525" cap="flat" cmpd="sng" algn="ctr">
-                      <a:solidFill>
-                        <a:srgbClr val="D8DEE2"/>
-                      </a:solidFill>
-                      <a:prstDash val="solid"/>
-                      <a:round/>
-                      <a:headEnd type="none" w="med" len="med"/>
-                      <a:tailEnd type="none" w="med" len="med"/>
-                    </a:lnL>
-                    <a:lnR w="9525" cap="flat" cmpd="sng" algn="ctr">
-                      <a:solidFill>
-                        <a:srgbClr val="D8DEE2"/>
-                      </a:solidFill>
-                      <a:prstDash val="solid"/>
-                      <a:round/>
-                      <a:headEnd type="none" w="med" len="med"/>
-                      <a:tailEnd type="none" w="med" len="med"/>
-                    </a:lnR>
-                    <a:lnT w="9525" cap="flat" cmpd="sng" algn="ctr">
-                      <a:solidFill>
-                        <a:srgbClr val="D8DEE2"/>
-                      </a:solidFill>
-                      <a:prstDash val="solid"/>
-                      <a:round/>
-                      <a:headEnd type="none" w="med" len="med"/>
-                      <a:tailEnd type="none" w="med" len="med"/>
-                    </a:lnT>
-                    <a:lnB w="9525" cap="flat" cmpd="sng" algn="ctr">
-                      <a:solidFill>
-                        <a:srgbClr val="D8DEE2"/>
-                      </a:solidFill>
-                      <a:prstDash val="solid"/>
-                      <a:round/>
-                      <a:headEnd type="none" w="med" len="med"/>
-                      <a:tailEnd type="none" w="med" len="med"/>
-                    </a:lnB>
-                  </a:tcPr>
-                </a:tc>
-              </a:tr>
-              <a:tr h="497840">
-                <a:tc>
-                  <a:txBody>
-                    <a:bodyPr/>
-                    <a:lstStyle/>
-                    <a:p>
-                      <a:pPr algn="ctr" indent="0" marL="0">
-                        <a:buNone/>
-                      </a:pPr>
-                      <a:r>
-                        <a:rPr lang="en-US" sz="1100" dirty="0">
-                          <a:solidFill>
-                            <a:srgbClr val="5B6B7A"/>
-                          </a:solidFill>
-                          <a:latin typeface="Calibri" pitchFamily="34" charset="0"/>
-                          <a:ea typeface="Calibri" pitchFamily="34" charset="-122"/>
-                          <a:cs typeface="Calibri" pitchFamily="34" charset="-120"/>
-                        </a:rPr>
-                        <a:t>5</a:t>
-                      </a:r>
-                      <a:endParaRPr lang="en-US" sz="1100" dirty="0">
-                        <a:latin typeface="Calibri" charset="0"/>
-                        <a:ea typeface="Calibri" charset="0"/>
-                        <a:cs typeface="Calibri" charset="0"/>
-                      </a:endParaRPr>
-                    </a:p>
-                  </a:txBody>
-                  <a:tcPr marL="101600" marR="101600" marT="63500" marB="63500" anchor="ctr">
-                    <a:lnL w="9525" cap="flat" cmpd="sng" algn="ctr">
-                      <a:solidFill>
-                        <a:srgbClr val="D8DEE2"/>
-                      </a:solidFill>
-                      <a:prstDash val="solid"/>
-                      <a:round/>
-                      <a:headEnd type="none" w="med" len="med"/>
-                      <a:tailEnd type="none" w="med" len="med"/>
-                    </a:lnL>
-                    <a:lnR w="9525" cap="flat" cmpd="sng" algn="ctr">
-                      <a:solidFill>
-                        <a:srgbClr val="D8DEE2"/>
-                      </a:solidFill>
-                      <a:prstDash val="solid"/>
-                      <a:round/>
-                      <a:headEnd type="none" w="med" len="med"/>
-                      <a:tailEnd type="none" w="med" len="med"/>
-                    </a:lnR>
-                    <a:lnT w="9525" cap="flat" cmpd="sng" algn="ctr">
-                      <a:solidFill>
-                        <a:srgbClr val="D8DEE2"/>
-                      </a:solidFill>
-                      <a:prstDash val="solid"/>
-                      <a:round/>
-                      <a:headEnd type="none" w="med" len="med"/>
-                      <a:tailEnd type="none" w="med" len="med"/>
-                    </a:lnT>
-                    <a:lnB w="9525" cap="flat" cmpd="sng" algn="ctr">
-                      <a:solidFill>
-                        <a:srgbClr val="D8DEE2"/>
-                      </a:solidFill>
-                      <a:prstDash val="solid"/>
-                      <a:round/>
-                      <a:headEnd type="none" w="med" len="med"/>
-                      <a:tailEnd type="none" w="med" len="med"/>
-                    </a:lnB>
-                  </a:tcPr>
-                </a:tc>
-                <a:tc>
-                  <a:txBody>
-                    <a:bodyPr/>
-                    <a:lstStyle/>
-                    <a:p>
-                      <a:pPr indent="0" marL="0">
-                        <a:buNone/>
-                      </a:pPr>
-                      <a:r>
-                        <a:rPr lang="en-US" sz="1100" b="1" dirty="0">
-                          <a:solidFill>
-                            <a:srgbClr val="1A2733"/>
-                          </a:solidFill>
-                          <a:latin typeface="Calibri" pitchFamily="34" charset="0"/>
-                          <a:ea typeface="Calibri" pitchFamily="34" charset="-122"/>
-                          <a:cs typeface="Calibri" pitchFamily="34" charset="-120"/>
-                        </a:rPr>
-                        <a:t>Интеграция</a:t>
-                      </a:r>
-                      <a:endParaRPr lang="en-US" sz="1100" dirty="0">
-                        <a:latin typeface="Calibri" charset="0"/>
-                        <a:ea typeface="Calibri" charset="0"/>
-                        <a:cs typeface="Calibri" charset="0"/>
-                      </a:endParaRPr>
-                    </a:p>
-                  </a:txBody>
-                  <a:tcPr marL="101600" marR="101600" marT="63500" marB="63500" anchor="ctr">
-                    <a:lnL w="9525" cap="flat" cmpd="sng" algn="ctr">
-                      <a:solidFill>
-                        <a:srgbClr val="D8DEE2"/>
-                      </a:solidFill>
-                      <a:prstDash val="solid"/>
-                      <a:round/>
-                      <a:headEnd type="none" w="med" len="med"/>
-                      <a:tailEnd type="none" w="med" len="med"/>
-                    </a:lnL>
-                    <a:lnR w="9525" cap="flat" cmpd="sng" algn="ctr">
-                      <a:solidFill>
-                        <a:srgbClr val="D8DEE2"/>
-                      </a:solidFill>
-                      <a:prstDash val="solid"/>
-                      <a:round/>
-                      <a:headEnd type="none" w="med" len="med"/>
-                      <a:tailEnd type="none" w="med" len="med"/>
-                    </a:lnR>
-                    <a:lnT w="9525" cap="flat" cmpd="sng" algn="ctr">
-                      <a:solidFill>
-                        <a:srgbClr val="D8DEE2"/>
-                      </a:solidFill>
-                      <a:prstDash val="solid"/>
-                      <a:round/>
-                      <a:headEnd type="none" w="med" len="med"/>
-                      <a:tailEnd type="none" w="med" len="med"/>
-                    </a:lnT>
-                    <a:lnB w="9525" cap="flat" cmpd="sng" algn="ctr">
-                      <a:solidFill>
-                        <a:srgbClr val="D8DEE2"/>
-                      </a:solidFill>
-                      <a:prstDash val="solid"/>
-                      <a:round/>
-                      <a:headEnd type="none" w="med" len="med"/>
-                      <a:tailEnd type="none" w="med" len="med"/>
-                    </a:lnB>
-                  </a:tcPr>
-                </a:tc>
-                <a:tc>
-                  <a:txBody>
-                    <a:bodyPr/>
-                    <a:lstStyle/>
-                    <a:p>
-                      <a:pPr algn="ctr" indent="0" marL="0">
-                        <a:buNone/>
-                      </a:pPr>
-                      <a:r>
-                        <a:rPr lang="en-US" sz="1050" b="1" dirty="0">
-                          <a:solidFill>
-                            <a:srgbClr val="C97A1A"/>
-                          </a:solidFill>
-                          <a:latin typeface="Calibri" pitchFamily="34" charset="0"/>
-                          <a:ea typeface="Calibri" pitchFamily="34" charset="-122"/>
-                          <a:cs typeface="Calibri" pitchFamily="34" charset="-120"/>
-                        </a:rPr>
-                        <a:t>Высокий</a:t>
-                      </a:r>
-                      <a:endParaRPr lang="en-US" sz="1050" dirty="0">
-                        <a:latin typeface="Calibri" charset="0"/>
-                        <a:ea typeface="Calibri" charset="0"/>
-                        <a:cs typeface="Calibri" charset="0"/>
-                      </a:endParaRPr>
-                    </a:p>
-                  </a:txBody>
-                  <a:tcPr marL="101600" marR="101600" marT="63500" marB="63500" anchor="ctr">
-                    <a:lnL w="9525" cap="flat" cmpd="sng" algn="ctr">
-                      <a:solidFill>
-                        <a:srgbClr val="D8DEE2"/>
-                      </a:solidFill>
-                      <a:prstDash val="solid"/>
-                      <a:round/>
-                      <a:headEnd type="none" w="med" len="med"/>
-                      <a:tailEnd type="none" w="med" len="med"/>
-                    </a:lnL>
-                    <a:lnR w="9525" cap="flat" cmpd="sng" algn="ctr">
-                      <a:solidFill>
-                        <a:srgbClr val="D8DEE2"/>
-                      </a:solidFill>
-                      <a:prstDash val="solid"/>
-                      <a:round/>
-                      <a:headEnd type="none" w="med" len="med"/>
-                      <a:tailEnd type="none" w="med" len="med"/>
-                    </a:lnR>
-                    <a:lnT w="9525" cap="flat" cmpd="sng" algn="ctr">
-                      <a:solidFill>
-                        <a:srgbClr val="D8DEE2"/>
-                      </a:solidFill>
-                      <a:prstDash val="solid"/>
-                      <a:round/>
-                      <a:headEnd type="none" w="med" len="med"/>
-                      <a:tailEnd type="none" w="med" len="med"/>
-                    </a:lnT>
-                    <a:lnB w="9525" cap="flat" cmpd="sng" algn="ctr">
-                      <a:solidFill>
-                        <a:srgbClr val="D8DEE2"/>
-                      </a:solidFill>
-                      <a:prstDash val="solid"/>
-                      <a:round/>
-                      <a:headEnd type="none" w="med" len="med"/>
-                      <a:tailEnd type="none" w="med" len="med"/>
-                    </a:lnB>
-                  </a:tcPr>
-                </a:tc>
-                <a:tc>
-                  <a:txBody>
-                    <a:bodyPr/>
-                    <a:lstStyle/>
-                    <a:p>
-                      <a:pPr indent="0" marL="0">
-                        <a:buNone/>
-                      </a:pPr>
-                      <a:r>
-                        <a:rPr lang="en-US" sz="1100" dirty="0">
-                          <a:solidFill>
-                            <a:srgbClr val="5B6B7A"/>
-                          </a:solidFill>
-                          <a:latin typeface="Calibri" pitchFamily="34" charset="0"/>
-                          <a:ea typeface="Calibri" pitchFamily="34" charset="-122"/>
-                          <a:cs typeface="Calibri" pitchFamily="34" charset="-120"/>
-                        </a:rPr>
-                        <a:t>Какие конкретно API открыть через шину — система-источник, формат, ответственный на стороне Д8?</a:t>
-                      </a:r>
-                      <a:endParaRPr lang="en-US" sz="1100" dirty="0">
-                        <a:latin typeface="Calibri" charset="0"/>
-                        <a:ea typeface="Calibri" charset="0"/>
-                        <a:cs typeface="Calibri" charset="0"/>
-                      </a:endParaRPr>
-                    </a:p>
-                  </a:txBody>
-                  <a:tcPr marL="101600" marR="101600" marT="63500" marB="63500" anchor="ctr">
-                    <a:lnL w="9525" cap="flat" cmpd="sng" algn="ctr">
-                      <a:solidFill>
-                        <a:srgbClr val="D8DEE2"/>
-                      </a:solidFill>
-                      <a:prstDash val="solid"/>
-                      <a:round/>
-                      <a:headEnd type="none" w="med" len="med"/>
-                      <a:tailEnd type="none" w="med" len="med"/>
-                    </a:lnL>
-                    <a:lnR w="9525" cap="flat" cmpd="sng" algn="ctr">
-                      <a:solidFill>
-                        <a:srgbClr val="D8DEE2"/>
-                      </a:solidFill>
-                      <a:prstDash val="solid"/>
-                      <a:round/>
-                      <a:headEnd type="none" w="med" len="med"/>
-                      <a:tailEnd type="none" w="med" len="med"/>
-                    </a:lnR>
-                    <a:lnT w="9525" cap="flat" cmpd="sng" algn="ctr">
-                      <a:solidFill>
-                        <a:srgbClr val="D8DEE2"/>
-                      </a:solidFill>
-                      <a:prstDash val="solid"/>
-                      <a:round/>
-                      <a:headEnd type="none" w="med" len="med"/>
-                      <a:tailEnd type="none" w="med" len="med"/>
-                    </a:lnT>
-                    <a:lnB w="9525" cap="flat" cmpd="sng" algn="ctr">
-                      <a:solidFill>
-                        <a:srgbClr val="D8DEE2"/>
-                      </a:solidFill>
-                      <a:prstDash val="solid"/>
-                      <a:round/>
-                      <a:headEnd type="none" w="med" len="med"/>
-                      <a:tailEnd type="none" w="med" len="med"/>
-                    </a:lnB>
-                  </a:tcPr>
-                </a:tc>
-              </a:tr>
-              <a:tr h="497840">
-                <a:tc>
-                  <a:txBody>
-                    <a:bodyPr/>
-                    <a:lstStyle/>
-                    <a:p>
-                      <a:pPr algn="ctr" indent="0" marL="0">
-                        <a:buNone/>
-                      </a:pPr>
-                      <a:r>
-                        <a:rPr lang="en-US" sz="1100" dirty="0">
-                          <a:solidFill>
-                            <a:srgbClr val="5B6B7A"/>
-                          </a:solidFill>
-                          <a:latin typeface="Calibri" pitchFamily="34" charset="0"/>
-                          <a:ea typeface="Calibri" pitchFamily="34" charset="-122"/>
-                          <a:cs typeface="Calibri" pitchFamily="34" charset="-120"/>
-                        </a:rPr>
-                        <a:t>6</a:t>
-                      </a:r>
-                      <a:endParaRPr lang="en-US" sz="1100" dirty="0">
-                        <a:latin typeface="Calibri" charset="0"/>
-                        <a:ea typeface="Calibri" charset="0"/>
-                        <a:cs typeface="Calibri" charset="0"/>
-                      </a:endParaRPr>
-                    </a:p>
-                  </a:txBody>
-                  <a:tcPr marL="101600" marR="101600" marT="63500" marB="63500" anchor="ctr">
-                    <a:lnL w="9525" cap="flat" cmpd="sng" algn="ctr">
-                      <a:solidFill>
-                        <a:srgbClr val="D8DEE2"/>
-                      </a:solidFill>
-                      <a:prstDash val="solid"/>
-                      <a:round/>
-                      <a:headEnd type="none" w="med" len="med"/>
-                      <a:tailEnd type="none" w="med" len="med"/>
-                    </a:lnL>
-                    <a:lnR w="9525" cap="flat" cmpd="sng" algn="ctr">
-                      <a:solidFill>
-                        <a:srgbClr val="D8DEE2"/>
-                      </a:solidFill>
-                      <a:prstDash val="solid"/>
-                      <a:round/>
-                      <a:headEnd type="none" w="med" len="med"/>
-                      <a:tailEnd type="none" w="med" len="med"/>
-                    </a:lnR>
-                    <a:lnT w="9525" cap="flat" cmpd="sng" algn="ctr">
-                      <a:solidFill>
-                        <a:srgbClr val="D8DEE2"/>
-                      </a:solidFill>
-                      <a:prstDash val="solid"/>
-                      <a:round/>
-                      <a:headEnd type="none" w="med" len="med"/>
-                      <a:tailEnd type="none" w="med" len="med"/>
-                    </a:lnT>
-                    <a:lnB w="9525" cap="flat" cmpd="sng" algn="ctr">
-                      <a:solidFill>
-                        <a:srgbClr val="D8DEE2"/>
-                      </a:solidFill>
-                      <a:prstDash val="solid"/>
-                      <a:round/>
-                      <a:headEnd type="none" w="med" len="med"/>
-                      <a:tailEnd type="none" w="med" len="med"/>
-                    </a:lnB>
-                  </a:tcPr>
-                </a:tc>
-                <a:tc>
-                  <a:txBody>
-                    <a:bodyPr/>
-                    <a:lstStyle/>
-                    <a:p>
-                      <a:pPr indent="0" marL="0">
-                        <a:buNone/>
-                      </a:pPr>
-                      <a:r>
-                        <a:rPr lang="en-US" sz="1100" b="1" dirty="0">
-                          <a:solidFill>
-                            <a:srgbClr val="1A2733"/>
-                          </a:solidFill>
-                          <a:latin typeface="Calibri" pitchFamily="34" charset="0"/>
-                          <a:ea typeface="Calibri" pitchFamily="34" charset="-122"/>
-                          <a:cs typeface="Calibri" pitchFamily="34" charset="-120"/>
-                        </a:rPr>
-                        <a:t>Интеграция</a:t>
-                      </a:r>
-                      <a:endParaRPr lang="en-US" sz="1100" dirty="0">
-                        <a:latin typeface="Calibri" charset="0"/>
-                        <a:ea typeface="Calibri" charset="0"/>
-                        <a:cs typeface="Calibri" charset="0"/>
-                      </a:endParaRPr>
-                    </a:p>
-                  </a:txBody>
-                  <a:tcPr marL="101600" marR="101600" marT="63500" marB="63500" anchor="ctr">
-                    <a:lnL w="9525" cap="flat" cmpd="sng" algn="ctr">
-                      <a:solidFill>
-                        <a:srgbClr val="D8DEE2"/>
-                      </a:solidFill>
-                      <a:prstDash val="solid"/>
-                      <a:round/>
-                      <a:headEnd type="none" w="med" len="med"/>
-                      <a:tailEnd type="none" w="med" len="med"/>
-                    </a:lnL>
-                    <a:lnR w="9525" cap="flat" cmpd="sng" algn="ctr">
-                      <a:solidFill>
-                        <a:srgbClr val="D8DEE2"/>
-                      </a:solidFill>
-                      <a:prstDash val="solid"/>
-                      <a:round/>
-                      <a:headEnd type="none" w="med" len="med"/>
-                      <a:tailEnd type="none" w="med" len="med"/>
-                    </a:lnR>
-                    <a:lnT w="9525" cap="flat" cmpd="sng" algn="ctr">
-                      <a:solidFill>
-                        <a:srgbClr val="D8DEE2"/>
-                      </a:solidFill>
-                      <a:prstDash val="solid"/>
-                      <a:round/>
-                      <a:headEnd type="none" w="med" len="med"/>
-                      <a:tailEnd type="none" w="med" len="med"/>
-                    </a:lnT>
-                    <a:lnB w="9525" cap="flat" cmpd="sng" algn="ctr">
-                      <a:solidFill>
-                        <a:srgbClr val="D8DEE2"/>
-                      </a:solidFill>
-                      <a:prstDash val="solid"/>
-                      <a:round/>
-                      <a:headEnd type="none" w="med" len="med"/>
-                      <a:tailEnd type="none" w="med" len="med"/>
-                    </a:lnB>
-                  </a:tcPr>
-                </a:tc>
-                <a:tc>
-                  <a:txBody>
-                    <a:bodyPr/>
-                    <a:lstStyle/>
-                    <a:p>
-                      <a:pPr algn="ctr" indent="0" marL="0">
-                        <a:buNone/>
-                      </a:pPr>
-                      <a:r>
-                        <a:rPr lang="en-US" sz="1050" b="1" dirty="0">
-                          <a:solidFill>
-                            <a:srgbClr val="C97A1A"/>
-                          </a:solidFill>
-                          <a:latin typeface="Calibri" pitchFamily="34" charset="0"/>
-                          <a:ea typeface="Calibri" pitchFamily="34" charset="-122"/>
-                          <a:cs typeface="Calibri" pitchFamily="34" charset="-120"/>
-                        </a:rPr>
-                        <a:t>Высокий</a:t>
-                      </a:r>
-                      <a:endParaRPr lang="en-US" sz="1050" dirty="0">
-                        <a:latin typeface="Calibri" charset="0"/>
-                        <a:ea typeface="Calibri" charset="0"/>
-                        <a:cs typeface="Calibri" charset="0"/>
-                      </a:endParaRPr>
-                    </a:p>
-                  </a:txBody>
-                  <a:tcPr marL="101600" marR="101600" marT="63500" marB="63500" anchor="ctr">
-                    <a:lnL w="9525" cap="flat" cmpd="sng" algn="ctr">
-                      <a:solidFill>
-                        <a:srgbClr val="D8DEE2"/>
-                      </a:solidFill>
-                      <a:prstDash val="solid"/>
-                      <a:round/>
-                      <a:headEnd type="none" w="med" len="med"/>
-                      <a:tailEnd type="none" w="med" len="med"/>
-                    </a:lnL>
-                    <a:lnR w="9525" cap="flat" cmpd="sng" algn="ctr">
-                      <a:solidFill>
-                        <a:srgbClr val="D8DEE2"/>
-                      </a:solidFill>
-                      <a:prstDash val="solid"/>
-                      <a:round/>
-                      <a:headEnd type="none" w="med" len="med"/>
-                      <a:tailEnd type="none" w="med" len="med"/>
-                    </a:lnR>
-                    <a:lnT w="9525" cap="flat" cmpd="sng" algn="ctr">
-                      <a:solidFill>
-                        <a:srgbClr val="D8DEE2"/>
-                      </a:solidFill>
-                      <a:prstDash val="solid"/>
-                      <a:round/>
-                      <a:headEnd type="none" w="med" len="med"/>
-                      <a:tailEnd type="none" w="med" len="med"/>
-                    </a:lnT>
-                    <a:lnB w="9525" cap="flat" cmpd="sng" algn="ctr">
-                      <a:solidFill>
-                        <a:srgbClr val="D8DEE2"/>
-                      </a:solidFill>
-                      <a:prstDash val="solid"/>
-                      <a:round/>
-                      <a:headEnd type="none" w="med" len="med"/>
-                      <a:tailEnd type="none" w="med" len="med"/>
-                    </a:lnB>
-                  </a:tcPr>
-                </a:tc>
-                <a:tc>
-                  <a:txBody>
-                    <a:bodyPr/>
-                    <a:lstStyle/>
-                    <a:p>
-                      <a:pPr indent="0" marL="0">
-                        <a:buNone/>
-                      </a:pPr>
-                      <a:r>
-                        <a:rPr lang="en-US" sz="1100" dirty="0">
-                          <a:solidFill>
-                            <a:srgbClr val="5B6B7A"/>
-                          </a:solidFill>
-                          <a:latin typeface="Calibri" pitchFamily="34" charset="0"/>
-                          <a:ea typeface="Calibri" pitchFamily="34" charset="-122"/>
-                          <a:cs typeface="Calibri" pitchFamily="34" charset="-120"/>
-                        </a:rPr>
-                        <a:t>КХД — расширяется ли состав таблиц/витрин, или периметр остаётся как в пилоте?</a:t>
-                      </a:r>
-                      <a:endParaRPr lang="en-US" sz="1100" dirty="0">
-                        <a:latin typeface="Calibri" charset="0"/>
-                        <a:ea typeface="Calibri" charset="0"/>
-                        <a:cs typeface="Calibri" charset="0"/>
-                      </a:endParaRPr>
-                    </a:p>
-                  </a:txBody>
-                  <a:tcPr marL="101600" marR="101600" marT="63500" marB="63500" anchor="ctr">
-                    <a:lnL w="9525" cap="flat" cmpd="sng" algn="ctr">
-                      <a:solidFill>
-                        <a:srgbClr val="D8DEE2"/>
-                      </a:solidFill>
-                      <a:prstDash val="solid"/>
-                      <a:round/>
-                      <a:headEnd type="none" w="med" len="med"/>
-                      <a:tailEnd type="none" w="med" len="med"/>
-                    </a:lnL>
-                    <a:lnR w="9525" cap="flat" cmpd="sng" algn="ctr">
-                      <a:solidFill>
-                        <a:srgbClr val="D8DEE2"/>
-                      </a:solidFill>
-                      <a:prstDash val="solid"/>
-                      <a:round/>
-                      <a:headEnd type="none" w="med" len="med"/>
-                      <a:tailEnd type="none" w="med" len="med"/>
-                    </a:lnR>
-                    <a:lnT w="9525" cap="flat" cmpd="sng" algn="ctr">
-                      <a:solidFill>
-                        <a:srgbClr val="D8DEE2"/>
-                      </a:solidFill>
-                      <a:prstDash val="solid"/>
-                      <a:round/>
-                      <a:headEnd type="none" w="med" len="med"/>
-                      <a:tailEnd type="none" w="med" len="med"/>
-                    </a:lnT>
-                    <a:lnB w="9525" cap="flat" cmpd="sng" algn="ctr">
-                      <a:solidFill>
-                        <a:srgbClr val="D8DEE2"/>
-                      </a:solidFill>
-                      <a:prstDash val="solid"/>
-                      <a:round/>
-                      <a:headEnd type="none" w="med" len="med"/>
-                      <a:tailEnd type="none" w="med" len="med"/>
-                    </a:lnB>
-                  </a:tcPr>
-                </a:tc>
-              </a:tr>
-              <a:tr h="497840">
-                <a:tc>
-                  <a:txBody>
-                    <a:bodyPr/>
-                    <a:lstStyle/>
-                    <a:p>
-                      <a:pPr algn="ctr" indent="0" marL="0">
-                        <a:buNone/>
-                      </a:pPr>
-                      <a:r>
-                        <a:rPr lang="en-US" sz="1100" dirty="0">
-                          <a:solidFill>
-                            <a:srgbClr val="5B6B7A"/>
-                          </a:solidFill>
-                          <a:latin typeface="Calibri" pitchFamily="34" charset="0"/>
-                          <a:ea typeface="Calibri" pitchFamily="34" charset="-122"/>
-                          <a:cs typeface="Calibri" pitchFamily="34" charset="-120"/>
-                        </a:rPr>
-                        <a:t>7</a:t>
-                      </a:r>
-                      <a:endParaRPr lang="en-US" sz="1100" dirty="0">
-                        <a:latin typeface="Calibri" charset="0"/>
-                        <a:ea typeface="Calibri" charset="0"/>
-                        <a:cs typeface="Calibri" charset="0"/>
-                      </a:endParaRPr>
-                    </a:p>
-                  </a:txBody>
-                  <a:tcPr marL="101600" marR="101600" marT="63500" marB="63500" anchor="ctr">
-                    <a:lnL w="9525" cap="flat" cmpd="sng" algn="ctr">
-                      <a:solidFill>
-                        <a:srgbClr val="D8DEE2"/>
-                      </a:solidFill>
-                      <a:prstDash val="solid"/>
-                      <a:round/>
-                      <a:headEnd type="none" w="med" len="med"/>
-                      <a:tailEnd type="none" w="med" len="med"/>
-                    </a:lnL>
-                    <a:lnR w="9525" cap="flat" cmpd="sng" algn="ctr">
-                      <a:solidFill>
-                        <a:srgbClr val="D8DEE2"/>
-                      </a:solidFill>
-                      <a:prstDash val="solid"/>
-                      <a:round/>
-                      <a:headEnd type="none" w="med" len="med"/>
-                      <a:tailEnd type="none" w="med" len="med"/>
-                    </a:lnR>
-                    <a:lnT w="9525" cap="flat" cmpd="sng" algn="ctr">
-                      <a:solidFill>
-                        <a:srgbClr val="D8DEE2"/>
-                      </a:solidFill>
-                      <a:prstDash val="solid"/>
-                      <a:round/>
-                      <a:headEnd type="none" w="med" len="med"/>
-                      <a:tailEnd type="none" w="med" len="med"/>
-                    </a:lnT>
-                    <a:lnB w="9525" cap="flat" cmpd="sng" algn="ctr">
-                      <a:solidFill>
-                        <a:srgbClr val="D8DEE2"/>
-                      </a:solidFill>
-                      <a:prstDash val="solid"/>
-                      <a:round/>
-                      <a:headEnd type="none" w="med" len="med"/>
-                      <a:tailEnd type="none" w="med" len="med"/>
-                    </a:lnB>
-                  </a:tcPr>
-                </a:tc>
-                <a:tc>
-                  <a:txBody>
-                    <a:bodyPr/>
-                    <a:lstStyle/>
-                    <a:p>
-                      <a:pPr indent="0" marL="0">
-                        <a:buNone/>
-                      </a:pPr>
-                      <a:r>
-                        <a:rPr lang="en-US" sz="1100" b="1" dirty="0">
-                          <a:solidFill>
-                            <a:srgbClr val="1A2733"/>
-                          </a:solidFill>
-                          <a:latin typeface="Calibri" pitchFamily="34" charset="0"/>
-                          <a:ea typeface="Calibri" pitchFamily="34" charset="-122"/>
-                          <a:cs typeface="Calibri" pitchFamily="34" charset="-120"/>
-                        </a:rPr>
-                        <a:t>Доступ и роли</a:t>
-                      </a:r>
-                      <a:endParaRPr lang="en-US" sz="1100" dirty="0">
-                        <a:latin typeface="Calibri" charset="0"/>
-                        <a:ea typeface="Calibri" charset="0"/>
-                        <a:cs typeface="Calibri" charset="0"/>
-                      </a:endParaRPr>
-                    </a:p>
-                  </a:txBody>
-                  <a:tcPr marL="101600" marR="101600" marT="63500" marB="63500" anchor="ctr">
-                    <a:lnL w="9525" cap="flat" cmpd="sng" algn="ctr">
-                      <a:solidFill>
-                        <a:srgbClr val="D8DEE2"/>
-                      </a:solidFill>
-                      <a:prstDash val="solid"/>
-                      <a:round/>
-                      <a:headEnd type="none" w="med" len="med"/>
-                      <a:tailEnd type="none" w="med" len="med"/>
-                    </a:lnL>
-                    <a:lnR w="9525" cap="flat" cmpd="sng" algn="ctr">
-                      <a:solidFill>
-                        <a:srgbClr val="D8DEE2"/>
-                      </a:solidFill>
-                      <a:prstDash val="solid"/>
-                      <a:round/>
-                      <a:headEnd type="none" w="med" len="med"/>
-                      <a:tailEnd type="none" w="med" len="med"/>
-                    </a:lnR>
-                    <a:lnT w="9525" cap="flat" cmpd="sng" algn="ctr">
-                      <a:solidFill>
-                        <a:srgbClr val="D8DEE2"/>
-                      </a:solidFill>
-                      <a:prstDash val="solid"/>
-                      <a:round/>
-                      <a:headEnd type="none" w="med" len="med"/>
-                      <a:tailEnd type="none" w="med" len="med"/>
-                    </a:lnT>
-                    <a:lnB w="9525" cap="flat" cmpd="sng" algn="ctr">
-                      <a:solidFill>
-                        <a:srgbClr val="D8DEE2"/>
-                      </a:solidFill>
-                      <a:prstDash val="solid"/>
-                      <a:round/>
-                      <a:headEnd type="none" w="med" len="med"/>
-                      <a:tailEnd type="none" w="med" len="med"/>
-                    </a:lnB>
-                  </a:tcPr>
-                </a:tc>
-                <a:tc>
-                  <a:txBody>
-                    <a:bodyPr/>
-                    <a:lstStyle/>
-                    <a:p>
-                      <a:pPr algn="ctr" indent="0" marL="0">
-                        <a:buNone/>
-                      </a:pPr>
-                      <a:r>
-                        <a:rPr lang="en-US" sz="1050" b="1" dirty="0">
-                          <a:solidFill>
-                            <a:srgbClr val="5B6B7A"/>
-                          </a:solidFill>
-                          <a:latin typeface="Calibri" pitchFamily="34" charset="0"/>
-                          <a:ea typeface="Calibri" pitchFamily="34" charset="-122"/>
-                          <a:cs typeface="Calibri" pitchFamily="34" charset="-120"/>
-                        </a:rPr>
-                        <a:t>Нормальный</a:t>
-                      </a:r>
-                      <a:endParaRPr lang="en-US" sz="1050" dirty="0">
-                        <a:latin typeface="Calibri" charset="0"/>
-                        <a:ea typeface="Calibri" charset="0"/>
-                        <a:cs typeface="Calibri" charset="0"/>
-                      </a:endParaRPr>
-                    </a:p>
-                  </a:txBody>
-                  <a:tcPr marL="101600" marR="101600" marT="63500" marB="63500" anchor="ctr">
-                    <a:lnL w="9525" cap="flat" cmpd="sng" algn="ctr">
-                      <a:solidFill>
-                        <a:srgbClr val="D8DEE2"/>
-                      </a:solidFill>
-                      <a:prstDash val="solid"/>
-                      <a:round/>
-                      <a:headEnd type="none" w="med" len="med"/>
-                      <a:tailEnd type="none" w="med" len="med"/>
-                    </a:lnL>
-                    <a:lnR w="9525" cap="flat" cmpd="sng" algn="ctr">
-                      <a:solidFill>
-                        <a:srgbClr val="D8DEE2"/>
-                      </a:solidFill>
-                      <a:prstDash val="solid"/>
-                      <a:round/>
-                      <a:headEnd type="none" w="med" len="med"/>
-                      <a:tailEnd type="none" w="med" len="med"/>
-                    </a:lnR>
-                    <a:lnT w="9525" cap="flat" cmpd="sng" algn="ctr">
-                      <a:solidFill>
-                        <a:srgbClr val="D8DEE2"/>
-                      </a:solidFill>
-                      <a:prstDash val="solid"/>
-                      <a:round/>
-                      <a:headEnd type="none" w="med" len="med"/>
-                      <a:tailEnd type="none" w="med" len="med"/>
-                    </a:lnT>
-                    <a:lnB w="9525" cap="flat" cmpd="sng" algn="ctr">
-                      <a:solidFill>
-                        <a:srgbClr val="D8DEE2"/>
-                      </a:solidFill>
-                      <a:prstDash val="solid"/>
-                      <a:round/>
-                      <a:headEnd type="none" w="med" len="med"/>
-                      <a:tailEnd type="none" w="med" len="med"/>
-                    </a:lnB>
-                  </a:tcPr>
-                </a:tc>
-                <a:tc>
-                  <a:txBody>
-                    <a:bodyPr/>
-                    <a:lstStyle/>
-                    <a:p>
-                      <a:pPr indent="0" marL="0">
-                        <a:buNone/>
-                      </a:pPr>
-                      <a:r>
-                        <a:rPr lang="en-US" sz="1100" dirty="0">
-                          <a:solidFill>
-                            <a:srgbClr val="5B6B7A"/>
-                          </a:solidFill>
-                          <a:latin typeface="Calibri" pitchFamily="34" charset="0"/>
-                          <a:ea typeface="Calibri" pitchFamily="34" charset="-122"/>
-                          <a:cs typeface="Calibri" pitchFamily="34" charset="-120"/>
-                        </a:rPr>
-                        <a:t>Реальная оргструктура: подразделения/роли с числом пользователей — факт, не гипотеза из мастер-ТЗ.</a:t>
-                      </a:r>
-                      <a:endParaRPr lang="en-US" sz="1100" dirty="0">
-                        <a:latin typeface="Calibri" charset="0"/>
-                        <a:ea typeface="Calibri" charset="0"/>
-                        <a:cs typeface="Calibri" charset="0"/>
-                      </a:endParaRPr>
-                    </a:p>
-                  </a:txBody>
-                  <a:tcPr marL="101600" marR="101600" marT="63500" marB="63500" anchor="ctr">
-                    <a:lnL w="9525" cap="flat" cmpd="sng" algn="ctr">
-                      <a:solidFill>
-                        <a:srgbClr val="D8DEE2"/>
-                      </a:solidFill>
-                      <a:prstDash val="solid"/>
-                      <a:round/>
-                      <a:headEnd type="none" w="med" len="med"/>
-                      <a:tailEnd type="none" w="med" len="med"/>
-                    </a:lnL>
-                    <a:lnR w="9525" cap="flat" cmpd="sng" algn="ctr">
-                      <a:solidFill>
-                        <a:srgbClr val="D8DEE2"/>
-                      </a:solidFill>
-                      <a:prstDash val="solid"/>
-                      <a:round/>
-                      <a:headEnd type="none" w="med" len="med"/>
-                      <a:tailEnd type="none" w="med" len="med"/>
-                    </a:lnR>
-                    <a:lnT w="9525" cap="flat" cmpd="sng" algn="ctr">
-                      <a:solidFill>
-                        <a:srgbClr val="D8DEE2"/>
-                      </a:solidFill>
-                      <a:prstDash val="solid"/>
-                      <a:round/>
-                      <a:headEnd type="none" w="med" len="med"/>
-                      <a:tailEnd type="none" w="med" len="med"/>
-                    </a:lnT>
-                    <a:lnB w="9525" cap="flat" cmpd="sng" algn="ctr">
-                      <a:solidFill>
-                        <a:srgbClr val="D8DEE2"/>
-                      </a:solidFill>
-                      <a:prstDash val="solid"/>
-                      <a:round/>
-                      <a:headEnd type="none" w="med" len="med"/>
-                      <a:tailEnd type="none" w="med" len="med"/>
-                    </a:lnB>
-                  </a:tcPr>
-                </a:tc>
-              </a:tr>
-              <a:tr h="497840">
-                <a:tc>
-                  <a:txBody>
-                    <a:bodyPr/>
-                    <a:lstStyle/>
-                    <a:p>
-                      <a:pPr algn="ctr" indent="0" marL="0">
-                        <a:buNone/>
-                      </a:pPr>
-                      <a:r>
-                        <a:rPr lang="en-US" sz="1100" dirty="0">
-                          <a:solidFill>
-                            <a:srgbClr val="5B6B7A"/>
-                          </a:solidFill>
-                          <a:latin typeface="Calibri" pitchFamily="34" charset="0"/>
-                          <a:ea typeface="Calibri" pitchFamily="34" charset="-122"/>
-                          <a:cs typeface="Calibri" pitchFamily="34" charset="-120"/>
-                        </a:rPr>
-                        <a:t>12</a:t>
-                      </a:r>
-                      <a:endParaRPr lang="en-US" sz="1100" dirty="0">
-                        <a:latin typeface="Calibri" charset="0"/>
-                        <a:ea typeface="Calibri" charset="0"/>
-                        <a:cs typeface="Calibri" charset="0"/>
-                      </a:endParaRPr>
-                    </a:p>
-                  </a:txBody>
-                  <a:tcPr marL="101600" marR="101600" marT="63500" marB="63500" anchor="ctr">
-                    <a:lnL w="9525" cap="flat" cmpd="sng" algn="ctr">
-                      <a:solidFill>
-                        <a:srgbClr val="D8DEE2"/>
-                      </a:solidFill>
-                      <a:prstDash val="solid"/>
-                      <a:round/>
-                      <a:headEnd type="none" w="med" len="med"/>
-                      <a:tailEnd type="none" w="med" len="med"/>
-                    </a:lnL>
-                    <a:lnR w="9525" cap="flat" cmpd="sng" algn="ctr">
-                      <a:solidFill>
-                        <a:srgbClr val="D8DEE2"/>
-                      </a:solidFill>
-                      <a:prstDash val="solid"/>
-                      <a:round/>
-                      <a:headEnd type="none" w="med" len="med"/>
-                      <a:tailEnd type="none" w="med" len="med"/>
-                    </a:lnR>
-                    <a:lnT w="9525" cap="flat" cmpd="sng" algn="ctr">
-                      <a:solidFill>
-                        <a:srgbClr val="D8DEE2"/>
-                      </a:solidFill>
-                      <a:prstDash val="solid"/>
-                      <a:round/>
-                      <a:headEnd type="none" w="med" len="med"/>
-                      <a:tailEnd type="none" w="med" len="med"/>
-                    </a:lnT>
-                    <a:lnB w="9525" cap="flat" cmpd="sng" algn="ctr">
-                      <a:solidFill>
-                        <a:srgbClr val="D8DEE2"/>
-                      </a:solidFill>
-                      <a:prstDash val="solid"/>
-                      <a:round/>
-                      <a:headEnd type="none" w="med" len="med"/>
-                      <a:tailEnd type="none" w="med" len="med"/>
-                    </a:lnB>
-                  </a:tcPr>
-                </a:tc>
-                <a:tc>
-                  <a:txBody>
-                    <a:bodyPr/>
-                    <a:lstStyle/>
-                    <a:p>
-                      <a:pPr indent="0" marL="0">
-                        <a:buNone/>
-                      </a:pPr>
-                      <a:r>
-                        <a:rPr lang="en-US" sz="1100" b="1" dirty="0">
-                          <a:solidFill>
-                            <a:srgbClr val="1A2733"/>
-                          </a:solidFill>
-                          <a:latin typeface="Calibri" pitchFamily="34" charset="0"/>
-                          <a:ea typeface="Calibri" pitchFamily="34" charset="-122"/>
-                          <a:cs typeface="Calibri" pitchFamily="34" charset="-120"/>
-                        </a:rPr>
-                        <a:t>Общее</a:t>
-                      </a:r>
-                      <a:endParaRPr lang="en-US" sz="1100" dirty="0">
-                        <a:latin typeface="Calibri" charset="0"/>
-                        <a:ea typeface="Calibri" charset="0"/>
-                        <a:cs typeface="Calibri" charset="0"/>
-                      </a:endParaRPr>
-                    </a:p>
-                  </a:txBody>
-                  <a:tcPr marL="101600" marR="101600" marT="63500" marB="63500" anchor="ctr">
-                    <a:lnL w="9525" cap="flat" cmpd="sng" algn="ctr">
-                      <a:solidFill>
-                        <a:srgbClr val="D8DEE2"/>
-                      </a:solidFill>
-                      <a:prstDash val="solid"/>
-                      <a:round/>
-                      <a:headEnd type="none" w="med" len="med"/>
-                      <a:tailEnd type="none" w="med" len="med"/>
-                    </a:lnL>
-                    <a:lnR w="9525" cap="flat" cmpd="sng" algn="ctr">
-                      <a:solidFill>
-                        <a:srgbClr val="D8DEE2"/>
-                      </a:solidFill>
-                      <a:prstDash val="solid"/>
-                      <a:round/>
-                      <a:headEnd type="none" w="med" len="med"/>
-                      <a:tailEnd type="none" w="med" len="med"/>
-                    </a:lnR>
-                    <a:lnT w="9525" cap="flat" cmpd="sng" algn="ctr">
-                      <a:solidFill>
-                        <a:srgbClr val="D8DEE2"/>
-                      </a:solidFill>
-                      <a:prstDash val="solid"/>
-                      <a:round/>
-                      <a:headEnd type="none" w="med" len="med"/>
-                      <a:tailEnd type="none" w="med" len="med"/>
-                    </a:lnT>
-                    <a:lnB w="9525" cap="flat" cmpd="sng" algn="ctr">
-                      <a:solidFill>
-                        <a:srgbClr val="D8DEE2"/>
-                      </a:solidFill>
-                      <a:prstDash val="solid"/>
-                      <a:round/>
-                      <a:headEnd type="none" w="med" len="med"/>
-                      <a:tailEnd type="none" w="med" len="med"/>
-                    </a:lnB>
-                  </a:tcPr>
-                </a:tc>
-                <a:tc>
-                  <a:txBody>
-                    <a:bodyPr/>
-                    <a:lstStyle/>
-                    <a:p>
-                      <a:pPr algn="ctr" indent="0" marL="0">
-                        <a:buNone/>
-                      </a:pPr>
-                      <a:r>
-                        <a:rPr lang="en-US" sz="1050" b="1" dirty="0">
-                          <a:solidFill>
-                            <a:srgbClr val="5B6B7A"/>
-                          </a:solidFill>
-                          <a:latin typeface="Calibri" pitchFamily="34" charset="0"/>
-                          <a:ea typeface="Calibri" pitchFamily="34" charset="-122"/>
-                          <a:cs typeface="Calibri" pitchFamily="34" charset="-120"/>
-                        </a:rPr>
-                        <a:t>Нормальный</a:t>
-                      </a:r>
-                      <a:endParaRPr lang="en-US" sz="1050" dirty="0">
-                        <a:latin typeface="Calibri" charset="0"/>
-                        <a:ea typeface="Calibri" charset="0"/>
-                        <a:cs typeface="Calibri" charset="0"/>
-                      </a:endParaRPr>
-                    </a:p>
-                  </a:txBody>
-                  <a:tcPr marL="101600" marR="101600" marT="63500" marB="63500" anchor="ctr">
-                    <a:lnL w="9525" cap="flat" cmpd="sng" algn="ctr">
-                      <a:solidFill>
-                        <a:srgbClr val="D8DEE2"/>
-                      </a:solidFill>
-                      <a:prstDash val="solid"/>
-                      <a:round/>
-                      <a:headEnd type="none" w="med" len="med"/>
-                      <a:tailEnd type="none" w="med" len="med"/>
-                    </a:lnL>
-                    <a:lnR w="9525" cap="flat" cmpd="sng" algn="ctr">
-                      <a:solidFill>
-                        <a:srgbClr val="D8DEE2"/>
-                      </a:solidFill>
-                      <a:prstDash val="solid"/>
-                      <a:round/>
-                      <a:headEnd type="none" w="med" len="med"/>
-                      <a:tailEnd type="none" w="med" len="med"/>
-                    </a:lnR>
-                    <a:lnT w="9525" cap="flat" cmpd="sng" algn="ctr">
-                      <a:solidFill>
-                        <a:srgbClr val="D8DEE2"/>
-                      </a:solidFill>
-                      <a:prstDash val="solid"/>
-                      <a:round/>
-                      <a:headEnd type="none" w="med" len="med"/>
-                      <a:tailEnd type="none" w="med" len="med"/>
-                    </a:lnT>
-                    <a:lnB w="9525" cap="flat" cmpd="sng" algn="ctr">
-                      <a:solidFill>
-                        <a:srgbClr val="D8DEE2"/>
-                      </a:solidFill>
-                      <a:prstDash val="solid"/>
-                      <a:round/>
-                      <a:headEnd type="none" w="med" len="med"/>
-                      <a:tailEnd type="none" w="med" len="med"/>
-                    </a:lnB>
-                  </a:tcPr>
-                </a:tc>
-                <a:tc>
-                  <a:txBody>
-                    <a:bodyPr/>
-                    <a:lstStyle/>
-                    <a:p>
-                      <a:pPr indent="0" marL="0">
-                        <a:buNone/>
-                      </a:pPr>
-                      <a:r>
-                        <a:rPr lang="en-US" sz="1100" dirty="0">
-                          <a:solidFill>
-                            <a:srgbClr val="5B6B7A"/>
-                          </a:solidFill>
-                          <a:latin typeface="Calibri" pitchFamily="34" charset="0"/>
-                          <a:ea typeface="Calibri" pitchFamily="34" charset="-122"/>
-                          <a:cs typeface="Calibri" pitchFamily="34" charset="-120"/>
-                        </a:rPr>
-                        <a:t>Кто со стороны Д8 — владелец процесса на фазе П4 (промышленная эксплуатация)?</a:t>
-                      </a:r>
-                      <a:endParaRPr lang="en-US" sz="1100" dirty="0">
-                        <a:latin typeface="Calibri" charset="0"/>
-                        <a:ea typeface="Calibri" charset="0"/>
-                        <a:cs typeface="Calibri" charset="0"/>
-                      </a:endParaRPr>
-                    </a:p>
-                  </a:txBody>
-                  <a:tcPr marL="101600" marR="101600" marT="63500" marB="63500" anchor="ctr">
-                    <a:lnL w="9525" cap="flat" cmpd="sng" algn="ctr">
-                      <a:solidFill>
-                        <a:srgbClr val="D8DEE2"/>
-                      </a:solidFill>
-                      <a:prstDash val="solid"/>
-                      <a:round/>
-                      <a:headEnd type="none" w="med" len="med"/>
-                      <a:tailEnd type="none" w="med" len="med"/>
-                    </a:lnL>
-                    <a:lnR w="9525" cap="flat" cmpd="sng" algn="ctr">
-                      <a:solidFill>
-                        <a:srgbClr val="D8DEE2"/>
-                      </a:solidFill>
-                      <a:prstDash val="solid"/>
-                      <a:round/>
-                      <a:headEnd type="none" w="med" len="med"/>
-                      <a:tailEnd type="none" w="med" len="med"/>
-                    </a:lnR>
-                    <a:lnT w="9525" cap="flat" cmpd="sng" algn="ctr">
-                      <a:solidFill>
-                        <a:srgbClr val="D8DEE2"/>
-                      </a:solidFill>
-                      <a:prstDash val="solid"/>
-                      <a:round/>
-                      <a:headEnd type="none" w="med" len="med"/>
-                      <a:tailEnd type="none" w="med" len="med"/>
-                    </a:lnT>
-                    <a:lnB w="9525" cap="flat" cmpd="sng" algn="ctr">
-                      <a:solidFill>
-                        <a:srgbClr val="D8DEE2"/>
-                      </a:solidFill>
-                      <a:prstDash val="solid"/>
-                      <a:round/>
-                      <a:headEnd type="none" w="med" len="med"/>
-                      <a:tailEnd type="none" w="med" len="med"/>
-                    </a:lnB>
-                  </a:tcPr>
-                </a:tc>
-              </a:tr>
-            </a:tbl>
-          </a:graphicData>
-        </a:graphic>
-      </p:graphicFrame>
-      <p:sp>
-        <p:nvSpPr>
-          <p:cNvPr id="6" name="Text 3"/>
-          <p:cNvSpPr txBox="1"/>
-          <p:nvPr/>
-        </p:nvSpPr>
-        <p:spPr>
-          <a:xfrm>
-            <a:off x="10881360" y="6473952"/>
-            <a:ext cx="822960" cy="274320"/>
-          </a:xfrm>
-          <a:prstGeom prst="rect">
-            <a:avLst/>
-          </a:prstGeom>
-          <a:noFill/>
-          <a:ln/>
-        </p:spPr>
-        <p:txBody>
-          <a:bodyPr wrap="square" lIns="0" tIns="0" rIns="0" bIns="0" rtlCol="0" anchor="ctr"/>
-          <a:lstStyle/>
-          <a:p>
-            <a:pPr algn="r" indent="0" marL="0">
-              <a:buNone/>
-            </a:pPr>
-            <a:r>
-              <a:rPr lang="en-US" sz="1050" dirty="0">
-                <a:solidFill>
-                  <a:srgbClr val="8C99A6"/>
-                </a:solidFill>
-                <a:latin typeface="Calibri" pitchFamily="34" charset="0"/>
-                <a:ea typeface="Calibri" pitchFamily="34" charset="-122"/>
-                <a:cs typeface="Calibri" pitchFamily="34" charset="-120"/>
-              </a:rPr>
-              <a:t>4 / 5</a:t>
+              <a:t>4 / 6</a:t>
             </a:r>
             <a:endParaRPr lang="en-US" sz="1050" dirty="0"/>
           </a:p>
@@ -9929,7 +7601,866 @@
                 <a:ea typeface="Calibri" pitchFamily="34" charset="-122"/>
                 <a:cs typeface="Calibri" pitchFamily="34" charset="-120"/>
               </a:rPr>
-              <a:t>3 · НАШИ ВОПРОСЫ · ПО ПОЖЕЛАНИЯМ ЗАКАЗЧИКА</a:t>
+              <a:t>4 · НАШИ ВОПРОСЫ · ПО ВОЛНАМ</a:t>
+            </a:r>
+            <a:endParaRPr lang="en-US" sz="1100" dirty="0"/>
+          </a:p>
+        </p:txBody>
+      </p:sp>
+      <p:sp>
+        <p:nvSpPr>
+          <p:cNvPr id="3" name="Text 1"/>
+          <p:cNvSpPr txBox="1"/>
+          <p:nvPr/>
+        </p:nvSpPr>
+        <p:spPr>
+          <a:xfrm>
+            <a:off x="502920" y="621792"/>
+            <a:ext cx="11155680" cy="548640"/>
+          </a:xfrm>
+          <a:prstGeom prst="rect">
+            <a:avLst/>
+          </a:prstGeom>
+          <a:noFill/>
+          <a:ln/>
+        </p:spPr>
+        <p:txBody>
+          <a:bodyPr wrap="square" lIns="0" tIns="0" rIns="0" bIns="0" rtlCol="0" anchor="ctr"/>
+          <a:lstStyle/>
+          <a:p>
+            <a:pPr indent="0" marL="0">
+              <a:buNone/>
+            </a:pPr>
+            <a:r>
+              <a:rPr lang="en-US" sz="2700" b="1" dirty="0">
+                <a:solidFill>
+                  <a:srgbClr val="1A2733"/>
+                </a:solidFill>
+                <a:latin typeface="Cambria" pitchFamily="34" charset="0"/>
+                <a:ea typeface="Cambria" pitchFamily="34" charset="-122"/>
+                <a:cs typeface="Cambria" pitchFamily="34" charset="-120"/>
+              </a:rPr>
+              <a:t>Что нужно от заказчика по каждой волне</a:t>
+            </a:r>
+            <a:endParaRPr lang="en-US" sz="2700" dirty="0"/>
+          </a:p>
+        </p:txBody>
+      </p:sp>
+      <p:sp>
+        <p:nvSpPr>
+          <p:cNvPr id="4" name="Text 2"/>
+          <p:cNvSpPr txBox="1"/>
+          <p:nvPr/>
+        </p:nvSpPr>
+        <p:spPr>
+          <a:xfrm>
+            <a:off x="502920" y="1170432"/>
+            <a:ext cx="11155680" cy="365760"/>
+          </a:xfrm>
+          <a:prstGeom prst="rect">
+            <a:avLst/>
+          </a:prstGeom>
+          <a:noFill/>
+          <a:ln/>
+        </p:spPr>
+        <p:txBody>
+          <a:bodyPr wrap="square" lIns="0" tIns="0" rIns="0" bIns="0" rtlCol="0" anchor="ctr"/>
+          <a:lstStyle/>
+          <a:p>
+            <a:pPr indent="0" marL="0">
+              <a:buNone/>
+            </a:pPr>
+            <a:r>
+              <a:rPr lang="en-US" sz="1300" dirty="0">
+                <a:solidFill>
+                  <a:srgbClr val="5B6B7A"/>
+                </a:solidFill>
+                <a:latin typeface="Calibri" pitchFamily="34" charset="0"/>
+                <a:ea typeface="Calibri" pitchFamily="34" charset="-122"/>
+                <a:cs typeface="Calibri" pitchFamily="34" charset="-120"/>
+              </a:rPr>
+              <a:t>Один и тот же набор параметров на каждую волну: состав данных, витрины/коллекции, пользователи, роли</a:t>
+            </a:r>
+            <a:endParaRPr lang="en-US" sz="1300" dirty="0"/>
+          </a:p>
+        </p:txBody>
+      </p:sp>
+      <p:sp>
+        <p:nvSpPr>
+          <p:cNvPr id="5" name="Shape 3"/>
+          <p:cNvSpPr/>
+          <p:nvPr/>
+        </p:nvSpPr>
+        <p:spPr>
+          <a:xfrm>
+            <a:off x="502920" y="1691640"/>
+            <a:ext cx="3520440" cy="4526280"/>
+          </a:xfrm>
+          <a:prstGeom prst="roundRect">
+            <a:avLst>
+              <a:gd name="adj" fmla="val 1558"/>
+            </a:avLst>
+          </a:prstGeom>
+          <a:solidFill>
+            <a:srgbClr val="F4F6F7"/>
+          </a:solidFill>
+          <a:ln w="9525">
+            <a:solidFill>
+              <a:srgbClr val="D8DEE2"/>
+            </a:solidFill>
+            <a:prstDash val="solid"/>
+          </a:ln>
+        </p:spPr>
+      </p:sp>
+      <p:sp>
+        <p:nvSpPr>
+          <p:cNvPr id="6" name="Text 4"/>
+          <p:cNvSpPr txBox="1"/>
+          <p:nvPr/>
+        </p:nvSpPr>
+        <p:spPr>
+          <a:xfrm>
+            <a:off x="704088" y="1874520"/>
+            <a:ext cx="3118104" cy="256032"/>
+          </a:xfrm>
+          <a:prstGeom prst="rect">
+            <a:avLst/>
+          </a:prstGeom>
+          <a:noFill/>
+          <a:ln/>
+        </p:spPr>
+        <p:txBody>
+          <a:bodyPr wrap="square" lIns="0" tIns="0" rIns="0" bIns="0" rtlCol="0" anchor="ctr"/>
+          <a:lstStyle/>
+          <a:p>
+            <a:pPr indent="0" marL="0">
+              <a:buNone/>
+            </a:pPr>
+            <a:r>
+              <a:rPr lang="en-US" sz="1000" b="1" spc="100" kern="0" dirty="0">
+                <a:solidFill>
+                  <a:srgbClr val="C0392B"/>
+                </a:solidFill>
+                <a:latin typeface="Calibri" pitchFamily="34" charset="0"/>
+                <a:ea typeface="Calibri" pitchFamily="34" charset="-122"/>
+                <a:cs typeface="Calibri" pitchFamily="34" charset="-120"/>
+              </a:rPr>
+              <a:t>КРИТИЧНЫЙ</a:t>
+            </a:r>
+            <a:endParaRPr lang="en-US" sz="1000" dirty="0"/>
+          </a:p>
+        </p:txBody>
+      </p:sp>
+      <p:sp>
+        <p:nvSpPr>
+          <p:cNvPr id="7" name="Text 5"/>
+          <p:cNvSpPr txBox="1"/>
+          <p:nvPr/>
+        </p:nvSpPr>
+        <p:spPr>
+          <a:xfrm>
+            <a:off x="704088" y="2148840"/>
+            <a:ext cx="3118104" cy="594360"/>
+          </a:xfrm>
+          <a:prstGeom prst="rect">
+            <a:avLst/>
+          </a:prstGeom>
+          <a:noFill/>
+          <a:ln/>
+        </p:spPr>
+        <p:txBody>
+          <a:bodyPr wrap="square" lIns="0" tIns="0" rIns="0" bIns="0" rtlCol="0" anchor="ctr"/>
+          <a:lstStyle/>
+          <a:p>
+            <a:pPr indent="0" marL="0">
+              <a:lnSpc>
+                <a:spcPct val="105000"/>
+              </a:lnSpc>
+              <a:buNone/>
+            </a:pPr>
+            <a:r>
+              <a:rPr lang="en-US" sz="1550" b="1" dirty="0">
+                <a:solidFill>
+                  <a:srgbClr val="1A2733"/>
+                </a:solidFill>
+                <a:latin typeface="Cambria" pitchFamily="34" charset="0"/>
+                <a:ea typeface="Cambria" pitchFamily="34" charset="-122"/>
+                <a:cs typeface="Cambria" pitchFamily="34" charset="-120"/>
+              </a:rPr>
+              <a:t>Волна 1 — RAG-документы</a:t>
+            </a:r>
+            <a:endParaRPr lang="en-US" sz="1550" dirty="0"/>
+          </a:p>
+        </p:txBody>
+      </p:sp>
+      <p:sp>
+        <p:nvSpPr>
+          <p:cNvPr id="8" name="Text 6"/>
+          <p:cNvSpPr txBox="1"/>
+          <p:nvPr/>
+        </p:nvSpPr>
+        <p:spPr>
+          <a:xfrm>
+            <a:off x="704088" y="2834640"/>
+            <a:ext cx="3118104" cy="3200400"/>
+          </a:xfrm>
+          <a:prstGeom prst="rect">
+            <a:avLst/>
+          </a:prstGeom>
+          <a:noFill/>
+          <a:ln/>
+        </p:spPr>
+        <p:txBody>
+          <a:bodyPr wrap="square" lIns="0" tIns="0" rIns="0" bIns="0" rtlCol="0" anchor="t"/>
+          <a:lstStyle/>
+          <a:p>
+            <a:pPr marL="177800" indent="-177800">
+              <a:lnSpc>
+                <a:spcPct val="115000"/>
+              </a:lnSpc>
+              <a:spcAft>
+                <a:spcPts val="1000"/>
+              </a:spcAft>
+              <a:buSzPct val="100000"/>
+              <a:buChar char="•"/>
+            </a:pPr>
+            <a:r>
+              <a:rPr lang="en-US" sz="1100" dirty="0">
+                <a:solidFill>
+                  <a:srgbClr val="5B6B7A"/>
+                </a:solidFill>
+                <a:latin typeface="Calibri" pitchFamily="34" charset="0"/>
+                <a:ea typeface="Calibri" pitchFamily="34" charset="-122"/>
+                <a:cs typeface="Calibri" pitchFamily="34" charset="-120"/>
+              </a:rPr>
+              <a:t>Толкование: новые типы документов / улучшение существующих / отдельная новая коллекция?</a:t>
+            </a:r>
+            <a:endParaRPr lang="en-US" sz="1100" dirty="0"/>
+          </a:p>
+          <a:p>
+            <a:pPr marL="177800" indent="-177800">
+              <a:lnSpc>
+                <a:spcPct val="115000"/>
+              </a:lnSpc>
+              <a:spcAft>
+                <a:spcPts val="1000"/>
+              </a:spcAft>
+              <a:buSzPct val="100000"/>
+              <a:buChar char="•"/>
+            </a:pPr>
+            <a:r>
+              <a:rPr lang="en-US" sz="1100" dirty="0">
+                <a:solidFill>
+                  <a:srgbClr val="5B6B7A"/>
+                </a:solidFill>
+                <a:latin typeface="Calibri" pitchFamily="34" charset="0"/>
+                <a:ea typeface="Calibri" pitchFamily="34" charset="-122"/>
+                <a:cs typeface="Calibri" pitchFamily="34" charset="-120"/>
+              </a:rPr>
+              <a:t>Состав данных: какие темы/типы документов (если новые)</a:t>
+            </a:r>
+            <a:endParaRPr lang="en-US" sz="1100" dirty="0"/>
+          </a:p>
+          <a:p>
+            <a:pPr marL="177800" indent="-177800">
+              <a:lnSpc>
+                <a:spcPct val="115000"/>
+              </a:lnSpc>
+              <a:spcAft>
+                <a:spcPts val="1000"/>
+              </a:spcAft>
+              <a:buSzPct val="100000"/>
+              <a:buChar char="•"/>
+            </a:pPr>
+            <a:r>
+              <a:rPr lang="en-US" sz="1100" dirty="0">
+                <a:solidFill>
+                  <a:srgbClr val="5B6B7A"/>
+                </a:solidFill>
+                <a:latin typeface="Calibri" pitchFamily="34" charset="0"/>
+                <a:ea typeface="Calibri" pitchFamily="34" charset="-122"/>
+                <a:cs typeface="Calibri" pitchFamily="34" charset="-120"/>
+              </a:rPr>
+              <a:t>Количество коллекций: расширяются текущие 2, или новые — сколько</a:t>
+            </a:r>
+            <a:endParaRPr lang="en-US" sz="1100" dirty="0"/>
+          </a:p>
+          <a:p>
+            <a:pPr marL="177800" indent="-177800">
+              <a:lnSpc>
+                <a:spcPct val="115000"/>
+              </a:lnSpc>
+              <a:spcAft>
+                <a:spcPts val="1000"/>
+              </a:spcAft>
+              <a:buSzPct val="100000"/>
+              <a:buChar char="•"/>
+            </a:pPr>
+            <a:r>
+              <a:rPr lang="en-US" sz="1100" dirty="0">
+                <a:solidFill>
+                  <a:srgbClr val="5B6B7A"/>
+                </a:solidFill>
+                <a:latin typeface="Calibri" pitchFamily="34" charset="0"/>
+                <a:ea typeface="Calibri" pitchFamily="34" charset="-122"/>
+                <a:cs typeface="Calibri" pitchFamily="34" charset="-120"/>
+              </a:rPr>
+              <a:t>Объём: примерное число документов в корпусе</a:t>
+            </a:r>
+            <a:endParaRPr lang="en-US" sz="1100" dirty="0"/>
+          </a:p>
+          <a:p>
+            <a:pPr marL="177800" indent="-177800">
+              <a:lnSpc>
+                <a:spcPct val="115000"/>
+              </a:lnSpc>
+              <a:spcAft>
+                <a:spcPts val="1000"/>
+              </a:spcAft>
+              <a:buSzPct val="100000"/>
+              <a:buChar char="•"/>
+            </a:pPr>
+            <a:r>
+              <a:rPr lang="en-US" sz="1100" dirty="0">
+                <a:solidFill>
+                  <a:srgbClr val="5B6B7A"/>
+                </a:solidFill>
+                <a:latin typeface="Calibri" pitchFamily="34" charset="0"/>
+                <a:ea typeface="Calibri" pitchFamily="34" charset="-122"/>
+                <a:cs typeface="Calibri" pitchFamily="34" charset="-120"/>
+              </a:rPr>
+              <a:t>Пользователи и роли: кто получит доступ именно в этой волне</a:t>
+            </a:r>
+            <a:endParaRPr lang="en-US" sz="1100" dirty="0"/>
+          </a:p>
+        </p:txBody>
+      </p:sp>
+      <p:sp>
+        <p:nvSpPr>
+          <p:cNvPr id="9" name="Shape 7"/>
+          <p:cNvSpPr/>
+          <p:nvPr/>
+        </p:nvSpPr>
+        <p:spPr>
+          <a:xfrm>
+            <a:off x="4320540" y="1691640"/>
+            <a:ext cx="3520440" cy="4526280"/>
+          </a:xfrm>
+          <a:prstGeom prst="roundRect">
+            <a:avLst>
+              <a:gd name="adj" fmla="val 1558"/>
+            </a:avLst>
+          </a:prstGeom>
+          <a:solidFill>
+            <a:srgbClr val="F4F6F7"/>
+          </a:solidFill>
+          <a:ln w="9525">
+            <a:solidFill>
+              <a:srgbClr val="D8DEE2"/>
+            </a:solidFill>
+            <a:prstDash val="solid"/>
+          </a:ln>
+        </p:spPr>
+      </p:sp>
+      <p:sp>
+        <p:nvSpPr>
+          <p:cNvPr id="10" name="Text 8"/>
+          <p:cNvSpPr txBox="1"/>
+          <p:nvPr/>
+        </p:nvSpPr>
+        <p:spPr>
+          <a:xfrm>
+            <a:off x="4521708" y="1874520"/>
+            <a:ext cx="3118104" cy="256032"/>
+          </a:xfrm>
+          <a:prstGeom prst="rect">
+            <a:avLst/>
+          </a:prstGeom>
+          <a:noFill/>
+          <a:ln/>
+        </p:spPr>
+        <p:txBody>
+          <a:bodyPr wrap="square" lIns="0" tIns="0" rIns="0" bIns="0" rtlCol="0" anchor="ctr"/>
+          <a:lstStyle/>
+          <a:p>
+            <a:pPr indent="0" marL="0">
+              <a:buNone/>
+            </a:pPr>
+            <a:r>
+              <a:rPr lang="en-US" sz="1000" b="1" spc="100" kern="0" dirty="0">
+                <a:solidFill>
+                  <a:srgbClr val="C97A1A"/>
+                </a:solidFill>
+                <a:latin typeface="Calibri" pitchFamily="34" charset="0"/>
+                <a:ea typeface="Calibri" pitchFamily="34" charset="-122"/>
+                <a:cs typeface="Calibri" pitchFamily="34" charset="-120"/>
+              </a:rPr>
+              <a:t>ВЫСОКИЙ</a:t>
+            </a:r>
+            <a:endParaRPr lang="en-US" sz="1000" dirty="0"/>
+          </a:p>
+        </p:txBody>
+      </p:sp>
+      <p:sp>
+        <p:nvSpPr>
+          <p:cNvPr id="11" name="Text 9"/>
+          <p:cNvSpPr txBox="1"/>
+          <p:nvPr/>
+        </p:nvSpPr>
+        <p:spPr>
+          <a:xfrm>
+            <a:off x="4521708" y="2148840"/>
+            <a:ext cx="3118104" cy="594360"/>
+          </a:xfrm>
+          <a:prstGeom prst="rect">
+            <a:avLst/>
+          </a:prstGeom>
+          <a:noFill/>
+          <a:ln/>
+        </p:spPr>
+        <p:txBody>
+          <a:bodyPr wrap="square" lIns="0" tIns="0" rIns="0" bIns="0" rtlCol="0" anchor="ctr"/>
+          <a:lstStyle/>
+          <a:p>
+            <a:pPr indent="0" marL="0">
+              <a:lnSpc>
+                <a:spcPct val="105000"/>
+              </a:lnSpc>
+              <a:buNone/>
+            </a:pPr>
+            <a:r>
+              <a:rPr lang="en-US" sz="1550" b="1" dirty="0">
+                <a:solidFill>
+                  <a:srgbClr val="1A2733"/>
+                </a:solidFill>
+                <a:latin typeface="Cambria" pitchFamily="34" charset="0"/>
+                <a:ea typeface="Cambria" pitchFamily="34" charset="-122"/>
+                <a:cs typeface="Cambria" pitchFamily="34" charset="-120"/>
+              </a:rPr>
+              <a:t>Волна 2 — КХД / ESB</a:t>
+            </a:r>
+            <a:endParaRPr lang="en-US" sz="1550" dirty="0"/>
+          </a:p>
+        </p:txBody>
+      </p:sp>
+      <p:sp>
+        <p:nvSpPr>
+          <p:cNvPr id="12" name="Text 10"/>
+          <p:cNvSpPr txBox="1"/>
+          <p:nvPr/>
+        </p:nvSpPr>
+        <p:spPr>
+          <a:xfrm>
+            <a:off x="4521708" y="2834640"/>
+            <a:ext cx="3118104" cy="3200400"/>
+          </a:xfrm>
+          <a:prstGeom prst="rect">
+            <a:avLst/>
+          </a:prstGeom>
+          <a:noFill/>
+          <a:ln/>
+        </p:spPr>
+        <p:txBody>
+          <a:bodyPr wrap="square" lIns="0" tIns="0" rIns="0" bIns="0" rtlCol="0" anchor="t"/>
+          <a:lstStyle/>
+          <a:p>
+            <a:pPr marL="177800" indent="-177800">
+              <a:lnSpc>
+                <a:spcPct val="115000"/>
+              </a:lnSpc>
+              <a:spcAft>
+                <a:spcPts val="1000"/>
+              </a:spcAft>
+              <a:buSzPct val="100000"/>
+              <a:buChar char="•"/>
+            </a:pPr>
+            <a:r>
+              <a:rPr lang="en-US" sz="1100" dirty="0">
+                <a:solidFill>
+                  <a:srgbClr val="5B6B7A"/>
+                </a:solidFill>
+                <a:latin typeface="Calibri" pitchFamily="34" charset="0"/>
+                <a:ea typeface="Calibri" pitchFamily="34" charset="-122"/>
+                <a:cs typeface="Calibri" pitchFamily="34" charset="-120"/>
+              </a:rPr>
+              <a:t>Витрины: список с владельцами на стороне Д8 + точное число сверх пилотных 4</a:t>
+            </a:r>
+            <a:endParaRPr lang="en-US" sz="1100" dirty="0"/>
+          </a:p>
+          <a:p>
+            <a:pPr marL="177800" indent="-177800">
+              <a:lnSpc>
+                <a:spcPct val="115000"/>
+              </a:lnSpc>
+              <a:spcAft>
+                <a:spcPts val="1000"/>
+              </a:spcAft>
+              <a:buSzPct val="100000"/>
+              <a:buChar char="•"/>
+            </a:pPr>
+            <a:r>
+              <a:rPr lang="en-US" sz="1100" dirty="0">
+                <a:solidFill>
+                  <a:srgbClr val="5B6B7A"/>
+                </a:solidFill>
+                <a:latin typeface="Calibri" pitchFamily="34" charset="0"/>
+                <a:ea typeface="Calibri" pitchFamily="34" charset="-122"/>
+                <a:cs typeface="Calibri" pitchFamily="34" charset="-120"/>
+              </a:rPr>
+              <a:t>API шины: система-источник, формат, ответственный за контракт</a:t>
+            </a:r>
+            <a:endParaRPr lang="en-US" sz="1100" dirty="0"/>
+          </a:p>
+          <a:p>
+            <a:pPr marL="177800" indent="-177800">
+              <a:lnSpc>
+                <a:spcPct val="115000"/>
+              </a:lnSpc>
+              <a:spcAft>
+                <a:spcPts val="1000"/>
+              </a:spcAft>
+              <a:buSzPct val="100000"/>
+              <a:buChar char="•"/>
+            </a:pPr>
+            <a:r>
+              <a:rPr lang="en-US" sz="1100" dirty="0">
+                <a:solidFill>
+                  <a:srgbClr val="5B6B7A"/>
+                </a:solidFill>
+                <a:latin typeface="Calibri" pitchFamily="34" charset="0"/>
+                <a:ea typeface="Calibri" pitchFamily="34" charset="-122"/>
+                <a:cs typeface="Calibri" pitchFamily="34" charset="-120"/>
+              </a:rPr>
+              <a:t>КХД: расширяется ли периметр хранилища, или остаётся как в пилоте</a:t>
+            </a:r>
+            <a:endParaRPr lang="en-US" sz="1100" dirty="0"/>
+          </a:p>
+          <a:p>
+            <a:pPr marL="177800" indent="-177800">
+              <a:lnSpc>
+                <a:spcPct val="115000"/>
+              </a:lnSpc>
+              <a:spcAft>
+                <a:spcPts val="1000"/>
+              </a:spcAft>
+              <a:buSzPct val="100000"/>
+              <a:buChar char="•"/>
+            </a:pPr>
+            <a:r>
+              <a:rPr lang="en-US" sz="1100" dirty="0">
+                <a:solidFill>
+                  <a:srgbClr val="5B6B7A"/>
+                </a:solidFill>
+                <a:latin typeface="Calibri" pitchFamily="34" charset="0"/>
+                <a:ea typeface="Calibri" pitchFamily="34" charset="-122"/>
+                <a:cs typeface="Calibri" pitchFamily="34" charset="-120"/>
+              </a:rPr>
+              <a:t>Пользователи и роли: кто получит доступ к расширенным данным</a:t>
+            </a:r>
+            <a:endParaRPr lang="en-US" sz="1100" dirty="0"/>
+          </a:p>
+        </p:txBody>
+      </p:sp>
+      <p:sp>
+        <p:nvSpPr>
+          <p:cNvPr id="13" name="Shape 11"/>
+          <p:cNvSpPr/>
+          <p:nvPr/>
+        </p:nvSpPr>
+        <p:spPr>
+          <a:xfrm>
+            <a:off x="8138160" y="1691640"/>
+            <a:ext cx="3520440" cy="4526280"/>
+          </a:xfrm>
+          <a:prstGeom prst="roundRect">
+            <a:avLst>
+              <a:gd name="adj" fmla="val 1558"/>
+            </a:avLst>
+          </a:prstGeom>
+          <a:solidFill>
+            <a:srgbClr val="F4F6F7"/>
+          </a:solidFill>
+          <a:ln w="9525">
+            <a:solidFill>
+              <a:srgbClr val="D8DEE2"/>
+            </a:solidFill>
+            <a:prstDash val="solid"/>
+          </a:ln>
+        </p:spPr>
+      </p:sp>
+      <p:sp>
+        <p:nvSpPr>
+          <p:cNvPr id="14" name="Text 12"/>
+          <p:cNvSpPr txBox="1"/>
+          <p:nvPr/>
+        </p:nvSpPr>
+        <p:spPr>
+          <a:xfrm>
+            <a:off x="8339328" y="1874520"/>
+            <a:ext cx="3118104" cy="256032"/>
+          </a:xfrm>
+          <a:prstGeom prst="rect">
+            <a:avLst/>
+          </a:prstGeom>
+          <a:noFill/>
+          <a:ln/>
+        </p:spPr>
+        <p:txBody>
+          <a:bodyPr wrap="square" lIns="0" tIns="0" rIns="0" bIns="0" rtlCol="0" anchor="ctr"/>
+          <a:lstStyle/>
+          <a:p>
+            <a:pPr indent="0" marL="0">
+              <a:buNone/>
+            </a:pPr>
+            <a:r>
+              <a:rPr lang="en-US" sz="1000" b="1" spc="100" kern="0" dirty="0">
+                <a:solidFill>
+                  <a:srgbClr val="C97A1A"/>
+                </a:solidFill>
+                <a:latin typeface="Calibri" pitchFamily="34" charset="0"/>
+                <a:ea typeface="Calibri" pitchFamily="34" charset="-122"/>
+                <a:cs typeface="Calibri" pitchFamily="34" charset="-120"/>
+              </a:rPr>
+              <a:t>ОТКРЫТО</a:t>
+            </a:r>
+            <a:endParaRPr lang="en-US" sz="1000" dirty="0"/>
+          </a:p>
+        </p:txBody>
+      </p:sp>
+      <p:sp>
+        <p:nvSpPr>
+          <p:cNvPr id="15" name="Text 13"/>
+          <p:cNvSpPr txBox="1"/>
+          <p:nvPr/>
+        </p:nvSpPr>
+        <p:spPr>
+          <a:xfrm>
+            <a:off x="8339328" y="2148840"/>
+            <a:ext cx="3118104" cy="594360"/>
+          </a:xfrm>
+          <a:prstGeom prst="rect">
+            <a:avLst/>
+          </a:prstGeom>
+          <a:noFill/>
+          <a:ln/>
+        </p:spPr>
+        <p:txBody>
+          <a:bodyPr wrap="square" lIns="0" tIns="0" rIns="0" bIns="0" rtlCol="0" anchor="ctr"/>
+          <a:lstStyle/>
+          <a:p>
+            <a:pPr indent="0" marL="0">
+              <a:lnSpc>
+                <a:spcPct val="105000"/>
+              </a:lnSpc>
+              <a:buNone/>
+            </a:pPr>
+            <a:r>
+              <a:rPr lang="en-US" sz="1550" b="1" dirty="0">
+                <a:solidFill>
+                  <a:srgbClr val="1A2733"/>
+                </a:solidFill>
+                <a:latin typeface="Cambria" pitchFamily="34" charset="0"/>
+                <a:ea typeface="Cambria" pitchFamily="34" charset="-122"/>
+                <a:cs typeface="Cambria" pitchFamily="34" charset="-120"/>
+              </a:rPr>
+              <a:t>Волна 3+ — направление не определено</a:t>
+            </a:r>
+            <a:endParaRPr lang="en-US" sz="1550" dirty="0"/>
+          </a:p>
+        </p:txBody>
+      </p:sp>
+      <p:sp>
+        <p:nvSpPr>
+          <p:cNvPr id="16" name="Text 14"/>
+          <p:cNvSpPr txBox="1"/>
+          <p:nvPr/>
+        </p:nvSpPr>
+        <p:spPr>
+          <a:xfrm>
+            <a:off x="8339328" y="2834640"/>
+            <a:ext cx="3118104" cy="3200400"/>
+          </a:xfrm>
+          <a:prstGeom prst="rect">
+            <a:avLst/>
+          </a:prstGeom>
+          <a:noFill/>
+          <a:ln/>
+        </p:spPr>
+        <p:txBody>
+          <a:bodyPr wrap="square" lIns="0" tIns="0" rIns="0" bIns="0" rtlCol="0" anchor="t"/>
+          <a:lstStyle/>
+          <a:p>
+            <a:pPr marL="177800" indent="-177800">
+              <a:lnSpc>
+                <a:spcPct val="115000"/>
+              </a:lnSpc>
+              <a:spcAft>
+                <a:spcPts val="1000"/>
+              </a:spcAft>
+              <a:buSzPct val="100000"/>
+              <a:buChar char="•"/>
+            </a:pPr>
+            <a:r>
+              <a:rPr lang="en-US" sz="1100" dirty="0">
+                <a:solidFill>
+                  <a:srgbClr val="5B6B7A"/>
+                </a:solidFill>
+                <a:latin typeface="Calibri" pitchFamily="34" charset="0"/>
+                <a:ea typeface="Calibri" pitchFamily="34" charset="-122"/>
+                <a:cs typeface="Calibri" pitchFamily="34" charset="-120"/>
+              </a:rPr>
+              <a:t>Кандидаты: роллаут по ролям, динамические права, источники вне пилота</a:t>
+            </a:r>
+            <a:endParaRPr lang="en-US" sz="1100" dirty="0"/>
+          </a:p>
+          <a:p>
+            <a:pPr marL="177800" indent="-177800">
+              <a:lnSpc>
+                <a:spcPct val="115000"/>
+              </a:lnSpc>
+              <a:spcAft>
+                <a:spcPts val="1000"/>
+              </a:spcAft>
+              <a:buSzPct val="100000"/>
+              <a:buChar char="•"/>
+            </a:pPr>
+            <a:r>
+              <a:rPr lang="en-US" sz="1100" dirty="0">
+                <a:solidFill>
+                  <a:srgbClr val="5B6B7A"/>
+                </a:solidFill>
+                <a:latin typeface="Calibri" pitchFamily="34" charset="0"/>
+                <a:ea typeface="Calibri" pitchFamily="34" charset="-122"/>
+                <a:cs typeface="Calibri" pitchFamily="34" charset="-120"/>
+              </a:rPr>
+              <a:t>Реальная оргструктура: подразделения/роли с числом пользователей — факт, не гипотеза из мастер-ТЗ</a:t>
+            </a:r>
+            <a:endParaRPr lang="en-US" sz="1100" dirty="0"/>
+          </a:p>
+          <a:p>
+            <a:pPr marL="177800" indent="-177800">
+              <a:lnSpc>
+                <a:spcPct val="115000"/>
+              </a:lnSpc>
+              <a:spcAft>
+                <a:spcPts val="1000"/>
+              </a:spcAft>
+              <a:buSzPct val="100000"/>
+              <a:buChar char="•"/>
+            </a:pPr>
+            <a:r>
+              <a:rPr lang="en-US" sz="1100" dirty="0">
+                <a:solidFill>
+                  <a:srgbClr val="5B6B7A"/>
+                </a:solidFill>
+                <a:latin typeface="Calibri" pitchFamily="34" charset="0"/>
+                <a:ea typeface="Calibri" pitchFamily="34" charset="-122"/>
+                <a:cs typeface="Calibri" pitchFamily="34" charset="-120"/>
+              </a:rPr>
+              <a:t>Как только определится — тот же набор: данные, витрины/коллекции, пользователи, роли</a:t>
+            </a:r>
+            <a:endParaRPr lang="en-US" sz="1100" dirty="0"/>
+          </a:p>
+        </p:txBody>
+      </p:sp>
+      <p:sp>
+        <p:nvSpPr>
+          <p:cNvPr id="17" name="Text 15"/>
+          <p:cNvSpPr txBox="1"/>
+          <p:nvPr/>
+        </p:nvSpPr>
+        <p:spPr>
+          <a:xfrm>
+            <a:off x="10881360" y="6473952"/>
+            <a:ext cx="822960" cy="274320"/>
+          </a:xfrm>
+          <a:prstGeom prst="rect">
+            <a:avLst/>
+          </a:prstGeom>
+          <a:noFill/>
+          <a:ln/>
+        </p:spPr>
+        <p:txBody>
+          <a:bodyPr wrap="square" lIns="0" tIns="0" rIns="0" bIns="0" rtlCol="0" anchor="ctr"/>
+          <a:lstStyle/>
+          <a:p>
+            <a:pPr algn="r" indent="0" marL="0">
+              <a:buNone/>
+            </a:pPr>
+            <a:r>
+              <a:rPr lang="en-US" sz="1050" dirty="0">
+                <a:solidFill>
+                  <a:srgbClr val="8C99A6"/>
+                </a:solidFill>
+                <a:latin typeface="Calibri" pitchFamily="34" charset="0"/>
+                <a:ea typeface="Calibri" pitchFamily="34" charset="-122"/>
+                <a:cs typeface="Calibri" pitchFamily="34" charset="-120"/>
+              </a:rPr>
+              <a:t>5 / 6</a:t>
+            </a:r>
+            <a:endParaRPr lang="en-US" sz="1050" dirty="0"/>
+          </a:p>
+        </p:txBody>
+      </p:sp>
+    </p:spTree>
+  </p:cSld>
+  <p:clrMapOvr>
+    <a:masterClrMapping/>
+  </p:clrMapOvr>
+</p:sld>
+</file>
+
+<file path=ppt/slides/slide6.xml><?xml version="1.0" encoding="utf-8"?>
+<p:sld xmlns:a="http://schemas.openxmlformats.org/drawingml/2006/main" xmlns:r="http://schemas.openxmlformats.org/officeDocument/2006/relationships" xmlns:p="http://schemas.openxmlformats.org/presentationml/2006/main">
+  <p:cSld name="Slide 6">
+    <p:spTree>
+      <p:nvGrpSpPr>
+        <p:cNvPr id="1" name=""/>
+        <p:cNvGrpSpPr/>
+        <p:nvPr/>
+      </p:nvGrpSpPr>
+      <p:grpSpPr>
+        <a:xfrm>
+          <a:off x="0" y="0"/>
+          <a:ext cx="0" cy="0"/>
+          <a:chOff x="0" y="0"/>
+          <a:chExt cx="0" cy="0"/>
+        </a:xfrm>
+      </p:grpSpPr>
+      <p:sp>
+        <p:nvSpPr>
+          <p:cNvPr id="2" name="Text 0"/>
+          <p:cNvSpPr txBox="1"/>
+          <p:nvPr/>
+        </p:nvSpPr>
+        <p:spPr>
+          <a:xfrm>
+            <a:off x="502920" y="320040"/>
+            <a:ext cx="11155680" cy="274320"/>
+          </a:xfrm>
+          <a:prstGeom prst="rect">
+            <a:avLst/>
+          </a:prstGeom>
+          <a:noFill/>
+          <a:ln/>
+        </p:spPr>
+        <p:txBody>
+          <a:bodyPr wrap="square" lIns="0" tIns="0" rIns="0" bIns="0" rtlCol="0" anchor="ctr"/>
+          <a:lstStyle/>
+          <a:p>
+            <a:pPr indent="0" marL="0">
+              <a:buNone/>
+            </a:pPr>
+            <a:r>
+              <a:rPr lang="en-US" sz="1100" b="1" spc="120" kern="0" dirty="0">
+                <a:solidFill>
+                  <a:srgbClr val="0E7C86"/>
+                </a:solidFill>
+                <a:latin typeface="Calibri" pitchFamily="34" charset="0"/>
+                <a:ea typeface="Calibri" pitchFamily="34" charset="-122"/>
+                <a:cs typeface="Calibri" pitchFamily="34" charset="-120"/>
+              </a:rPr>
+              <a:t>4 · НАШИ ВОПРОСЫ · ПО ПОЖЕЛАНИЯМ ЗАКАЗЧИКА</a:t>
             </a:r>
             <a:endParaRPr lang="en-US" sz="1100" dirty="0"/>
           </a:p>
@@ -10015,7 +8546,7 @@
       </p:sp>
       <p:graphicFrame>
         <p:nvGraphicFramePr>
-          <p:cNvPr id="6" name="Table 0"/>
+          <p:cNvPr id="7" name="Table 0"/>
           <p:cNvGraphicFramePr>
             <a:graphicFrameLocks noGrp="1"/>
           </p:cNvGraphicFramePr>
@@ -10597,7 +9128,7 @@
                           <a:ea typeface="Calibri" pitchFamily="34" charset="-122"/>
                           <a:cs typeface="Calibri" pitchFamily="34" charset="-120"/>
                         </a:rPr>
-                        <a:t>Права доступа — переход на динамическую модель (через API)? Какая система — источник истины?</a:t>
+                        <a:t>Права доступа через API — где они хранятся и администрируются: внутри платформы, или платформа лишь получает их из внешней системы и применяет? Если второе — какая система источник и как часто обновляется?</a:t>
                       </a:r>
                       <a:endParaRPr lang="en-US" sz="1050" dirty="0">
                         <a:latin typeface="Calibri" charset="0"/>
@@ -10924,7 +9455,7 @@
                           <a:ea typeface="Calibri" pitchFamily="34" charset="-122"/>
                           <a:cs typeface="Calibri" pitchFamily="34" charset="-120"/>
                         </a:rPr>
-                        <a:t>Кастомизация выбора источников — нужно ли включать/отключать источники в чате и через API?</a:t>
+                        <a:t>Кастомизация выбора источников — что имеется в виду: (а) подключение/отключение целых каталогов данных внутри домена, или (б) выбор персоны/профиля с отдельным набором прав? Разный объём реализации.</a:t>
                       </a:r>
                       <a:endParaRPr lang="en-US" sz="1050" dirty="0">
                         <a:latin typeface="Calibri" charset="0"/>
@@ -11251,7 +9782,7 @@
                           <a:ea typeface="Calibri" pitchFamily="34" charset="-122"/>
                           <a:cs typeface="Calibri" pitchFamily="34" charset="-120"/>
                         </a:rPr>
-                        <a:t>Персональные RAG-коллекции — нужна ли пользователям возможность создавать свои и делиться?</a:t>
+                        <a:t>Персональные RAG-коллекции — механика: фильтр по документам внутри существующей коллекции, или отдельная новая коллекция, которую пользователь создаёт и наполняет сам?</a:t>
                       </a:r>
                       <a:endParaRPr lang="en-US" sz="1050" dirty="0">
                         <a:latin typeface="Calibri" charset="0"/>
@@ -11578,7 +10109,7 @@
                           <a:ea typeface="Calibri" pitchFamily="34" charset="-122"/>
                           <a:cs typeface="Calibri" pitchFamily="34" charset="-120"/>
                         </a:rPr>
-                        <a:t>Упрощение заведения пользователей — что именно неудобно сейчас? Нужен конкретный сценарий.</a:t>
+                        <a:t>Упрощение заведения пользователей — нужен конкретный кейс: как должен выглядеть процесс пошагово (кто инициирует, какие поля, кто подтверждает).</a:t>
                       </a:r>
                       <a:endParaRPr lang="en-US" sz="1050" dirty="0">
                         <a:latin typeface="Calibri" charset="0"/>
@@ -11729,7 +10260,7 @@
                 <a:ea typeface="Calibri" pitchFamily="34" charset="-122"/>
                 <a:cs typeface="Calibri" pitchFamily="34" charset="-120"/>
               </a:rPr>
-              <a:t>5 / 5</a:t>
+              <a:t>6 / 6</a:t>
             </a:r>
             <a:endParaRPr lang="en-US" sz="1050" dirty="0"/>
           </a:p>

</xml_diff>

<commit_message>
Turn wave goal/criteria into questions to the customer, add proposals slide
- Волновые карточки (пптx) и вопросы 2/4/8 (md) больше не содержат
  наших формулировок цели/критерия — это прямые вопросы к Д8: какая
  цель волны и какой критерий её достижения. Добавлено в xlsx (новые
  вопросы №2, №5, №9) и синхронизировано в md/docx (вопросы 1-18,
  полная renumbering всех перекрёстных ссылок).
- Новый слайд «Наши предложения» (6/7) — 6 рабочих позиций по
  умолчанию из §6 документа, на основе программы проекта.

Co-Authored-By: Claude Sonnet 5 <noreply@anthropic.com>
Claude-Session: https://claude.ai/code/session_01DpSN8JwCJ3tg3JVUadr2zE
</commit_message>
<xml_diff>
--- a/docs/presentations/case-27-proekt-d8-skoup-i-voprosy.pptx
+++ b/docs/presentations/case-27-proekt-d8-skoup-i-voprosy.pptx
@@ -11,9 +11,10 @@
     <p:sldId id="259" r:id="rId5"/>
     <p:sldId id="260" r:id="rId6"/>
     <p:sldId id="261" r:id="rId7"/>
+    <p:sldId id="262" r:id="rId8"/>
   </p:sldIdLst>
   <p:notesMasterIdLst>
-    <p:notesMasterId r:id="rId8"/>
+    <p:notesMasterId r:id="rId9"/>
   </p:notesMasterIdLst>
   <p:sldSz cx="12192000" cy="6858000"/>
   <p:notesSz cx="6858000" cy="12192000"/>
@@ -989,6 +990,94 @@
 </p:notes>
 </file>
 
+<file path=ppt/notesSlides/notesSlide7.xml><?xml version="1.0" encoding="utf-8"?>
+<p:notes xmlns:a="http://schemas.openxmlformats.org/drawingml/2006/main" xmlns:r="http://schemas.openxmlformats.org/officeDocument/2006/relationships" xmlns:p="http://schemas.openxmlformats.org/presentationml/2006/main">
+  <p:cSld>
+    <p:spTree>
+      <p:nvGrpSpPr>
+        <p:cNvPr id="1" name=""/>
+        <p:cNvGrpSpPr/>
+        <p:nvPr/>
+      </p:nvGrpSpPr>
+      <p:grpSpPr>
+        <a:xfrm>
+          <a:off x="0" y="0"/>
+          <a:ext cx="0" cy="0"/>
+          <a:chOff x="0" y="0"/>
+          <a:chExt cx="0" cy="0"/>
+        </a:xfrm>
+      </p:grpSpPr>
+      <p:sp>
+        <p:nvSpPr>
+          <p:cNvPr id="2" name="Slide Image Placeholder 1"/>
+          <p:cNvSpPr>
+            <a:spLocks noGrp="1" noRot="1" noChangeAspect="1"/>
+          </p:cNvSpPr>
+          <p:nvPr>
+            <p:ph type="sldImg"/>
+          </p:nvPr>
+        </p:nvSpPr>
+        <p:spPr/>
+      </p:sp>
+      <p:sp>
+        <p:nvSpPr>
+          <p:cNvPr id="3" name="Notes Placeholder 2"/>
+          <p:cNvSpPr>
+            <a:spLocks noGrp="1"/>
+          </p:cNvSpPr>
+          <p:nvPr>
+            <p:ph type="body" idx="1"/>
+          </p:nvPr>
+        </p:nvSpPr>
+        <p:spPr/>
+        <p:txBody>
+          <a:bodyPr/>
+          <a:lstStyle/>
+          <a:p>
+            <a:r>
+              <a:rPr lang="en-US" dirty="0"/>
+              <a:t/>
+            </a:r>
+            <a:endParaRPr lang="en-US" dirty="0"/>
+          </a:p>
+        </p:txBody>
+      </p:sp>
+      <p:sp>
+        <p:nvSpPr>
+          <p:cNvPr id="4" name="Slide Number Placeholder 3"/>
+          <p:cNvSpPr>
+            <a:spLocks noGrp="1"/>
+          </p:cNvSpPr>
+          <p:nvPr>
+            <p:ph type="sldNum" sz="quarter" idx="10"/>
+          </p:nvPr>
+        </p:nvSpPr>
+        <p:spPr/>
+        <p:txBody>
+          <a:bodyPr/>
+          <a:lstStyle/>
+          <a:p>
+            <a:fld id="{F7021451-1387-4CA6-816F-3879F97B5CBC}" type="slidenum">
+              <a:rPr lang="en-US"/>
+              <a:t>7</a:t>
+            </a:fld>
+            <a:endParaRPr lang="en-US"/>
+          </a:p>
+        </p:txBody>
+      </p:sp>
+    </p:spTree>
+    <p:extLst>
+      <p:ext uri="{BB962C8B-B14F-4D97-AF65-F5344CB8AC3E}">
+        <p14:creationId xmlns:p14="http://schemas.microsoft.com/office/powerpoint/2010/main" val="1024086991"/>
+      </p:ext>
+    </p:extLst>
+  </p:cSld>
+  <p:clrMapOvr>
+    <a:masterClrMapping/>
+  </p:clrMapOvr>
+</p:notes>
+</file>
+
 <file path=ppt/slideLayouts/slideLayout1.xml><?xml version="1.0" encoding="utf-8"?>
 <p:sldLayout xmlns:a="http://schemas.openxmlformats.org/drawingml/2006/main" xmlns:r="http://schemas.openxmlformats.org/officeDocument/2006/relationships" xmlns:p="http://schemas.openxmlformats.org/presentationml/2006/main" preserve="1">
   <p:cSld name="DEFAULT">
@@ -1931,7 +2020,7 @@
                 <a:ea typeface="Calibri" pitchFamily="34" charset="-122"/>
                 <a:cs typeface="Calibri" pitchFamily="34" charset="-120"/>
               </a:rPr>
-              <a:t>1 / 6</a:t>
+              <a:t>1 / 7</a:t>
             </a:r>
             <a:endParaRPr lang="en-US" sz="1050" dirty="0"/>
           </a:p>
@@ -2073,7 +2162,7 @@
                 <a:ea typeface="Calibri" pitchFamily="34" charset="-122"/>
                 <a:cs typeface="Calibri" pitchFamily="34" charset="-120"/>
               </a:rPr>
-              <a:t>Цель, что нужно уточнить и критерий достижения — единый формат для каждой волны</a:t>
+              <a:t>Цель и критерий достижения — вопросы к Д8, не наши формулировки. Плюс что нужно уточнить по содержанию</a:t>
             </a:r>
             <a:endParaRPr lang="en-US" sz="1300" dirty="0"/>
           </a:p>
@@ -2196,7 +2285,7 @@
         <p:spPr>
           <a:xfrm>
             <a:off x="704088" y="2697480"/>
-            <a:ext cx="3118104" cy="182880"/>
+            <a:ext cx="3118104" cy="292608"/>
           </a:xfrm>
           <a:prstGeom prst="rect">
             <a:avLst/>
@@ -2205,7 +2294,7 @@
           <a:ln/>
         </p:spPr>
         <p:txBody>
-          <a:bodyPr wrap="square" lIns="0" tIns="0" rIns="0" bIns="0" rtlCol="0" anchor="ctr"/>
+          <a:bodyPr wrap="square" lIns="0" tIns="0" rIns="0" bIns="0" rtlCol="0" anchor="t"/>
           <a:lstStyle/>
           <a:p>
             <a:pPr indent="0" marL="0">
@@ -2220,7 +2309,7 @@
                 <a:ea typeface="Calibri" pitchFamily="34" charset="-122"/>
                 <a:cs typeface="Calibri" pitchFamily="34" charset="-120"/>
               </a:rPr>
-              <a:t>ЦЕЛЬ</a:t>
+              <a:t>ВОПРОС — ЦЕЛЬ ВОЛНЫ</a:t>
             </a:r>
             <a:endParaRPr lang="en-US" sz="900" dirty="0"/>
           </a:p>
@@ -2234,8 +2323,8 @@
         </p:nvSpPr>
         <p:spPr>
           <a:xfrm>
-            <a:off x="704088" y="2880360"/>
-            <a:ext cx="3118104" cy="566928"/>
+            <a:off x="704088" y="2990088"/>
+            <a:ext cx="3118104" cy="475488"/>
           </a:xfrm>
           <a:prstGeom prst="rect">
             <a:avLst/>
@@ -2262,7 +2351,7 @@
                 <a:ea typeface="Calibri" pitchFamily="34" charset="-122"/>
                 <a:cs typeface="Calibri" pitchFamily="34" charset="-120"/>
               </a:rPr>
-              <a:t>Рабочий RAG-поиск по новому/расширенному документному корпусу для затронутой роли.</a:t>
+              <a:t>Какой результат для бизнеса должна дать волна 1? Что изменится для пользователей/процессов?</a:t>
             </a:r>
             <a:endParaRPr lang="en-US" sz="1050" dirty="0"/>
           </a:p>
@@ -2393,7 +2482,7 @@
         <p:spPr>
           <a:xfrm>
             <a:off x="795528" y="5166360"/>
-            <a:ext cx="2935224" cy="182880"/>
+            <a:ext cx="2935224" cy="292608"/>
           </a:xfrm>
           <a:prstGeom prst="rect">
             <a:avLst/>
@@ -2402,7 +2491,7 @@
           <a:ln/>
         </p:spPr>
         <p:txBody>
-          <a:bodyPr wrap="square" lIns="0" tIns="0" rIns="0" bIns="0" rtlCol="0" anchor="ctr"/>
+          <a:bodyPr wrap="square" lIns="0" tIns="0" rIns="0" bIns="0" rtlCol="0" anchor="t"/>
           <a:lstStyle/>
           <a:p>
             <a:pPr indent="0" marL="0">
@@ -2417,7 +2506,7 @@
                 <a:ea typeface="Calibri" pitchFamily="34" charset="-122"/>
                 <a:cs typeface="Calibri" pitchFamily="34" charset="-120"/>
               </a:rPr>
-              <a:t>КРИТЕРИЙ ДОСТИЖЕНИЯ</a:t>
+              <a:t>ВОПРОС — КРИТЕРИЙ ДОСТИЖЕНИЯ</a:t>
             </a:r>
             <a:endParaRPr lang="en-US" sz="900" dirty="0"/>
           </a:p>
@@ -2431,8 +2520,8 @@
         </p:nvSpPr>
         <p:spPr>
           <a:xfrm>
-            <a:off x="795528" y="5367528"/>
-            <a:ext cx="2935224" cy="594360"/>
+            <a:off x="795528" y="5477256"/>
+            <a:ext cx="2935224" cy="484632"/>
           </a:xfrm>
           <a:prstGeom prst="rect">
             <a:avLst/>
@@ -2459,7 +2548,7 @@
                 <a:ea typeface="Calibri" pitchFamily="34" charset="-122"/>
                 <a:cs typeface="Calibri" pitchFamily="34" charset="-120"/>
               </a:rPr>
-              <a:t>Пороги точности как в пилоте (см. критерии сценариев, case-21) достигнуты на новом корпусе; заказчик подтвердил полноту контента.</a:t>
+              <a:t>По каким признакам вы будете считать волну 1 завершённой и успешной?</a:t>
             </a:r>
             <a:endParaRPr lang="en-US" sz="1000" dirty="0"/>
           </a:p>
@@ -2582,7 +2671,7 @@
         <p:spPr>
           <a:xfrm>
             <a:off x="4521708" y="2697480"/>
-            <a:ext cx="3118104" cy="182880"/>
+            <a:ext cx="3118104" cy="292608"/>
           </a:xfrm>
           <a:prstGeom prst="rect">
             <a:avLst/>
@@ -2591,7 +2680,7 @@
           <a:ln/>
         </p:spPr>
         <p:txBody>
-          <a:bodyPr wrap="square" lIns="0" tIns="0" rIns="0" bIns="0" rtlCol="0" anchor="ctr"/>
+          <a:bodyPr wrap="square" lIns="0" tIns="0" rIns="0" bIns="0" rtlCol="0" anchor="t"/>
           <a:lstStyle/>
           <a:p>
             <a:pPr indent="0" marL="0">
@@ -2606,7 +2695,7 @@
                 <a:ea typeface="Calibri" pitchFamily="34" charset="-122"/>
                 <a:cs typeface="Calibri" pitchFamily="34" charset="-120"/>
               </a:rPr>
-              <a:t>ЦЕЛЬ</a:t>
+              <a:t>ВОПРОС — ЦЕЛЬ ВОЛНЫ</a:t>
             </a:r>
             <a:endParaRPr lang="en-US" sz="900" dirty="0"/>
           </a:p>
@@ -2620,8 +2709,8 @@
         </p:nvSpPr>
         <p:spPr>
           <a:xfrm>
-            <a:off x="4521708" y="2880360"/>
-            <a:ext cx="3118104" cy="566928"/>
+            <a:off x="4521708" y="2990088"/>
+            <a:ext cx="3118104" cy="475488"/>
           </a:xfrm>
           <a:prstGeom prst="rect">
             <a:avLst/>
@@ -2648,7 +2737,7 @@
                 <a:ea typeface="Calibri" pitchFamily="34" charset="-122"/>
                 <a:cs typeface="Calibri" pitchFamily="34" charset="-120"/>
               </a:rPr>
-              <a:t>Подключить согласованные витрины КХД и API шины сверх пилотных 4 источников.</a:t>
+              <a:t>Какую бизнес-задачу решает расширение ESB/КХД? Что станет возможным, чего нет сейчас?</a:t>
             </a:r>
             <a:endParaRPr lang="en-US" sz="1050" dirty="0"/>
           </a:p>
@@ -2779,7 +2868,7 @@
         <p:spPr>
           <a:xfrm>
             <a:off x="4613148" y="5166360"/>
-            <a:ext cx="2935224" cy="182880"/>
+            <a:ext cx="2935224" cy="292608"/>
           </a:xfrm>
           <a:prstGeom prst="rect">
             <a:avLst/>
@@ -2788,7 +2877,7 @@
           <a:ln/>
         </p:spPr>
         <p:txBody>
-          <a:bodyPr wrap="square" lIns="0" tIns="0" rIns="0" bIns="0" rtlCol="0" anchor="ctr"/>
+          <a:bodyPr wrap="square" lIns="0" tIns="0" rIns="0" bIns="0" rtlCol="0" anchor="t"/>
           <a:lstStyle/>
           <a:p>
             <a:pPr indent="0" marL="0">
@@ -2803,7 +2892,7 @@
                 <a:ea typeface="Calibri" pitchFamily="34" charset="-122"/>
                 <a:cs typeface="Calibri" pitchFamily="34" charset="-120"/>
               </a:rPr>
-              <a:t>КРИТЕРИЙ ДОСТИЖЕНИЯ</a:t>
+              <a:t>ВОПРОС — КРИТЕРИЙ ДОСТИЖЕНИЯ</a:t>
             </a:r>
             <a:endParaRPr lang="en-US" sz="900" dirty="0"/>
           </a:p>
@@ -2817,8 +2906,8 @@
         </p:nvSpPr>
         <p:spPr>
           <a:xfrm>
-            <a:off x="4613148" y="5367528"/>
-            <a:ext cx="2935224" cy="594360"/>
+            <a:off x="4613148" y="5477256"/>
+            <a:ext cx="2935224" cy="484632"/>
           </a:xfrm>
           <a:prstGeom prst="rect">
             <a:avLst/>
@@ -2845,7 +2934,7 @@
                 <a:ea typeface="Calibri" pitchFamily="34" charset="-122"/>
                 <a:cs typeface="Calibri" pitchFamily="34" charset="-120"/>
               </a:rPr>
-              <a:t>Витрины/API подключены и проходят приёмку по тем же сценариям, что пилот, на новом периметре данных.</a:t>
+              <a:t>По какому набору проверок/сценариев вы примете волну 2 как завершённую?</a:t>
             </a:r>
             <a:endParaRPr lang="en-US" sz="1000" dirty="0"/>
           </a:p>
@@ -2968,7 +3057,7 @@
         <p:spPr>
           <a:xfrm>
             <a:off x="8339328" y="2697480"/>
-            <a:ext cx="3118104" cy="182880"/>
+            <a:ext cx="3118104" cy="292608"/>
           </a:xfrm>
           <a:prstGeom prst="rect">
             <a:avLst/>
@@ -2977,7 +3066,7 @@
           <a:ln/>
         </p:spPr>
         <p:txBody>
-          <a:bodyPr wrap="square" lIns="0" tIns="0" rIns="0" bIns="0" rtlCol="0" anchor="ctr"/>
+          <a:bodyPr wrap="square" lIns="0" tIns="0" rIns="0" bIns="0" rtlCol="0" anchor="t"/>
           <a:lstStyle/>
           <a:p>
             <a:pPr indent="0" marL="0">
@@ -2992,7 +3081,7 @@
                 <a:ea typeface="Calibri" pitchFamily="34" charset="-122"/>
                 <a:cs typeface="Calibri" pitchFamily="34" charset="-120"/>
               </a:rPr>
-              <a:t>ЦЕЛЬ</a:t>
+              <a:t>ВОПРОС — ЦЕЛЬ ВОЛНЫ</a:t>
             </a:r>
             <a:endParaRPr lang="en-US" sz="900" dirty="0"/>
           </a:p>
@@ -3006,8 +3095,8 @@
         </p:nvSpPr>
         <p:spPr>
           <a:xfrm>
-            <a:off x="8339328" y="2880360"/>
-            <a:ext cx="3118104" cy="566928"/>
+            <a:off x="8339328" y="2990088"/>
+            <a:ext cx="3118104" cy="475488"/>
           </a:xfrm>
           <a:prstGeom prst="rect">
             <a:avLst/>
@@ -3034,7 +3123,7 @@
                 <a:ea typeface="Calibri" pitchFamily="34" charset="-122"/>
                 <a:cs typeface="Calibri" pitchFamily="34" charset="-120"/>
               </a:rPr>
-              <a:t>Не определена — зависит от исхода волны 2 (см. кандидаты).</a:t>
+              <a:t>Когда направление определится — какая бизнес-цель будет стоять за волной 3+?</a:t>
             </a:r>
             <a:endParaRPr lang="en-US" sz="1050" dirty="0"/>
           </a:p>
@@ -3165,7 +3254,7 @@
         <p:spPr>
           <a:xfrm>
             <a:off x="8430768" y="5166360"/>
-            <a:ext cx="2935224" cy="182880"/>
+            <a:ext cx="2935224" cy="292608"/>
           </a:xfrm>
           <a:prstGeom prst="rect">
             <a:avLst/>
@@ -3174,7 +3263,7 @@
           <a:ln/>
         </p:spPr>
         <p:txBody>
-          <a:bodyPr wrap="square" lIns="0" tIns="0" rIns="0" bIns="0" rtlCol="0" anchor="ctr"/>
+          <a:bodyPr wrap="square" lIns="0" tIns="0" rIns="0" bIns="0" rtlCol="0" anchor="t"/>
           <a:lstStyle/>
           <a:p>
             <a:pPr indent="0" marL="0">
@@ -3189,7 +3278,7 @@
                 <a:ea typeface="Calibri" pitchFamily="34" charset="-122"/>
                 <a:cs typeface="Calibri" pitchFamily="34" charset="-120"/>
               </a:rPr>
-              <a:t>КРИТЕРИЙ ДОСТИЖЕНИЯ</a:t>
+              <a:t>ВОПРОС — КРИТЕРИЙ ДОСТИЖЕНИЯ</a:t>
             </a:r>
             <a:endParaRPr lang="en-US" sz="900" dirty="0"/>
           </a:p>
@@ -3203,8 +3292,8 @@
         </p:nvSpPr>
         <p:spPr>
           <a:xfrm>
-            <a:off x="8430768" y="5367528"/>
-            <a:ext cx="2935224" cy="594360"/>
+            <a:off x="8430768" y="5477256"/>
+            <a:ext cx="2935224" cy="484632"/>
           </a:xfrm>
           <a:prstGeom prst="rect">
             <a:avLst/>
@@ -3231,7 +3320,7 @@
                 <a:ea typeface="Calibri" pitchFamily="34" charset="-122"/>
                 <a:cs typeface="Calibri" pitchFamily="34" charset="-120"/>
               </a:rPr>
-              <a:t>Будет сформулирован вместе с направлением волны — тот же принцип: тестовые сценарии + приёмка на новом периметре (методика, П3).</a:t>
+              <a:t>Какими критериями вы будете руководствоваться при выборе направления?</a:t>
             </a:r>
             <a:endParaRPr lang="en-US" sz="1000" dirty="0"/>
           </a:p>
@@ -3270,7 +3359,7 @@
                 <a:ea typeface="Calibri" pitchFamily="34" charset="-122"/>
                 <a:cs typeface="Calibri" pitchFamily="34" charset="-120"/>
               </a:rPr>
-              <a:t>2 / 6</a:t>
+              <a:t>2 / 7</a:t>
             </a:r>
             <a:endParaRPr lang="en-US" sz="1050" dirty="0"/>
           </a:p>
@@ -5368,7 +5457,7 @@
                 <a:ea typeface="Calibri" pitchFamily="34" charset="-122"/>
                 <a:cs typeface="Calibri" pitchFamily="34" charset="-120"/>
               </a:rPr>
-              <a:t>3 / 6</a:t>
+              <a:t>3 / 7</a:t>
             </a:r>
             <a:endParaRPr lang="en-US" sz="1050" dirty="0"/>
           </a:p>
@@ -8671,7 +8760,7 @@
                 <a:ea typeface="Calibri" pitchFamily="34" charset="-122"/>
                 <a:cs typeface="Calibri" pitchFamily="34" charset="-120"/>
               </a:rPr>
-              <a:t>4 / 6</a:t>
+              <a:t>4 / 7</a:t>
             </a:r>
             <a:endParaRPr lang="en-US" sz="1050" dirty="0"/>
           </a:p>
@@ -9208,7 +9297,7 @@
                           <a:ea typeface="Calibri" pitchFamily="34" charset="-122"/>
                           <a:cs typeface="Calibri" pitchFamily="34" charset="-120"/>
                         </a:rPr>
-                        <a:t>8</a:t>
+                        <a:t>11</a:t>
                       </a:r>
                       <a:endParaRPr lang="en-US" sz="1100" dirty="0">
                         <a:latin typeface="Calibri" charset="0"/>
@@ -9535,7 +9624,7 @@
                           <a:ea typeface="Calibri" pitchFamily="34" charset="-122"/>
                           <a:cs typeface="Calibri" pitchFamily="34" charset="-120"/>
                         </a:rPr>
-                        <a:t>9</a:t>
+                        <a:t>14</a:t>
                       </a:r>
                       <a:endParaRPr lang="en-US" sz="1100" dirty="0">
                         <a:latin typeface="Calibri" charset="0"/>
@@ -9862,7 +9951,7 @@
                           <a:ea typeface="Calibri" pitchFamily="34" charset="-122"/>
                           <a:cs typeface="Calibri" pitchFamily="34" charset="-120"/>
                         </a:rPr>
-                        <a:t>10</a:t>
+                        <a:t>15</a:t>
                       </a:r>
                       <a:endParaRPr lang="en-US" sz="1100" dirty="0">
                         <a:latin typeface="Calibri" charset="0"/>
@@ -10189,7 +10278,7 @@
                           <a:ea typeface="Calibri" pitchFamily="34" charset="-122"/>
                           <a:cs typeface="Calibri" pitchFamily="34" charset="-120"/>
                         </a:rPr>
-                        <a:t>11</a:t>
+                        <a:t>16</a:t>
                       </a:r>
                       <a:endParaRPr lang="en-US" sz="1100" dirty="0">
                         <a:latin typeface="Calibri" charset="0"/>
@@ -10535,7 +10624,7 @@
                 <a:ea typeface="Calibri" pitchFamily="34" charset="-122"/>
                 <a:cs typeface="Calibri" pitchFamily="34" charset="-120"/>
               </a:rPr>
-              <a:t>5 / 6</a:t>
+              <a:t>5 / 7</a:t>
             </a:r>
             <a:endParaRPr lang="en-US" sz="1050" dirty="0"/>
           </a:p>
@@ -10599,7 +10688,1607 @@
                 <a:ea typeface="Calibri" pitchFamily="34" charset="-122"/>
                 <a:cs typeface="Calibri" pitchFamily="34" charset="-120"/>
               </a:rPr>
-              <a:t>5 · АРХИТЕКТУРА ПИЛОТА</a:t>
+              <a:t>5 · НАШИ ПРЕДЛОЖЕНИЯ</a:t>
+            </a:r>
+            <a:endParaRPr lang="en-US" sz="1100" dirty="0"/>
+          </a:p>
+        </p:txBody>
+      </p:sp>
+      <p:sp>
+        <p:nvSpPr>
+          <p:cNvPr id="3" name="Text 1"/>
+          <p:cNvSpPr txBox="1"/>
+          <p:nvPr/>
+        </p:nvSpPr>
+        <p:spPr>
+          <a:xfrm>
+            <a:off x="502920" y="621792"/>
+            <a:ext cx="11155680" cy="548640"/>
+          </a:xfrm>
+          <a:prstGeom prst="rect">
+            <a:avLst/>
+          </a:prstGeom>
+          <a:noFill/>
+          <a:ln/>
+        </p:spPr>
+        <p:txBody>
+          <a:bodyPr wrap="square" lIns="0" tIns="0" rIns="0" bIns="0" rtlCol="0" anchor="ctr"/>
+          <a:lstStyle/>
+          <a:p>
+            <a:pPr indent="0" marL="0">
+              <a:buNone/>
+            </a:pPr>
+            <a:r>
+              <a:rPr lang="en-US" sz="2700" b="1" dirty="0">
+                <a:solidFill>
+                  <a:srgbClr val="1A2733"/>
+                </a:solidFill>
+                <a:latin typeface="Cambria" pitchFamily="34" charset="0"/>
+                <a:ea typeface="Cambria" pitchFamily="34" charset="-122"/>
+                <a:cs typeface="Cambria" pitchFamily="34" charset="-120"/>
+              </a:rPr>
+              <a:t>Рабочая позиция по умолчанию</a:t>
+            </a:r>
+            <a:endParaRPr lang="en-US" sz="2700" dirty="0"/>
+          </a:p>
+        </p:txBody>
+      </p:sp>
+      <p:sp>
+        <p:nvSpPr>
+          <p:cNvPr id="4" name="Text 2"/>
+          <p:cNvSpPr txBox="1"/>
+          <p:nvPr/>
+        </p:nvSpPr>
+        <p:spPr>
+          <a:xfrm>
+            <a:off x="502920" y="1170432"/>
+            <a:ext cx="11155680" cy="365760"/>
+          </a:xfrm>
+          <a:prstGeom prst="rect">
+            <a:avLst/>
+          </a:prstGeom>
+          <a:noFill/>
+          <a:ln/>
+        </p:spPr>
+        <p:txBody>
+          <a:bodyPr wrap="square" lIns="0" tIns="0" rIns="0" bIns="0" rtlCol="0" anchor="ctr"/>
+          <a:lstStyle/>
+          <a:p>
+            <a:pPr indent="0" marL="0">
+              <a:buNone/>
+            </a:pPr>
+            <a:r>
+              <a:rPr lang="en-US" sz="1300" dirty="0">
+                <a:solidFill>
+                  <a:srgbClr val="5B6B7A"/>
+                </a:solidFill>
+                <a:latin typeface="Calibri" pitchFamily="34" charset="0"/>
+                <a:ea typeface="Calibri" pitchFamily="34" charset="-122"/>
+                <a:cs typeface="Calibri" pitchFamily="34" charset="-120"/>
+              </a:rPr>
+              <a:t>На основе программы проекта — проще поправить готовое предложение, чем отвечать на открытый вопрос с нуля</a:t>
+            </a:r>
+            <a:endParaRPr lang="en-US" sz="1300" dirty="0"/>
+          </a:p>
+        </p:txBody>
+      </p:sp>
+      <p:graphicFrame>
+        <p:nvGraphicFramePr>
+          <p:cNvPr id="7" name="Table 0"/>
+          <p:cNvGraphicFramePr>
+            <a:graphicFrameLocks noGrp="1"/>
+          </p:cNvGraphicFramePr>
+          <p:nvPr>
+            <p:extLst>
+              <p:ext uri="{D42A27DB-BD31-4B8C-83A1-F6EECF244321}">
+                <p14:modId xmlns:p14="http://schemas.microsoft.com/office/powerpoint/2010/main" val="1579011935"/>
+              </p:ext>
+            </p:extLst>
+          </p:nvPr>
+        </p:nvGraphicFramePr>
+        <p:xfrm>
+          <a:off x="502920" y="1691640"/>
+          <a:ext cx="11155680" cy="4480560"/>
+        </p:xfrm>
+        <a:graphic>
+          <a:graphicData uri="http://schemas.openxmlformats.org/drawingml/2006/table">
+            <a:tbl>
+              <a:tblPr/>
+              <a:tblGrid>
+                <a:gridCol w="548640"/>
+                <a:gridCol w="4754880"/>
+                <a:gridCol w="5852160"/>
+              </a:tblGrid>
+              <a:tr h="640080">
+                <a:tc>
+                  <a:txBody>
+                    <a:bodyPr/>
+                    <a:lstStyle/>
+                    <a:p>
+                      <a:pPr algn="ctr" indent="0" marL="0">
+                        <a:buNone/>
+                      </a:pPr>
+                      <a:r>
+                        <a:rPr lang="en-US" sz="1100" b="1" dirty="0">
+                          <a:solidFill>
+                            <a:srgbClr val="FFFFFF"/>
+                          </a:solidFill>
+                          <a:latin typeface="Calibri" pitchFamily="34" charset="0"/>
+                          <a:ea typeface="Calibri" pitchFamily="34" charset="-122"/>
+                          <a:cs typeface="Calibri" pitchFamily="34" charset="-120"/>
+                        </a:rPr>
+                        <a:t>№</a:t>
+                      </a:r>
+                      <a:endParaRPr lang="en-US" sz="1100" dirty="0">
+                        <a:latin typeface="Calibri" charset="0"/>
+                        <a:ea typeface="Calibri" charset="0"/>
+                        <a:cs typeface="Calibri" charset="0"/>
+                      </a:endParaRPr>
+                    </a:p>
+                  </a:txBody>
+                  <a:tcPr marL="114300" marR="114300" marT="76200" marB="76200" anchor="ctr">
+                    <a:lnL w="9525" cap="flat" cmpd="sng" algn="ctr">
+                      <a:solidFill>
+                        <a:srgbClr val="D8DEE2"/>
+                      </a:solidFill>
+                      <a:prstDash val="solid"/>
+                      <a:round/>
+                      <a:headEnd type="none" w="med" len="med"/>
+                      <a:tailEnd type="none" w="med" len="med"/>
+                    </a:lnL>
+                    <a:lnR w="9525" cap="flat" cmpd="sng" algn="ctr">
+                      <a:solidFill>
+                        <a:srgbClr val="D8DEE2"/>
+                      </a:solidFill>
+                      <a:prstDash val="solid"/>
+                      <a:round/>
+                      <a:headEnd type="none" w="med" len="med"/>
+                      <a:tailEnd type="none" w="med" len="med"/>
+                    </a:lnR>
+                    <a:lnT w="9525" cap="flat" cmpd="sng" algn="ctr">
+                      <a:solidFill>
+                        <a:srgbClr val="D8DEE2"/>
+                      </a:solidFill>
+                      <a:prstDash val="solid"/>
+                      <a:round/>
+                      <a:headEnd type="none" w="med" len="med"/>
+                      <a:tailEnd type="none" w="med" len="med"/>
+                    </a:lnT>
+                    <a:lnB w="9525" cap="flat" cmpd="sng" algn="ctr">
+                      <a:solidFill>
+                        <a:srgbClr val="D8DEE2"/>
+                      </a:solidFill>
+                      <a:prstDash val="solid"/>
+                      <a:round/>
+                      <a:headEnd type="none" w="med" len="med"/>
+                      <a:tailEnd type="none" w="med" len="med"/>
+                    </a:lnB>
+                    <a:solidFill>
+                      <a:srgbClr val="1A2733"/>
+                    </a:solidFill>
+                  </a:tcPr>
+                </a:tc>
+                <a:tc>
+                  <a:txBody>
+                    <a:bodyPr/>
+                    <a:lstStyle/>
+                    <a:p>
+                      <a:pPr indent="0" marL="0">
+                        <a:buNone/>
+                      </a:pPr>
+                      <a:r>
+                        <a:rPr lang="en-US" sz="1100" b="1" dirty="0">
+                          <a:solidFill>
+                            <a:srgbClr val="FFFFFF"/>
+                          </a:solidFill>
+                          <a:latin typeface="Calibri" pitchFamily="34" charset="0"/>
+                          <a:ea typeface="Calibri" pitchFamily="34" charset="-122"/>
+                          <a:cs typeface="Calibri" pitchFamily="34" charset="-120"/>
+                        </a:rPr>
+                        <a:t>Предложение</a:t>
+                      </a:r>
+                      <a:endParaRPr lang="en-US" sz="1100" dirty="0">
+                        <a:latin typeface="Calibri" charset="0"/>
+                        <a:ea typeface="Calibri" charset="0"/>
+                        <a:cs typeface="Calibri" charset="0"/>
+                      </a:endParaRPr>
+                    </a:p>
+                  </a:txBody>
+                  <a:tcPr marL="114300" marR="114300" marT="76200" marB="76200" anchor="ctr">
+                    <a:lnL w="9525" cap="flat" cmpd="sng" algn="ctr">
+                      <a:solidFill>
+                        <a:srgbClr val="D8DEE2"/>
+                      </a:solidFill>
+                      <a:prstDash val="solid"/>
+                      <a:round/>
+                      <a:headEnd type="none" w="med" len="med"/>
+                      <a:tailEnd type="none" w="med" len="med"/>
+                    </a:lnL>
+                    <a:lnR w="9525" cap="flat" cmpd="sng" algn="ctr">
+                      <a:solidFill>
+                        <a:srgbClr val="D8DEE2"/>
+                      </a:solidFill>
+                      <a:prstDash val="solid"/>
+                      <a:round/>
+                      <a:headEnd type="none" w="med" len="med"/>
+                      <a:tailEnd type="none" w="med" len="med"/>
+                    </a:lnR>
+                    <a:lnT w="9525" cap="flat" cmpd="sng" algn="ctr">
+                      <a:solidFill>
+                        <a:srgbClr val="D8DEE2"/>
+                      </a:solidFill>
+                      <a:prstDash val="solid"/>
+                      <a:round/>
+                      <a:headEnd type="none" w="med" len="med"/>
+                      <a:tailEnd type="none" w="med" len="med"/>
+                    </a:lnT>
+                    <a:lnB w="9525" cap="flat" cmpd="sng" algn="ctr">
+                      <a:solidFill>
+                        <a:srgbClr val="D8DEE2"/>
+                      </a:solidFill>
+                      <a:prstDash val="solid"/>
+                      <a:round/>
+                      <a:headEnd type="none" w="med" len="med"/>
+                      <a:tailEnd type="none" w="med" len="med"/>
+                    </a:lnB>
+                    <a:solidFill>
+                      <a:srgbClr val="1A2733"/>
+                    </a:solidFill>
+                  </a:tcPr>
+                </a:tc>
+                <a:tc>
+                  <a:txBody>
+                    <a:bodyPr/>
+                    <a:lstStyle/>
+                    <a:p>
+                      <a:pPr indent="0" marL="0">
+                        <a:buNone/>
+                      </a:pPr>
+                      <a:r>
+                        <a:rPr lang="en-US" sz="1100" b="1" dirty="0">
+                          <a:solidFill>
+                            <a:srgbClr val="FFFFFF"/>
+                          </a:solidFill>
+                          <a:latin typeface="Calibri" pitchFamily="34" charset="0"/>
+                          <a:ea typeface="Calibri" pitchFamily="34" charset="-122"/>
+                          <a:cs typeface="Calibri" pitchFamily="34" charset="-120"/>
+                        </a:rPr>
+                        <a:t>Обоснование</a:t>
+                      </a:r>
+                      <a:endParaRPr lang="en-US" sz="1100" dirty="0">
+                        <a:latin typeface="Calibri" charset="0"/>
+                        <a:ea typeface="Calibri" charset="0"/>
+                        <a:cs typeface="Calibri" charset="0"/>
+                      </a:endParaRPr>
+                    </a:p>
+                  </a:txBody>
+                  <a:tcPr marL="114300" marR="114300" marT="76200" marB="76200" anchor="ctr">
+                    <a:lnL w="9525" cap="flat" cmpd="sng" algn="ctr">
+                      <a:solidFill>
+                        <a:srgbClr val="D8DEE2"/>
+                      </a:solidFill>
+                      <a:prstDash val="solid"/>
+                      <a:round/>
+                      <a:headEnd type="none" w="med" len="med"/>
+                      <a:tailEnd type="none" w="med" len="med"/>
+                    </a:lnL>
+                    <a:lnR w="9525" cap="flat" cmpd="sng" algn="ctr">
+                      <a:solidFill>
+                        <a:srgbClr val="D8DEE2"/>
+                      </a:solidFill>
+                      <a:prstDash val="solid"/>
+                      <a:round/>
+                      <a:headEnd type="none" w="med" len="med"/>
+                      <a:tailEnd type="none" w="med" len="med"/>
+                    </a:lnR>
+                    <a:lnT w="9525" cap="flat" cmpd="sng" algn="ctr">
+                      <a:solidFill>
+                        <a:srgbClr val="D8DEE2"/>
+                      </a:solidFill>
+                      <a:prstDash val="solid"/>
+                      <a:round/>
+                      <a:headEnd type="none" w="med" len="med"/>
+                      <a:tailEnd type="none" w="med" len="med"/>
+                    </a:lnT>
+                    <a:lnB w="9525" cap="flat" cmpd="sng" algn="ctr">
+                      <a:solidFill>
+                        <a:srgbClr val="D8DEE2"/>
+                      </a:solidFill>
+                      <a:prstDash val="solid"/>
+                      <a:round/>
+                      <a:headEnd type="none" w="med" len="med"/>
+                      <a:tailEnd type="none" w="med" len="med"/>
+                    </a:lnB>
+                    <a:solidFill>
+                      <a:srgbClr val="1A2733"/>
+                    </a:solidFill>
+                  </a:tcPr>
+                </a:tc>
+              </a:tr>
+              <a:tr h="640080">
+                <a:tc>
+                  <a:txBody>
+                    <a:bodyPr/>
+                    <a:lstStyle/>
+                    <a:p>
+                      <a:pPr algn="ctr" indent="0" marL="0">
+                        <a:buNone/>
+                      </a:pPr>
+                      <a:r>
+                        <a:rPr lang="en-US" sz="1100" dirty="0">
+                          <a:solidFill>
+                            <a:srgbClr val="5B6B7A"/>
+                          </a:solidFill>
+                          <a:latin typeface="Calibri" pitchFamily="34" charset="0"/>
+                          <a:ea typeface="Calibri" pitchFamily="34" charset="-122"/>
+                          <a:cs typeface="Calibri" pitchFamily="34" charset="-120"/>
+                        </a:rPr>
+                        <a:t>1</a:t>
+                      </a:r>
+                      <a:endParaRPr lang="en-US" sz="1100" dirty="0">
+                        <a:latin typeface="Calibri" charset="0"/>
+                        <a:ea typeface="Calibri" charset="0"/>
+                        <a:cs typeface="Calibri" charset="0"/>
+                      </a:endParaRPr>
+                    </a:p>
+                  </a:txBody>
+                  <a:tcPr marL="114300" marR="114300" marT="76200" marB="76200" anchor="ctr">
+                    <a:lnL w="9525" cap="flat" cmpd="sng" algn="ctr">
+                      <a:solidFill>
+                        <a:srgbClr val="D8DEE2"/>
+                      </a:solidFill>
+                      <a:prstDash val="solid"/>
+                      <a:round/>
+                      <a:headEnd type="none" w="med" len="med"/>
+                      <a:tailEnd type="none" w="med" len="med"/>
+                    </a:lnL>
+                    <a:lnR w="9525" cap="flat" cmpd="sng" algn="ctr">
+                      <a:solidFill>
+                        <a:srgbClr val="D8DEE2"/>
+                      </a:solidFill>
+                      <a:prstDash val="solid"/>
+                      <a:round/>
+                      <a:headEnd type="none" w="med" len="med"/>
+                      <a:tailEnd type="none" w="med" len="med"/>
+                    </a:lnR>
+                    <a:lnT w="9525" cap="flat" cmpd="sng" algn="ctr">
+                      <a:solidFill>
+                        <a:srgbClr val="D8DEE2"/>
+                      </a:solidFill>
+                      <a:prstDash val="solid"/>
+                      <a:round/>
+                      <a:headEnd type="none" w="med" len="med"/>
+                      <a:tailEnd type="none" w="med" len="med"/>
+                    </a:lnT>
+                    <a:lnB w="9525" cap="flat" cmpd="sng" algn="ctr">
+                      <a:solidFill>
+                        <a:srgbClr val="D8DEE2"/>
+                      </a:solidFill>
+                      <a:prstDash val="solid"/>
+                      <a:round/>
+                      <a:headEnd type="none" w="med" len="med"/>
+                      <a:tailEnd type="none" w="med" len="med"/>
+                    </a:lnB>
+                  </a:tcPr>
+                </a:tc>
+                <a:tc>
+                  <a:txBody>
+                    <a:bodyPr/>
+                    <a:lstStyle/>
+                    <a:p>
+                      <a:pPr indent="0" marL="0">
+                        <a:buNone/>
+                      </a:pPr>
+                      <a:r>
+                        <a:rPr lang="en-US" sz="1100" b="1" dirty="0">
+                          <a:solidFill>
+                            <a:srgbClr val="1A2733"/>
+                          </a:solidFill>
+                          <a:latin typeface="Calibri" pitchFamily="34" charset="0"/>
+                          <a:ea typeface="Calibri" pitchFamily="34" charset="-122"/>
+                          <a:cs typeface="Calibri" pitchFamily="34" charset="-120"/>
+                        </a:rPr>
+                        <a:t>Волна 1 — закрыть звонком, не перепиской</a:t>
+                      </a:r>
+                      <a:endParaRPr lang="en-US" sz="1100" dirty="0">
+                        <a:latin typeface="Calibri" charset="0"/>
+                        <a:ea typeface="Calibri" charset="0"/>
+                        <a:cs typeface="Calibri" charset="0"/>
+                      </a:endParaRPr>
+                    </a:p>
+                  </a:txBody>
+                  <a:tcPr marL="114300" marR="114300" marT="76200" marB="76200" anchor="ctr">
+                    <a:lnL w="9525" cap="flat" cmpd="sng" algn="ctr">
+                      <a:solidFill>
+                        <a:srgbClr val="D8DEE2"/>
+                      </a:solidFill>
+                      <a:prstDash val="solid"/>
+                      <a:round/>
+                      <a:headEnd type="none" w="med" len="med"/>
+                      <a:tailEnd type="none" w="med" len="med"/>
+                    </a:lnL>
+                    <a:lnR w="9525" cap="flat" cmpd="sng" algn="ctr">
+                      <a:solidFill>
+                        <a:srgbClr val="D8DEE2"/>
+                      </a:solidFill>
+                      <a:prstDash val="solid"/>
+                      <a:round/>
+                      <a:headEnd type="none" w="med" len="med"/>
+                      <a:tailEnd type="none" w="med" len="med"/>
+                    </a:lnR>
+                    <a:lnT w="9525" cap="flat" cmpd="sng" algn="ctr">
+                      <a:solidFill>
+                        <a:srgbClr val="D8DEE2"/>
+                      </a:solidFill>
+                      <a:prstDash val="solid"/>
+                      <a:round/>
+                      <a:headEnd type="none" w="med" len="med"/>
+                      <a:tailEnd type="none" w="med" len="med"/>
+                    </a:lnT>
+                    <a:lnB w="9525" cap="flat" cmpd="sng" algn="ctr">
+                      <a:solidFill>
+                        <a:srgbClr val="D8DEE2"/>
+                      </a:solidFill>
+                      <a:prstDash val="solid"/>
+                      <a:round/>
+                      <a:headEnd type="none" w="med" len="med"/>
+                      <a:tailEnd type="none" w="med" len="med"/>
+                    </a:lnB>
+                  </a:tcPr>
+                </a:tc>
+                <a:tc>
+                  <a:txBody>
+                    <a:bodyPr/>
+                    <a:lstStyle/>
+                    <a:p>
+                      <a:pPr indent="0" marL="0">
+                        <a:buNone/>
+                      </a:pPr>
+                      <a:r>
+                        <a:rPr lang="en-US" sz="1050" dirty="0">
+                          <a:solidFill>
+                            <a:srgbClr val="5B6B7A"/>
+                          </a:solidFill>
+                          <a:latin typeface="Calibri" pitchFamily="34" charset="0"/>
+                          <a:ea typeface="Calibri" pitchFamily="34" charset="-122"/>
+                          <a:cs typeface="Calibri" pitchFamily="34" charset="-120"/>
+                        </a:rPr>
+                        <a:t>Три толкования слишком разные по объёму работ, чтобы гадать — первый вопрос из всего списка.</a:t>
+                      </a:r>
+                      <a:endParaRPr lang="en-US" sz="1050" dirty="0">
+                        <a:latin typeface="Calibri" charset="0"/>
+                        <a:ea typeface="Calibri" charset="0"/>
+                        <a:cs typeface="Calibri" charset="0"/>
+                      </a:endParaRPr>
+                    </a:p>
+                  </a:txBody>
+                  <a:tcPr marL="114300" marR="114300" marT="76200" marB="76200" anchor="ctr">
+                    <a:lnL w="9525" cap="flat" cmpd="sng" algn="ctr">
+                      <a:solidFill>
+                        <a:srgbClr val="D8DEE2"/>
+                      </a:solidFill>
+                      <a:prstDash val="solid"/>
+                      <a:round/>
+                      <a:headEnd type="none" w="med" len="med"/>
+                      <a:tailEnd type="none" w="med" len="med"/>
+                    </a:lnL>
+                    <a:lnR w="9525" cap="flat" cmpd="sng" algn="ctr">
+                      <a:solidFill>
+                        <a:srgbClr val="D8DEE2"/>
+                      </a:solidFill>
+                      <a:prstDash val="solid"/>
+                      <a:round/>
+                      <a:headEnd type="none" w="med" len="med"/>
+                      <a:tailEnd type="none" w="med" len="med"/>
+                    </a:lnR>
+                    <a:lnT w="9525" cap="flat" cmpd="sng" algn="ctr">
+                      <a:solidFill>
+                        <a:srgbClr val="D8DEE2"/>
+                      </a:solidFill>
+                      <a:prstDash val="solid"/>
+                      <a:round/>
+                      <a:headEnd type="none" w="med" len="med"/>
+                      <a:tailEnd type="none" w="med" len="med"/>
+                    </a:lnT>
+                    <a:lnB w="9525" cap="flat" cmpd="sng" algn="ctr">
+                      <a:solidFill>
+                        <a:srgbClr val="D8DEE2"/>
+                      </a:solidFill>
+                      <a:prstDash val="solid"/>
+                      <a:round/>
+                      <a:headEnd type="none" w="med" len="med"/>
+                      <a:tailEnd type="none" w="med" len="med"/>
+                    </a:lnB>
+                  </a:tcPr>
+                </a:tc>
+              </a:tr>
+              <a:tr h="640080">
+                <a:tc>
+                  <a:txBody>
+                    <a:bodyPr/>
+                    <a:lstStyle/>
+                    <a:p>
+                      <a:pPr algn="ctr" indent="0" marL="0">
+                        <a:buNone/>
+                      </a:pPr>
+                      <a:r>
+                        <a:rPr lang="en-US" sz="1100" dirty="0">
+                          <a:solidFill>
+                            <a:srgbClr val="5B6B7A"/>
+                          </a:solidFill>
+                          <a:latin typeface="Calibri" pitchFamily="34" charset="0"/>
+                          <a:ea typeface="Calibri" pitchFamily="34" charset="-122"/>
+                          <a:cs typeface="Calibri" pitchFamily="34" charset="-120"/>
+                        </a:rPr>
+                        <a:t>2</a:t>
+                      </a:r>
+                      <a:endParaRPr lang="en-US" sz="1100" dirty="0">
+                        <a:latin typeface="Calibri" charset="0"/>
+                        <a:ea typeface="Calibri" charset="0"/>
+                        <a:cs typeface="Calibri" charset="0"/>
+                      </a:endParaRPr>
+                    </a:p>
+                  </a:txBody>
+                  <a:tcPr marL="114300" marR="114300" marT="76200" marB="76200" anchor="ctr">
+                    <a:lnL w="9525" cap="flat" cmpd="sng" algn="ctr">
+                      <a:solidFill>
+                        <a:srgbClr val="D8DEE2"/>
+                      </a:solidFill>
+                      <a:prstDash val="solid"/>
+                      <a:round/>
+                      <a:headEnd type="none" w="med" len="med"/>
+                      <a:tailEnd type="none" w="med" len="med"/>
+                    </a:lnL>
+                    <a:lnR w="9525" cap="flat" cmpd="sng" algn="ctr">
+                      <a:solidFill>
+                        <a:srgbClr val="D8DEE2"/>
+                      </a:solidFill>
+                      <a:prstDash val="solid"/>
+                      <a:round/>
+                      <a:headEnd type="none" w="med" len="med"/>
+                      <a:tailEnd type="none" w="med" len="med"/>
+                    </a:lnR>
+                    <a:lnT w="9525" cap="flat" cmpd="sng" algn="ctr">
+                      <a:solidFill>
+                        <a:srgbClr val="D8DEE2"/>
+                      </a:solidFill>
+                      <a:prstDash val="solid"/>
+                      <a:round/>
+                      <a:headEnd type="none" w="med" len="med"/>
+                      <a:tailEnd type="none" w="med" len="med"/>
+                    </a:lnT>
+                    <a:lnB w="9525" cap="flat" cmpd="sng" algn="ctr">
+                      <a:solidFill>
+                        <a:srgbClr val="D8DEE2"/>
+                      </a:solidFill>
+                      <a:prstDash val="solid"/>
+                      <a:round/>
+                      <a:headEnd type="none" w="med" len="med"/>
+                      <a:tailEnd type="none" w="med" len="med"/>
+                    </a:lnB>
+                  </a:tcPr>
+                </a:tc>
+                <a:tc>
+                  <a:txBody>
+                    <a:bodyPr/>
+                    <a:lstStyle/>
+                    <a:p>
+                      <a:pPr indent="0" marL="0">
+                        <a:buNone/>
+                      </a:pPr>
+                      <a:r>
+                        <a:rPr lang="en-US" sz="1100" b="1" dirty="0">
+                          <a:solidFill>
+                            <a:srgbClr val="1A2733"/>
+                          </a:solidFill>
+                          <a:latin typeface="Calibri" pitchFamily="34" charset="0"/>
+                          <a:ea typeface="Calibri" pitchFamily="34" charset="-122"/>
+                          <a:cs typeface="Calibri" pitchFamily="34" charset="-120"/>
+                        </a:rPr>
+                        <a:t>ESB/КХД (волна 2) зафиксировать письменно как есть — расширение, не сужение</a:t>
+                      </a:r>
+                      <a:endParaRPr lang="en-US" sz="1100" dirty="0">
+                        <a:latin typeface="Calibri" charset="0"/>
+                        <a:ea typeface="Calibri" charset="0"/>
+                        <a:cs typeface="Calibri" charset="0"/>
+                      </a:endParaRPr>
+                    </a:p>
+                  </a:txBody>
+                  <a:tcPr marL="114300" marR="114300" marT="76200" marB="76200" anchor="ctr">
+                    <a:lnL w="9525" cap="flat" cmpd="sng" algn="ctr">
+                      <a:solidFill>
+                        <a:srgbClr val="D8DEE2"/>
+                      </a:solidFill>
+                      <a:prstDash val="solid"/>
+                      <a:round/>
+                      <a:headEnd type="none" w="med" len="med"/>
+                      <a:tailEnd type="none" w="med" len="med"/>
+                    </a:lnL>
+                    <a:lnR w="9525" cap="flat" cmpd="sng" algn="ctr">
+                      <a:solidFill>
+                        <a:srgbClr val="D8DEE2"/>
+                      </a:solidFill>
+                      <a:prstDash val="solid"/>
+                      <a:round/>
+                      <a:headEnd type="none" w="med" len="med"/>
+                      <a:tailEnd type="none" w="med" len="med"/>
+                    </a:lnR>
+                    <a:lnT w="9525" cap="flat" cmpd="sng" algn="ctr">
+                      <a:solidFill>
+                        <a:srgbClr val="D8DEE2"/>
+                      </a:solidFill>
+                      <a:prstDash val="solid"/>
+                      <a:round/>
+                      <a:headEnd type="none" w="med" len="med"/>
+                      <a:tailEnd type="none" w="med" len="med"/>
+                    </a:lnT>
+                    <a:lnB w="9525" cap="flat" cmpd="sng" algn="ctr">
+                      <a:solidFill>
+                        <a:srgbClr val="D8DEE2"/>
+                      </a:solidFill>
+                      <a:prstDash val="solid"/>
+                      <a:round/>
+                      <a:headEnd type="none" w="med" len="med"/>
+                      <a:tailEnd type="none" w="med" len="med"/>
+                    </a:lnB>
+                  </a:tcPr>
+                </a:tc>
+                <a:tc>
+                  <a:txBody>
+                    <a:bodyPr/>
+                    <a:lstStyle/>
+                    <a:p>
+                      <a:pPr indent="0" marL="0">
+                        <a:buNone/>
+                      </a:pPr>
+                      <a:r>
+                        <a:rPr lang="en-US" sz="1050" dirty="0">
+                          <a:solidFill>
+                            <a:srgbClr val="5B6B7A"/>
+                          </a:solidFill>
+                          <a:latin typeface="Calibri" pitchFamily="34" charset="0"/>
+                          <a:ea typeface="Calibri" pitchFamily="34" charset="-122"/>
+                          <a:cs typeface="Calibri" pitchFamily="34" charset="-120"/>
+                        </a:rPr>
+                        <a:t>Все 3 пилотных источника остаются; ESB и КХД получают расширение, MCP-сервер — на пилотном уровне.</a:t>
+                      </a:r>
+                      <a:endParaRPr lang="en-US" sz="1050" dirty="0">
+                        <a:latin typeface="Calibri" charset="0"/>
+                        <a:ea typeface="Calibri" charset="0"/>
+                        <a:cs typeface="Calibri" charset="0"/>
+                      </a:endParaRPr>
+                    </a:p>
+                  </a:txBody>
+                  <a:tcPr marL="114300" marR="114300" marT="76200" marB="76200" anchor="ctr">
+                    <a:lnL w="9525" cap="flat" cmpd="sng" algn="ctr">
+                      <a:solidFill>
+                        <a:srgbClr val="D8DEE2"/>
+                      </a:solidFill>
+                      <a:prstDash val="solid"/>
+                      <a:round/>
+                      <a:headEnd type="none" w="med" len="med"/>
+                      <a:tailEnd type="none" w="med" len="med"/>
+                    </a:lnL>
+                    <a:lnR w="9525" cap="flat" cmpd="sng" algn="ctr">
+                      <a:solidFill>
+                        <a:srgbClr val="D8DEE2"/>
+                      </a:solidFill>
+                      <a:prstDash val="solid"/>
+                      <a:round/>
+                      <a:headEnd type="none" w="med" len="med"/>
+                      <a:tailEnd type="none" w="med" len="med"/>
+                    </a:lnR>
+                    <a:lnT w="9525" cap="flat" cmpd="sng" algn="ctr">
+                      <a:solidFill>
+                        <a:srgbClr val="D8DEE2"/>
+                      </a:solidFill>
+                      <a:prstDash val="solid"/>
+                      <a:round/>
+                      <a:headEnd type="none" w="med" len="med"/>
+                      <a:tailEnd type="none" w="med" len="med"/>
+                    </a:lnT>
+                    <a:lnB w="9525" cap="flat" cmpd="sng" algn="ctr">
+                      <a:solidFill>
+                        <a:srgbClr val="D8DEE2"/>
+                      </a:solidFill>
+                      <a:prstDash val="solid"/>
+                      <a:round/>
+                      <a:headEnd type="none" w="med" len="med"/>
+                      <a:tailEnd type="none" w="med" len="med"/>
+                    </a:lnB>
+                  </a:tcPr>
+                </a:tc>
+              </a:tr>
+              <a:tr h="640080">
+                <a:tc>
+                  <a:txBody>
+                    <a:bodyPr/>
+                    <a:lstStyle/>
+                    <a:p>
+                      <a:pPr algn="ctr" indent="0" marL="0">
+                        <a:buNone/>
+                      </a:pPr>
+                      <a:r>
+                        <a:rPr lang="en-US" sz="1100" dirty="0">
+                          <a:solidFill>
+                            <a:srgbClr val="5B6B7A"/>
+                          </a:solidFill>
+                          <a:latin typeface="Calibri" pitchFamily="34" charset="0"/>
+                          <a:ea typeface="Calibri" pitchFamily="34" charset="-122"/>
+                          <a:cs typeface="Calibri" pitchFamily="34" charset="-120"/>
+                        </a:rPr>
+                        <a:t>3</a:t>
+                      </a:r>
+                      <a:endParaRPr lang="en-US" sz="1100" dirty="0">
+                        <a:latin typeface="Calibri" charset="0"/>
+                        <a:ea typeface="Calibri" charset="0"/>
+                        <a:cs typeface="Calibri" charset="0"/>
+                      </a:endParaRPr>
+                    </a:p>
+                  </a:txBody>
+                  <a:tcPr marL="114300" marR="114300" marT="76200" marB="76200" anchor="ctr">
+                    <a:lnL w="9525" cap="flat" cmpd="sng" algn="ctr">
+                      <a:solidFill>
+                        <a:srgbClr val="D8DEE2"/>
+                      </a:solidFill>
+                      <a:prstDash val="solid"/>
+                      <a:round/>
+                      <a:headEnd type="none" w="med" len="med"/>
+                      <a:tailEnd type="none" w="med" len="med"/>
+                    </a:lnL>
+                    <a:lnR w="9525" cap="flat" cmpd="sng" algn="ctr">
+                      <a:solidFill>
+                        <a:srgbClr val="D8DEE2"/>
+                      </a:solidFill>
+                      <a:prstDash val="solid"/>
+                      <a:round/>
+                      <a:headEnd type="none" w="med" len="med"/>
+                      <a:tailEnd type="none" w="med" len="med"/>
+                    </a:lnR>
+                    <a:lnT w="9525" cap="flat" cmpd="sng" algn="ctr">
+                      <a:solidFill>
+                        <a:srgbClr val="D8DEE2"/>
+                      </a:solidFill>
+                      <a:prstDash val="solid"/>
+                      <a:round/>
+                      <a:headEnd type="none" w="med" len="med"/>
+                      <a:tailEnd type="none" w="med" len="med"/>
+                    </a:lnT>
+                    <a:lnB w="9525" cap="flat" cmpd="sng" algn="ctr">
+                      <a:solidFill>
+                        <a:srgbClr val="D8DEE2"/>
+                      </a:solidFill>
+                      <a:prstDash val="solid"/>
+                      <a:round/>
+                      <a:headEnd type="none" w="med" len="med"/>
+                      <a:tailEnd type="none" w="med" len="med"/>
+                    </a:lnB>
+                  </a:tcPr>
+                </a:tc>
+                <a:tc>
+                  <a:txBody>
+                    <a:bodyPr/>
+                    <a:lstStyle/>
+                    <a:p>
+                      <a:pPr indent="0" marL="0">
+                        <a:buNone/>
+                      </a:pPr>
+                      <a:r>
+                        <a:rPr lang="en-US" sz="1100" b="1" dirty="0">
+                          <a:solidFill>
+                            <a:srgbClr val="1A2733"/>
+                          </a:solidFill>
+                          <a:latin typeface="Calibri" pitchFamily="34" charset="0"/>
+                          <a:ea typeface="Calibri" pitchFamily="34" charset="-122"/>
+                          <a:cs typeface="Calibri" pitchFamily="34" charset="-120"/>
+                        </a:rPr>
+                        <a:t>Разграничение прав compliance/менеджер — сделать обязательным для проекта</a:t>
+                      </a:r>
+                      <a:endParaRPr lang="en-US" sz="1100" dirty="0">
+                        <a:latin typeface="Calibri" charset="0"/>
+                        <a:ea typeface="Calibri" charset="0"/>
+                        <a:cs typeface="Calibri" charset="0"/>
+                      </a:endParaRPr>
+                    </a:p>
+                  </a:txBody>
+                  <a:tcPr marL="114300" marR="114300" marT="76200" marB="76200" anchor="ctr">
+                    <a:lnL w="9525" cap="flat" cmpd="sng" algn="ctr">
+                      <a:solidFill>
+                        <a:srgbClr val="D8DEE2"/>
+                      </a:solidFill>
+                      <a:prstDash val="solid"/>
+                      <a:round/>
+                      <a:headEnd type="none" w="med" len="med"/>
+                      <a:tailEnd type="none" w="med" len="med"/>
+                    </a:lnL>
+                    <a:lnR w="9525" cap="flat" cmpd="sng" algn="ctr">
+                      <a:solidFill>
+                        <a:srgbClr val="D8DEE2"/>
+                      </a:solidFill>
+                      <a:prstDash val="solid"/>
+                      <a:round/>
+                      <a:headEnd type="none" w="med" len="med"/>
+                      <a:tailEnd type="none" w="med" len="med"/>
+                    </a:lnR>
+                    <a:lnT w="9525" cap="flat" cmpd="sng" algn="ctr">
+                      <a:solidFill>
+                        <a:srgbClr val="D8DEE2"/>
+                      </a:solidFill>
+                      <a:prstDash val="solid"/>
+                      <a:round/>
+                      <a:headEnd type="none" w="med" len="med"/>
+                      <a:tailEnd type="none" w="med" len="med"/>
+                    </a:lnT>
+                    <a:lnB w="9525" cap="flat" cmpd="sng" algn="ctr">
+                      <a:solidFill>
+                        <a:srgbClr val="D8DEE2"/>
+                      </a:solidFill>
+                      <a:prstDash val="solid"/>
+                      <a:round/>
+                      <a:headEnd type="none" w="med" len="med"/>
+                      <a:tailEnd type="none" w="med" len="med"/>
+                    </a:lnB>
+                  </a:tcPr>
+                </a:tc>
+                <a:tc>
+                  <a:txBody>
+                    <a:bodyPr/>
+                    <a:lstStyle/>
+                    <a:p>
+                      <a:pPr indent="0" marL="0">
+                        <a:buNone/>
+                      </a:pPr>
+                      <a:r>
+                        <a:rPr lang="en-US" sz="1050" dirty="0">
+                          <a:solidFill>
+                            <a:srgbClr val="5B6B7A"/>
+                          </a:solidFill>
+                          <a:latin typeface="Calibri" pitchFamily="34" charset="0"/>
+                          <a:ea typeface="Calibri" pitchFamily="34" charset="-122"/>
+                          <a:cs typeface="Calibri" pitchFamily="34" charset="-120"/>
+                        </a:rPr>
+                        <a:t>Д8 — брокер/инвесткомпания: доступ менеджера к чужим клиентам — комплаенс-риск, не UX-неудобство.</a:t>
+                      </a:r>
+                      <a:endParaRPr lang="en-US" sz="1050" dirty="0">
+                        <a:latin typeface="Calibri" charset="0"/>
+                        <a:ea typeface="Calibri" charset="0"/>
+                        <a:cs typeface="Calibri" charset="0"/>
+                      </a:endParaRPr>
+                    </a:p>
+                  </a:txBody>
+                  <a:tcPr marL="114300" marR="114300" marT="76200" marB="76200" anchor="ctr">
+                    <a:lnL w="9525" cap="flat" cmpd="sng" algn="ctr">
+                      <a:solidFill>
+                        <a:srgbClr val="D8DEE2"/>
+                      </a:solidFill>
+                      <a:prstDash val="solid"/>
+                      <a:round/>
+                      <a:headEnd type="none" w="med" len="med"/>
+                      <a:tailEnd type="none" w="med" len="med"/>
+                    </a:lnL>
+                    <a:lnR w="9525" cap="flat" cmpd="sng" algn="ctr">
+                      <a:solidFill>
+                        <a:srgbClr val="D8DEE2"/>
+                      </a:solidFill>
+                      <a:prstDash val="solid"/>
+                      <a:round/>
+                      <a:headEnd type="none" w="med" len="med"/>
+                      <a:tailEnd type="none" w="med" len="med"/>
+                    </a:lnR>
+                    <a:lnT w="9525" cap="flat" cmpd="sng" algn="ctr">
+                      <a:solidFill>
+                        <a:srgbClr val="D8DEE2"/>
+                      </a:solidFill>
+                      <a:prstDash val="solid"/>
+                      <a:round/>
+                      <a:headEnd type="none" w="med" len="med"/>
+                      <a:tailEnd type="none" w="med" len="med"/>
+                    </a:lnT>
+                    <a:lnB w="9525" cap="flat" cmpd="sng" algn="ctr">
+                      <a:solidFill>
+                        <a:srgbClr val="D8DEE2"/>
+                      </a:solidFill>
+                      <a:prstDash val="solid"/>
+                      <a:round/>
+                      <a:headEnd type="none" w="med" len="med"/>
+                      <a:tailEnd type="none" w="med" len="med"/>
+                    </a:lnB>
+                  </a:tcPr>
+                </a:tc>
+              </a:tr>
+              <a:tr h="640080">
+                <a:tc>
+                  <a:txBody>
+                    <a:bodyPr/>
+                    <a:lstStyle/>
+                    <a:p>
+                      <a:pPr algn="ctr" indent="0" marL="0">
+                        <a:buNone/>
+                      </a:pPr>
+                      <a:r>
+                        <a:rPr lang="en-US" sz="1100" dirty="0">
+                          <a:solidFill>
+                            <a:srgbClr val="5B6B7A"/>
+                          </a:solidFill>
+                          <a:latin typeface="Calibri" pitchFamily="34" charset="0"/>
+                          <a:ea typeface="Calibri" pitchFamily="34" charset="-122"/>
+                          <a:cs typeface="Calibri" pitchFamily="34" charset="-120"/>
+                        </a:rPr>
+                        <a:t>4</a:t>
+                      </a:r>
+                      <a:endParaRPr lang="en-US" sz="1100" dirty="0">
+                        <a:latin typeface="Calibri" charset="0"/>
+                        <a:ea typeface="Calibri" charset="0"/>
+                        <a:cs typeface="Calibri" charset="0"/>
+                      </a:endParaRPr>
+                    </a:p>
+                  </a:txBody>
+                  <a:tcPr marL="114300" marR="114300" marT="76200" marB="76200" anchor="ctr">
+                    <a:lnL w="9525" cap="flat" cmpd="sng" algn="ctr">
+                      <a:solidFill>
+                        <a:srgbClr val="D8DEE2"/>
+                      </a:solidFill>
+                      <a:prstDash val="solid"/>
+                      <a:round/>
+                      <a:headEnd type="none" w="med" len="med"/>
+                      <a:tailEnd type="none" w="med" len="med"/>
+                    </a:lnL>
+                    <a:lnR w="9525" cap="flat" cmpd="sng" algn="ctr">
+                      <a:solidFill>
+                        <a:srgbClr val="D8DEE2"/>
+                      </a:solidFill>
+                      <a:prstDash val="solid"/>
+                      <a:round/>
+                      <a:headEnd type="none" w="med" len="med"/>
+                      <a:tailEnd type="none" w="med" len="med"/>
+                    </a:lnR>
+                    <a:lnT w="9525" cap="flat" cmpd="sng" algn="ctr">
+                      <a:solidFill>
+                        <a:srgbClr val="D8DEE2"/>
+                      </a:solidFill>
+                      <a:prstDash val="solid"/>
+                      <a:round/>
+                      <a:headEnd type="none" w="med" len="med"/>
+                      <a:tailEnd type="none" w="med" len="med"/>
+                    </a:lnT>
+                    <a:lnB w="9525" cap="flat" cmpd="sng" algn="ctr">
+                      <a:solidFill>
+                        <a:srgbClr val="D8DEE2"/>
+                      </a:solidFill>
+                      <a:prstDash val="solid"/>
+                      <a:round/>
+                      <a:headEnd type="none" w="med" len="med"/>
+                      <a:tailEnd type="none" w="med" len="med"/>
+                    </a:lnB>
+                  </a:tcPr>
+                </a:tc>
+                <a:tc>
+                  <a:txBody>
+                    <a:bodyPr/>
+                    <a:lstStyle/>
+                    <a:p>
+                      <a:pPr indent="0" marL="0">
+                        <a:buNone/>
+                      </a:pPr>
+                      <a:r>
+                        <a:rPr lang="en-US" sz="1100" b="1" dirty="0">
+                          <a:solidFill>
+                            <a:srgbClr val="1A2733"/>
+                          </a:solidFill>
+                          <a:latin typeface="Calibri" pitchFamily="34" charset="0"/>
+                          <a:ea typeface="Calibri" pitchFamily="34" charset="-122"/>
+                          <a:cs typeface="Calibri" pitchFamily="34" charset="-120"/>
+                        </a:rPr>
+                        <a:t>Динамические права доступа — не блокировать волну 2, но зафиксировать как gate</a:t>
+                      </a:r>
+                      <a:endParaRPr lang="en-US" sz="1100" dirty="0">
+                        <a:latin typeface="Calibri" charset="0"/>
+                        <a:ea typeface="Calibri" charset="0"/>
+                        <a:cs typeface="Calibri" charset="0"/>
+                      </a:endParaRPr>
+                    </a:p>
+                  </a:txBody>
+                  <a:tcPr marL="114300" marR="114300" marT="76200" marB="76200" anchor="ctr">
+                    <a:lnL w="9525" cap="flat" cmpd="sng" algn="ctr">
+                      <a:solidFill>
+                        <a:srgbClr val="D8DEE2"/>
+                      </a:solidFill>
+                      <a:prstDash val="solid"/>
+                      <a:round/>
+                      <a:headEnd type="none" w="med" len="med"/>
+                      <a:tailEnd type="none" w="med" len="med"/>
+                    </a:lnL>
+                    <a:lnR w="9525" cap="flat" cmpd="sng" algn="ctr">
+                      <a:solidFill>
+                        <a:srgbClr val="D8DEE2"/>
+                      </a:solidFill>
+                      <a:prstDash val="solid"/>
+                      <a:round/>
+                      <a:headEnd type="none" w="med" len="med"/>
+                      <a:tailEnd type="none" w="med" len="med"/>
+                    </a:lnR>
+                    <a:lnT w="9525" cap="flat" cmpd="sng" algn="ctr">
+                      <a:solidFill>
+                        <a:srgbClr val="D8DEE2"/>
+                      </a:solidFill>
+                      <a:prstDash val="solid"/>
+                      <a:round/>
+                      <a:headEnd type="none" w="med" len="med"/>
+                      <a:tailEnd type="none" w="med" len="med"/>
+                    </a:lnT>
+                    <a:lnB w="9525" cap="flat" cmpd="sng" algn="ctr">
+                      <a:solidFill>
+                        <a:srgbClr val="D8DEE2"/>
+                      </a:solidFill>
+                      <a:prstDash val="solid"/>
+                      <a:round/>
+                      <a:headEnd type="none" w="med" len="med"/>
+                      <a:tailEnd type="none" w="med" len="med"/>
+                    </a:lnB>
+                  </a:tcPr>
+                </a:tc>
+                <a:tc>
+                  <a:txBody>
+                    <a:bodyPr/>
+                    <a:lstStyle/>
+                    <a:p>
+                      <a:pPr indent="0" marL="0">
+                        <a:buNone/>
+                      </a:pPr>
+                      <a:r>
+                        <a:rPr lang="en-US" sz="1050" dirty="0">
+                          <a:solidFill>
+                            <a:srgbClr val="5B6B7A"/>
+                          </a:solidFill>
+                          <a:latin typeface="Calibri" pitchFamily="34" charset="0"/>
+                          <a:ea typeface="Calibri" pitchFamily="34" charset="-122"/>
+                          <a:cs typeface="Calibri" pitchFamily="34" charset="-120"/>
+                        </a:rPr>
+                        <a:t>Волну 2 запускать на статичной модели (как в пилоте); чувствительные волны — только когда готово с обеих сторон.</a:t>
+                      </a:r>
+                      <a:endParaRPr lang="en-US" sz="1050" dirty="0">
+                        <a:latin typeface="Calibri" charset="0"/>
+                        <a:ea typeface="Calibri" charset="0"/>
+                        <a:cs typeface="Calibri" charset="0"/>
+                      </a:endParaRPr>
+                    </a:p>
+                  </a:txBody>
+                  <a:tcPr marL="114300" marR="114300" marT="76200" marB="76200" anchor="ctr">
+                    <a:lnL w="9525" cap="flat" cmpd="sng" algn="ctr">
+                      <a:solidFill>
+                        <a:srgbClr val="D8DEE2"/>
+                      </a:solidFill>
+                      <a:prstDash val="solid"/>
+                      <a:round/>
+                      <a:headEnd type="none" w="med" len="med"/>
+                      <a:tailEnd type="none" w="med" len="med"/>
+                    </a:lnL>
+                    <a:lnR w="9525" cap="flat" cmpd="sng" algn="ctr">
+                      <a:solidFill>
+                        <a:srgbClr val="D8DEE2"/>
+                      </a:solidFill>
+                      <a:prstDash val="solid"/>
+                      <a:round/>
+                      <a:headEnd type="none" w="med" len="med"/>
+                      <a:tailEnd type="none" w="med" len="med"/>
+                    </a:lnR>
+                    <a:lnT w="9525" cap="flat" cmpd="sng" algn="ctr">
+                      <a:solidFill>
+                        <a:srgbClr val="D8DEE2"/>
+                      </a:solidFill>
+                      <a:prstDash val="solid"/>
+                      <a:round/>
+                      <a:headEnd type="none" w="med" len="med"/>
+                      <a:tailEnd type="none" w="med" len="med"/>
+                    </a:lnT>
+                    <a:lnB w="9525" cap="flat" cmpd="sng" algn="ctr">
+                      <a:solidFill>
+                        <a:srgbClr val="D8DEE2"/>
+                      </a:solidFill>
+                      <a:prstDash val="solid"/>
+                      <a:round/>
+                      <a:headEnd type="none" w="med" len="med"/>
+                      <a:tailEnd type="none" w="med" len="med"/>
+                    </a:lnB>
+                  </a:tcPr>
+                </a:tc>
+              </a:tr>
+              <a:tr h="640080">
+                <a:tc>
+                  <a:txBody>
+                    <a:bodyPr/>
+                    <a:lstStyle/>
+                    <a:p>
+                      <a:pPr algn="ctr" indent="0" marL="0">
+                        <a:buNone/>
+                      </a:pPr>
+                      <a:r>
+                        <a:rPr lang="en-US" sz="1100" dirty="0">
+                          <a:solidFill>
+                            <a:srgbClr val="5B6B7A"/>
+                          </a:solidFill>
+                          <a:latin typeface="Calibri" pitchFamily="34" charset="0"/>
+                          <a:ea typeface="Calibri" pitchFamily="34" charset="-122"/>
+                          <a:cs typeface="Calibri" pitchFamily="34" charset="-120"/>
+                        </a:rPr>
+                        <a:t>5</a:t>
+                      </a:r>
+                      <a:endParaRPr lang="en-US" sz="1100" dirty="0">
+                        <a:latin typeface="Calibri" charset="0"/>
+                        <a:ea typeface="Calibri" charset="0"/>
+                        <a:cs typeface="Calibri" charset="0"/>
+                      </a:endParaRPr>
+                    </a:p>
+                  </a:txBody>
+                  <a:tcPr marL="114300" marR="114300" marT="76200" marB="76200" anchor="ctr">
+                    <a:lnL w="9525" cap="flat" cmpd="sng" algn="ctr">
+                      <a:solidFill>
+                        <a:srgbClr val="D8DEE2"/>
+                      </a:solidFill>
+                      <a:prstDash val="solid"/>
+                      <a:round/>
+                      <a:headEnd type="none" w="med" len="med"/>
+                      <a:tailEnd type="none" w="med" len="med"/>
+                    </a:lnL>
+                    <a:lnR w="9525" cap="flat" cmpd="sng" algn="ctr">
+                      <a:solidFill>
+                        <a:srgbClr val="D8DEE2"/>
+                      </a:solidFill>
+                      <a:prstDash val="solid"/>
+                      <a:round/>
+                      <a:headEnd type="none" w="med" len="med"/>
+                      <a:tailEnd type="none" w="med" len="med"/>
+                    </a:lnR>
+                    <a:lnT w="9525" cap="flat" cmpd="sng" algn="ctr">
+                      <a:solidFill>
+                        <a:srgbClr val="D8DEE2"/>
+                      </a:solidFill>
+                      <a:prstDash val="solid"/>
+                      <a:round/>
+                      <a:headEnd type="none" w="med" len="med"/>
+                      <a:tailEnd type="none" w="med" len="med"/>
+                    </a:lnT>
+                    <a:lnB w="9525" cap="flat" cmpd="sng" algn="ctr">
+                      <a:solidFill>
+                        <a:srgbClr val="D8DEE2"/>
+                      </a:solidFill>
+                      <a:prstDash val="solid"/>
+                      <a:round/>
+                      <a:headEnd type="none" w="med" len="med"/>
+                      <a:tailEnd type="none" w="med" len="med"/>
+                    </a:lnB>
+                  </a:tcPr>
+                </a:tc>
+                <a:tc>
+                  <a:txBody>
+                    <a:bodyPr/>
+                    <a:lstStyle/>
+                    <a:p>
+                      <a:pPr indent="0" marL="0">
+                        <a:buNone/>
+                      </a:pPr>
+                      <a:r>
+                        <a:rPr lang="en-US" sz="1100" b="1" dirty="0">
+                          <a:solidFill>
+                            <a:srgbClr val="1A2733"/>
+                          </a:solidFill>
+                          <a:latin typeface="Calibri" pitchFamily="34" charset="0"/>
+                          <a:ea typeface="Calibri" pitchFamily="34" charset="-122"/>
+                          <a:cs typeface="Calibri" pitchFamily="34" charset="-120"/>
+                        </a:rPr>
+                        <a:t>Волна 3+ (роллаут по ролям) — порядок по умолчанию: фронт-офис → аналитики/УК → руководство → бэк-офис</a:t>
+                      </a:r>
+                      <a:endParaRPr lang="en-US" sz="1100" dirty="0">
+                        <a:latin typeface="Calibri" charset="0"/>
+                        <a:ea typeface="Calibri" charset="0"/>
+                        <a:cs typeface="Calibri" charset="0"/>
+                      </a:endParaRPr>
+                    </a:p>
+                  </a:txBody>
+                  <a:tcPr marL="114300" marR="114300" marT="76200" marB="76200" anchor="ctr">
+                    <a:lnL w="9525" cap="flat" cmpd="sng" algn="ctr">
+                      <a:solidFill>
+                        <a:srgbClr val="D8DEE2"/>
+                      </a:solidFill>
+                      <a:prstDash val="solid"/>
+                      <a:round/>
+                      <a:headEnd type="none" w="med" len="med"/>
+                      <a:tailEnd type="none" w="med" len="med"/>
+                    </a:lnL>
+                    <a:lnR w="9525" cap="flat" cmpd="sng" algn="ctr">
+                      <a:solidFill>
+                        <a:srgbClr val="D8DEE2"/>
+                      </a:solidFill>
+                      <a:prstDash val="solid"/>
+                      <a:round/>
+                      <a:headEnd type="none" w="med" len="med"/>
+                      <a:tailEnd type="none" w="med" len="med"/>
+                    </a:lnR>
+                    <a:lnT w="9525" cap="flat" cmpd="sng" algn="ctr">
+                      <a:solidFill>
+                        <a:srgbClr val="D8DEE2"/>
+                      </a:solidFill>
+                      <a:prstDash val="solid"/>
+                      <a:round/>
+                      <a:headEnd type="none" w="med" len="med"/>
+                      <a:tailEnd type="none" w="med" len="med"/>
+                    </a:lnT>
+                    <a:lnB w="9525" cap="flat" cmpd="sng" algn="ctr">
+                      <a:solidFill>
+                        <a:srgbClr val="D8DEE2"/>
+                      </a:solidFill>
+                      <a:prstDash val="solid"/>
+                      <a:round/>
+                      <a:headEnd type="none" w="med" len="med"/>
+                      <a:tailEnd type="none" w="med" len="med"/>
+                    </a:lnB>
+                  </a:tcPr>
+                </a:tc>
+                <a:tc>
+                  <a:txBody>
+                    <a:bodyPr/>
+                    <a:lstStyle/>
+                    <a:p>
+                      <a:pPr indent="0" marL="0">
+                        <a:buNone/>
+                      </a:pPr>
+                      <a:r>
+                        <a:rPr lang="en-US" sz="1050" dirty="0">
+                          <a:solidFill>
+                            <a:srgbClr val="5B6B7A"/>
+                          </a:solidFill>
+                          <a:latin typeface="Calibri" pitchFamily="34" charset="0"/>
+                          <a:ea typeface="Calibri" pitchFamily="34" charset="-122"/>
+                          <a:cs typeface="Calibri" pitchFamily="34" charset="-120"/>
+                        </a:rPr>
+                        <a:t>Фронт-офис уже протестирован в пилоте — наименьший риск; бэк-офис — самые чувствительные данные, последним.</a:t>
+                      </a:r>
+                      <a:endParaRPr lang="en-US" sz="1050" dirty="0">
+                        <a:latin typeface="Calibri" charset="0"/>
+                        <a:ea typeface="Calibri" charset="0"/>
+                        <a:cs typeface="Calibri" charset="0"/>
+                      </a:endParaRPr>
+                    </a:p>
+                  </a:txBody>
+                  <a:tcPr marL="114300" marR="114300" marT="76200" marB="76200" anchor="ctr">
+                    <a:lnL w="9525" cap="flat" cmpd="sng" algn="ctr">
+                      <a:solidFill>
+                        <a:srgbClr val="D8DEE2"/>
+                      </a:solidFill>
+                      <a:prstDash val="solid"/>
+                      <a:round/>
+                      <a:headEnd type="none" w="med" len="med"/>
+                      <a:tailEnd type="none" w="med" len="med"/>
+                    </a:lnL>
+                    <a:lnR w="9525" cap="flat" cmpd="sng" algn="ctr">
+                      <a:solidFill>
+                        <a:srgbClr val="D8DEE2"/>
+                      </a:solidFill>
+                      <a:prstDash val="solid"/>
+                      <a:round/>
+                      <a:headEnd type="none" w="med" len="med"/>
+                      <a:tailEnd type="none" w="med" len="med"/>
+                    </a:lnR>
+                    <a:lnT w="9525" cap="flat" cmpd="sng" algn="ctr">
+                      <a:solidFill>
+                        <a:srgbClr val="D8DEE2"/>
+                      </a:solidFill>
+                      <a:prstDash val="solid"/>
+                      <a:round/>
+                      <a:headEnd type="none" w="med" len="med"/>
+                      <a:tailEnd type="none" w="med" len="med"/>
+                    </a:lnT>
+                    <a:lnB w="9525" cap="flat" cmpd="sng" algn="ctr">
+                      <a:solidFill>
+                        <a:srgbClr val="D8DEE2"/>
+                      </a:solidFill>
+                      <a:prstDash val="solid"/>
+                      <a:round/>
+                      <a:headEnd type="none" w="med" len="med"/>
+                      <a:tailEnd type="none" w="med" len="med"/>
+                    </a:lnB>
+                  </a:tcPr>
+                </a:tc>
+              </a:tr>
+              <a:tr h="640080">
+                <a:tc>
+                  <a:txBody>
+                    <a:bodyPr/>
+                    <a:lstStyle/>
+                    <a:p>
+                      <a:pPr algn="ctr" indent="0" marL="0">
+                        <a:buNone/>
+                      </a:pPr>
+                      <a:r>
+                        <a:rPr lang="en-US" sz="1100" dirty="0">
+                          <a:solidFill>
+                            <a:srgbClr val="5B6B7A"/>
+                          </a:solidFill>
+                          <a:latin typeface="Calibri" pitchFamily="34" charset="0"/>
+                          <a:ea typeface="Calibri" pitchFamily="34" charset="-122"/>
+                          <a:cs typeface="Calibri" pitchFamily="34" charset="-120"/>
+                        </a:rPr>
+                        <a:t>6</a:t>
+                      </a:r>
+                      <a:endParaRPr lang="en-US" sz="1100" dirty="0">
+                        <a:latin typeface="Calibri" charset="0"/>
+                        <a:ea typeface="Calibri" charset="0"/>
+                        <a:cs typeface="Calibri" charset="0"/>
+                      </a:endParaRPr>
+                    </a:p>
+                  </a:txBody>
+                  <a:tcPr marL="114300" marR="114300" marT="76200" marB="76200" anchor="ctr">
+                    <a:lnL w="9525" cap="flat" cmpd="sng" algn="ctr">
+                      <a:solidFill>
+                        <a:srgbClr val="D8DEE2"/>
+                      </a:solidFill>
+                      <a:prstDash val="solid"/>
+                      <a:round/>
+                      <a:headEnd type="none" w="med" len="med"/>
+                      <a:tailEnd type="none" w="med" len="med"/>
+                    </a:lnL>
+                    <a:lnR w="9525" cap="flat" cmpd="sng" algn="ctr">
+                      <a:solidFill>
+                        <a:srgbClr val="D8DEE2"/>
+                      </a:solidFill>
+                      <a:prstDash val="solid"/>
+                      <a:round/>
+                      <a:headEnd type="none" w="med" len="med"/>
+                      <a:tailEnd type="none" w="med" len="med"/>
+                    </a:lnR>
+                    <a:lnT w="9525" cap="flat" cmpd="sng" algn="ctr">
+                      <a:solidFill>
+                        <a:srgbClr val="D8DEE2"/>
+                      </a:solidFill>
+                      <a:prstDash val="solid"/>
+                      <a:round/>
+                      <a:headEnd type="none" w="med" len="med"/>
+                      <a:tailEnd type="none" w="med" len="med"/>
+                    </a:lnT>
+                    <a:lnB w="9525" cap="flat" cmpd="sng" algn="ctr">
+                      <a:solidFill>
+                        <a:srgbClr val="D8DEE2"/>
+                      </a:solidFill>
+                      <a:prstDash val="solid"/>
+                      <a:round/>
+                      <a:headEnd type="none" w="med" len="med"/>
+                      <a:tailEnd type="none" w="med" len="med"/>
+                    </a:lnB>
+                  </a:tcPr>
+                </a:tc>
+                <a:tc>
+                  <a:txBody>
+                    <a:bodyPr/>
+                    <a:lstStyle/>
+                    <a:p>
+                      <a:pPr indent="0" marL="0">
+                        <a:buNone/>
+                      </a:pPr>
+                      <a:r>
+                        <a:rPr lang="en-US" sz="1100" b="1" dirty="0">
+                          <a:solidFill>
+                            <a:srgbClr val="1A2733"/>
+                          </a:solidFill>
+                          <a:latin typeface="Calibri" pitchFamily="34" charset="0"/>
+                          <a:ea typeface="Calibri" pitchFamily="34" charset="-122"/>
+                          <a:cs typeface="Calibri" pitchFamily="34" charset="-120"/>
+                        </a:rPr>
+                        <a:t>Критерий перехода — не ждать дозакрытия сценариев 6 и 4</a:t>
+                      </a:r>
+                      <a:endParaRPr lang="en-US" sz="1100" dirty="0">
+                        <a:latin typeface="Calibri" charset="0"/>
+                        <a:ea typeface="Calibri" charset="0"/>
+                        <a:cs typeface="Calibri" charset="0"/>
+                      </a:endParaRPr>
+                    </a:p>
+                  </a:txBody>
+                  <a:tcPr marL="114300" marR="114300" marT="76200" marB="76200" anchor="ctr">
+                    <a:lnL w="9525" cap="flat" cmpd="sng" algn="ctr">
+                      <a:solidFill>
+                        <a:srgbClr val="D8DEE2"/>
+                      </a:solidFill>
+                      <a:prstDash val="solid"/>
+                      <a:round/>
+                      <a:headEnd type="none" w="med" len="med"/>
+                      <a:tailEnd type="none" w="med" len="med"/>
+                    </a:lnL>
+                    <a:lnR w="9525" cap="flat" cmpd="sng" algn="ctr">
+                      <a:solidFill>
+                        <a:srgbClr val="D8DEE2"/>
+                      </a:solidFill>
+                      <a:prstDash val="solid"/>
+                      <a:round/>
+                      <a:headEnd type="none" w="med" len="med"/>
+                      <a:tailEnd type="none" w="med" len="med"/>
+                    </a:lnR>
+                    <a:lnT w="9525" cap="flat" cmpd="sng" algn="ctr">
+                      <a:solidFill>
+                        <a:srgbClr val="D8DEE2"/>
+                      </a:solidFill>
+                      <a:prstDash val="solid"/>
+                      <a:round/>
+                      <a:headEnd type="none" w="med" len="med"/>
+                      <a:tailEnd type="none" w="med" len="med"/>
+                    </a:lnT>
+                    <a:lnB w="9525" cap="flat" cmpd="sng" algn="ctr">
+                      <a:solidFill>
+                        <a:srgbClr val="D8DEE2"/>
+                      </a:solidFill>
+                      <a:prstDash val="solid"/>
+                      <a:round/>
+                      <a:headEnd type="none" w="med" len="med"/>
+                      <a:tailEnd type="none" w="med" len="med"/>
+                    </a:lnB>
+                  </a:tcPr>
+                </a:tc>
+                <a:tc>
+                  <a:txBody>
+                    <a:bodyPr/>
+                    <a:lstStyle/>
+                    <a:p>
+                      <a:pPr indent="0" marL="0">
+                        <a:buNone/>
+                      </a:pPr>
+                      <a:r>
+                        <a:rPr lang="en-US" sz="1050" dirty="0">
+                          <a:solidFill>
+                            <a:srgbClr val="5B6B7A"/>
+                          </a:solidFill>
+                          <a:latin typeface="Calibri" pitchFamily="34" charset="0"/>
+                          <a:ea typeface="Calibri" pitchFamily="34" charset="-122"/>
+                          <a:cs typeface="Calibri" pitchFamily="34" charset="-120"/>
+                        </a:rPr>
+                        <a:t>Перенести оба пункта в список долга бизнес-кейса П1, а не тихо забыть при переходе в проект.</a:t>
+                      </a:r>
+                      <a:endParaRPr lang="en-US" sz="1050" dirty="0">
+                        <a:latin typeface="Calibri" charset="0"/>
+                        <a:ea typeface="Calibri" charset="0"/>
+                        <a:cs typeface="Calibri" charset="0"/>
+                      </a:endParaRPr>
+                    </a:p>
+                  </a:txBody>
+                  <a:tcPr marL="114300" marR="114300" marT="76200" marB="76200" anchor="ctr">
+                    <a:lnL w="9525" cap="flat" cmpd="sng" algn="ctr">
+                      <a:solidFill>
+                        <a:srgbClr val="D8DEE2"/>
+                      </a:solidFill>
+                      <a:prstDash val="solid"/>
+                      <a:round/>
+                      <a:headEnd type="none" w="med" len="med"/>
+                      <a:tailEnd type="none" w="med" len="med"/>
+                    </a:lnL>
+                    <a:lnR w="9525" cap="flat" cmpd="sng" algn="ctr">
+                      <a:solidFill>
+                        <a:srgbClr val="D8DEE2"/>
+                      </a:solidFill>
+                      <a:prstDash val="solid"/>
+                      <a:round/>
+                      <a:headEnd type="none" w="med" len="med"/>
+                      <a:tailEnd type="none" w="med" len="med"/>
+                    </a:lnR>
+                    <a:lnT w="9525" cap="flat" cmpd="sng" algn="ctr">
+                      <a:solidFill>
+                        <a:srgbClr val="D8DEE2"/>
+                      </a:solidFill>
+                      <a:prstDash val="solid"/>
+                      <a:round/>
+                      <a:headEnd type="none" w="med" len="med"/>
+                      <a:tailEnd type="none" w="med" len="med"/>
+                    </a:lnT>
+                    <a:lnB w="9525" cap="flat" cmpd="sng" algn="ctr">
+                      <a:solidFill>
+                        <a:srgbClr val="D8DEE2"/>
+                      </a:solidFill>
+                      <a:prstDash val="solid"/>
+                      <a:round/>
+                      <a:headEnd type="none" w="med" len="med"/>
+                      <a:tailEnd type="none" w="med" len="med"/>
+                    </a:lnB>
+                  </a:tcPr>
+                </a:tc>
+              </a:tr>
+            </a:tbl>
+          </a:graphicData>
+        </a:graphic>
+      </p:graphicFrame>
+      <p:sp>
+        <p:nvSpPr>
+          <p:cNvPr id="6" name="Text 3"/>
+          <p:cNvSpPr txBox="1"/>
+          <p:nvPr/>
+        </p:nvSpPr>
+        <p:spPr>
+          <a:xfrm>
+            <a:off x="10881360" y="6473952"/>
+            <a:ext cx="822960" cy="274320"/>
+          </a:xfrm>
+          <a:prstGeom prst="rect">
+            <a:avLst/>
+          </a:prstGeom>
+          <a:noFill/>
+          <a:ln/>
+        </p:spPr>
+        <p:txBody>
+          <a:bodyPr wrap="square" lIns="0" tIns="0" rIns="0" bIns="0" rtlCol="0" anchor="ctr"/>
+          <a:lstStyle/>
+          <a:p>
+            <a:pPr algn="r" indent="0" marL="0">
+              <a:buNone/>
+            </a:pPr>
+            <a:r>
+              <a:rPr lang="en-US" sz="1050" dirty="0">
+                <a:solidFill>
+                  <a:srgbClr val="8C99A6"/>
+                </a:solidFill>
+                <a:latin typeface="Calibri" pitchFamily="34" charset="0"/>
+                <a:ea typeface="Calibri" pitchFamily="34" charset="-122"/>
+                <a:cs typeface="Calibri" pitchFamily="34" charset="-120"/>
+              </a:rPr>
+              <a:t>6 / 7</a:t>
+            </a:r>
+            <a:endParaRPr lang="en-US" sz="1050" dirty="0"/>
+          </a:p>
+        </p:txBody>
+      </p:sp>
+    </p:spTree>
+  </p:cSld>
+  <p:clrMapOvr>
+    <a:masterClrMapping/>
+  </p:clrMapOvr>
+</p:sld>
+</file>
+
+<file path=ppt/slides/slide7.xml><?xml version="1.0" encoding="utf-8"?>
+<p:sld xmlns:a="http://schemas.openxmlformats.org/drawingml/2006/main" xmlns:r="http://schemas.openxmlformats.org/officeDocument/2006/relationships" xmlns:p="http://schemas.openxmlformats.org/presentationml/2006/main">
+  <p:cSld name="Slide 7">
+    <p:spTree>
+      <p:nvGrpSpPr>
+        <p:cNvPr id="1" name=""/>
+        <p:cNvGrpSpPr/>
+        <p:nvPr/>
+      </p:nvGrpSpPr>
+      <p:grpSpPr>
+        <a:xfrm>
+          <a:off x="0" y="0"/>
+          <a:ext cx="0" cy="0"/>
+          <a:chOff x="0" y="0"/>
+          <a:chExt cx="0" cy="0"/>
+        </a:xfrm>
+      </p:grpSpPr>
+      <p:sp>
+        <p:nvSpPr>
+          <p:cNvPr id="2" name="Text 0"/>
+          <p:cNvSpPr txBox="1"/>
+          <p:nvPr/>
+        </p:nvSpPr>
+        <p:spPr>
+          <a:xfrm>
+            <a:off x="502920" y="320040"/>
+            <a:ext cx="11155680" cy="274320"/>
+          </a:xfrm>
+          <a:prstGeom prst="rect">
+            <a:avLst/>
+          </a:prstGeom>
+          <a:noFill/>
+          <a:ln/>
+        </p:spPr>
+        <p:txBody>
+          <a:bodyPr wrap="square" lIns="0" tIns="0" rIns="0" bIns="0" rtlCol="0" anchor="ctr"/>
+          <a:lstStyle/>
+          <a:p>
+            <a:pPr indent="0" marL="0">
+              <a:buNone/>
+            </a:pPr>
+            <a:r>
+              <a:rPr lang="en-US" sz="1100" b="1" spc="120" kern="0" dirty="0">
+                <a:solidFill>
+                  <a:srgbClr val="0E7C86"/>
+                </a:solidFill>
+                <a:latin typeface="Calibri" pitchFamily="34" charset="0"/>
+                <a:ea typeface="Calibri" pitchFamily="34" charset="-122"/>
+                <a:cs typeface="Calibri" pitchFamily="34" charset="-120"/>
+              </a:rPr>
+              <a:t>6 · АРХИТЕКТУРА ПИЛОТА</a:t>
             </a:r>
             <a:endParaRPr lang="en-US" sz="1100" dirty="0"/>
           </a:p>
@@ -10740,7 +12429,7 @@
                 <a:ea typeface="Calibri" pitchFamily="34" charset="-122"/>
                 <a:cs typeface="Calibri" pitchFamily="34" charset="-120"/>
               </a:rPr>
-              <a:t>6 / 6</a:t>
+              <a:t>7 / 7</a:t>
             </a:r>
             <a:endParaRPr lang="en-US" sz="1050" dirty="0"/>
           </a:p>

</xml_diff>

<commit_message>
Remove Наши предложения slide — content didn't match what was needed
Co-Authored-By: Claude Sonnet 5 <noreply@anthropic.com>
Claude-Session: https://claude.ai/code/session_01DpSN8JwCJ3tg3JVUadr2zE
</commit_message>
<xml_diff>
--- a/docs/presentations/case-27-proekt-d8-skoup-i-voprosy.pptx
+++ b/docs/presentations/case-27-proekt-d8-skoup-i-voprosy.pptx
@@ -11,10 +11,9 @@
     <p:sldId id="259" r:id="rId5"/>
     <p:sldId id="260" r:id="rId6"/>
     <p:sldId id="261" r:id="rId7"/>
-    <p:sldId id="262" r:id="rId8"/>
   </p:sldIdLst>
   <p:notesMasterIdLst>
-    <p:notesMasterId r:id="rId9"/>
+    <p:notesMasterId r:id="rId8"/>
   </p:notesMasterIdLst>
   <p:sldSz cx="12192000" cy="6858000"/>
   <p:notesSz cx="6858000" cy="12192000"/>
@@ -990,94 +989,6 @@
 </p:notes>
 </file>
 
-<file path=ppt/notesSlides/notesSlide7.xml><?xml version="1.0" encoding="utf-8"?>
-<p:notes xmlns:a="http://schemas.openxmlformats.org/drawingml/2006/main" xmlns:r="http://schemas.openxmlformats.org/officeDocument/2006/relationships" xmlns:p="http://schemas.openxmlformats.org/presentationml/2006/main">
-  <p:cSld>
-    <p:spTree>
-      <p:nvGrpSpPr>
-        <p:cNvPr id="1" name=""/>
-        <p:cNvGrpSpPr/>
-        <p:nvPr/>
-      </p:nvGrpSpPr>
-      <p:grpSpPr>
-        <a:xfrm>
-          <a:off x="0" y="0"/>
-          <a:ext cx="0" cy="0"/>
-          <a:chOff x="0" y="0"/>
-          <a:chExt cx="0" cy="0"/>
-        </a:xfrm>
-      </p:grpSpPr>
-      <p:sp>
-        <p:nvSpPr>
-          <p:cNvPr id="2" name="Slide Image Placeholder 1"/>
-          <p:cNvSpPr>
-            <a:spLocks noGrp="1" noRot="1" noChangeAspect="1"/>
-          </p:cNvSpPr>
-          <p:nvPr>
-            <p:ph type="sldImg"/>
-          </p:nvPr>
-        </p:nvSpPr>
-        <p:spPr/>
-      </p:sp>
-      <p:sp>
-        <p:nvSpPr>
-          <p:cNvPr id="3" name="Notes Placeholder 2"/>
-          <p:cNvSpPr>
-            <a:spLocks noGrp="1"/>
-          </p:cNvSpPr>
-          <p:nvPr>
-            <p:ph type="body" idx="1"/>
-          </p:nvPr>
-        </p:nvSpPr>
-        <p:spPr/>
-        <p:txBody>
-          <a:bodyPr/>
-          <a:lstStyle/>
-          <a:p>
-            <a:r>
-              <a:rPr lang="en-US" dirty="0"/>
-              <a:t/>
-            </a:r>
-            <a:endParaRPr lang="en-US" dirty="0"/>
-          </a:p>
-        </p:txBody>
-      </p:sp>
-      <p:sp>
-        <p:nvSpPr>
-          <p:cNvPr id="4" name="Slide Number Placeholder 3"/>
-          <p:cNvSpPr>
-            <a:spLocks noGrp="1"/>
-          </p:cNvSpPr>
-          <p:nvPr>
-            <p:ph type="sldNum" sz="quarter" idx="10"/>
-          </p:nvPr>
-        </p:nvSpPr>
-        <p:spPr/>
-        <p:txBody>
-          <a:bodyPr/>
-          <a:lstStyle/>
-          <a:p>
-            <a:fld id="{F7021451-1387-4CA6-816F-3879F97B5CBC}" type="slidenum">
-              <a:rPr lang="en-US"/>
-              <a:t>7</a:t>
-            </a:fld>
-            <a:endParaRPr lang="en-US"/>
-          </a:p>
-        </p:txBody>
-      </p:sp>
-    </p:spTree>
-    <p:extLst>
-      <p:ext uri="{BB962C8B-B14F-4D97-AF65-F5344CB8AC3E}">
-        <p14:creationId xmlns:p14="http://schemas.microsoft.com/office/powerpoint/2010/main" val="1024086991"/>
-      </p:ext>
-    </p:extLst>
-  </p:cSld>
-  <p:clrMapOvr>
-    <a:masterClrMapping/>
-  </p:clrMapOvr>
-</p:notes>
-</file>
-
 <file path=ppt/slideLayouts/slideLayout1.xml><?xml version="1.0" encoding="utf-8"?>
 <p:sldLayout xmlns:a="http://schemas.openxmlformats.org/drawingml/2006/main" xmlns:r="http://schemas.openxmlformats.org/officeDocument/2006/relationships" xmlns:p="http://schemas.openxmlformats.org/presentationml/2006/main" preserve="1">
   <p:cSld name="DEFAULT">
@@ -2020,7 +1931,7 @@
                 <a:ea typeface="Calibri" pitchFamily="34" charset="-122"/>
                 <a:cs typeface="Calibri" pitchFamily="34" charset="-120"/>
               </a:rPr>
-              <a:t>1 / 7</a:t>
+              <a:t>1 / 6</a:t>
             </a:r>
             <a:endParaRPr lang="en-US" sz="1050" dirty="0"/>
           </a:p>
@@ -3359,7 +3270,7 @@
                 <a:ea typeface="Calibri" pitchFamily="34" charset="-122"/>
                 <a:cs typeface="Calibri" pitchFamily="34" charset="-120"/>
               </a:rPr>
-              <a:t>2 / 7</a:t>
+              <a:t>2 / 6</a:t>
             </a:r>
             <a:endParaRPr lang="en-US" sz="1050" dirty="0"/>
           </a:p>
@@ -5457,7 +5368,7 @@
                 <a:ea typeface="Calibri" pitchFamily="34" charset="-122"/>
                 <a:cs typeface="Calibri" pitchFamily="34" charset="-120"/>
               </a:rPr>
-              <a:t>3 / 7</a:t>
+              <a:t>3 / 6</a:t>
             </a:r>
             <a:endParaRPr lang="en-US" sz="1050" dirty="0"/>
           </a:p>
@@ -8760,7 +8671,7 @@
                 <a:ea typeface="Calibri" pitchFamily="34" charset="-122"/>
                 <a:cs typeface="Calibri" pitchFamily="34" charset="-120"/>
               </a:rPr>
-              <a:t>4 / 7</a:t>
+              <a:t>4 / 6</a:t>
             </a:r>
             <a:endParaRPr lang="en-US" sz="1050" dirty="0"/>
           </a:p>
@@ -10624,7 +10535,7 @@
                 <a:ea typeface="Calibri" pitchFamily="34" charset="-122"/>
                 <a:cs typeface="Calibri" pitchFamily="34" charset="-120"/>
               </a:rPr>
-              <a:t>5 / 7</a:t>
+              <a:t>5 / 6</a:t>
             </a:r>
             <a:endParaRPr lang="en-US" sz="1050" dirty="0"/>
           </a:p>
@@ -10688,1607 +10599,7 @@
                 <a:ea typeface="Calibri" pitchFamily="34" charset="-122"/>
                 <a:cs typeface="Calibri" pitchFamily="34" charset="-120"/>
               </a:rPr>
-              <a:t>5 · НАШИ ПРЕДЛОЖЕНИЯ</a:t>
-            </a:r>
-            <a:endParaRPr lang="en-US" sz="1100" dirty="0"/>
-          </a:p>
-        </p:txBody>
-      </p:sp>
-      <p:sp>
-        <p:nvSpPr>
-          <p:cNvPr id="3" name="Text 1"/>
-          <p:cNvSpPr txBox="1"/>
-          <p:nvPr/>
-        </p:nvSpPr>
-        <p:spPr>
-          <a:xfrm>
-            <a:off x="502920" y="621792"/>
-            <a:ext cx="11155680" cy="548640"/>
-          </a:xfrm>
-          <a:prstGeom prst="rect">
-            <a:avLst/>
-          </a:prstGeom>
-          <a:noFill/>
-          <a:ln/>
-        </p:spPr>
-        <p:txBody>
-          <a:bodyPr wrap="square" lIns="0" tIns="0" rIns="0" bIns="0" rtlCol="0" anchor="ctr"/>
-          <a:lstStyle/>
-          <a:p>
-            <a:pPr indent="0" marL="0">
-              <a:buNone/>
-            </a:pPr>
-            <a:r>
-              <a:rPr lang="en-US" sz="2700" b="1" dirty="0">
-                <a:solidFill>
-                  <a:srgbClr val="1A2733"/>
-                </a:solidFill>
-                <a:latin typeface="Cambria" pitchFamily="34" charset="0"/>
-                <a:ea typeface="Cambria" pitchFamily="34" charset="-122"/>
-                <a:cs typeface="Cambria" pitchFamily="34" charset="-120"/>
-              </a:rPr>
-              <a:t>Рабочая позиция по умолчанию</a:t>
-            </a:r>
-            <a:endParaRPr lang="en-US" sz="2700" dirty="0"/>
-          </a:p>
-        </p:txBody>
-      </p:sp>
-      <p:sp>
-        <p:nvSpPr>
-          <p:cNvPr id="4" name="Text 2"/>
-          <p:cNvSpPr txBox="1"/>
-          <p:nvPr/>
-        </p:nvSpPr>
-        <p:spPr>
-          <a:xfrm>
-            <a:off x="502920" y="1170432"/>
-            <a:ext cx="11155680" cy="365760"/>
-          </a:xfrm>
-          <a:prstGeom prst="rect">
-            <a:avLst/>
-          </a:prstGeom>
-          <a:noFill/>
-          <a:ln/>
-        </p:spPr>
-        <p:txBody>
-          <a:bodyPr wrap="square" lIns="0" tIns="0" rIns="0" bIns="0" rtlCol="0" anchor="ctr"/>
-          <a:lstStyle/>
-          <a:p>
-            <a:pPr indent="0" marL="0">
-              <a:buNone/>
-            </a:pPr>
-            <a:r>
-              <a:rPr lang="en-US" sz="1300" dirty="0">
-                <a:solidFill>
-                  <a:srgbClr val="5B6B7A"/>
-                </a:solidFill>
-                <a:latin typeface="Calibri" pitchFamily="34" charset="0"/>
-                <a:ea typeface="Calibri" pitchFamily="34" charset="-122"/>
-                <a:cs typeface="Calibri" pitchFamily="34" charset="-120"/>
-              </a:rPr>
-              <a:t>На основе программы проекта — проще поправить готовое предложение, чем отвечать на открытый вопрос с нуля</a:t>
-            </a:r>
-            <a:endParaRPr lang="en-US" sz="1300" dirty="0"/>
-          </a:p>
-        </p:txBody>
-      </p:sp>
-      <p:graphicFrame>
-        <p:nvGraphicFramePr>
-          <p:cNvPr id="7" name="Table 0"/>
-          <p:cNvGraphicFramePr>
-            <a:graphicFrameLocks noGrp="1"/>
-          </p:cNvGraphicFramePr>
-          <p:nvPr>
-            <p:extLst>
-              <p:ext uri="{D42A27DB-BD31-4B8C-83A1-F6EECF244321}">
-                <p14:modId xmlns:p14="http://schemas.microsoft.com/office/powerpoint/2010/main" val="1579011935"/>
-              </p:ext>
-            </p:extLst>
-          </p:nvPr>
-        </p:nvGraphicFramePr>
-        <p:xfrm>
-          <a:off x="502920" y="1691640"/>
-          <a:ext cx="11155680" cy="4480560"/>
-        </p:xfrm>
-        <a:graphic>
-          <a:graphicData uri="http://schemas.openxmlformats.org/drawingml/2006/table">
-            <a:tbl>
-              <a:tblPr/>
-              <a:tblGrid>
-                <a:gridCol w="548640"/>
-                <a:gridCol w="4754880"/>
-                <a:gridCol w="5852160"/>
-              </a:tblGrid>
-              <a:tr h="640080">
-                <a:tc>
-                  <a:txBody>
-                    <a:bodyPr/>
-                    <a:lstStyle/>
-                    <a:p>
-                      <a:pPr algn="ctr" indent="0" marL="0">
-                        <a:buNone/>
-                      </a:pPr>
-                      <a:r>
-                        <a:rPr lang="en-US" sz="1100" b="1" dirty="0">
-                          <a:solidFill>
-                            <a:srgbClr val="FFFFFF"/>
-                          </a:solidFill>
-                          <a:latin typeface="Calibri" pitchFamily="34" charset="0"/>
-                          <a:ea typeface="Calibri" pitchFamily="34" charset="-122"/>
-                          <a:cs typeface="Calibri" pitchFamily="34" charset="-120"/>
-                        </a:rPr>
-                        <a:t>№</a:t>
-                      </a:r>
-                      <a:endParaRPr lang="en-US" sz="1100" dirty="0">
-                        <a:latin typeface="Calibri" charset="0"/>
-                        <a:ea typeface="Calibri" charset="0"/>
-                        <a:cs typeface="Calibri" charset="0"/>
-                      </a:endParaRPr>
-                    </a:p>
-                  </a:txBody>
-                  <a:tcPr marL="114300" marR="114300" marT="76200" marB="76200" anchor="ctr">
-                    <a:lnL w="9525" cap="flat" cmpd="sng" algn="ctr">
-                      <a:solidFill>
-                        <a:srgbClr val="D8DEE2"/>
-                      </a:solidFill>
-                      <a:prstDash val="solid"/>
-                      <a:round/>
-                      <a:headEnd type="none" w="med" len="med"/>
-                      <a:tailEnd type="none" w="med" len="med"/>
-                    </a:lnL>
-                    <a:lnR w="9525" cap="flat" cmpd="sng" algn="ctr">
-                      <a:solidFill>
-                        <a:srgbClr val="D8DEE2"/>
-                      </a:solidFill>
-                      <a:prstDash val="solid"/>
-                      <a:round/>
-                      <a:headEnd type="none" w="med" len="med"/>
-                      <a:tailEnd type="none" w="med" len="med"/>
-                    </a:lnR>
-                    <a:lnT w="9525" cap="flat" cmpd="sng" algn="ctr">
-                      <a:solidFill>
-                        <a:srgbClr val="D8DEE2"/>
-                      </a:solidFill>
-                      <a:prstDash val="solid"/>
-                      <a:round/>
-                      <a:headEnd type="none" w="med" len="med"/>
-                      <a:tailEnd type="none" w="med" len="med"/>
-                    </a:lnT>
-                    <a:lnB w="9525" cap="flat" cmpd="sng" algn="ctr">
-                      <a:solidFill>
-                        <a:srgbClr val="D8DEE2"/>
-                      </a:solidFill>
-                      <a:prstDash val="solid"/>
-                      <a:round/>
-                      <a:headEnd type="none" w="med" len="med"/>
-                      <a:tailEnd type="none" w="med" len="med"/>
-                    </a:lnB>
-                    <a:solidFill>
-                      <a:srgbClr val="1A2733"/>
-                    </a:solidFill>
-                  </a:tcPr>
-                </a:tc>
-                <a:tc>
-                  <a:txBody>
-                    <a:bodyPr/>
-                    <a:lstStyle/>
-                    <a:p>
-                      <a:pPr indent="0" marL="0">
-                        <a:buNone/>
-                      </a:pPr>
-                      <a:r>
-                        <a:rPr lang="en-US" sz="1100" b="1" dirty="0">
-                          <a:solidFill>
-                            <a:srgbClr val="FFFFFF"/>
-                          </a:solidFill>
-                          <a:latin typeface="Calibri" pitchFamily="34" charset="0"/>
-                          <a:ea typeface="Calibri" pitchFamily="34" charset="-122"/>
-                          <a:cs typeface="Calibri" pitchFamily="34" charset="-120"/>
-                        </a:rPr>
-                        <a:t>Предложение</a:t>
-                      </a:r>
-                      <a:endParaRPr lang="en-US" sz="1100" dirty="0">
-                        <a:latin typeface="Calibri" charset="0"/>
-                        <a:ea typeface="Calibri" charset="0"/>
-                        <a:cs typeface="Calibri" charset="0"/>
-                      </a:endParaRPr>
-                    </a:p>
-                  </a:txBody>
-                  <a:tcPr marL="114300" marR="114300" marT="76200" marB="76200" anchor="ctr">
-                    <a:lnL w="9525" cap="flat" cmpd="sng" algn="ctr">
-                      <a:solidFill>
-                        <a:srgbClr val="D8DEE2"/>
-                      </a:solidFill>
-                      <a:prstDash val="solid"/>
-                      <a:round/>
-                      <a:headEnd type="none" w="med" len="med"/>
-                      <a:tailEnd type="none" w="med" len="med"/>
-                    </a:lnL>
-                    <a:lnR w="9525" cap="flat" cmpd="sng" algn="ctr">
-                      <a:solidFill>
-                        <a:srgbClr val="D8DEE2"/>
-                      </a:solidFill>
-                      <a:prstDash val="solid"/>
-                      <a:round/>
-                      <a:headEnd type="none" w="med" len="med"/>
-                      <a:tailEnd type="none" w="med" len="med"/>
-                    </a:lnR>
-                    <a:lnT w="9525" cap="flat" cmpd="sng" algn="ctr">
-                      <a:solidFill>
-                        <a:srgbClr val="D8DEE2"/>
-                      </a:solidFill>
-                      <a:prstDash val="solid"/>
-                      <a:round/>
-                      <a:headEnd type="none" w="med" len="med"/>
-                      <a:tailEnd type="none" w="med" len="med"/>
-                    </a:lnT>
-                    <a:lnB w="9525" cap="flat" cmpd="sng" algn="ctr">
-                      <a:solidFill>
-                        <a:srgbClr val="D8DEE2"/>
-                      </a:solidFill>
-                      <a:prstDash val="solid"/>
-                      <a:round/>
-                      <a:headEnd type="none" w="med" len="med"/>
-                      <a:tailEnd type="none" w="med" len="med"/>
-                    </a:lnB>
-                    <a:solidFill>
-                      <a:srgbClr val="1A2733"/>
-                    </a:solidFill>
-                  </a:tcPr>
-                </a:tc>
-                <a:tc>
-                  <a:txBody>
-                    <a:bodyPr/>
-                    <a:lstStyle/>
-                    <a:p>
-                      <a:pPr indent="0" marL="0">
-                        <a:buNone/>
-                      </a:pPr>
-                      <a:r>
-                        <a:rPr lang="en-US" sz="1100" b="1" dirty="0">
-                          <a:solidFill>
-                            <a:srgbClr val="FFFFFF"/>
-                          </a:solidFill>
-                          <a:latin typeface="Calibri" pitchFamily="34" charset="0"/>
-                          <a:ea typeface="Calibri" pitchFamily="34" charset="-122"/>
-                          <a:cs typeface="Calibri" pitchFamily="34" charset="-120"/>
-                        </a:rPr>
-                        <a:t>Обоснование</a:t>
-                      </a:r>
-                      <a:endParaRPr lang="en-US" sz="1100" dirty="0">
-                        <a:latin typeface="Calibri" charset="0"/>
-                        <a:ea typeface="Calibri" charset="0"/>
-                        <a:cs typeface="Calibri" charset="0"/>
-                      </a:endParaRPr>
-                    </a:p>
-                  </a:txBody>
-                  <a:tcPr marL="114300" marR="114300" marT="76200" marB="76200" anchor="ctr">
-                    <a:lnL w="9525" cap="flat" cmpd="sng" algn="ctr">
-                      <a:solidFill>
-                        <a:srgbClr val="D8DEE2"/>
-                      </a:solidFill>
-                      <a:prstDash val="solid"/>
-                      <a:round/>
-                      <a:headEnd type="none" w="med" len="med"/>
-                      <a:tailEnd type="none" w="med" len="med"/>
-                    </a:lnL>
-                    <a:lnR w="9525" cap="flat" cmpd="sng" algn="ctr">
-                      <a:solidFill>
-                        <a:srgbClr val="D8DEE2"/>
-                      </a:solidFill>
-                      <a:prstDash val="solid"/>
-                      <a:round/>
-                      <a:headEnd type="none" w="med" len="med"/>
-                      <a:tailEnd type="none" w="med" len="med"/>
-                    </a:lnR>
-                    <a:lnT w="9525" cap="flat" cmpd="sng" algn="ctr">
-                      <a:solidFill>
-                        <a:srgbClr val="D8DEE2"/>
-                      </a:solidFill>
-                      <a:prstDash val="solid"/>
-                      <a:round/>
-                      <a:headEnd type="none" w="med" len="med"/>
-                      <a:tailEnd type="none" w="med" len="med"/>
-                    </a:lnT>
-                    <a:lnB w="9525" cap="flat" cmpd="sng" algn="ctr">
-                      <a:solidFill>
-                        <a:srgbClr val="D8DEE2"/>
-                      </a:solidFill>
-                      <a:prstDash val="solid"/>
-                      <a:round/>
-                      <a:headEnd type="none" w="med" len="med"/>
-                      <a:tailEnd type="none" w="med" len="med"/>
-                    </a:lnB>
-                    <a:solidFill>
-                      <a:srgbClr val="1A2733"/>
-                    </a:solidFill>
-                  </a:tcPr>
-                </a:tc>
-              </a:tr>
-              <a:tr h="640080">
-                <a:tc>
-                  <a:txBody>
-                    <a:bodyPr/>
-                    <a:lstStyle/>
-                    <a:p>
-                      <a:pPr algn="ctr" indent="0" marL="0">
-                        <a:buNone/>
-                      </a:pPr>
-                      <a:r>
-                        <a:rPr lang="en-US" sz="1100" dirty="0">
-                          <a:solidFill>
-                            <a:srgbClr val="5B6B7A"/>
-                          </a:solidFill>
-                          <a:latin typeface="Calibri" pitchFamily="34" charset="0"/>
-                          <a:ea typeface="Calibri" pitchFamily="34" charset="-122"/>
-                          <a:cs typeface="Calibri" pitchFamily="34" charset="-120"/>
-                        </a:rPr>
-                        <a:t>1</a:t>
-                      </a:r>
-                      <a:endParaRPr lang="en-US" sz="1100" dirty="0">
-                        <a:latin typeface="Calibri" charset="0"/>
-                        <a:ea typeface="Calibri" charset="0"/>
-                        <a:cs typeface="Calibri" charset="0"/>
-                      </a:endParaRPr>
-                    </a:p>
-                  </a:txBody>
-                  <a:tcPr marL="114300" marR="114300" marT="76200" marB="76200" anchor="ctr">
-                    <a:lnL w="9525" cap="flat" cmpd="sng" algn="ctr">
-                      <a:solidFill>
-                        <a:srgbClr val="D8DEE2"/>
-                      </a:solidFill>
-                      <a:prstDash val="solid"/>
-                      <a:round/>
-                      <a:headEnd type="none" w="med" len="med"/>
-                      <a:tailEnd type="none" w="med" len="med"/>
-                    </a:lnL>
-                    <a:lnR w="9525" cap="flat" cmpd="sng" algn="ctr">
-                      <a:solidFill>
-                        <a:srgbClr val="D8DEE2"/>
-                      </a:solidFill>
-                      <a:prstDash val="solid"/>
-                      <a:round/>
-                      <a:headEnd type="none" w="med" len="med"/>
-                      <a:tailEnd type="none" w="med" len="med"/>
-                    </a:lnR>
-                    <a:lnT w="9525" cap="flat" cmpd="sng" algn="ctr">
-                      <a:solidFill>
-                        <a:srgbClr val="D8DEE2"/>
-                      </a:solidFill>
-                      <a:prstDash val="solid"/>
-                      <a:round/>
-                      <a:headEnd type="none" w="med" len="med"/>
-                      <a:tailEnd type="none" w="med" len="med"/>
-                    </a:lnT>
-                    <a:lnB w="9525" cap="flat" cmpd="sng" algn="ctr">
-                      <a:solidFill>
-                        <a:srgbClr val="D8DEE2"/>
-                      </a:solidFill>
-                      <a:prstDash val="solid"/>
-                      <a:round/>
-                      <a:headEnd type="none" w="med" len="med"/>
-                      <a:tailEnd type="none" w="med" len="med"/>
-                    </a:lnB>
-                  </a:tcPr>
-                </a:tc>
-                <a:tc>
-                  <a:txBody>
-                    <a:bodyPr/>
-                    <a:lstStyle/>
-                    <a:p>
-                      <a:pPr indent="0" marL="0">
-                        <a:buNone/>
-                      </a:pPr>
-                      <a:r>
-                        <a:rPr lang="en-US" sz="1100" b="1" dirty="0">
-                          <a:solidFill>
-                            <a:srgbClr val="1A2733"/>
-                          </a:solidFill>
-                          <a:latin typeface="Calibri" pitchFamily="34" charset="0"/>
-                          <a:ea typeface="Calibri" pitchFamily="34" charset="-122"/>
-                          <a:cs typeface="Calibri" pitchFamily="34" charset="-120"/>
-                        </a:rPr>
-                        <a:t>Волна 1 — закрыть звонком, не перепиской</a:t>
-                      </a:r>
-                      <a:endParaRPr lang="en-US" sz="1100" dirty="0">
-                        <a:latin typeface="Calibri" charset="0"/>
-                        <a:ea typeface="Calibri" charset="0"/>
-                        <a:cs typeface="Calibri" charset="0"/>
-                      </a:endParaRPr>
-                    </a:p>
-                  </a:txBody>
-                  <a:tcPr marL="114300" marR="114300" marT="76200" marB="76200" anchor="ctr">
-                    <a:lnL w="9525" cap="flat" cmpd="sng" algn="ctr">
-                      <a:solidFill>
-                        <a:srgbClr val="D8DEE2"/>
-                      </a:solidFill>
-                      <a:prstDash val="solid"/>
-                      <a:round/>
-                      <a:headEnd type="none" w="med" len="med"/>
-                      <a:tailEnd type="none" w="med" len="med"/>
-                    </a:lnL>
-                    <a:lnR w="9525" cap="flat" cmpd="sng" algn="ctr">
-                      <a:solidFill>
-                        <a:srgbClr val="D8DEE2"/>
-                      </a:solidFill>
-                      <a:prstDash val="solid"/>
-                      <a:round/>
-                      <a:headEnd type="none" w="med" len="med"/>
-                      <a:tailEnd type="none" w="med" len="med"/>
-                    </a:lnR>
-                    <a:lnT w="9525" cap="flat" cmpd="sng" algn="ctr">
-                      <a:solidFill>
-                        <a:srgbClr val="D8DEE2"/>
-                      </a:solidFill>
-                      <a:prstDash val="solid"/>
-                      <a:round/>
-                      <a:headEnd type="none" w="med" len="med"/>
-                      <a:tailEnd type="none" w="med" len="med"/>
-                    </a:lnT>
-                    <a:lnB w="9525" cap="flat" cmpd="sng" algn="ctr">
-                      <a:solidFill>
-                        <a:srgbClr val="D8DEE2"/>
-                      </a:solidFill>
-                      <a:prstDash val="solid"/>
-                      <a:round/>
-                      <a:headEnd type="none" w="med" len="med"/>
-                      <a:tailEnd type="none" w="med" len="med"/>
-                    </a:lnB>
-                  </a:tcPr>
-                </a:tc>
-                <a:tc>
-                  <a:txBody>
-                    <a:bodyPr/>
-                    <a:lstStyle/>
-                    <a:p>
-                      <a:pPr indent="0" marL="0">
-                        <a:buNone/>
-                      </a:pPr>
-                      <a:r>
-                        <a:rPr lang="en-US" sz="1050" dirty="0">
-                          <a:solidFill>
-                            <a:srgbClr val="5B6B7A"/>
-                          </a:solidFill>
-                          <a:latin typeface="Calibri" pitchFamily="34" charset="0"/>
-                          <a:ea typeface="Calibri" pitchFamily="34" charset="-122"/>
-                          <a:cs typeface="Calibri" pitchFamily="34" charset="-120"/>
-                        </a:rPr>
-                        <a:t>Три толкования слишком разные по объёму работ, чтобы гадать — первый вопрос из всего списка.</a:t>
-                      </a:r>
-                      <a:endParaRPr lang="en-US" sz="1050" dirty="0">
-                        <a:latin typeface="Calibri" charset="0"/>
-                        <a:ea typeface="Calibri" charset="0"/>
-                        <a:cs typeface="Calibri" charset="0"/>
-                      </a:endParaRPr>
-                    </a:p>
-                  </a:txBody>
-                  <a:tcPr marL="114300" marR="114300" marT="76200" marB="76200" anchor="ctr">
-                    <a:lnL w="9525" cap="flat" cmpd="sng" algn="ctr">
-                      <a:solidFill>
-                        <a:srgbClr val="D8DEE2"/>
-                      </a:solidFill>
-                      <a:prstDash val="solid"/>
-                      <a:round/>
-                      <a:headEnd type="none" w="med" len="med"/>
-                      <a:tailEnd type="none" w="med" len="med"/>
-                    </a:lnL>
-                    <a:lnR w="9525" cap="flat" cmpd="sng" algn="ctr">
-                      <a:solidFill>
-                        <a:srgbClr val="D8DEE2"/>
-                      </a:solidFill>
-                      <a:prstDash val="solid"/>
-                      <a:round/>
-                      <a:headEnd type="none" w="med" len="med"/>
-                      <a:tailEnd type="none" w="med" len="med"/>
-                    </a:lnR>
-                    <a:lnT w="9525" cap="flat" cmpd="sng" algn="ctr">
-                      <a:solidFill>
-                        <a:srgbClr val="D8DEE2"/>
-                      </a:solidFill>
-                      <a:prstDash val="solid"/>
-                      <a:round/>
-                      <a:headEnd type="none" w="med" len="med"/>
-                      <a:tailEnd type="none" w="med" len="med"/>
-                    </a:lnT>
-                    <a:lnB w="9525" cap="flat" cmpd="sng" algn="ctr">
-                      <a:solidFill>
-                        <a:srgbClr val="D8DEE2"/>
-                      </a:solidFill>
-                      <a:prstDash val="solid"/>
-                      <a:round/>
-                      <a:headEnd type="none" w="med" len="med"/>
-                      <a:tailEnd type="none" w="med" len="med"/>
-                    </a:lnB>
-                  </a:tcPr>
-                </a:tc>
-              </a:tr>
-              <a:tr h="640080">
-                <a:tc>
-                  <a:txBody>
-                    <a:bodyPr/>
-                    <a:lstStyle/>
-                    <a:p>
-                      <a:pPr algn="ctr" indent="0" marL="0">
-                        <a:buNone/>
-                      </a:pPr>
-                      <a:r>
-                        <a:rPr lang="en-US" sz="1100" dirty="0">
-                          <a:solidFill>
-                            <a:srgbClr val="5B6B7A"/>
-                          </a:solidFill>
-                          <a:latin typeface="Calibri" pitchFamily="34" charset="0"/>
-                          <a:ea typeface="Calibri" pitchFamily="34" charset="-122"/>
-                          <a:cs typeface="Calibri" pitchFamily="34" charset="-120"/>
-                        </a:rPr>
-                        <a:t>2</a:t>
-                      </a:r>
-                      <a:endParaRPr lang="en-US" sz="1100" dirty="0">
-                        <a:latin typeface="Calibri" charset="0"/>
-                        <a:ea typeface="Calibri" charset="0"/>
-                        <a:cs typeface="Calibri" charset="0"/>
-                      </a:endParaRPr>
-                    </a:p>
-                  </a:txBody>
-                  <a:tcPr marL="114300" marR="114300" marT="76200" marB="76200" anchor="ctr">
-                    <a:lnL w="9525" cap="flat" cmpd="sng" algn="ctr">
-                      <a:solidFill>
-                        <a:srgbClr val="D8DEE2"/>
-                      </a:solidFill>
-                      <a:prstDash val="solid"/>
-                      <a:round/>
-                      <a:headEnd type="none" w="med" len="med"/>
-                      <a:tailEnd type="none" w="med" len="med"/>
-                    </a:lnL>
-                    <a:lnR w="9525" cap="flat" cmpd="sng" algn="ctr">
-                      <a:solidFill>
-                        <a:srgbClr val="D8DEE2"/>
-                      </a:solidFill>
-                      <a:prstDash val="solid"/>
-                      <a:round/>
-                      <a:headEnd type="none" w="med" len="med"/>
-                      <a:tailEnd type="none" w="med" len="med"/>
-                    </a:lnR>
-                    <a:lnT w="9525" cap="flat" cmpd="sng" algn="ctr">
-                      <a:solidFill>
-                        <a:srgbClr val="D8DEE2"/>
-                      </a:solidFill>
-                      <a:prstDash val="solid"/>
-                      <a:round/>
-                      <a:headEnd type="none" w="med" len="med"/>
-                      <a:tailEnd type="none" w="med" len="med"/>
-                    </a:lnT>
-                    <a:lnB w="9525" cap="flat" cmpd="sng" algn="ctr">
-                      <a:solidFill>
-                        <a:srgbClr val="D8DEE2"/>
-                      </a:solidFill>
-                      <a:prstDash val="solid"/>
-                      <a:round/>
-                      <a:headEnd type="none" w="med" len="med"/>
-                      <a:tailEnd type="none" w="med" len="med"/>
-                    </a:lnB>
-                  </a:tcPr>
-                </a:tc>
-                <a:tc>
-                  <a:txBody>
-                    <a:bodyPr/>
-                    <a:lstStyle/>
-                    <a:p>
-                      <a:pPr indent="0" marL="0">
-                        <a:buNone/>
-                      </a:pPr>
-                      <a:r>
-                        <a:rPr lang="en-US" sz="1100" b="1" dirty="0">
-                          <a:solidFill>
-                            <a:srgbClr val="1A2733"/>
-                          </a:solidFill>
-                          <a:latin typeface="Calibri" pitchFamily="34" charset="0"/>
-                          <a:ea typeface="Calibri" pitchFamily="34" charset="-122"/>
-                          <a:cs typeface="Calibri" pitchFamily="34" charset="-120"/>
-                        </a:rPr>
-                        <a:t>ESB/КХД (волна 2) зафиксировать письменно как есть — расширение, не сужение</a:t>
-                      </a:r>
-                      <a:endParaRPr lang="en-US" sz="1100" dirty="0">
-                        <a:latin typeface="Calibri" charset="0"/>
-                        <a:ea typeface="Calibri" charset="0"/>
-                        <a:cs typeface="Calibri" charset="0"/>
-                      </a:endParaRPr>
-                    </a:p>
-                  </a:txBody>
-                  <a:tcPr marL="114300" marR="114300" marT="76200" marB="76200" anchor="ctr">
-                    <a:lnL w="9525" cap="flat" cmpd="sng" algn="ctr">
-                      <a:solidFill>
-                        <a:srgbClr val="D8DEE2"/>
-                      </a:solidFill>
-                      <a:prstDash val="solid"/>
-                      <a:round/>
-                      <a:headEnd type="none" w="med" len="med"/>
-                      <a:tailEnd type="none" w="med" len="med"/>
-                    </a:lnL>
-                    <a:lnR w="9525" cap="flat" cmpd="sng" algn="ctr">
-                      <a:solidFill>
-                        <a:srgbClr val="D8DEE2"/>
-                      </a:solidFill>
-                      <a:prstDash val="solid"/>
-                      <a:round/>
-                      <a:headEnd type="none" w="med" len="med"/>
-                      <a:tailEnd type="none" w="med" len="med"/>
-                    </a:lnR>
-                    <a:lnT w="9525" cap="flat" cmpd="sng" algn="ctr">
-                      <a:solidFill>
-                        <a:srgbClr val="D8DEE2"/>
-                      </a:solidFill>
-                      <a:prstDash val="solid"/>
-                      <a:round/>
-                      <a:headEnd type="none" w="med" len="med"/>
-                      <a:tailEnd type="none" w="med" len="med"/>
-                    </a:lnT>
-                    <a:lnB w="9525" cap="flat" cmpd="sng" algn="ctr">
-                      <a:solidFill>
-                        <a:srgbClr val="D8DEE2"/>
-                      </a:solidFill>
-                      <a:prstDash val="solid"/>
-                      <a:round/>
-                      <a:headEnd type="none" w="med" len="med"/>
-                      <a:tailEnd type="none" w="med" len="med"/>
-                    </a:lnB>
-                  </a:tcPr>
-                </a:tc>
-                <a:tc>
-                  <a:txBody>
-                    <a:bodyPr/>
-                    <a:lstStyle/>
-                    <a:p>
-                      <a:pPr indent="0" marL="0">
-                        <a:buNone/>
-                      </a:pPr>
-                      <a:r>
-                        <a:rPr lang="en-US" sz="1050" dirty="0">
-                          <a:solidFill>
-                            <a:srgbClr val="5B6B7A"/>
-                          </a:solidFill>
-                          <a:latin typeface="Calibri" pitchFamily="34" charset="0"/>
-                          <a:ea typeface="Calibri" pitchFamily="34" charset="-122"/>
-                          <a:cs typeface="Calibri" pitchFamily="34" charset="-120"/>
-                        </a:rPr>
-                        <a:t>Все 3 пилотных источника остаются; ESB и КХД получают расширение, MCP-сервер — на пилотном уровне.</a:t>
-                      </a:r>
-                      <a:endParaRPr lang="en-US" sz="1050" dirty="0">
-                        <a:latin typeface="Calibri" charset="0"/>
-                        <a:ea typeface="Calibri" charset="0"/>
-                        <a:cs typeface="Calibri" charset="0"/>
-                      </a:endParaRPr>
-                    </a:p>
-                  </a:txBody>
-                  <a:tcPr marL="114300" marR="114300" marT="76200" marB="76200" anchor="ctr">
-                    <a:lnL w="9525" cap="flat" cmpd="sng" algn="ctr">
-                      <a:solidFill>
-                        <a:srgbClr val="D8DEE2"/>
-                      </a:solidFill>
-                      <a:prstDash val="solid"/>
-                      <a:round/>
-                      <a:headEnd type="none" w="med" len="med"/>
-                      <a:tailEnd type="none" w="med" len="med"/>
-                    </a:lnL>
-                    <a:lnR w="9525" cap="flat" cmpd="sng" algn="ctr">
-                      <a:solidFill>
-                        <a:srgbClr val="D8DEE2"/>
-                      </a:solidFill>
-                      <a:prstDash val="solid"/>
-                      <a:round/>
-                      <a:headEnd type="none" w="med" len="med"/>
-                      <a:tailEnd type="none" w="med" len="med"/>
-                    </a:lnR>
-                    <a:lnT w="9525" cap="flat" cmpd="sng" algn="ctr">
-                      <a:solidFill>
-                        <a:srgbClr val="D8DEE2"/>
-                      </a:solidFill>
-                      <a:prstDash val="solid"/>
-                      <a:round/>
-                      <a:headEnd type="none" w="med" len="med"/>
-                      <a:tailEnd type="none" w="med" len="med"/>
-                    </a:lnT>
-                    <a:lnB w="9525" cap="flat" cmpd="sng" algn="ctr">
-                      <a:solidFill>
-                        <a:srgbClr val="D8DEE2"/>
-                      </a:solidFill>
-                      <a:prstDash val="solid"/>
-                      <a:round/>
-                      <a:headEnd type="none" w="med" len="med"/>
-                      <a:tailEnd type="none" w="med" len="med"/>
-                    </a:lnB>
-                  </a:tcPr>
-                </a:tc>
-              </a:tr>
-              <a:tr h="640080">
-                <a:tc>
-                  <a:txBody>
-                    <a:bodyPr/>
-                    <a:lstStyle/>
-                    <a:p>
-                      <a:pPr algn="ctr" indent="0" marL="0">
-                        <a:buNone/>
-                      </a:pPr>
-                      <a:r>
-                        <a:rPr lang="en-US" sz="1100" dirty="0">
-                          <a:solidFill>
-                            <a:srgbClr val="5B6B7A"/>
-                          </a:solidFill>
-                          <a:latin typeface="Calibri" pitchFamily="34" charset="0"/>
-                          <a:ea typeface="Calibri" pitchFamily="34" charset="-122"/>
-                          <a:cs typeface="Calibri" pitchFamily="34" charset="-120"/>
-                        </a:rPr>
-                        <a:t>3</a:t>
-                      </a:r>
-                      <a:endParaRPr lang="en-US" sz="1100" dirty="0">
-                        <a:latin typeface="Calibri" charset="0"/>
-                        <a:ea typeface="Calibri" charset="0"/>
-                        <a:cs typeface="Calibri" charset="0"/>
-                      </a:endParaRPr>
-                    </a:p>
-                  </a:txBody>
-                  <a:tcPr marL="114300" marR="114300" marT="76200" marB="76200" anchor="ctr">
-                    <a:lnL w="9525" cap="flat" cmpd="sng" algn="ctr">
-                      <a:solidFill>
-                        <a:srgbClr val="D8DEE2"/>
-                      </a:solidFill>
-                      <a:prstDash val="solid"/>
-                      <a:round/>
-                      <a:headEnd type="none" w="med" len="med"/>
-                      <a:tailEnd type="none" w="med" len="med"/>
-                    </a:lnL>
-                    <a:lnR w="9525" cap="flat" cmpd="sng" algn="ctr">
-                      <a:solidFill>
-                        <a:srgbClr val="D8DEE2"/>
-                      </a:solidFill>
-                      <a:prstDash val="solid"/>
-                      <a:round/>
-                      <a:headEnd type="none" w="med" len="med"/>
-                      <a:tailEnd type="none" w="med" len="med"/>
-                    </a:lnR>
-                    <a:lnT w="9525" cap="flat" cmpd="sng" algn="ctr">
-                      <a:solidFill>
-                        <a:srgbClr val="D8DEE2"/>
-                      </a:solidFill>
-                      <a:prstDash val="solid"/>
-                      <a:round/>
-                      <a:headEnd type="none" w="med" len="med"/>
-                      <a:tailEnd type="none" w="med" len="med"/>
-                    </a:lnT>
-                    <a:lnB w="9525" cap="flat" cmpd="sng" algn="ctr">
-                      <a:solidFill>
-                        <a:srgbClr val="D8DEE2"/>
-                      </a:solidFill>
-                      <a:prstDash val="solid"/>
-                      <a:round/>
-                      <a:headEnd type="none" w="med" len="med"/>
-                      <a:tailEnd type="none" w="med" len="med"/>
-                    </a:lnB>
-                  </a:tcPr>
-                </a:tc>
-                <a:tc>
-                  <a:txBody>
-                    <a:bodyPr/>
-                    <a:lstStyle/>
-                    <a:p>
-                      <a:pPr indent="0" marL="0">
-                        <a:buNone/>
-                      </a:pPr>
-                      <a:r>
-                        <a:rPr lang="en-US" sz="1100" b="1" dirty="0">
-                          <a:solidFill>
-                            <a:srgbClr val="1A2733"/>
-                          </a:solidFill>
-                          <a:latin typeface="Calibri" pitchFamily="34" charset="0"/>
-                          <a:ea typeface="Calibri" pitchFamily="34" charset="-122"/>
-                          <a:cs typeface="Calibri" pitchFamily="34" charset="-120"/>
-                        </a:rPr>
-                        <a:t>Разграничение прав compliance/менеджер — сделать обязательным для проекта</a:t>
-                      </a:r>
-                      <a:endParaRPr lang="en-US" sz="1100" dirty="0">
-                        <a:latin typeface="Calibri" charset="0"/>
-                        <a:ea typeface="Calibri" charset="0"/>
-                        <a:cs typeface="Calibri" charset="0"/>
-                      </a:endParaRPr>
-                    </a:p>
-                  </a:txBody>
-                  <a:tcPr marL="114300" marR="114300" marT="76200" marB="76200" anchor="ctr">
-                    <a:lnL w="9525" cap="flat" cmpd="sng" algn="ctr">
-                      <a:solidFill>
-                        <a:srgbClr val="D8DEE2"/>
-                      </a:solidFill>
-                      <a:prstDash val="solid"/>
-                      <a:round/>
-                      <a:headEnd type="none" w="med" len="med"/>
-                      <a:tailEnd type="none" w="med" len="med"/>
-                    </a:lnL>
-                    <a:lnR w="9525" cap="flat" cmpd="sng" algn="ctr">
-                      <a:solidFill>
-                        <a:srgbClr val="D8DEE2"/>
-                      </a:solidFill>
-                      <a:prstDash val="solid"/>
-                      <a:round/>
-                      <a:headEnd type="none" w="med" len="med"/>
-                      <a:tailEnd type="none" w="med" len="med"/>
-                    </a:lnR>
-                    <a:lnT w="9525" cap="flat" cmpd="sng" algn="ctr">
-                      <a:solidFill>
-                        <a:srgbClr val="D8DEE2"/>
-                      </a:solidFill>
-                      <a:prstDash val="solid"/>
-                      <a:round/>
-                      <a:headEnd type="none" w="med" len="med"/>
-                      <a:tailEnd type="none" w="med" len="med"/>
-                    </a:lnT>
-                    <a:lnB w="9525" cap="flat" cmpd="sng" algn="ctr">
-                      <a:solidFill>
-                        <a:srgbClr val="D8DEE2"/>
-                      </a:solidFill>
-                      <a:prstDash val="solid"/>
-                      <a:round/>
-                      <a:headEnd type="none" w="med" len="med"/>
-                      <a:tailEnd type="none" w="med" len="med"/>
-                    </a:lnB>
-                  </a:tcPr>
-                </a:tc>
-                <a:tc>
-                  <a:txBody>
-                    <a:bodyPr/>
-                    <a:lstStyle/>
-                    <a:p>
-                      <a:pPr indent="0" marL="0">
-                        <a:buNone/>
-                      </a:pPr>
-                      <a:r>
-                        <a:rPr lang="en-US" sz="1050" dirty="0">
-                          <a:solidFill>
-                            <a:srgbClr val="5B6B7A"/>
-                          </a:solidFill>
-                          <a:latin typeface="Calibri" pitchFamily="34" charset="0"/>
-                          <a:ea typeface="Calibri" pitchFamily="34" charset="-122"/>
-                          <a:cs typeface="Calibri" pitchFamily="34" charset="-120"/>
-                        </a:rPr>
-                        <a:t>Д8 — брокер/инвесткомпания: доступ менеджера к чужим клиентам — комплаенс-риск, не UX-неудобство.</a:t>
-                      </a:r>
-                      <a:endParaRPr lang="en-US" sz="1050" dirty="0">
-                        <a:latin typeface="Calibri" charset="0"/>
-                        <a:ea typeface="Calibri" charset="0"/>
-                        <a:cs typeface="Calibri" charset="0"/>
-                      </a:endParaRPr>
-                    </a:p>
-                  </a:txBody>
-                  <a:tcPr marL="114300" marR="114300" marT="76200" marB="76200" anchor="ctr">
-                    <a:lnL w="9525" cap="flat" cmpd="sng" algn="ctr">
-                      <a:solidFill>
-                        <a:srgbClr val="D8DEE2"/>
-                      </a:solidFill>
-                      <a:prstDash val="solid"/>
-                      <a:round/>
-                      <a:headEnd type="none" w="med" len="med"/>
-                      <a:tailEnd type="none" w="med" len="med"/>
-                    </a:lnL>
-                    <a:lnR w="9525" cap="flat" cmpd="sng" algn="ctr">
-                      <a:solidFill>
-                        <a:srgbClr val="D8DEE2"/>
-                      </a:solidFill>
-                      <a:prstDash val="solid"/>
-                      <a:round/>
-                      <a:headEnd type="none" w="med" len="med"/>
-                      <a:tailEnd type="none" w="med" len="med"/>
-                    </a:lnR>
-                    <a:lnT w="9525" cap="flat" cmpd="sng" algn="ctr">
-                      <a:solidFill>
-                        <a:srgbClr val="D8DEE2"/>
-                      </a:solidFill>
-                      <a:prstDash val="solid"/>
-                      <a:round/>
-                      <a:headEnd type="none" w="med" len="med"/>
-                      <a:tailEnd type="none" w="med" len="med"/>
-                    </a:lnT>
-                    <a:lnB w="9525" cap="flat" cmpd="sng" algn="ctr">
-                      <a:solidFill>
-                        <a:srgbClr val="D8DEE2"/>
-                      </a:solidFill>
-                      <a:prstDash val="solid"/>
-                      <a:round/>
-                      <a:headEnd type="none" w="med" len="med"/>
-                      <a:tailEnd type="none" w="med" len="med"/>
-                    </a:lnB>
-                  </a:tcPr>
-                </a:tc>
-              </a:tr>
-              <a:tr h="640080">
-                <a:tc>
-                  <a:txBody>
-                    <a:bodyPr/>
-                    <a:lstStyle/>
-                    <a:p>
-                      <a:pPr algn="ctr" indent="0" marL="0">
-                        <a:buNone/>
-                      </a:pPr>
-                      <a:r>
-                        <a:rPr lang="en-US" sz="1100" dirty="0">
-                          <a:solidFill>
-                            <a:srgbClr val="5B6B7A"/>
-                          </a:solidFill>
-                          <a:latin typeface="Calibri" pitchFamily="34" charset="0"/>
-                          <a:ea typeface="Calibri" pitchFamily="34" charset="-122"/>
-                          <a:cs typeface="Calibri" pitchFamily="34" charset="-120"/>
-                        </a:rPr>
-                        <a:t>4</a:t>
-                      </a:r>
-                      <a:endParaRPr lang="en-US" sz="1100" dirty="0">
-                        <a:latin typeface="Calibri" charset="0"/>
-                        <a:ea typeface="Calibri" charset="0"/>
-                        <a:cs typeface="Calibri" charset="0"/>
-                      </a:endParaRPr>
-                    </a:p>
-                  </a:txBody>
-                  <a:tcPr marL="114300" marR="114300" marT="76200" marB="76200" anchor="ctr">
-                    <a:lnL w="9525" cap="flat" cmpd="sng" algn="ctr">
-                      <a:solidFill>
-                        <a:srgbClr val="D8DEE2"/>
-                      </a:solidFill>
-                      <a:prstDash val="solid"/>
-                      <a:round/>
-                      <a:headEnd type="none" w="med" len="med"/>
-                      <a:tailEnd type="none" w="med" len="med"/>
-                    </a:lnL>
-                    <a:lnR w="9525" cap="flat" cmpd="sng" algn="ctr">
-                      <a:solidFill>
-                        <a:srgbClr val="D8DEE2"/>
-                      </a:solidFill>
-                      <a:prstDash val="solid"/>
-                      <a:round/>
-                      <a:headEnd type="none" w="med" len="med"/>
-                      <a:tailEnd type="none" w="med" len="med"/>
-                    </a:lnR>
-                    <a:lnT w="9525" cap="flat" cmpd="sng" algn="ctr">
-                      <a:solidFill>
-                        <a:srgbClr val="D8DEE2"/>
-                      </a:solidFill>
-                      <a:prstDash val="solid"/>
-                      <a:round/>
-                      <a:headEnd type="none" w="med" len="med"/>
-                      <a:tailEnd type="none" w="med" len="med"/>
-                    </a:lnT>
-                    <a:lnB w="9525" cap="flat" cmpd="sng" algn="ctr">
-                      <a:solidFill>
-                        <a:srgbClr val="D8DEE2"/>
-                      </a:solidFill>
-                      <a:prstDash val="solid"/>
-                      <a:round/>
-                      <a:headEnd type="none" w="med" len="med"/>
-                      <a:tailEnd type="none" w="med" len="med"/>
-                    </a:lnB>
-                  </a:tcPr>
-                </a:tc>
-                <a:tc>
-                  <a:txBody>
-                    <a:bodyPr/>
-                    <a:lstStyle/>
-                    <a:p>
-                      <a:pPr indent="0" marL="0">
-                        <a:buNone/>
-                      </a:pPr>
-                      <a:r>
-                        <a:rPr lang="en-US" sz="1100" b="1" dirty="0">
-                          <a:solidFill>
-                            <a:srgbClr val="1A2733"/>
-                          </a:solidFill>
-                          <a:latin typeface="Calibri" pitchFamily="34" charset="0"/>
-                          <a:ea typeface="Calibri" pitchFamily="34" charset="-122"/>
-                          <a:cs typeface="Calibri" pitchFamily="34" charset="-120"/>
-                        </a:rPr>
-                        <a:t>Динамические права доступа — не блокировать волну 2, но зафиксировать как gate</a:t>
-                      </a:r>
-                      <a:endParaRPr lang="en-US" sz="1100" dirty="0">
-                        <a:latin typeface="Calibri" charset="0"/>
-                        <a:ea typeface="Calibri" charset="0"/>
-                        <a:cs typeface="Calibri" charset="0"/>
-                      </a:endParaRPr>
-                    </a:p>
-                  </a:txBody>
-                  <a:tcPr marL="114300" marR="114300" marT="76200" marB="76200" anchor="ctr">
-                    <a:lnL w="9525" cap="flat" cmpd="sng" algn="ctr">
-                      <a:solidFill>
-                        <a:srgbClr val="D8DEE2"/>
-                      </a:solidFill>
-                      <a:prstDash val="solid"/>
-                      <a:round/>
-                      <a:headEnd type="none" w="med" len="med"/>
-                      <a:tailEnd type="none" w="med" len="med"/>
-                    </a:lnL>
-                    <a:lnR w="9525" cap="flat" cmpd="sng" algn="ctr">
-                      <a:solidFill>
-                        <a:srgbClr val="D8DEE2"/>
-                      </a:solidFill>
-                      <a:prstDash val="solid"/>
-                      <a:round/>
-                      <a:headEnd type="none" w="med" len="med"/>
-                      <a:tailEnd type="none" w="med" len="med"/>
-                    </a:lnR>
-                    <a:lnT w="9525" cap="flat" cmpd="sng" algn="ctr">
-                      <a:solidFill>
-                        <a:srgbClr val="D8DEE2"/>
-                      </a:solidFill>
-                      <a:prstDash val="solid"/>
-                      <a:round/>
-                      <a:headEnd type="none" w="med" len="med"/>
-                      <a:tailEnd type="none" w="med" len="med"/>
-                    </a:lnT>
-                    <a:lnB w="9525" cap="flat" cmpd="sng" algn="ctr">
-                      <a:solidFill>
-                        <a:srgbClr val="D8DEE2"/>
-                      </a:solidFill>
-                      <a:prstDash val="solid"/>
-                      <a:round/>
-                      <a:headEnd type="none" w="med" len="med"/>
-                      <a:tailEnd type="none" w="med" len="med"/>
-                    </a:lnB>
-                  </a:tcPr>
-                </a:tc>
-                <a:tc>
-                  <a:txBody>
-                    <a:bodyPr/>
-                    <a:lstStyle/>
-                    <a:p>
-                      <a:pPr indent="0" marL="0">
-                        <a:buNone/>
-                      </a:pPr>
-                      <a:r>
-                        <a:rPr lang="en-US" sz="1050" dirty="0">
-                          <a:solidFill>
-                            <a:srgbClr val="5B6B7A"/>
-                          </a:solidFill>
-                          <a:latin typeface="Calibri" pitchFamily="34" charset="0"/>
-                          <a:ea typeface="Calibri" pitchFamily="34" charset="-122"/>
-                          <a:cs typeface="Calibri" pitchFamily="34" charset="-120"/>
-                        </a:rPr>
-                        <a:t>Волну 2 запускать на статичной модели (как в пилоте); чувствительные волны — только когда готово с обеих сторон.</a:t>
-                      </a:r>
-                      <a:endParaRPr lang="en-US" sz="1050" dirty="0">
-                        <a:latin typeface="Calibri" charset="0"/>
-                        <a:ea typeface="Calibri" charset="0"/>
-                        <a:cs typeface="Calibri" charset="0"/>
-                      </a:endParaRPr>
-                    </a:p>
-                  </a:txBody>
-                  <a:tcPr marL="114300" marR="114300" marT="76200" marB="76200" anchor="ctr">
-                    <a:lnL w="9525" cap="flat" cmpd="sng" algn="ctr">
-                      <a:solidFill>
-                        <a:srgbClr val="D8DEE2"/>
-                      </a:solidFill>
-                      <a:prstDash val="solid"/>
-                      <a:round/>
-                      <a:headEnd type="none" w="med" len="med"/>
-                      <a:tailEnd type="none" w="med" len="med"/>
-                    </a:lnL>
-                    <a:lnR w="9525" cap="flat" cmpd="sng" algn="ctr">
-                      <a:solidFill>
-                        <a:srgbClr val="D8DEE2"/>
-                      </a:solidFill>
-                      <a:prstDash val="solid"/>
-                      <a:round/>
-                      <a:headEnd type="none" w="med" len="med"/>
-                      <a:tailEnd type="none" w="med" len="med"/>
-                    </a:lnR>
-                    <a:lnT w="9525" cap="flat" cmpd="sng" algn="ctr">
-                      <a:solidFill>
-                        <a:srgbClr val="D8DEE2"/>
-                      </a:solidFill>
-                      <a:prstDash val="solid"/>
-                      <a:round/>
-                      <a:headEnd type="none" w="med" len="med"/>
-                      <a:tailEnd type="none" w="med" len="med"/>
-                    </a:lnT>
-                    <a:lnB w="9525" cap="flat" cmpd="sng" algn="ctr">
-                      <a:solidFill>
-                        <a:srgbClr val="D8DEE2"/>
-                      </a:solidFill>
-                      <a:prstDash val="solid"/>
-                      <a:round/>
-                      <a:headEnd type="none" w="med" len="med"/>
-                      <a:tailEnd type="none" w="med" len="med"/>
-                    </a:lnB>
-                  </a:tcPr>
-                </a:tc>
-              </a:tr>
-              <a:tr h="640080">
-                <a:tc>
-                  <a:txBody>
-                    <a:bodyPr/>
-                    <a:lstStyle/>
-                    <a:p>
-                      <a:pPr algn="ctr" indent="0" marL="0">
-                        <a:buNone/>
-                      </a:pPr>
-                      <a:r>
-                        <a:rPr lang="en-US" sz="1100" dirty="0">
-                          <a:solidFill>
-                            <a:srgbClr val="5B6B7A"/>
-                          </a:solidFill>
-                          <a:latin typeface="Calibri" pitchFamily="34" charset="0"/>
-                          <a:ea typeface="Calibri" pitchFamily="34" charset="-122"/>
-                          <a:cs typeface="Calibri" pitchFamily="34" charset="-120"/>
-                        </a:rPr>
-                        <a:t>5</a:t>
-                      </a:r>
-                      <a:endParaRPr lang="en-US" sz="1100" dirty="0">
-                        <a:latin typeface="Calibri" charset="0"/>
-                        <a:ea typeface="Calibri" charset="0"/>
-                        <a:cs typeface="Calibri" charset="0"/>
-                      </a:endParaRPr>
-                    </a:p>
-                  </a:txBody>
-                  <a:tcPr marL="114300" marR="114300" marT="76200" marB="76200" anchor="ctr">
-                    <a:lnL w="9525" cap="flat" cmpd="sng" algn="ctr">
-                      <a:solidFill>
-                        <a:srgbClr val="D8DEE2"/>
-                      </a:solidFill>
-                      <a:prstDash val="solid"/>
-                      <a:round/>
-                      <a:headEnd type="none" w="med" len="med"/>
-                      <a:tailEnd type="none" w="med" len="med"/>
-                    </a:lnL>
-                    <a:lnR w="9525" cap="flat" cmpd="sng" algn="ctr">
-                      <a:solidFill>
-                        <a:srgbClr val="D8DEE2"/>
-                      </a:solidFill>
-                      <a:prstDash val="solid"/>
-                      <a:round/>
-                      <a:headEnd type="none" w="med" len="med"/>
-                      <a:tailEnd type="none" w="med" len="med"/>
-                    </a:lnR>
-                    <a:lnT w="9525" cap="flat" cmpd="sng" algn="ctr">
-                      <a:solidFill>
-                        <a:srgbClr val="D8DEE2"/>
-                      </a:solidFill>
-                      <a:prstDash val="solid"/>
-                      <a:round/>
-                      <a:headEnd type="none" w="med" len="med"/>
-                      <a:tailEnd type="none" w="med" len="med"/>
-                    </a:lnT>
-                    <a:lnB w="9525" cap="flat" cmpd="sng" algn="ctr">
-                      <a:solidFill>
-                        <a:srgbClr val="D8DEE2"/>
-                      </a:solidFill>
-                      <a:prstDash val="solid"/>
-                      <a:round/>
-                      <a:headEnd type="none" w="med" len="med"/>
-                      <a:tailEnd type="none" w="med" len="med"/>
-                    </a:lnB>
-                  </a:tcPr>
-                </a:tc>
-                <a:tc>
-                  <a:txBody>
-                    <a:bodyPr/>
-                    <a:lstStyle/>
-                    <a:p>
-                      <a:pPr indent="0" marL="0">
-                        <a:buNone/>
-                      </a:pPr>
-                      <a:r>
-                        <a:rPr lang="en-US" sz="1100" b="1" dirty="0">
-                          <a:solidFill>
-                            <a:srgbClr val="1A2733"/>
-                          </a:solidFill>
-                          <a:latin typeface="Calibri" pitchFamily="34" charset="0"/>
-                          <a:ea typeface="Calibri" pitchFamily="34" charset="-122"/>
-                          <a:cs typeface="Calibri" pitchFamily="34" charset="-120"/>
-                        </a:rPr>
-                        <a:t>Волна 3+ (роллаут по ролям) — порядок по умолчанию: фронт-офис → аналитики/УК → руководство → бэк-офис</a:t>
-                      </a:r>
-                      <a:endParaRPr lang="en-US" sz="1100" dirty="0">
-                        <a:latin typeface="Calibri" charset="0"/>
-                        <a:ea typeface="Calibri" charset="0"/>
-                        <a:cs typeface="Calibri" charset="0"/>
-                      </a:endParaRPr>
-                    </a:p>
-                  </a:txBody>
-                  <a:tcPr marL="114300" marR="114300" marT="76200" marB="76200" anchor="ctr">
-                    <a:lnL w="9525" cap="flat" cmpd="sng" algn="ctr">
-                      <a:solidFill>
-                        <a:srgbClr val="D8DEE2"/>
-                      </a:solidFill>
-                      <a:prstDash val="solid"/>
-                      <a:round/>
-                      <a:headEnd type="none" w="med" len="med"/>
-                      <a:tailEnd type="none" w="med" len="med"/>
-                    </a:lnL>
-                    <a:lnR w="9525" cap="flat" cmpd="sng" algn="ctr">
-                      <a:solidFill>
-                        <a:srgbClr val="D8DEE2"/>
-                      </a:solidFill>
-                      <a:prstDash val="solid"/>
-                      <a:round/>
-                      <a:headEnd type="none" w="med" len="med"/>
-                      <a:tailEnd type="none" w="med" len="med"/>
-                    </a:lnR>
-                    <a:lnT w="9525" cap="flat" cmpd="sng" algn="ctr">
-                      <a:solidFill>
-                        <a:srgbClr val="D8DEE2"/>
-                      </a:solidFill>
-                      <a:prstDash val="solid"/>
-                      <a:round/>
-                      <a:headEnd type="none" w="med" len="med"/>
-                      <a:tailEnd type="none" w="med" len="med"/>
-                    </a:lnT>
-                    <a:lnB w="9525" cap="flat" cmpd="sng" algn="ctr">
-                      <a:solidFill>
-                        <a:srgbClr val="D8DEE2"/>
-                      </a:solidFill>
-                      <a:prstDash val="solid"/>
-                      <a:round/>
-                      <a:headEnd type="none" w="med" len="med"/>
-                      <a:tailEnd type="none" w="med" len="med"/>
-                    </a:lnB>
-                  </a:tcPr>
-                </a:tc>
-                <a:tc>
-                  <a:txBody>
-                    <a:bodyPr/>
-                    <a:lstStyle/>
-                    <a:p>
-                      <a:pPr indent="0" marL="0">
-                        <a:buNone/>
-                      </a:pPr>
-                      <a:r>
-                        <a:rPr lang="en-US" sz="1050" dirty="0">
-                          <a:solidFill>
-                            <a:srgbClr val="5B6B7A"/>
-                          </a:solidFill>
-                          <a:latin typeface="Calibri" pitchFamily="34" charset="0"/>
-                          <a:ea typeface="Calibri" pitchFamily="34" charset="-122"/>
-                          <a:cs typeface="Calibri" pitchFamily="34" charset="-120"/>
-                        </a:rPr>
-                        <a:t>Фронт-офис уже протестирован в пилоте — наименьший риск; бэк-офис — самые чувствительные данные, последним.</a:t>
-                      </a:r>
-                      <a:endParaRPr lang="en-US" sz="1050" dirty="0">
-                        <a:latin typeface="Calibri" charset="0"/>
-                        <a:ea typeface="Calibri" charset="0"/>
-                        <a:cs typeface="Calibri" charset="0"/>
-                      </a:endParaRPr>
-                    </a:p>
-                  </a:txBody>
-                  <a:tcPr marL="114300" marR="114300" marT="76200" marB="76200" anchor="ctr">
-                    <a:lnL w="9525" cap="flat" cmpd="sng" algn="ctr">
-                      <a:solidFill>
-                        <a:srgbClr val="D8DEE2"/>
-                      </a:solidFill>
-                      <a:prstDash val="solid"/>
-                      <a:round/>
-                      <a:headEnd type="none" w="med" len="med"/>
-                      <a:tailEnd type="none" w="med" len="med"/>
-                    </a:lnL>
-                    <a:lnR w="9525" cap="flat" cmpd="sng" algn="ctr">
-                      <a:solidFill>
-                        <a:srgbClr val="D8DEE2"/>
-                      </a:solidFill>
-                      <a:prstDash val="solid"/>
-                      <a:round/>
-                      <a:headEnd type="none" w="med" len="med"/>
-                      <a:tailEnd type="none" w="med" len="med"/>
-                    </a:lnR>
-                    <a:lnT w="9525" cap="flat" cmpd="sng" algn="ctr">
-                      <a:solidFill>
-                        <a:srgbClr val="D8DEE2"/>
-                      </a:solidFill>
-                      <a:prstDash val="solid"/>
-                      <a:round/>
-                      <a:headEnd type="none" w="med" len="med"/>
-                      <a:tailEnd type="none" w="med" len="med"/>
-                    </a:lnT>
-                    <a:lnB w="9525" cap="flat" cmpd="sng" algn="ctr">
-                      <a:solidFill>
-                        <a:srgbClr val="D8DEE2"/>
-                      </a:solidFill>
-                      <a:prstDash val="solid"/>
-                      <a:round/>
-                      <a:headEnd type="none" w="med" len="med"/>
-                      <a:tailEnd type="none" w="med" len="med"/>
-                    </a:lnB>
-                  </a:tcPr>
-                </a:tc>
-              </a:tr>
-              <a:tr h="640080">
-                <a:tc>
-                  <a:txBody>
-                    <a:bodyPr/>
-                    <a:lstStyle/>
-                    <a:p>
-                      <a:pPr algn="ctr" indent="0" marL="0">
-                        <a:buNone/>
-                      </a:pPr>
-                      <a:r>
-                        <a:rPr lang="en-US" sz="1100" dirty="0">
-                          <a:solidFill>
-                            <a:srgbClr val="5B6B7A"/>
-                          </a:solidFill>
-                          <a:latin typeface="Calibri" pitchFamily="34" charset="0"/>
-                          <a:ea typeface="Calibri" pitchFamily="34" charset="-122"/>
-                          <a:cs typeface="Calibri" pitchFamily="34" charset="-120"/>
-                        </a:rPr>
-                        <a:t>6</a:t>
-                      </a:r>
-                      <a:endParaRPr lang="en-US" sz="1100" dirty="0">
-                        <a:latin typeface="Calibri" charset="0"/>
-                        <a:ea typeface="Calibri" charset="0"/>
-                        <a:cs typeface="Calibri" charset="0"/>
-                      </a:endParaRPr>
-                    </a:p>
-                  </a:txBody>
-                  <a:tcPr marL="114300" marR="114300" marT="76200" marB="76200" anchor="ctr">
-                    <a:lnL w="9525" cap="flat" cmpd="sng" algn="ctr">
-                      <a:solidFill>
-                        <a:srgbClr val="D8DEE2"/>
-                      </a:solidFill>
-                      <a:prstDash val="solid"/>
-                      <a:round/>
-                      <a:headEnd type="none" w="med" len="med"/>
-                      <a:tailEnd type="none" w="med" len="med"/>
-                    </a:lnL>
-                    <a:lnR w="9525" cap="flat" cmpd="sng" algn="ctr">
-                      <a:solidFill>
-                        <a:srgbClr val="D8DEE2"/>
-                      </a:solidFill>
-                      <a:prstDash val="solid"/>
-                      <a:round/>
-                      <a:headEnd type="none" w="med" len="med"/>
-                      <a:tailEnd type="none" w="med" len="med"/>
-                    </a:lnR>
-                    <a:lnT w="9525" cap="flat" cmpd="sng" algn="ctr">
-                      <a:solidFill>
-                        <a:srgbClr val="D8DEE2"/>
-                      </a:solidFill>
-                      <a:prstDash val="solid"/>
-                      <a:round/>
-                      <a:headEnd type="none" w="med" len="med"/>
-                      <a:tailEnd type="none" w="med" len="med"/>
-                    </a:lnT>
-                    <a:lnB w="9525" cap="flat" cmpd="sng" algn="ctr">
-                      <a:solidFill>
-                        <a:srgbClr val="D8DEE2"/>
-                      </a:solidFill>
-                      <a:prstDash val="solid"/>
-                      <a:round/>
-                      <a:headEnd type="none" w="med" len="med"/>
-                      <a:tailEnd type="none" w="med" len="med"/>
-                    </a:lnB>
-                  </a:tcPr>
-                </a:tc>
-                <a:tc>
-                  <a:txBody>
-                    <a:bodyPr/>
-                    <a:lstStyle/>
-                    <a:p>
-                      <a:pPr indent="0" marL="0">
-                        <a:buNone/>
-                      </a:pPr>
-                      <a:r>
-                        <a:rPr lang="en-US" sz="1100" b="1" dirty="0">
-                          <a:solidFill>
-                            <a:srgbClr val="1A2733"/>
-                          </a:solidFill>
-                          <a:latin typeface="Calibri" pitchFamily="34" charset="0"/>
-                          <a:ea typeface="Calibri" pitchFamily="34" charset="-122"/>
-                          <a:cs typeface="Calibri" pitchFamily="34" charset="-120"/>
-                        </a:rPr>
-                        <a:t>Критерий перехода — не ждать дозакрытия сценариев 6 и 4</a:t>
-                      </a:r>
-                      <a:endParaRPr lang="en-US" sz="1100" dirty="0">
-                        <a:latin typeface="Calibri" charset="0"/>
-                        <a:ea typeface="Calibri" charset="0"/>
-                        <a:cs typeface="Calibri" charset="0"/>
-                      </a:endParaRPr>
-                    </a:p>
-                  </a:txBody>
-                  <a:tcPr marL="114300" marR="114300" marT="76200" marB="76200" anchor="ctr">
-                    <a:lnL w="9525" cap="flat" cmpd="sng" algn="ctr">
-                      <a:solidFill>
-                        <a:srgbClr val="D8DEE2"/>
-                      </a:solidFill>
-                      <a:prstDash val="solid"/>
-                      <a:round/>
-                      <a:headEnd type="none" w="med" len="med"/>
-                      <a:tailEnd type="none" w="med" len="med"/>
-                    </a:lnL>
-                    <a:lnR w="9525" cap="flat" cmpd="sng" algn="ctr">
-                      <a:solidFill>
-                        <a:srgbClr val="D8DEE2"/>
-                      </a:solidFill>
-                      <a:prstDash val="solid"/>
-                      <a:round/>
-                      <a:headEnd type="none" w="med" len="med"/>
-                      <a:tailEnd type="none" w="med" len="med"/>
-                    </a:lnR>
-                    <a:lnT w="9525" cap="flat" cmpd="sng" algn="ctr">
-                      <a:solidFill>
-                        <a:srgbClr val="D8DEE2"/>
-                      </a:solidFill>
-                      <a:prstDash val="solid"/>
-                      <a:round/>
-                      <a:headEnd type="none" w="med" len="med"/>
-                      <a:tailEnd type="none" w="med" len="med"/>
-                    </a:lnT>
-                    <a:lnB w="9525" cap="flat" cmpd="sng" algn="ctr">
-                      <a:solidFill>
-                        <a:srgbClr val="D8DEE2"/>
-                      </a:solidFill>
-                      <a:prstDash val="solid"/>
-                      <a:round/>
-                      <a:headEnd type="none" w="med" len="med"/>
-                      <a:tailEnd type="none" w="med" len="med"/>
-                    </a:lnB>
-                  </a:tcPr>
-                </a:tc>
-                <a:tc>
-                  <a:txBody>
-                    <a:bodyPr/>
-                    <a:lstStyle/>
-                    <a:p>
-                      <a:pPr indent="0" marL="0">
-                        <a:buNone/>
-                      </a:pPr>
-                      <a:r>
-                        <a:rPr lang="en-US" sz="1050" dirty="0">
-                          <a:solidFill>
-                            <a:srgbClr val="5B6B7A"/>
-                          </a:solidFill>
-                          <a:latin typeface="Calibri" pitchFamily="34" charset="0"/>
-                          <a:ea typeface="Calibri" pitchFamily="34" charset="-122"/>
-                          <a:cs typeface="Calibri" pitchFamily="34" charset="-120"/>
-                        </a:rPr>
-                        <a:t>Перенести оба пункта в список долга бизнес-кейса П1, а не тихо забыть при переходе в проект.</a:t>
-                      </a:r>
-                      <a:endParaRPr lang="en-US" sz="1050" dirty="0">
-                        <a:latin typeface="Calibri" charset="0"/>
-                        <a:ea typeface="Calibri" charset="0"/>
-                        <a:cs typeface="Calibri" charset="0"/>
-                      </a:endParaRPr>
-                    </a:p>
-                  </a:txBody>
-                  <a:tcPr marL="114300" marR="114300" marT="76200" marB="76200" anchor="ctr">
-                    <a:lnL w="9525" cap="flat" cmpd="sng" algn="ctr">
-                      <a:solidFill>
-                        <a:srgbClr val="D8DEE2"/>
-                      </a:solidFill>
-                      <a:prstDash val="solid"/>
-                      <a:round/>
-                      <a:headEnd type="none" w="med" len="med"/>
-                      <a:tailEnd type="none" w="med" len="med"/>
-                    </a:lnL>
-                    <a:lnR w="9525" cap="flat" cmpd="sng" algn="ctr">
-                      <a:solidFill>
-                        <a:srgbClr val="D8DEE2"/>
-                      </a:solidFill>
-                      <a:prstDash val="solid"/>
-                      <a:round/>
-                      <a:headEnd type="none" w="med" len="med"/>
-                      <a:tailEnd type="none" w="med" len="med"/>
-                    </a:lnR>
-                    <a:lnT w="9525" cap="flat" cmpd="sng" algn="ctr">
-                      <a:solidFill>
-                        <a:srgbClr val="D8DEE2"/>
-                      </a:solidFill>
-                      <a:prstDash val="solid"/>
-                      <a:round/>
-                      <a:headEnd type="none" w="med" len="med"/>
-                      <a:tailEnd type="none" w="med" len="med"/>
-                    </a:lnT>
-                    <a:lnB w="9525" cap="flat" cmpd="sng" algn="ctr">
-                      <a:solidFill>
-                        <a:srgbClr val="D8DEE2"/>
-                      </a:solidFill>
-                      <a:prstDash val="solid"/>
-                      <a:round/>
-                      <a:headEnd type="none" w="med" len="med"/>
-                      <a:tailEnd type="none" w="med" len="med"/>
-                    </a:lnB>
-                  </a:tcPr>
-                </a:tc>
-              </a:tr>
-            </a:tbl>
-          </a:graphicData>
-        </a:graphic>
-      </p:graphicFrame>
-      <p:sp>
-        <p:nvSpPr>
-          <p:cNvPr id="6" name="Text 3"/>
-          <p:cNvSpPr txBox="1"/>
-          <p:nvPr/>
-        </p:nvSpPr>
-        <p:spPr>
-          <a:xfrm>
-            <a:off x="10881360" y="6473952"/>
-            <a:ext cx="822960" cy="274320"/>
-          </a:xfrm>
-          <a:prstGeom prst="rect">
-            <a:avLst/>
-          </a:prstGeom>
-          <a:noFill/>
-          <a:ln/>
-        </p:spPr>
-        <p:txBody>
-          <a:bodyPr wrap="square" lIns="0" tIns="0" rIns="0" bIns="0" rtlCol="0" anchor="ctr"/>
-          <a:lstStyle/>
-          <a:p>
-            <a:pPr algn="r" indent="0" marL="0">
-              <a:buNone/>
-            </a:pPr>
-            <a:r>
-              <a:rPr lang="en-US" sz="1050" dirty="0">
-                <a:solidFill>
-                  <a:srgbClr val="8C99A6"/>
-                </a:solidFill>
-                <a:latin typeface="Calibri" pitchFamily="34" charset="0"/>
-                <a:ea typeface="Calibri" pitchFamily="34" charset="-122"/>
-                <a:cs typeface="Calibri" pitchFamily="34" charset="-120"/>
-              </a:rPr>
-              <a:t>6 / 7</a:t>
-            </a:r>
-            <a:endParaRPr lang="en-US" sz="1050" dirty="0"/>
-          </a:p>
-        </p:txBody>
-      </p:sp>
-    </p:spTree>
-  </p:cSld>
-  <p:clrMapOvr>
-    <a:masterClrMapping/>
-  </p:clrMapOvr>
-</p:sld>
-</file>
-
-<file path=ppt/slides/slide7.xml><?xml version="1.0" encoding="utf-8"?>
-<p:sld xmlns:a="http://schemas.openxmlformats.org/drawingml/2006/main" xmlns:r="http://schemas.openxmlformats.org/officeDocument/2006/relationships" xmlns:p="http://schemas.openxmlformats.org/presentationml/2006/main">
-  <p:cSld name="Slide 7">
-    <p:spTree>
-      <p:nvGrpSpPr>
-        <p:cNvPr id="1" name=""/>
-        <p:cNvGrpSpPr/>
-        <p:nvPr/>
-      </p:nvGrpSpPr>
-      <p:grpSpPr>
-        <a:xfrm>
-          <a:off x="0" y="0"/>
-          <a:ext cx="0" cy="0"/>
-          <a:chOff x="0" y="0"/>
-          <a:chExt cx="0" cy="0"/>
-        </a:xfrm>
-      </p:grpSpPr>
-      <p:sp>
-        <p:nvSpPr>
-          <p:cNvPr id="2" name="Text 0"/>
-          <p:cNvSpPr txBox="1"/>
-          <p:nvPr/>
-        </p:nvSpPr>
-        <p:spPr>
-          <a:xfrm>
-            <a:off x="502920" y="320040"/>
-            <a:ext cx="11155680" cy="274320"/>
-          </a:xfrm>
-          <a:prstGeom prst="rect">
-            <a:avLst/>
-          </a:prstGeom>
-          <a:noFill/>
-          <a:ln/>
-        </p:spPr>
-        <p:txBody>
-          <a:bodyPr wrap="square" lIns="0" tIns="0" rIns="0" bIns="0" rtlCol="0" anchor="ctr"/>
-          <a:lstStyle/>
-          <a:p>
-            <a:pPr indent="0" marL="0">
-              <a:buNone/>
-            </a:pPr>
-            <a:r>
-              <a:rPr lang="en-US" sz="1100" b="1" spc="120" kern="0" dirty="0">
-                <a:solidFill>
-                  <a:srgbClr val="0E7C86"/>
-                </a:solidFill>
-                <a:latin typeface="Calibri" pitchFamily="34" charset="0"/>
-                <a:ea typeface="Calibri" pitchFamily="34" charset="-122"/>
-                <a:cs typeface="Calibri" pitchFamily="34" charset="-120"/>
-              </a:rPr>
-              <a:t>6 · АРХИТЕКТУРА ПИЛОТА</a:t>
+              <a:t>5 · АРХИТЕКТУРА ПИЛОТА</a:t>
             </a:r>
             <a:endParaRPr lang="en-US" sz="1100" dirty="0"/>
           </a:p>
@@ -12429,7 +10740,7 @@
                 <a:ea typeface="Calibri" pitchFamily="34" charset="-122"/>
                 <a:cs typeface="Calibri" pitchFamily="34" charset="-120"/>
               </a:rPr>
-              <a:t>7 / 7</a:t>
+              <a:t>6 / 6</a:t>
             </a:r>
             <a:endParaRPr lang="en-US" sz="1050" dirty="0"/>
           </a:p>

</xml_diff>

<commit_message>
Remove architecture diagram slide from D8 deck
Co-Authored-By: Claude Sonnet 5 <noreply@anthropic.com>
Claude-Session: https://claude.ai/code/session_01DpSN8JwCJ3tg3JVUadr2zE
</commit_message>
<xml_diff>
--- a/docs/presentations/case-27-proekt-d8-skoup-i-voprosy.pptx
+++ b/docs/presentations/case-27-proekt-d8-skoup-i-voprosy.pptx
@@ -10,10 +10,9 @@
     <p:sldId id="258" r:id="rId4"/>
     <p:sldId id="259" r:id="rId5"/>
     <p:sldId id="260" r:id="rId6"/>
-    <p:sldId id="261" r:id="rId7"/>
   </p:sldIdLst>
   <p:notesMasterIdLst>
-    <p:notesMasterId r:id="rId8"/>
+    <p:notesMasterId r:id="rId7"/>
   </p:notesMasterIdLst>
   <p:sldSz cx="12192000" cy="6858000"/>
   <p:notesSz cx="6858000" cy="12192000"/>
@@ -883,94 +882,6 @@
             <a:fld id="{F7021451-1387-4CA6-816F-3879F97B5CBC}" type="slidenum">
               <a:rPr lang="en-US"/>
               <a:t>5</a:t>
-            </a:fld>
-            <a:endParaRPr lang="en-US"/>
-          </a:p>
-        </p:txBody>
-      </p:sp>
-    </p:spTree>
-    <p:extLst>
-      <p:ext uri="{BB962C8B-B14F-4D97-AF65-F5344CB8AC3E}">
-        <p14:creationId xmlns:p14="http://schemas.microsoft.com/office/powerpoint/2010/main" val="1024086991"/>
-      </p:ext>
-    </p:extLst>
-  </p:cSld>
-  <p:clrMapOvr>
-    <a:masterClrMapping/>
-  </p:clrMapOvr>
-</p:notes>
-</file>
-
-<file path=ppt/notesSlides/notesSlide6.xml><?xml version="1.0" encoding="utf-8"?>
-<p:notes xmlns:a="http://schemas.openxmlformats.org/drawingml/2006/main" xmlns:r="http://schemas.openxmlformats.org/officeDocument/2006/relationships" xmlns:p="http://schemas.openxmlformats.org/presentationml/2006/main">
-  <p:cSld>
-    <p:spTree>
-      <p:nvGrpSpPr>
-        <p:cNvPr id="1" name=""/>
-        <p:cNvGrpSpPr/>
-        <p:nvPr/>
-      </p:nvGrpSpPr>
-      <p:grpSpPr>
-        <a:xfrm>
-          <a:off x="0" y="0"/>
-          <a:ext cx="0" cy="0"/>
-          <a:chOff x="0" y="0"/>
-          <a:chExt cx="0" cy="0"/>
-        </a:xfrm>
-      </p:grpSpPr>
-      <p:sp>
-        <p:nvSpPr>
-          <p:cNvPr id="2" name="Slide Image Placeholder 1"/>
-          <p:cNvSpPr>
-            <a:spLocks noGrp="1" noRot="1" noChangeAspect="1"/>
-          </p:cNvSpPr>
-          <p:nvPr>
-            <p:ph type="sldImg"/>
-          </p:nvPr>
-        </p:nvSpPr>
-        <p:spPr/>
-      </p:sp>
-      <p:sp>
-        <p:nvSpPr>
-          <p:cNvPr id="3" name="Notes Placeholder 2"/>
-          <p:cNvSpPr>
-            <a:spLocks noGrp="1"/>
-          </p:cNvSpPr>
-          <p:nvPr>
-            <p:ph type="body" idx="1"/>
-          </p:nvPr>
-        </p:nvSpPr>
-        <p:spPr/>
-        <p:txBody>
-          <a:bodyPr/>
-          <a:lstStyle/>
-          <a:p>
-            <a:r>
-              <a:rPr lang="en-US" dirty="0"/>
-              <a:t/>
-            </a:r>
-            <a:endParaRPr lang="en-US" dirty="0"/>
-          </a:p>
-        </p:txBody>
-      </p:sp>
-      <p:sp>
-        <p:nvSpPr>
-          <p:cNvPr id="4" name="Slide Number Placeholder 3"/>
-          <p:cNvSpPr>
-            <a:spLocks noGrp="1"/>
-          </p:cNvSpPr>
-          <p:nvPr>
-            <p:ph type="sldNum" sz="quarter" idx="10"/>
-          </p:nvPr>
-        </p:nvSpPr>
-        <p:spPr/>
-        <p:txBody>
-          <a:bodyPr/>
-          <a:lstStyle/>
-          <a:p>
-            <a:fld id="{F7021451-1387-4CA6-816F-3879F97B5CBC}" type="slidenum">
-              <a:rPr lang="en-US"/>
-              <a:t>6</a:t>
             </a:fld>
             <a:endParaRPr lang="en-US"/>
           </a:p>
@@ -1931,7 +1842,7 @@
                 <a:ea typeface="Calibri" pitchFamily="34" charset="-122"/>
                 <a:cs typeface="Calibri" pitchFamily="34" charset="-120"/>
               </a:rPr>
-              <a:t>1 / 6</a:t>
+              <a:t>1 / 5</a:t>
             </a:r>
             <a:endParaRPr lang="en-US" sz="1050" dirty="0"/>
           </a:p>
@@ -3270,7 +3181,7 @@
                 <a:ea typeface="Calibri" pitchFamily="34" charset="-122"/>
                 <a:cs typeface="Calibri" pitchFamily="34" charset="-120"/>
               </a:rPr>
-              <a:t>2 / 6</a:t>
+              <a:t>2 / 5</a:t>
             </a:r>
             <a:endParaRPr lang="en-US" sz="1050" dirty="0"/>
           </a:p>
@@ -5368,7 +5279,7 @@
                 <a:ea typeface="Calibri" pitchFamily="34" charset="-122"/>
                 <a:cs typeface="Calibri" pitchFamily="34" charset="-120"/>
               </a:rPr>
-              <a:t>3 / 6</a:t>
+              <a:t>3 / 5</a:t>
             </a:r>
             <a:endParaRPr lang="en-US" sz="1050" dirty="0"/>
           </a:p>
@@ -8671,7 +8582,7 @@
                 <a:ea typeface="Calibri" pitchFamily="34" charset="-122"/>
                 <a:cs typeface="Calibri" pitchFamily="34" charset="-120"/>
               </a:rPr>
-              <a:t>4 / 6</a:t>
+              <a:t>4 / 5</a:t>
             </a:r>
             <a:endParaRPr lang="en-US" sz="1050" dirty="0"/>
           </a:p>
@@ -10535,212 +10446,7 @@
                 <a:ea typeface="Calibri" pitchFamily="34" charset="-122"/>
                 <a:cs typeface="Calibri" pitchFamily="34" charset="-120"/>
               </a:rPr>
-              <a:t>5 / 6</a:t>
-            </a:r>
-            <a:endParaRPr lang="en-US" sz="1050" dirty="0"/>
-          </a:p>
-        </p:txBody>
-      </p:sp>
-    </p:spTree>
-  </p:cSld>
-  <p:clrMapOvr>
-    <a:masterClrMapping/>
-  </p:clrMapOvr>
-</p:sld>
-</file>
-
-<file path=ppt/slides/slide6.xml><?xml version="1.0" encoding="utf-8"?>
-<p:sld xmlns:a="http://schemas.openxmlformats.org/drawingml/2006/main" xmlns:r="http://schemas.openxmlformats.org/officeDocument/2006/relationships" xmlns:p="http://schemas.openxmlformats.org/presentationml/2006/main">
-  <p:cSld name="Slide 6">
-    <p:spTree>
-      <p:nvGrpSpPr>
-        <p:cNvPr id="1" name=""/>
-        <p:cNvGrpSpPr/>
-        <p:nvPr/>
-      </p:nvGrpSpPr>
-      <p:grpSpPr>
-        <a:xfrm>
-          <a:off x="0" y="0"/>
-          <a:ext cx="0" cy="0"/>
-          <a:chOff x="0" y="0"/>
-          <a:chExt cx="0" cy="0"/>
-        </a:xfrm>
-      </p:grpSpPr>
-      <p:sp>
-        <p:nvSpPr>
-          <p:cNvPr id="2" name="Text 0"/>
-          <p:cNvSpPr txBox="1"/>
-          <p:nvPr/>
-        </p:nvSpPr>
-        <p:spPr>
-          <a:xfrm>
-            <a:off x="502920" y="320040"/>
-            <a:ext cx="11155680" cy="274320"/>
-          </a:xfrm>
-          <a:prstGeom prst="rect">
-            <a:avLst/>
-          </a:prstGeom>
-          <a:noFill/>
-          <a:ln/>
-        </p:spPr>
-        <p:txBody>
-          <a:bodyPr wrap="square" lIns="0" tIns="0" rIns="0" bIns="0" rtlCol="0" anchor="ctr"/>
-          <a:lstStyle/>
-          <a:p>
-            <a:pPr indent="0" marL="0">
-              <a:buNone/>
-            </a:pPr>
-            <a:r>
-              <a:rPr lang="en-US" sz="1100" b="1" spc="120" kern="0" dirty="0">
-                <a:solidFill>
-                  <a:srgbClr val="0E7C86"/>
-                </a:solidFill>
-                <a:latin typeface="Calibri" pitchFamily="34" charset="0"/>
-                <a:ea typeface="Calibri" pitchFamily="34" charset="-122"/>
-                <a:cs typeface="Calibri" pitchFamily="34" charset="-120"/>
-              </a:rPr>
-              <a:t>5 · АРХИТЕКТУРА ПИЛОТА</a:t>
-            </a:r>
-            <a:endParaRPr lang="en-US" sz="1100" dirty="0"/>
-          </a:p>
-        </p:txBody>
-      </p:sp>
-      <p:sp>
-        <p:nvSpPr>
-          <p:cNvPr id="3" name="Text 1"/>
-          <p:cNvSpPr txBox="1"/>
-          <p:nvPr/>
-        </p:nvSpPr>
-        <p:spPr>
-          <a:xfrm>
-            <a:off x="502920" y="621792"/>
-            <a:ext cx="11155680" cy="548640"/>
-          </a:xfrm>
-          <a:prstGeom prst="rect">
-            <a:avLst/>
-          </a:prstGeom>
-          <a:noFill/>
-          <a:ln/>
-        </p:spPr>
-        <p:txBody>
-          <a:bodyPr wrap="square" lIns="0" tIns="0" rIns="0" bIns="0" rtlCol="0" anchor="ctr"/>
-          <a:lstStyle/>
-          <a:p>
-            <a:pPr indent="0" marL="0">
-              <a:buNone/>
-            </a:pPr>
-            <a:r>
-              <a:rPr lang="en-US" sz="2700" b="1" dirty="0">
-                <a:solidFill>
-                  <a:srgbClr val="1A2733"/>
-                </a:solidFill>
-                <a:latin typeface="Cambria" pitchFamily="34" charset="0"/>
-                <a:ea typeface="Cambria" pitchFamily="34" charset="-122"/>
-                <a:cs typeface="Cambria" pitchFamily="34" charset="-120"/>
-              </a:rPr>
-              <a:t>Источники и получатели данных</a:t>
-            </a:r>
-            <a:endParaRPr lang="en-US" sz="2700" dirty="0"/>
-          </a:p>
-        </p:txBody>
-      </p:sp>
-      <p:sp>
-        <p:nvSpPr>
-          <p:cNvPr id="4" name="Text 2"/>
-          <p:cNvSpPr txBox="1"/>
-          <p:nvPr/>
-        </p:nvSpPr>
-        <p:spPr>
-          <a:xfrm>
-            <a:off x="502920" y="1170432"/>
-            <a:ext cx="11155680" cy="365760"/>
-          </a:xfrm>
-          <a:prstGeom prst="rect">
-            <a:avLst/>
-          </a:prstGeom>
-          <a:noFill/>
-          <a:ln/>
-        </p:spPr>
-        <p:txBody>
-          <a:bodyPr wrap="square" lIns="0" tIns="0" rIns="0" bIns="0" rtlCol="0" anchor="ctr"/>
-          <a:lstStyle/>
-          <a:p>
-            <a:pPr indent="0" marL="0">
-              <a:buNone/>
-            </a:pPr>
-            <a:r>
-              <a:rPr lang="en-US" sz="1300" dirty="0">
-                <a:solidFill>
-                  <a:srgbClr val="5B6B7A"/>
-                </a:solidFill>
-                <a:latin typeface="Calibri" pitchFamily="34" charset="0"/>
-                <a:ea typeface="Calibri" pitchFamily="34" charset="-122"/>
-                <a:cs typeface="Calibri" pitchFamily="34" charset="-120"/>
-              </a:rPr>
-              <a:t>Платформа «Камерата» по фактам пилота (не проектный скоуп) — расширение см. в разделе «Программа проекта»</a:t>
-            </a:r>
-            <a:endParaRPr lang="en-US" sz="1300" dirty="0"/>
-          </a:p>
-        </p:txBody>
-      </p:sp>
-      <p:pic>
-        <p:nvPicPr>
-          <p:cNvPr id="5" name="Image 0" descr="arhitektura-pilota.png">    </p:cNvPr>
-          <p:cNvPicPr>
-            <a:picLocks noChangeAspect="1"/>
-          </p:cNvPicPr>
-          <p:nvPr/>
-        </p:nvPicPr>
-        <p:blipFill>
-          <a:blip r:embed="rId1"/>
-          <a:stretch>
-            <a:fillRect/>
-          </a:stretch>
-        </p:blipFill>
-        <p:spPr>
-          <a:xfrm>
-            <a:off x="2148840" y="1783080"/>
-            <a:ext cx="7863840" cy="4456176"/>
-          </a:xfrm>
-          <a:prstGeom prst="rect">
-            <a:avLst/>
-          </a:prstGeom>
-        </p:spPr>
-      </p:pic>
-      <p:sp>
-        <p:nvSpPr>
-          <p:cNvPr id="6" name="Text 3"/>
-          <p:cNvSpPr txBox="1"/>
-          <p:nvPr/>
-        </p:nvSpPr>
-        <p:spPr>
-          <a:xfrm>
-            <a:off x="10881360" y="6473952"/>
-            <a:ext cx="822960" cy="274320"/>
-          </a:xfrm>
-          <a:prstGeom prst="rect">
-            <a:avLst/>
-          </a:prstGeom>
-          <a:noFill/>
-          <a:ln/>
-        </p:spPr>
-        <p:txBody>
-          <a:bodyPr wrap="square" lIns="0" tIns="0" rIns="0" bIns="0" rtlCol="0" anchor="ctr"/>
-          <a:lstStyle/>
-          <a:p>
-            <a:pPr algn="r" indent="0" marL="0">
-              <a:buNone/>
-            </a:pPr>
-            <a:r>
-              <a:rPr lang="en-US" sz="1050" dirty="0">
-                <a:solidFill>
-                  <a:srgbClr val="8C99A6"/>
-                </a:solidFill>
-                <a:latin typeface="Calibri" pitchFamily="34" charset="0"/>
-                <a:ea typeface="Calibri" pitchFamily="34" charset="-122"/>
-                <a:cs typeface="Calibri" pitchFamily="34" charset="-120"/>
-              </a:rPr>
-              <a:t>6 / 6</a:t>
+              <a:t>5 / 5</a:t>
             </a:r>
             <a:endParaRPr lang="en-US" sz="1050" dirty="0"/>
           </a:p>

</xml_diff>